<commit_message>
Replace rotablation left main PCI slides with a PowerPoint-compatible build
Swap the deck and PDF for the version that opens in Microsoft PowerPoint on Android.

Co-authored-by: Dr. Mohd Maqbool Sohil <drsohailpgimer@gmail.com>
</commit_message>
<xml_diff>
--- a/presentations/Rotablation-Left-Main-PCI-Sohil-2026.pptx
+++ b/presentations/Rotablation-Left-Main-PCI-Sohil-2026.pptx
@@ -27,7 +27,7 @@
     <p:sldId id="265" r:id="rId11"/>
   </p:sldIdLst>
   <p:sldSz cx="9144000" cy="5143500"/>
-  <p:notesSz cx="5143500" cy="9144000"/>
+  <p:notesSz cx="6858000" cy="9144000"/>
   <p:defaultTextStyle>
     <a:lvl1pPr marL="0" algn="l" defTabSz="914400" rtl="0" eaLnBrk="1" latinLnBrk="0" hangingPunct="1">
       <a:defRPr sz="1800" kern="1200">
@@ -126,7 +126,8 @@
 <file path=ppt/charts/chart1.xml><?xml version="1.0" encoding="utf-8"?>
 <c:chartSpace xmlns:c="http://schemas.openxmlformats.org/drawingml/2006/chart" xmlns:a="http://schemas.openxmlformats.org/drawingml/2006/main" xmlns:r="http://schemas.openxmlformats.org/officeDocument/2006/relationships">
   <c:date1904 val="0"/>
-  <c:roundedCorners val="1"/>
+  <c:lang val="en-US"/>
+  <c:roundedCorners val="0"/>
   <c:chart>
     <c:autoTitleDeleted val="1"/>
     <c:plotArea>
@@ -187,7 +188,7 @@
                     <a:solidFill>
                       <a:srgbClr val="0B3D66"/>
                     </a:solidFill>
-                    <a:latin typeface="Space Grotesk"/>
+                    <a:latin typeface="Arial"/>
                   </a:defRPr>
                 </a:pPr>
               </a:p>
@@ -201,32 +202,30 @@
             <c:showLeaderLines val="0"/>
           </c:dLbls>
           <c:cat>
-            <c:multiLvlStrRef>
+            <c:strRef>
               <c:f>Sheet1!$A$2:$A$7</c:f>
-              <c:multiLvlStrCache>
+              <c:strCache>
                 <c:ptCount val="6"/>
-                <c:lvl>
-                  <c:pt idx="0">
-                    <c:v>This study: in-hosp. death</c:v>
-                  </c:pt>
-                  <c:pt idx="1">
-                    <c:v>This study: 2-yr TLR</c:v>
-                  </c:pt>
-                  <c:pt idx="2">
-                    <c:v>ROTATE: in-hosp. MACE</c:v>
-                  </c:pt>
-                  <c:pt idx="3">
-                    <c:v>Bouisset: 1-yr MACE</c:v>
-                  </c:pt>
-                  <c:pt idx="4">
-                    <c:v>Garcia-Lara: 2-yr TVR</c:v>
-                  </c:pt>
-                  <c:pt idx="5">
-                    <c:v>ROTATE: 2-yr MACE</c:v>
-                  </c:pt>
-                </c:lvl>
-              </c:multiLvlStrCache>
-            </c:multiLvlStrRef>
+                <c:pt idx="0">
+                  <c:v>This study: in-hosp. death</c:v>
+                </c:pt>
+                <c:pt idx="1">
+                  <c:v>This study: 2-yr TLR</c:v>
+                </c:pt>
+                <c:pt idx="2">
+                  <c:v>ROTATE: in-hosp. MACE</c:v>
+                </c:pt>
+                <c:pt idx="3">
+                  <c:v>Bouisset: 1-yr MACE</c:v>
+                </c:pt>
+                <c:pt idx="4">
+                  <c:v>Garcia-Lara: 2-yr TVR</c:v>
+                </c:pt>
+                <c:pt idx="5">
+                  <c:v>ROTATE: 2-yr MACE</c:v>
+                </c:pt>
+              </c:strCache>
+            </c:strRef>
           </c:cat>
           <c:val>
             <c:numRef>
@@ -267,7 +266,7 @@
                   <a:solidFill>
                     <a:srgbClr val="0B3D66"/>
                   </a:solidFill>
-                  <a:latin typeface="Space Grotesk"/>
+                  <a:latin typeface="Arial"/>
                 </a:defRPr>
               </a:pPr>
             </a:p>
@@ -314,7 +313,7 @@
                 <a:solidFill>
                   <a:srgbClr val="000000"/>
                 </a:solidFill>
-                <a:latin typeface="Space Grotesk Light"/>
+                <a:latin typeface="Arial"/>
               </a:defRPr>
             </a:pPr>
             <a:endParaRPr lang="en-US"/>
@@ -394,7 +393,8 @@
 <file path=ppt/charts/chart2.xml><?xml version="1.0" encoding="utf-8"?>
 <c:chartSpace xmlns:c="http://schemas.openxmlformats.org/drawingml/2006/chart" xmlns:a="http://schemas.openxmlformats.org/drawingml/2006/main" xmlns:r="http://schemas.openxmlformats.org/officeDocument/2006/relationships">
   <c:date1904 val="0"/>
-  <c:roundedCorners val="1"/>
+  <c:lang val="en-US"/>
+  <c:roundedCorners val="0"/>
   <c:chart>
     <c:autoTitleDeleted val="1"/>
     <c:plotArea>
@@ -445,7 +445,7 @@
                     <a:solidFill>
                       <a:srgbClr val="0B3D66"/>
                     </a:solidFill>
-                    <a:latin typeface="Space Grotesk"/>
+                    <a:latin typeface="Arial"/>
                   </a:defRPr>
                 </a:pPr>
               </a:p>
@@ -459,26 +459,24 @@
             <c:showLeaderLines val="0"/>
           </c:dLbls>
           <c:cat>
-            <c:multiLvlStrRef>
+            <c:strRef>
               <c:f>Sheet1!$A$2:$A$5</c:f>
-              <c:multiLvlStrCache>
+              <c:strCache>
                 <c:ptCount val="4"/>
-                <c:lvl>
-                  <c:pt idx="0">
-                    <c:v>Isolated LMCA</c:v>
-                  </c:pt>
-                  <c:pt idx="1">
-                    <c:v>LMCA + SVD</c:v>
-                  </c:pt>
-                  <c:pt idx="2">
-                    <c:v>LMCA + DVD</c:v>
-                  </c:pt>
-                  <c:pt idx="3">
-                    <c:v>LMCA + TVD</c:v>
-                  </c:pt>
-                </c:lvl>
-              </c:multiLvlStrCache>
-            </c:multiLvlStrRef>
+                <c:pt idx="0">
+                  <c:v>Isolated LMCA</c:v>
+                </c:pt>
+                <c:pt idx="1">
+                  <c:v>LMCA + SVD</c:v>
+                </c:pt>
+                <c:pt idx="2">
+                  <c:v>LMCA + DVD</c:v>
+                </c:pt>
+                <c:pt idx="3">
+                  <c:v>LMCA + TVD</c:v>
+                </c:pt>
+              </c:strCache>
+            </c:strRef>
           </c:cat>
           <c:val>
             <c:numRef>
@@ -513,7 +511,7 @@
                   <a:solidFill>
                     <a:srgbClr val="0B3D66"/>
                   </a:solidFill>
-                  <a:latin typeface="Space Grotesk"/>
+                  <a:latin typeface="Arial"/>
                 </a:defRPr>
               </a:pPr>
             </a:p>
@@ -560,7 +558,7 @@
                 <a:solidFill>
                   <a:srgbClr val="000000"/>
                 </a:solidFill>
-                <a:latin typeface="Space Grotesk Light"/>
+                <a:latin typeface="Arial"/>
               </a:defRPr>
             </a:pPr>
             <a:endParaRPr lang="en-US"/>
@@ -886,7 +884,7 @@
     </p:spTree>
     <p:extLst>
       <p:ext uri="{BB962C8B-B14F-4D97-AF65-F5344CB8AC3E}">
-        <p14:creationId xmlns:p14="http://schemas.microsoft.com/office/powerpoint/2010/main" val="1024086991"/>
+        <p14:creationId xmlns:p14="http://schemas.microsoft.com/office/powerpoint/2010/main" val="3019500803"/>
       </p:ext>
     </p:extLst>
   </p:cSld>
@@ -1099,7 +1097,7 @@
     </p:spTree>
     <p:extLst>
       <p:ext uri="{BB962C8B-B14F-4D97-AF65-F5344CB8AC3E}">
-        <p14:creationId xmlns:p14="http://schemas.microsoft.com/office/powerpoint/2010/main" val="1024086991"/>
+        <p14:creationId xmlns:p14="http://schemas.microsoft.com/office/powerpoint/2010/main" val="1614454866"/>
       </p:ext>
     </p:extLst>
   </p:cSld>
@@ -1210,7 +1208,7 @@
     </p:spTree>
     <p:extLst>
       <p:ext uri="{BB962C8B-B14F-4D97-AF65-F5344CB8AC3E}">
-        <p14:creationId xmlns:p14="http://schemas.microsoft.com/office/powerpoint/2010/main" val="1024086991"/>
+        <p14:creationId xmlns:p14="http://schemas.microsoft.com/office/powerpoint/2010/main" val="2588017306"/>
       </p:ext>
     </p:extLst>
   </p:cSld>
@@ -1333,7 +1331,7 @@
     </p:spTree>
     <p:extLst>
       <p:ext uri="{BB962C8B-B14F-4D97-AF65-F5344CB8AC3E}">
-        <p14:creationId xmlns:p14="http://schemas.microsoft.com/office/powerpoint/2010/main" val="1024086991"/>
+        <p14:creationId xmlns:p14="http://schemas.microsoft.com/office/powerpoint/2010/main" val="1315283931"/>
       </p:ext>
     </p:extLst>
   </p:cSld>
@@ -1450,7 +1448,7 @@
     </p:spTree>
     <p:extLst>
       <p:ext uri="{BB962C8B-B14F-4D97-AF65-F5344CB8AC3E}">
-        <p14:creationId xmlns:p14="http://schemas.microsoft.com/office/powerpoint/2010/main" val="1024086991"/>
+        <p14:creationId xmlns:p14="http://schemas.microsoft.com/office/powerpoint/2010/main" val="3767399567"/>
       </p:ext>
     </p:extLst>
   </p:cSld>
@@ -1555,7 +1553,7 @@
     </p:spTree>
     <p:extLst>
       <p:ext uri="{BB962C8B-B14F-4D97-AF65-F5344CB8AC3E}">
-        <p14:creationId xmlns:p14="http://schemas.microsoft.com/office/powerpoint/2010/main" val="1024086991"/>
+        <p14:creationId xmlns:p14="http://schemas.microsoft.com/office/powerpoint/2010/main" val="841091593"/>
       </p:ext>
     </p:extLst>
   </p:cSld>
@@ -1684,7 +1682,7 @@
     </p:spTree>
     <p:extLst>
       <p:ext uri="{BB962C8B-B14F-4D97-AF65-F5344CB8AC3E}">
-        <p14:creationId xmlns:p14="http://schemas.microsoft.com/office/powerpoint/2010/main" val="1024086991"/>
+        <p14:creationId xmlns:p14="http://schemas.microsoft.com/office/powerpoint/2010/main" val="308373719"/>
       </p:ext>
     </p:extLst>
   </p:cSld>
@@ -1795,7 +1793,7 @@
     </p:spTree>
     <p:extLst>
       <p:ext uri="{BB962C8B-B14F-4D97-AF65-F5344CB8AC3E}">
-        <p14:creationId xmlns:p14="http://schemas.microsoft.com/office/powerpoint/2010/main" val="1024086991"/>
+        <p14:creationId xmlns:p14="http://schemas.microsoft.com/office/powerpoint/2010/main" val="3637378079"/>
       </p:ext>
     </p:extLst>
   </p:cSld>
@@ -1918,7 +1916,7 @@
     </p:spTree>
     <p:extLst>
       <p:ext uri="{BB962C8B-B14F-4D97-AF65-F5344CB8AC3E}">
-        <p14:creationId xmlns:p14="http://schemas.microsoft.com/office/powerpoint/2010/main" val="1024086991"/>
+        <p14:creationId xmlns:p14="http://schemas.microsoft.com/office/powerpoint/2010/main" val="1137582237"/>
       </p:ext>
     </p:extLst>
   </p:cSld>
@@ -2035,7 +2033,7 @@
     </p:spTree>
     <p:extLst>
       <p:ext uri="{BB962C8B-B14F-4D97-AF65-F5344CB8AC3E}">
-        <p14:creationId xmlns:p14="http://schemas.microsoft.com/office/powerpoint/2010/main" val="1024086991"/>
+        <p14:creationId xmlns:p14="http://schemas.microsoft.com/office/powerpoint/2010/main" val="1089763266"/>
       </p:ext>
     </p:extLst>
   </p:cSld>
@@ -2152,7 +2150,7 @@
     </p:spTree>
     <p:extLst>
       <p:ext uri="{BB962C8B-B14F-4D97-AF65-F5344CB8AC3E}">
-        <p14:creationId xmlns:p14="http://schemas.microsoft.com/office/powerpoint/2010/main" val="1024086991"/>
+        <p14:creationId xmlns:p14="http://schemas.microsoft.com/office/powerpoint/2010/main" val="1107426713"/>
       </p:ext>
     </p:extLst>
   </p:cSld>
@@ -2275,7 +2273,7 @@
     </p:spTree>
     <p:extLst>
       <p:ext uri="{BB962C8B-B14F-4D97-AF65-F5344CB8AC3E}">
-        <p14:creationId xmlns:p14="http://schemas.microsoft.com/office/powerpoint/2010/main" val="1024086991"/>
+        <p14:creationId xmlns:p14="http://schemas.microsoft.com/office/powerpoint/2010/main" val="112566049"/>
       </p:ext>
     </p:extLst>
   </p:cSld>
@@ -2392,7 +2390,7 @@
     </p:spTree>
     <p:extLst>
       <p:ext uri="{BB962C8B-B14F-4D97-AF65-F5344CB8AC3E}">
-        <p14:creationId xmlns:p14="http://schemas.microsoft.com/office/powerpoint/2010/main" val="1024086991"/>
+        <p14:creationId xmlns:p14="http://schemas.microsoft.com/office/powerpoint/2010/main" val="3165157091"/>
       </p:ext>
     </p:extLst>
   </p:cSld>
@@ -2521,7 +2519,7 @@
     </p:spTree>
     <p:extLst>
       <p:ext uri="{BB962C8B-B14F-4D97-AF65-F5344CB8AC3E}">
-        <p14:creationId xmlns:p14="http://schemas.microsoft.com/office/powerpoint/2010/main" val="1024086991"/>
+        <p14:creationId xmlns:p14="http://schemas.microsoft.com/office/powerpoint/2010/main" val="3645493547"/>
       </p:ext>
     </p:extLst>
   </p:cSld>
@@ -2644,7 +2642,7 @@
     </p:spTree>
     <p:extLst>
       <p:ext uri="{BB962C8B-B14F-4D97-AF65-F5344CB8AC3E}">
-        <p14:creationId xmlns:p14="http://schemas.microsoft.com/office/powerpoint/2010/main" val="1024086991"/>
+        <p14:creationId xmlns:p14="http://schemas.microsoft.com/office/powerpoint/2010/main" val="2448450340"/>
       </p:ext>
     </p:extLst>
   </p:cSld>
@@ -2761,7 +2759,7 @@
     </p:spTree>
     <p:extLst>
       <p:ext uri="{BB962C8B-B14F-4D97-AF65-F5344CB8AC3E}">
-        <p14:creationId xmlns:p14="http://schemas.microsoft.com/office/powerpoint/2010/main" val="1024086991"/>
+        <p14:creationId xmlns:p14="http://schemas.microsoft.com/office/powerpoint/2010/main" val="665518533"/>
       </p:ext>
     </p:extLst>
   </p:cSld>
@@ -2890,7 +2888,7 @@
     </p:spTree>
     <p:extLst>
       <p:ext uri="{BB962C8B-B14F-4D97-AF65-F5344CB8AC3E}">
-        <p14:creationId xmlns:p14="http://schemas.microsoft.com/office/powerpoint/2010/main" val="1024086991"/>
+        <p14:creationId xmlns:p14="http://schemas.microsoft.com/office/powerpoint/2010/main" val="353793912"/>
       </p:ext>
     </p:extLst>
   </p:cSld>
@@ -3001,7 +2999,7 @@
     </p:spTree>
     <p:extLst>
       <p:ext uri="{BB962C8B-B14F-4D97-AF65-F5344CB8AC3E}">
-        <p14:creationId xmlns:p14="http://schemas.microsoft.com/office/powerpoint/2010/main" val="1024086991"/>
+        <p14:creationId xmlns:p14="http://schemas.microsoft.com/office/powerpoint/2010/main" val="954062247"/>
       </p:ext>
     </p:extLst>
   </p:cSld>
@@ -3371,9 +3369,9 @@
                 <a:solidFill>
                   <a:srgbClr val="FFFFFF"/>
                 </a:solidFill>
-                <a:latin typeface="Space Grotesk" pitchFamily="34" charset="0"/>
-                <a:ea typeface="Space Grotesk" pitchFamily="34" charset="-122"/>
-                <a:cs typeface="Space Grotesk" pitchFamily="34" charset="-120"/>
+                <a:latin typeface="Arial"/>
+                <a:ea typeface="Arial"/>
+                <a:cs typeface="Arial"/>
               </a:rPr>
               <a:t>ROTABLATION-ASSISTED</a:t>
             </a:r>
@@ -3410,9 +3408,9 @@
                 <a:solidFill>
                   <a:srgbClr val="FFFFFF"/>
                 </a:solidFill>
-                <a:latin typeface="Space Grotesk" pitchFamily="34" charset="0"/>
-                <a:ea typeface="Space Grotesk" pitchFamily="34" charset="-122"/>
-                <a:cs typeface="Space Grotesk" pitchFamily="34" charset="-120"/>
+                <a:latin typeface="Arial"/>
+                <a:ea typeface="Arial"/>
+                <a:cs typeface="Arial"/>
               </a:rPr>
               <a:t>LEFT MAIN PCI</a:t>
             </a:r>
@@ -3449,9 +3447,9 @@
                 <a:solidFill>
                   <a:srgbClr val="D6E6F5"/>
                 </a:solidFill>
-                <a:latin typeface="Space Grotesk Light" pitchFamily="34" charset="0"/>
-                <a:ea typeface="Space Grotesk Light" pitchFamily="34" charset="-122"/>
-                <a:cs typeface="Space Grotesk Light" pitchFamily="34" charset="-120"/>
+                <a:latin typeface="Arial"/>
+                <a:ea typeface="Arial"/>
+                <a:cs typeface="Arial"/>
               </a:rPr>
               <a:t>A single centre experience</a:t>
             </a:r>
@@ -3508,9 +3506,9 @@
                 <a:solidFill>
                   <a:srgbClr val="FFFFFF"/>
                 </a:solidFill>
-                <a:latin typeface="Space Grotesk" pitchFamily="34" charset="0"/>
-                <a:ea typeface="Space Grotesk" pitchFamily="34" charset="-122"/>
-                <a:cs typeface="Space Grotesk" pitchFamily="34" charset="-120"/>
+                <a:latin typeface="Arial"/>
+                <a:ea typeface="Arial"/>
+                <a:cs typeface="Arial"/>
               </a:rPr>
               <a:t>Dr. Mohd Maqbool Sohil, MD, DM, FSCAI</a:t>
             </a:r>
@@ -3525,9 +3523,9 @@
                 <a:solidFill>
                   <a:srgbClr val="FFFFFF"/>
                 </a:solidFill>
-                <a:latin typeface="Space Grotesk Light" pitchFamily="34" charset="0"/>
-                <a:ea typeface="Space Grotesk Light" pitchFamily="34" charset="-122"/>
-                <a:cs typeface="Space Grotesk Light" pitchFamily="34" charset="-120"/>
+                <a:latin typeface="Arial"/>
+                <a:ea typeface="Arial"/>
+                <a:cs typeface="Arial"/>
               </a:rPr>
               <a:t>Interventional Cardiologist</a:t>
             </a:r>
@@ -3545,9 +3543,9 @@
                 <a:solidFill>
                   <a:srgbClr val="FFFFFF"/>
                 </a:solidFill>
-                <a:latin typeface="Space Grotesk Light" pitchFamily="34" charset="0"/>
-                <a:ea typeface="Space Grotesk Light" pitchFamily="34" charset="-122"/>
-                <a:cs typeface="Space Grotesk Light" pitchFamily="34" charset="-120"/>
+                <a:latin typeface="Arial"/>
+                <a:ea typeface="Arial"/>
+                <a:cs typeface="Arial"/>
               </a:rPr>
               <a:t>Sohil MM</a:t>
             </a:r>
@@ -3556,9 +3554,9 @@
                 <a:solidFill>
                   <a:srgbClr val="FFFFFF"/>
                 </a:solidFill>
-                <a:latin typeface="Space Grotesk Light" pitchFamily="34" charset="0"/>
-                <a:ea typeface="Space Grotesk Light" pitchFamily="34" charset="-122"/>
-                <a:cs typeface="Space Grotesk Light" pitchFamily="34" charset="-120"/>
+                <a:latin typeface="Arial"/>
+                <a:ea typeface="Arial"/>
+                <a:cs typeface="Arial"/>
               </a:rPr>
               <a:t>a</a:t>
             </a:r>
@@ -3567,9 +3565,9 @@
                 <a:solidFill>
                   <a:srgbClr val="FFFFFF"/>
                 </a:solidFill>
-                <a:latin typeface="Space Grotesk Light" pitchFamily="34" charset="0"/>
-                <a:ea typeface="Space Grotesk Light" pitchFamily="34" charset="-122"/>
-                <a:cs typeface="Space Grotesk Light" pitchFamily="34" charset="-120"/>
+                <a:latin typeface="Arial"/>
+                <a:ea typeface="Arial"/>
+                <a:cs typeface="Arial"/>
               </a:rPr>
               <a:t>, Masood I</a:t>
             </a:r>
@@ -3578,9 +3576,9 @@
                 <a:solidFill>
                   <a:srgbClr val="FFFFFF"/>
                 </a:solidFill>
-                <a:latin typeface="Space Grotesk Light" pitchFamily="34" charset="0"/>
-                <a:ea typeface="Space Grotesk Light" pitchFamily="34" charset="-122"/>
-                <a:cs typeface="Space Grotesk Light" pitchFamily="34" charset="-120"/>
+                <a:latin typeface="Arial"/>
+                <a:ea typeface="Arial"/>
+                <a:cs typeface="Arial"/>
               </a:rPr>
               <a:t>b</a:t>
             </a:r>
@@ -3589,9 +3587,9 @@
                 <a:solidFill>
                   <a:srgbClr val="FFFFFF"/>
                 </a:solidFill>
-                <a:latin typeface="Space Grotesk Light" pitchFamily="34" charset="0"/>
-                <a:ea typeface="Space Grotesk Light" pitchFamily="34" charset="-122"/>
-                <a:cs typeface="Space Grotesk Light" pitchFamily="34" charset="-120"/>
+                <a:latin typeface="Arial"/>
+                <a:ea typeface="Arial"/>
+                <a:cs typeface="Arial"/>
               </a:rPr>
               <a:t>, Goyal D</a:t>
             </a:r>
@@ -3600,9 +3598,9 @@
                 <a:solidFill>
                   <a:srgbClr val="FFFFFF"/>
                 </a:solidFill>
-                <a:latin typeface="Space Grotesk Light" pitchFamily="34" charset="0"/>
-                <a:ea typeface="Space Grotesk Light" pitchFamily="34" charset="-122"/>
-                <a:cs typeface="Space Grotesk Light" pitchFamily="34" charset="-120"/>
+                <a:latin typeface="Arial"/>
+                <a:ea typeface="Arial"/>
+                <a:cs typeface="Arial"/>
               </a:rPr>
               <a:t>b</a:t>
             </a:r>
@@ -3611,9 +3609,9 @@
                 <a:solidFill>
                   <a:srgbClr val="FFFFFF"/>
                 </a:solidFill>
-                <a:latin typeface="Space Grotesk Light" pitchFamily="34" charset="0"/>
-                <a:ea typeface="Space Grotesk Light" pitchFamily="34" charset="-122"/>
-                <a:cs typeface="Space Grotesk Light" pitchFamily="34" charset="-120"/>
+                <a:latin typeface="Arial"/>
+                <a:ea typeface="Arial"/>
+                <a:cs typeface="Arial"/>
               </a:rPr>
               <a:t>, Rashid H</a:t>
             </a:r>
@@ -3622,9 +3620,9 @@
                 <a:solidFill>
                   <a:srgbClr val="FFFFFF"/>
                 </a:solidFill>
-                <a:latin typeface="Space Grotesk Light" pitchFamily="34" charset="0"/>
-                <a:ea typeface="Space Grotesk Light" pitchFamily="34" charset="-122"/>
-                <a:cs typeface="Space Grotesk Light" pitchFamily="34" charset="-120"/>
+                <a:latin typeface="Arial"/>
+                <a:ea typeface="Arial"/>
+                <a:cs typeface="Arial"/>
               </a:rPr>
               <a:t>a</a:t>
             </a:r>
@@ -3639,9 +3637,9 @@
                 <a:solidFill>
                   <a:srgbClr val="FFFFFF"/>
                 </a:solidFill>
-                <a:latin typeface="Space Grotesk Light" pitchFamily="34" charset="0"/>
-                <a:ea typeface="Space Grotesk Light" pitchFamily="34" charset="-122"/>
-                <a:cs typeface="Space Grotesk Light" pitchFamily="34" charset="-120"/>
+                <a:latin typeface="Arial"/>
+                <a:ea typeface="Arial"/>
+                <a:cs typeface="Arial"/>
               </a:rPr>
               <a:t>a</a:t>
             </a:r>
@@ -3650,9 +3648,9 @@
                 <a:solidFill>
                   <a:srgbClr val="FFFFFF"/>
                 </a:solidFill>
-                <a:latin typeface="Space Grotesk Light" pitchFamily="34" charset="0"/>
-                <a:ea typeface="Space Grotesk Light" pitchFamily="34" charset="-122"/>
-                <a:cs typeface="Space Grotesk Light" pitchFamily="34" charset="-120"/>
+                <a:latin typeface="Arial"/>
+                <a:ea typeface="Arial"/>
+                <a:cs typeface="Arial"/>
               </a:rPr>
               <a:t> Paras Hospital Srinagar, J&amp;K   </a:t>
             </a:r>
@@ -3661,9 +3659,9 @@
                 <a:solidFill>
                   <a:srgbClr val="FFFFFF"/>
                 </a:solidFill>
-                <a:latin typeface="Space Grotesk Light" pitchFamily="34" charset="0"/>
-                <a:ea typeface="Space Grotesk Light" pitchFamily="34" charset="-122"/>
-                <a:cs typeface="Space Grotesk Light" pitchFamily="34" charset="-120"/>
+                <a:latin typeface="Arial"/>
+                <a:ea typeface="Arial"/>
+                <a:cs typeface="Arial"/>
               </a:rPr>
               <a:t>b</a:t>
             </a:r>
@@ -3672,9 +3670,9 @@
                 <a:solidFill>
                   <a:srgbClr val="FFFFFF"/>
                 </a:solidFill>
-                <a:latin typeface="Space Grotesk Light" pitchFamily="34" charset="0"/>
-                <a:ea typeface="Space Grotesk Light" pitchFamily="34" charset="-122"/>
-                <a:cs typeface="Space Grotesk Light" pitchFamily="34" charset="-120"/>
+                <a:latin typeface="Arial"/>
+                <a:ea typeface="Arial"/>
+                <a:cs typeface="Arial"/>
               </a:rPr>
               <a:t> Max Hospital Bathinda, Punjab, India</a:t>
             </a:r>
@@ -3711,9 +3709,9 @@
                 <a:solidFill>
                   <a:srgbClr val="FFFFFF"/>
                 </a:solidFill>
-                <a:latin typeface="Space Grotesk Light" pitchFamily="34" charset="0"/>
-                <a:ea typeface="Space Grotesk Light" pitchFamily="34" charset="-122"/>
-                <a:cs typeface="Space Grotesk Light" pitchFamily="34" charset="-120"/>
+                <a:latin typeface="Arial"/>
+                <a:ea typeface="Arial"/>
+                <a:cs typeface="Arial"/>
               </a:rPr>
               <a:t>Am Heart J Plus: Cardiol Res Pract 2026;61:100678  |  doi:10.1016/j.ahjo.2025.100678</a:t>
             </a:r>
@@ -3929,9 +3927,9 @@
                 <a:solidFill>
                   <a:srgbClr val="0B3D66"/>
                 </a:solidFill>
-                <a:latin typeface="Space Grotesk" pitchFamily="34" charset="0"/>
-                <a:ea typeface="Space Grotesk" pitchFamily="34" charset="-122"/>
-                <a:cs typeface="Space Grotesk" pitchFamily="34" charset="-120"/>
+                <a:latin typeface="Arial"/>
+                <a:ea typeface="Arial"/>
+                <a:cs typeface="Arial"/>
               </a:rPr>
               <a:t>THANK YOU</a:t>
             </a:r>
@@ -3988,9 +3986,9 @@
                 <a:solidFill>
                   <a:srgbClr val="000000"/>
                 </a:solidFill>
-                <a:latin typeface="Space Grotesk Light" pitchFamily="34" charset="0"/>
-                <a:ea typeface="Space Grotesk Light" pitchFamily="34" charset="-122"/>
-                <a:cs typeface="Space Grotesk Light" pitchFamily="34" charset="-120"/>
+                <a:latin typeface="Arial"/>
+                <a:ea typeface="Arial"/>
+                <a:cs typeface="Arial"/>
               </a:rPr>
               <a:t>Questions and discussion</a:t>
             </a:r>
@@ -4005,9 +4003,9 @@
                 <a:solidFill>
                   <a:srgbClr val="0B3D66"/>
                 </a:solidFill>
-                <a:latin typeface="Space Grotesk Light" pitchFamily="34" charset="0"/>
-                <a:ea typeface="Space Grotesk Light" pitchFamily="34" charset="-122"/>
-                <a:cs typeface="Space Grotesk Light" pitchFamily="34" charset="-120"/>
+                <a:latin typeface="Arial"/>
+                <a:ea typeface="Arial"/>
+                <a:cs typeface="Arial"/>
               </a:rPr>
               <a:t>Dr. Mohd Maqbool Sohil, MD, DM, FSCAI</a:t>
             </a:r>
@@ -4022,9 +4020,9 @@
                 <a:solidFill>
                   <a:srgbClr val="000000"/>
                 </a:solidFill>
-                <a:latin typeface="Space Grotesk Light" pitchFamily="34" charset="0"/>
-                <a:ea typeface="Space Grotesk Light" pitchFamily="34" charset="-122"/>
-                <a:cs typeface="Space Grotesk Light" pitchFamily="34" charset="-120"/>
+                <a:latin typeface="Arial"/>
+                <a:ea typeface="Arial"/>
+                <a:cs typeface="Arial"/>
               </a:rPr>
               <a:t>Interventional Cardiologist  |  drmaqboolsohil.deed.page</a:t>
             </a:r>
@@ -4042,9 +4040,9 @@
                 <a:solidFill>
                   <a:srgbClr val="000000"/>
                 </a:solidFill>
-                <a:latin typeface="Space Grotesk Light" pitchFamily="34" charset="0"/>
-                <a:ea typeface="Space Grotesk Light" pitchFamily="34" charset="-122"/>
-                <a:cs typeface="Space Grotesk Light" pitchFamily="34" charset="-120"/>
+                <a:latin typeface="Arial"/>
+                <a:ea typeface="Arial"/>
+                <a:cs typeface="Arial"/>
               </a:rPr>
               <a:t>Sohil MM, Masood I, Goyal D, Rashid H. Single centre experience of rotablation-assisted left main percutaneous coronary intervention. Am Heart J Plus: Cardiol Res Pract 2026;61:100678.</a:t>
             </a:r>
@@ -4059,9 +4057,9 @@
                 <a:solidFill>
                   <a:srgbClr val="000000"/>
                 </a:solidFill>
-                <a:latin typeface="Space Grotesk Light" pitchFamily="34" charset="0"/>
-                <a:ea typeface="Space Grotesk Light" pitchFamily="34" charset="-122"/>
-                <a:cs typeface="Space Grotesk Light" pitchFamily="34" charset="-120"/>
+                <a:latin typeface="Arial"/>
+                <a:ea typeface="Arial"/>
+                <a:cs typeface="Arial"/>
               </a:rPr>
               <a:t>doi:10.1016/j.ahjo.2025.100678  |  Open access, CC BY-NC-ND 4.0</a:t>
             </a:r>
@@ -4245,9 +4243,9 @@
                 <a:solidFill>
                   <a:srgbClr val="0B3D66"/>
                 </a:solidFill>
-                <a:latin typeface="Space Grotesk Light" pitchFamily="34" charset="0"/>
-                <a:ea typeface="Space Grotesk Light" pitchFamily="34" charset="-122"/>
-                <a:cs typeface="Space Grotesk Light" pitchFamily="34" charset="-120"/>
+                <a:latin typeface="Arial"/>
+                <a:ea typeface="Arial"/>
+                <a:cs typeface="Arial"/>
               </a:rPr>
               <a:t>Sohil MM et al.  |  Am Heart J Plus 2026;61:100678</a:t>
             </a:r>
@@ -4284,9 +4282,9 @@
                 <a:solidFill>
                   <a:srgbClr val="0B3D66"/>
                 </a:solidFill>
-                <a:latin typeface="Space Grotesk" pitchFamily="34" charset="0"/>
-                <a:ea typeface="Space Grotesk" pitchFamily="34" charset="-122"/>
-                <a:cs typeface="Space Grotesk" pitchFamily="34" charset="-120"/>
+                <a:latin typeface="Arial"/>
+                <a:ea typeface="Arial"/>
+                <a:cs typeface="Arial"/>
               </a:rPr>
               <a:t>17</a:t>
             </a:r>
@@ -4355,9 +4353,9 @@
                 <a:solidFill>
                   <a:srgbClr val="0B3D66"/>
                 </a:solidFill>
-                <a:latin typeface="Space Grotesk" pitchFamily="34" charset="0"/>
-                <a:ea typeface="Space Grotesk" pitchFamily="34" charset="-122"/>
-                <a:cs typeface="Space Grotesk" pitchFamily="34" charset="-120"/>
+                <a:latin typeface="Arial"/>
+                <a:ea typeface="Arial"/>
+                <a:cs typeface="Arial"/>
               </a:rPr>
               <a:t>Rotablator RA technique</a:t>
             </a:r>
@@ -4417,9 +4415,9 @@
                 <a:solidFill>
                   <a:srgbClr val="0B3D66"/>
                 </a:solidFill>
-                <a:latin typeface="Space Grotesk" pitchFamily="34" charset="0"/>
-                <a:ea typeface="Space Grotesk" pitchFamily="34" charset="-122"/>
-                <a:cs typeface="Space Grotesk" pitchFamily="34" charset="-120"/>
+                <a:latin typeface="Arial"/>
+                <a:ea typeface="Arial"/>
+                <a:cs typeface="Arial"/>
               </a:rPr>
               <a:t>0.7</a:t>
             </a:r>
@@ -4456,9 +4454,9 @@
                 <a:solidFill>
                   <a:srgbClr val="000000"/>
                 </a:solidFill>
-                <a:latin typeface="Space Grotesk Light" pitchFamily="34" charset="0"/>
-                <a:ea typeface="Space Grotesk Light" pitchFamily="34" charset="-122"/>
-                <a:cs typeface="Space Grotesk Light" pitchFamily="34" charset="-120"/>
+                <a:latin typeface="Arial"/>
+                <a:ea typeface="Arial"/>
+                <a:cs typeface="Arial"/>
               </a:rPr>
               <a:t>target burr : artery ratio</a:t>
             </a:r>
@@ -4518,9 +4516,9 @@
                 <a:solidFill>
                   <a:srgbClr val="0B3D66"/>
                 </a:solidFill>
-                <a:latin typeface="Space Grotesk" pitchFamily="34" charset="0"/>
-                <a:ea typeface="Space Grotesk" pitchFamily="34" charset="-122"/>
-                <a:cs typeface="Space Grotesk" pitchFamily="34" charset="-120"/>
+                <a:latin typeface="Arial"/>
+                <a:ea typeface="Arial"/>
+                <a:cs typeface="Arial"/>
               </a:rPr>
               <a:t>1.25–2.0</a:t>
             </a:r>
@@ -4557,9 +4555,9 @@
                 <a:solidFill>
                   <a:srgbClr val="000000"/>
                 </a:solidFill>
-                <a:latin typeface="Space Grotesk Light" pitchFamily="34" charset="0"/>
-                <a:ea typeface="Space Grotesk Light" pitchFamily="34" charset="-122"/>
-                <a:cs typeface="Space Grotesk Light" pitchFamily="34" charset="-120"/>
+                <a:latin typeface="Arial"/>
+                <a:ea typeface="Arial"/>
+                <a:cs typeface="Arial"/>
               </a:rPr>
               <a:t>mm burrs; multiple if needed</a:t>
             </a:r>
@@ -4619,9 +4617,9 @@
                 <a:solidFill>
                   <a:srgbClr val="C8102E"/>
                 </a:solidFill>
-                <a:latin typeface="Space Grotesk" pitchFamily="34" charset="0"/>
-                <a:ea typeface="Space Grotesk" pitchFamily="34" charset="-122"/>
-                <a:cs typeface="Space Grotesk" pitchFamily="34" charset="-120"/>
+                <a:latin typeface="Arial"/>
+                <a:ea typeface="Arial"/>
+                <a:cs typeface="Arial"/>
               </a:rPr>
               <a:t>140–180k</a:t>
             </a:r>
@@ -4658,9 +4656,9 @@
                 <a:solidFill>
                   <a:srgbClr val="000000"/>
                 </a:solidFill>
-                <a:latin typeface="Space Grotesk Light" pitchFamily="34" charset="0"/>
-                <a:ea typeface="Space Grotesk Light" pitchFamily="34" charset="-122"/>
-                <a:cs typeface="Space Grotesk Light" pitchFamily="34" charset="-120"/>
+                <a:latin typeface="Arial"/>
+                <a:ea typeface="Arial"/>
+                <a:cs typeface="Arial"/>
               </a:rPr>
               <a:t>rpm; burr runs &lt;30 s</a:t>
             </a:r>
@@ -4844,9 +4842,9 @@
                 <a:solidFill>
                   <a:srgbClr val="0B3D66"/>
                 </a:solidFill>
-                <a:latin typeface="Space Grotesk Light" pitchFamily="34" charset="0"/>
-                <a:ea typeface="Space Grotesk Light" pitchFamily="34" charset="-122"/>
-                <a:cs typeface="Space Grotesk Light" pitchFamily="34" charset="-120"/>
+                <a:latin typeface="Arial"/>
+                <a:ea typeface="Arial"/>
+                <a:cs typeface="Arial"/>
               </a:rPr>
               <a:t>Sohil MM et al.  |  Am Heart J Plus 2026;61:100678</a:t>
             </a:r>
@@ -4883,9 +4881,9 @@
                 <a:solidFill>
                   <a:srgbClr val="0B3D66"/>
                 </a:solidFill>
-                <a:latin typeface="Space Grotesk" pitchFamily="34" charset="0"/>
-                <a:ea typeface="Space Grotesk" pitchFamily="34" charset="-122"/>
-                <a:cs typeface="Space Grotesk" pitchFamily="34" charset="-120"/>
+                <a:latin typeface="Arial"/>
+                <a:ea typeface="Arial"/>
+                <a:cs typeface="Arial"/>
               </a:rPr>
               <a:t>6</a:t>
             </a:r>
@@ -4954,9 +4952,9 @@
                 <a:solidFill>
                   <a:srgbClr val="0B3D66"/>
                 </a:solidFill>
-                <a:latin typeface="Space Grotesk" pitchFamily="34" charset="0"/>
-                <a:ea typeface="Space Grotesk" pitchFamily="34" charset="-122"/>
-                <a:cs typeface="Space Grotesk" pitchFamily="34" charset="-120"/>
+                <a:latin typeface="Arial"/>
+                <a:ea typeface="Arial"/>
+                <a:cs typeface="Arial"/>
               </a:rPr>
               <a:t>Procedural details</a:t>
             </a:r>
@@ -4996,7 +4994,7 @@
           <p:nvPr>
             <p:extLst>
               <p:ext uri="{D42A27DB-BD31-4B8C-83A1-F6EECF244321}">
-                <p14:modId xmlns:p14="http://schemas.microsoft.com/office/powerpoint/2010/main" val="1579011935"/>
+                <p14:modId xmlns:p14="http://schemas.microsoft.com/office/powerpoint/2010/main" val="930656917"/>
               </p:ext>
             </p:extLst>
           </p:nvPr>
@@ -5029,16 +5027,16 @@
                           <a:solidFill>
                             <a:srgbClr val="FFFFFF"/>
                           </a:solidFill>
-                          <a:latin typeface="Space Grotesk" pitchFamily="34" charset="0"/>
-                          <a:ea typeface="Space Grotesk" pitchFamily="34" charset="-122"/>
-                          <a:cs typeface="Space Grotesk" pitchFamily="34" charset="-120"/>
+                          <a:latin typeface="Arial"/>
+                          <a:ea typeface="Arial"/>
+                          <a:cs typeface="Arial"/>
                         </a:rPr>
                         <a:t>Technique</a:t>
                       </a:r>
                       <a:endParaRPr lang="en-US" sz="2200" dirty="0">
-                        <a:latin typeface="Space Grotesk" charset="0"/>
-                        <a:ea typeface="Space Grotesk" charset="0"/>
-                        <a:cs typeface="Space Grotesk" charset="0"/>
+                        <a:latin typeface="Arial"/>
+                        <a:ea typeface="Arial"/>
+                        <a:cs typeface="Arial"/>
                       </a:endParaRPr>
                     </a:p>
                   </a:txBody>
@@ -5097,16 +5095,16 @@
                           <a:solidFill>
                             <a:srgbClr val="FFFFFF"/>
                           </a:solidFill>
-                          <a:latin typeface="Space Grotesk" pitchFamily="34" charset="0"/>
-                          <a:ea typeface="Space Grotesk" pitchFamily="34" charset="-122"/>
-                          <a:cs typeface="Space Grotesk" pitchFamily="34" charset="-120"/>
+                          <a:latin typeface="Arial"/>
+                          <a:ea typeface="Arial"/>
+                          <a:cs typeface="Arial"/>
                         </a:rPr>
                         <a:t>n (%)</a:t>
                       </a:r>
                       <a:endParaRPr lang="en-US" sz="2200" dirty="0">
-                        <a:latin typeface="Space Grotesk" charset="0"/>
-                        <a:ea typeface="Space Grotesk" charset="0"/>
-                        <a:cs typeface="Space Grotesk" charset="0"/>
+                        <a:latin typeface="Arial"/>
+                        <a:ea typeface="Arial"/>
+                        <a:cs typeface="Arial"/>
                       </a:endParaRPr>
                     </a:p>
                   </a:txBody>
@@ -5165,16 +5163,16 @@
                           <a:solidFill>
                             <a:srgbClr val="FFFFFF"/>
                           </a:solidFill>
-                          <a:latin typeface="Space Grotesk" pitchFamily="34" charset="0"/>
-                          <a:ea typeface="Space Grotesk" pitchFamily="34" charset="-122"/>
-                          <a:cs typeface="Space Grotesk" pitchFamily="34" charset="-120"/>
+                          <a:latin typeface="Arial"/>
+                          <a:ea typeface="Arial"/>
+                          <a:cs typeface="Arial"/>
                         </a:rPr>
                         <a:t>Parameter</a:t>
                       </a:r>
                       <a:endParaRPr lang="en-US" sz="2200" dirty="0">
-                        <a:latin typeface="Space Grotesk" charset="0"/>
-                        <a:ea typeface="Space Grotesk" charset="0"/>
-                        <a:cs typeface="Space Grotesk" charset="0"/>
+                        <a:latin typeface="Arial"/>
+                        <a:ea typeface="Arial"/>
+                        <a:cs typeface="Arial"/>
                       </a:endParaRPr>
                     </a:p>
                   </a:txBody>
@@ -5233,16 +5231,16 @@
                           <a:solidFill>
                             <a:srgbClr val="FFFFFF"/>
                           </a:solidFill>
-                          <a:latin typeface="Space Grotesk" pitchFamily="34" charset="0"/>
-                          <a:ea typeface="Space Grotesk" pitchFamily="34" charset="-122"/>
-                          <a:cs typeface="Space Grotesk" pitchFamily="34" charset="-120"/>
+                          <a:latin typeface="Arial"/>
+                          <a:ea typeface="Arial"/>
+                          <a:cs typeface="Arial"/>
                         </a:rPr>
                         <a:t>Value</a:t>
                       </a:r>
                       <a:endParaRPr lang="en-US" sz="2200" dirty="0">
-                        <a:latin typeface="Space Grotesk" charset="0"/>
-                        <a:ea typeface="Space Grotesk" charset="0"/>
-                        <a:cs typeface="Space Grotesk" charset="0"/>
+                        <a:latin typeface="Arial"/>
+                        <a:ea typeface="Arial"/>
+                        <a:cs typeface="Arial"/>
                       </a:endParaRPr>
                     </a:p>
                   </a:txBody>
@@ -5303,16 +5301,16 @@
                           <a:solidFill>
                             <a:srgbClr val="000000"/>
                           </a:solidFill>
-                          <a:latin typeface="Space Grotesk Light" pitchFamily="34" charset="0"/>
-                          <a:ea typeface="Space Grotesk Light" pitchFamily="34" charset="-122"/>
-                          <a:cs typeface="Space Grotesk Light" pitchFamily="34" charset="-120"/>
+                          <a:latin typeface="Arial"/>
+                          <a:ea typeface="Arial"/>
+                          <a:cs typeface="Arial"/>
                         </a:rPr>
                         <a:t>Femoral access</a:t>
                       </a:r>
                       <a:endParaRPr lang="en-US" sz="2200" dirty="0">
-                        <a:latin typeface="Space Grotesk Light" charset="0"/>
-                        <a:ea typeface="Space Grotesk Light" charset="0"/>
-                        <a:cs typeface="Space Grotesk Light" charset="0"/>
+                        <a:latin typeface="Arial"/>
+                        <a:ea typeface="Arial"/>
+                        <a:cs typeface="Arial"/>
                       </a:endParaRPr>
                     </a:p>
                   </a:txBody>
@@ -5368,16 +5366,16 @@
                           <a:solidFill>
                             <a:srgbClr val="000000"/>
                           </a:solidFill>
-                          <a:latin typeface="Space Grotesk Light" pitchFamily="34" charset="0"/>
-                          <a:ea typeface="Space Grotesk Light" pitchFamily="34" charset="-122"/>
-                          <a:cs typeface="Space Grotesk Light" pitchFamily="34" charset="-120"/>
+                          <a:latin typeface="Arial"/>
+                          <a:ea typeface="Arial"/>
+                          <a:cs typeface="Arial"/>
                         </a:rPr>
                         <a:t>38 (84.4%)</a:t>
                       </a:r>
                       <a:endParaRPr lang="en-US" sz="2200" dirty="0">
-                        <a:latin typeface="Space Grotesk Light" charset="0"/>
-                        <a:ea typeface="Space Grotesk Light" charset="0"/>
-                        <a:cs typeface="Space Grotesk Light" charset="0"/>
+                        <a:latin typeface="Arial"/>
+                        <a:ea typeface="Arial"/>
+                        <a:cs typeface="Arial"/>
                       </a:endParaRPr>
                     </a:p>
                   </a:txBody>
@@ -5433,16 +5431,16 @@
                           <a:solidFill>
                             <a:srgbClr val="000000"/>
                           </a:solidFill>
-                          <a:latin typeface="Space Grotesk Light" pitchFamily="34" charset="0"/>
-                          <a:ea typeface="Space Grotesk Light" pitchFamily="34" charset="-122"/>
-                          <a:cs typeface="Space Grotesk Light" pitchFamily="34" charset="-120"/>
+                          <a:latin typeface="Arial"/>
+                          <a:ea typeface="Arial"/>
+                          <a:cs typeface="Arial"/>
                         </a:rPr>
                         <a:t>Max burr, mm</a:t>
                       </a:r>
                       <a:endParaRPr lang="en-US" sz="2200" dirty="0">
-                        <a:latin typeface="Space Grotesk Light" charset="0"/>
-                        <a:ea typeface="Space Grotesk Light" charset="0"/>
-                        <a:cs typeface="Space Grotesk Light" charset="0"/>
+                        <a:latin typeface="Arial"/>
+                        <a:ea typeface="Arial"/>
+                        <a:cs typeface="Arial"/>
                       </a:endParaRPr>
                     </a:p>
                   </a:txBody>
@@ -5498,16 +5496,16 @@
                           <a:solidFill>
                             <a:srgbClr val="000000"/>
                           </a:solidFill>
-                          <a:latin typeface="Space Grotesk Light" pitchFamily="34" charset="0"/>
-                          <a:ea typeface="Space Grotesk Light" pitchFamily="34" charset="-122"/>
-                          <a:cs typeface="Space Grotesk Light" pitchFamily="34" charset="-120"/>
+                          <a:latin typeface="Arial"/>
+                          <a:ea typeface="Arial"/>
+                          <a:cs typeface="Arial"/>
                         </a:rPr>
                         <a:t>1.50 ± 0.13</a:t>
                       </a:r>
                       <a:endParaRPr lang="en-US" sz="2200" dirty="0">
-                        <a:latin typeface="Space Grotesk Light" charset="0"/>
-                        <a:ea typeface="Space Grotesk Light" charset="0"/>
-                        <a:cs typeface="Space Grotesk Light" charset="0"/>
+                        <a:latin typeface="Arial"/>
+                        <a:ea typeface="Arial"/>
+                        <a:cs typeface="Arial"/>
                       </a:endParaRPr>
                     </a:p>
                   </a:txBody>
@@ -5565,16 +5563,16 @@
                           <a:solidFill>
                             <a:srgbClr val="000000"/>
                           </a:solidFill>
-                          <a:latin typeface="Space Grotesk Light" pitchFamily="34" charset="0"/>
-                          <a:ea typeface="Space Grotesk Light" pitchFamily="34" charset="-122"/>
-                          <a:cs typeface="Space Grotesk Light" pitchFamily="34" charset="-120"/>
+                          <a:latin typeface="Arial"/>
+                          <a:ea typeface="Arial"/>
+                          <a:cs typeface="Arial"/>
                         </a:rPr>
                         <a:t>7F guide</a:t>
                       </a:r>
                       <a:endParaRPr lang="en-US" sz="2200" dirty="0">
-                        <a:latin typeface="Space Grotesk Light" charset="0"/>
-                        <a:ea typeface="Space Grotesk Light" charset="0"/>
-                        <a:cs typeface="Space Grotesk Light" charset="0"/>
+                        <a:latin typeface="Arial"/>
+                        <a:ea typeface="Arial"/>
+                        <a:cs typeface="Arial"/>
                       </a:endParaRPr>
                     </a:p>
                   </a:txBody>
@@ -5633,16 +5631,16 @@
                           <a:solidFill>
                             <a:srgbClr val="000000"/>
                           </a:solidFill>
-                          <a:latin typeface="Space Grotesk Light" pitchFamily="34" charset="0"/>
-                          <a:ea typeface="Space Grotesk Light" pitchFamily="34" charset="-122"/>
-                          <a:cs typeface="Space Grotesk Light" pitchFamily="34" charset="-120"/>
+                          <a:latin typeface="Arial"/>
+                          <a:ea typeface="Arial"/>
+                          <a:cs typeface="Arial"/>
                         </a:rPr>
                         <a:t>45 (100%)</a:t>
                       </a:r>
                       <a:endParaRPr lang="en-US" sz="2200" dirty="0">
-                        <a:latin typeface="Space Grotesk Light" charset="0"/>
-                        <a:ea typeface="Space Grotesk Light" charset="0"/>
-                        <a:cs typeface="Space Grotesk Light" charset="0"/>
+                        <a:latin typeface="Arial"/>
+                        <a:ea typeface="Arial"/>
+                        <a:cs typeface="Arial"/>
                       </a:endParaRPr>
                     </a:p>
                   </a:txBody>
@@ -5701,16 +5699,16 @@
                           <a:solidFill>
                             <a:srgbClr val="000000"/>
                           </a:solidFill>
-                          <a:latin typeface="Space Grotesk Light" pitchFamily="34" charset="0"/>
-                          <a:ea typeface="Space Grotesk Light" pitchFamily="34" charset="-122"/>
-                          <a:cs typeface="Space Grotesk Light" pitchFamily="34" charset="-120"/>
+                          <a:latin typeface="Arial"/>
+                          <a:ea typeface="Arial"/>
+                          <a:cs typeface="Arial"/>
                         </a:rPr>
                         <a:t>Burrs/patient</a:t>
                       </a:r>
                       <a:endParaRPr lang="en-US" sz="2200" dirty="0">
-                        <a:latin typeface="Space Grotesk Light" charset="0"/>
-                        <a:ea typeface="Space Grotesk Light" charset="0"/>
-                        <a:cs typeface="Space Grotesk Light" charset="0"/>
+                        <a:latin typeface="Arial"/>
+                        <a:ea typeface="Arial"/>
+                        <a:cs typeface="Arial"/>
                       </a:endParaRPr>
                     </a:p>
                   </a:txBody>
@@ -5769,16 +5767,16 @@
                           <a:solidFill>
                             <a:srgbClr val="000000"/>
                           </a:solidFill>
-                          <a:latin typeface="Space Grotesk Light" pitchFamily="34" charset="0"/>
-                          <a:ea typeface="Space Grotesk Light" pitchFamily="34" charset="-122"/>
-                          <a:cs typeface="Space Grotesk Light" pitchFamily="34" charset="-120"/>
+                          <a:latin typeface="Arial"/>
+                          <a:ea typeface="Arial"/>
+                          <a:cs typeface="Arial"/>
                         </a:rPr>
                         <a:t>1.11 ± 0.31</a:t>
                       </a:r>
                       <a:endParaRPr lang="en-US" sz="2200" dirty="0">
-                        <a:latin typeface="Space Grotesk Light" charset="0"/>
-                        <a:ea typeface="Space Grotesk Light" charset="0"/>
-                        <a:cs typeface="Space Grotesk Light" charset="0"/>
+                        <a:latin typeface="Arial"/>
+                        <a:ea typeface="Arial"/>
+                        <a:cs typeface="Arial"/>
                       </a:endParaRPr>
                     </a:p>
                   </a:txBody>
@@ -5839,16 +5837,16 @@
                           <a:solidFill>
                             <a:srgbClr val="000000"/>
                           </a:solidFill>
-                          <a:latin typeface="Space Grotesk Light" pitchFamily="34" charset="0"/>
-                          <a:ea typeface="Space Grotesk Light" pitchFamily="34" charset="-122"/>
-                          <a:cs typeface="Space Grotesk Light" pitchFamily="34" charset="-120"/>
+                          <a:latin typeface="Arial"/>
+                          <a:ea typeface="Arial"/>
+                          <a:cs typeface="Arial"/>
                         </a:rPr>
                         <a:t>Two-stent</a:t>
                       </a:r>
                       <a:endParaRPr lang="en-US" sz="2200" dirty="0">
-                        <a:latin typeface="Space Grotesk Light" charset="0"/>
-                        <a:ea typeface="Space Grotesk Light" charset="0"/>
-                        <a:cs typeface="Space Grotesk Light" charset="0"/>
+                        <a:latin typeface="Arial"/>
+                        <a:ea typeface="Arial"/>
+                        <a:cs typeface="Arial"/>
                       </a:endParaRPr>
                     </a:p>
                   </a:txBody>
@@ -5904,16 +5902,16 @@
                           <a:solidFill>
                             <a:srgbClr val="000000"/>
                           </a:solidFill>
-                          <a:latin typeface="Space Grotesk Light" pitchFamily="34" charset="0"/>
-                          <a:ea typeface="Space Grotesk Light" pitchFamily="34" charset="-122"/>
-                          <a:cs typeface="Space Grotesk Light" pitchFamily="34" charset="-120"/>
+                          <a:latin typeface="Arial"/>
+                          <a:ea typeface="Arial"/>
+                          <a:cs typeface="Arial"/>
                         </a:rPr>
                         <a:t>34 (75.6%)</a:t>
                       </a:r>
                       <a:endParaRPr lang="en-US" sz="2200" dirty="0">
-                        <a:latin typeface="Space Grotesk Light" charset="0"/>
-                        <a:ea typeface="Space Grotesk Light" charset="0"/>
-                        <a:cs typeface="Space Grotesk Light" charset="0"/>
+                        <a:latin typeface="Arial"/>
+                        <a:ea typeface="Arial"/>
+                        <a:cs typeface="Arial"/>
                       </a:endParaRPr>
                     </a:p>
                   </a:txBody>
@@ -5969,16 +5967,16 @@
                           <a:solidFill>
                             <a:srgbClr val="000000"/>
                           </a:solidFill>
-                          <a:latin typeface="Space Grotesk Light" pitchFamily="34" charset="0"/>
-                          <a:ea typeface="Space Grotesk Light" pitchFamily="34" charset="-122"/>
-                          <a:cs typeface="Space Grotesk Light" pitchFamily="34" charset="-120"/>
+                          <a:latin typeface="Arial"/>
+                          <a:ea typeface="Arial"/>
+                          <a:cs typeface="Arial"/>
                         </a:rPr>
                         <a:t>Stent len., mm</a:t>
                       </a:r>
                       <a:endParaRPr lang="en-US" sz="2200" dirty="0">
-                        <a:latin typeface="Space Grotesk Light" charset="0"/>
-                        <a:ea typeface="Space Grotesk Light" charset="0"/>
-                        <a:cs typeface="Space Grotesk Light" charset="0"/>
+                        <a:latin typeface="Arial"/>
+                        <a:ea typeface="Arial"/>
+                        <a:cs typeface="Arial"/>
                       </a:endParaRPr>
                     </a:p>
                   </a:txBody>
@@ -6034,16 +6032,16 @@
                           <a:solidFill>
                             <a:srgbClr val="000000"/>
                           </a:solidFill>
-                          <a:latin typeface="Space Grotesk Light" pitchFamily="34" charset="0"/>
-                          <a:ea typeface="Space Grotesk Light" pitchFamily="34" charset="-122"/>
-                          <a:cs typeface="Space Grotesk Light" pitchFamily="34" charset="-120"/>
+                          <a:latin typeface="Arial"/>
+                          <a:ea typeface="Arial"/>
+                          <a:cs typeface="Arial"/>
                         </a:rPr>
                         <a:t>22.98 ± 6.54</a:t>
                       </a:r>
                       <a:endParaRPr lang="en-US" sz="2200" dirty="0">
-                        <a:latin typeface="Space Grotesk Light" charset="0"/>
-                        <a:ea typeface="Space Grotesk Light" charset="0"/>
-                        <a:cs typeface="Space Grotesk Light" charset="0"/>
+                        <a:latin typeface="Arial"/>
+                        <a:ea typeface="Arial"/>
+                        <a:cs typeface="Arial"/>
                       </a:endParaRPr>
                     </a:p>
                   </a:txBody>
@@ -6101,16 +6099,16 @@
                           <a:solidFill>
                             <a:srgbClr val="000000"/>
                           </a:solidFill>
-                          <a:latin typeface="Space Grotesk Light" pitchFamily="34" charset="0"/>
-                          <a:ea typeface="Space Grotesk Light" pitchFamily="34" charset="-122"/>
-                          <a:cs typeface="Space Grotesk Light" pitchFamily="34" charset="-120"/>
+                          <a:latin typeface="Arial"/>
+                          <a:ea typeface="Arial"/>
+                          <a:cs typeface="Arial"/>
                         </a:rPr>
                         <a:t>DK crush</a:t>
                       </a:r>
                       <a:endParaRPr lang="en-US" sz="2200" dirty="0">
-                        <a:latin typeface="Space Grotesk Light" charset="0"/>
-                        <a:ea typeface="Space Grotesk Light" charset="0"/>
-                        <a:cs typeface="Space Grotesk Light" charset="0"/>
+                        <a:latin typeface="Arial"/>
+                        <a:ea typeface="Arial"/>
+                        <a:cs typeface="Arial"/>
                       </a:endParaRPr>
                     </a:p>
                   </a:txBody>
@@ -6169,16 +6167,16 @@
                           <a:solidFill>
                             <a:srgbClr val="000000"/>
                           </a:solidFill>
-                          <a:latin typeface="Space Grotesk Light" pitchFamily="34" charset="0"/>
-                          <a:ea typeface="Space Grotesk Light" pitchFamily="34" charset="-122"/>
-                          <a:cs typeface="Space Grotesk Light" pitchFamily="34" charset="-120"/>
+                          <a:latin typeface="Arial"/>
+                          <a:ea typeface="Arial"/>
+                          <a:cs typeface="Arial"/>
                         </a:rPr>
                         <a:t>32 (71.1%)</a:t>
                       </a:r>
                       <a:endParaRPr lang="en-US" sz="2200" dirty="0">
-                        <a:latin typeface="Space Grotesk Light" charset="0"/>
-                        <a:ea typeface="Space Grotesk Light" charset="0"/>
-                        <a:cs typeface="Space Grotesk Light" charset="0"/>
+                        <a:latin typeface="Arial"/>
+                        <a:ea typeface="Arial"/>
+                        <a:cs typeface="Arial"/>
                       </a:endParaRPr>
                     </a:p>
                   </a:txBody>
@@ -6237,16 +6235,16 @@
                           <a:solidFill>
                             <a:srgbClr val="000000"/>
                           </a:solidFill>
-                          <a:latin typeface="Space Grotesk Light" pitchFamily="34" charset="0"/>
-                          <a:ea typeface="Space Grotesk Light" pitchFamily="34" charset="-122"/>
-                          <a:cs typeface="Space Grotesk Light" pitchFamily="34" charset="-120"/>
+                          <a:latin typeface="Arial"/>
+                          <a:ea typeface="Arial"/>
+                          <a:cs typeface="Arial"/>
                         </a:rPr>
                         <a:t>Stent dia., mm</a:t>
                       </a:r>
                       <a:endParaRPr lang="en-US" sz="2200" dirty="0">
-                        <a:latin typeface="Space Grotesk Light" charset="0"/>
-                        <a:ea typeface="Space Grotesk Light" charset="0"/>
-                        <a:cs typeface="Space Grotesk Light" charset="0"/>
+                        <a:latin typeface="Arial"/>
+                        <a:ea typeface="Arial"/>
+                        <a:cs typeface="Arial"/>
                       </a:endParaRPr>
                     </a:p>
                   </a:txBody>
@@ -6305,16 +6303,16 @@
                           <a:solidFill>
                             <a:srgbClr val="000000"/>
                           </a:solidFill>
-                          <a:latin typeface="Space Grotesk Light" pitchFamily="34" charset="0"/>
-                          <a:ea typeface="Space Grotesk Light" pitchFamily="34" charset="-122"/>
-                          <a:cs typeface="Space Grotesk Light" pitchFamily="34" charset="-120"/>
+                          <a:latin typeface="Arial"/>
+                          <a:ea typeface="Arial"/>
+                          <a:cs typeface="Arial"/>
                         </a:rPr>
                         <a:t>3.49 ± 0.40</a:t>
                       </a:r>
                       <a:endParaRPr lang="en-US" sz="2200" dirty="0">
-                        <a:latin typeface="Space Grotesk Light" charset="0"/>
-                        <a:ea typeface="Space Grotesk Light" charset="0"/>
-                        <a:cs typeface="Space Grotesk Light" charset="0"/>
+                        <a:latin typeface="Arial"/>
+                        <a:ea typeface="Arial"/>
+                        <a:cs typeface="Arial"/>
                       </a:endParaRPr>
                     </a:p>
                   </a:txBody>
@@ -6375,16 +6373,16 @@
                           <a:solidFill>
                             <a:srgbClr val="000000"/>
                           </a:solidFill>
-                          <a:latin typeface="Space Grotesk Light" pitchFamily="34" charset="0"/>
-                          <a:ea typeface="Space Grotesk Light" pitchFamily="34" charset="-122"/>
-                          <a:cs typeface="Space Grotesk Light" pitchFamily="34" charset="-120"/>
+                          <a:latin typeface="Arial"/>
+                          <a:ea typeface="Arial"/>
+                          <a:cs typeface="Arial"/>
                         </a:rPr>
                         <a:t>IVUS</a:t>
                       </a:r>
                       <a:endParaRPr lang="en-US" sz="2200" dirty="0">
-                        <a:latin typeface="Space Grotesk Light" charset="0"/>
-                        <a:ea typeface="Space Grotesk Light" charset="0"/>
-                        <a:cs typeface="Space Grotesk Light" charset="0"/>
+                        <a:latin typeface="Arial"/>
+                        <a:ea typeface="Arial"/>
+                        <a:cs typeface="Arial"/>
                       </a:endParaRPr>
                     </a:p>
                   </a:txBody>
@@ -6440,16 +6438,16 @@
                           <a:solidFill>
                             <a:srgbClr val="000000"/>
                           </a:solidFill>
-                          <a:latin typeface="Space Grotesk Light" pitchFamily="34" charset="0"/>
-                          <a:ea typeface="Space Grotesk Light" pitchFamily="34" charset="-122"/>
-                          <a:cs typeface="Space Grotesk Light" pitchFamily="34" charset="-120"/>
+                          <a:latin typeface="Arial"/>
+                          <a:ea typeface="Arial"/>
+                          <a:cs typeface="Arial"/>
                         </a:rPr>
                         <a:t>34 (75.6%)</a:t>
                       </a:r>
                       <a:endParaRPr lang="en-US" sz="2200" dirty="0">
-                        <a:latin typeface="Space Grotesk Light" charset="0"/>
-                        <a:ea typeface="Space Grotesk Light" charset="0"/>
-                        <a:cs typeface="Space Grotesk Light" charset="0"/>
+                        <a:latin typeface="Arial"/>
+                        <a:ea typeface="Arial"/>
+                        <a:cs typeface="Arial"/>
                       </a:endParaRPr>
                     </a:p>
                   </a:txBody>
@@ -6505,16 +6503,16 @@
                           <a:solidFill>
                             <a:srgbClr val="000000"/>
                           </a:solidFill>
-                          <a:latin typeface="Space Grotesk Light" pitchFamily="34" charset="0"/>
-                          <a:ea typeface="Space Grotesk Light" pitchFamily="34" charset="-122"/>
-                          <a:cs typeface="Space Grotesk Light" pitchFamily="34" charset="-120"/>
+                          <a:latin typeface="Arial"/>
+                          <a:ea typeface="Arial"/>
+                          <a:cs typeface="Arial"/>
                         </a:rPr>
                         <a:t>IABP, n (%)</a:t>
                       </a:r>
                       <a:endParaRPr lang="en-US" sz="2200" dirty="0">
-                        <a:latin typeface="Space Grotesk Light" charset="0"/>
-                        <a:ea typeface="Space Grotesk Light" charset="0"/>
-                        <a:cs typeface="Space Grotesk Light" charset="0"/>
+                        <a:latin typeface="Arial"/>
+                        <a:ea typeface="Arial"/>
+                        <a:cs typeface="Arial"/>
                       </a:endParaRPr>
                     </a:p>
                   </a:txBody>
@@ -6570,16 +6568,16 @@
                           <a:solidFill>
                             <a:srgbClr val="000000"/>
                           </a:solidFill>
-                          <a:latin typeface="Space Grotesk Light" pitchFamily="34" charset="0"/>
-                          <a:ea typeface="Space Grotesk Light" pitchFamily="34" charset="-122"/>
-                          <a:cs typeface="Space Grotesk Light" pitchFamily="34" charset="-120"/>
+                          <a:latin typeface="Arial"/>
+                          <a:ea typeface="Arial"/>
+                          <a:cs typeface="Arial"/>
                         </a:rPr>
                         <a:t>7 (15.6%)</a:t>
                       </a:r>
                       <a:endParaRPr lang="en-US" sz="2200" dirty="0">
-                        <a:latin typeface="Space Grotesk Light" charset="0"/>
-                        <a:ea typeface="Space Grotesk Light" charset="0"/>
-                        <a:cs typeface="Space Grotesk Light" charset="0"/>
+                        <a:latin typeface="Arial"/>
+                        <a:ea typeface="Arial"/>
+                        <a:cs typeface="Arial"/>
                       </a:endParaRPr>
                     </a:p>
                   </a:txBody>
@@ -6803,9 +6801,9 @@
                 <a:solidFill>
                   <a:srgbClr val="0B3D66"/>
                 </a:solidFill>
-                <a:latin typeface="Space Grotesk Light" pitchFamily="34" charset="0"/>
-                <a:ea typeface="Space Grotesk Light" pitchFamily="34" charset="-122"/>
-                <a:cs typeface="Space Grotesk Light" pitchFamily="34" charset="-120"/>
+                <a:latin typeface="Arial"/>
+                <a:ea typeface="Arial"/>
+                <a:cs typeface="Arial"/>
               </a:rPr>
               <a:t>Sohil MM et al.  |  Am Heart J Plus 2026;61:100678</a:t>
             </a:r>
@@ -6842,9 +6840,9 @@
                 <a:solidFill>
                   <a:srgbClr val="0B3D66"/>
                 </a:solidFill>
-                <a:latin typeface="Space Grotesk" pitchFamily="34" charset="0"/>
-                <a:ea typeface="Space Grotesk" pitchFamily="34" charset="-122"/>
-                <a:cs typeface="Space Grotesk" pitchFamily="34" charset="-120"/>
+                <a:latin typeface="Arial"/>
+                <a:ea typeface="Arial"/>
+                <a:cs typeface="Arial"/>
               </a:rPr>
               <a:t>10</a:t>
             </a:r>
@@ -6913,9 +6911,9 @@
                 <a:solidFill>
                   <a:srgbClr val="0B3D66"/>
                 </a:solidFill>
-                <a:latin typeface="Space Grotesk" pitchFamily="34" charset="0"/>
-                <a:ea typeface="Space Grotesk" pitchFamily="34" charset="-122"/>
-                <a:cs typeface="Space Grotesk" pitchFamily="34" charset="-120"/>
+                <a:latin typeface="Arial"/>
+                <a:ea typeface="Arial"/>
+                <a:cs typeface="Arial"/>
               </a:rPr>
               <a:t>In-hospital outcomes</a:t>
             </a:r>
@@ -6975,9 +6973,9 @@
                 <a:solidFill>
                   <a:srgbClr val="0B3D66"/>
                 </a:solidFill>
-                <a:latin typeface="Space Grotesk" pitchFamily="34" charset="0"/>
-                <a:ea typeface="Space Grotesk" pitchFamily="34" charset="-122"/>
-                <a:cs typeface="Space Grotesk" pitchFamily="34" charset="-120"/>
+                <a:latin typeface="Arial"/>
+                <a:ea typeface="Arial"/>
+                <a:cs typeface="Arial"/>
               </a:rPr>
               <a:t>100%</a:t>
             </a:r>
@@ -7014,9 +7012,9 @@
                 <a:solidFill>
                   <a:srgbClr val="000000"/>
                 </a:solidFill>
-                <a:latin typeface="Space Grotesk Light" pitchFamily="34" charset="0"/>
-                <a:ea typeface="Space Grotesk Light" pitchFamily="34" charset="-122"/>
-                <a:cs typeface="Space Grotesk Light" pitchFamily="34" charset="-120"/>
+                <a:latin typeface="Arial"/>
+                <a:ea typeface="Arial"/>
+                <a:cs typeface="Arial"/>
               </a:rPr>
               <a:t>angiographic success (45/45)</a:t>
             </a:r>
@@ -7076,9 +7074,9 @@
                 <a:solidFill>
                   <a:srgbClr val="0B3D66"/>
                 </a:solidFill>
-                <a:latin typeface="Space Grotesk" pitchFamily="34" charset="0"/>
-                <a:ea typeface="Space Grotesk" pitchFamily="34" charset="-122"/>
-                <a:cs typeface="Space Grotesk" pitchFamily="34" charset="-120"/>
+                <a:latin typeface="Arial"/>
+                <a:ea typeface="Arial"/>
+                <a:cs typeface="Arial"/>
               </a:rPr>
               <a:t>97.8%</a:t>
             </a:r>
@@ -7115,9 +7113,9 @@
                 <a:solidFill>
                   <a:srgbClr val="000000"/>
                 </a:solidFill>
-                <a:latin typeface="Space Grotesk Light" pitchFamily="34" charset="0"/>
-                <a:ea typeface="Space Grotesk Light" pitchFamily="34" charset="-122"/>
-                <a:cs typeface="Space Grotesk Light" pitchFamily="34" charset="-120"/>
+                <a:latin typeface="Arial"/>
+                <a:ea typeface="Arial"/>
+                <a:cs typeface="Arial"/>
               </a:rPr>
               <a:t>procedural success (44/45)</a:t>
             </a:r>
@@ -7177,9 +7175,9 @@
                 <a:solidFill>
                   <a:srgbClr val="C8102E"/>
                 </a:solidFill>
-                <a:latin typeface="Space Grotesk" pitchFamily="34" charset="0"/>
-                <a:ea typeface="Space Grotesk" pitchFamily="34" charset="-122"/>
-                <a:cs typeface="Space Grotesk" pitchFamily="34" charset="-120"/>
+                <a:latin typeface="Arial"/>
+                <a:ea typeface="Arial"/>
+                <a:cs typeface="Arial"/>
               </a:rPr>
               <a:t>2.2%</a:t>
             </a:r>
@@ -7216,9 +7214,9 @@
                 <a:solidFill>
                   <a:srgbClr val="000000"/>
                 </a:solidFill>
-                <a:latin typeface="Space Grotesk Light" pitchFamily="34" charset="0"/>
-                <a:ea typeface="Space Grotesk Light" pitchFamily="34" charset="-122"/>
-                <a:cs typeface="Space Grotesk Light" pitchFamily="34" charset="-120"/>
+                <a:latin typeface="Arial"/>
+                <a:ea typeface="Arial"/>
+                <a:cs typeface="Arial"/>
               </a:rPr>
               <a:t>in-hospital death (1/45)</a:t>
             </a:r>
@@ -7402,9 +7400,9 @@
                 <a:solidFill>
                   <a:srgbClr val="0B3D66"/>
                 </a:solidFill>
-                <a:latin typeface="Space Grotesk Light" pitchFamily="34" charset="0"/>
-                <a:ea typeface="Space Grotesk Light" pitchFamily="34" charset="-122"/>
-                <a:cs typeface="Space Grotesk Light" pitchFamily="34" charset="-120"/>
+                <a:latin typeface="Arial"/>
+                <a:ea typeface="Arial"/>
+                <a:cs typeface="Arial"/>
               </a:rPr>
               <a:t>Sohil MM et al.  |  Am Heart J Plus 2026;61:100678</a:t>
             </a:r>
@@ -7441,9 +7439,9 @@
                 <a:solidFill>
                   <a:srgbClr val="0B3D66"/>
                 </a:solidFill>
-                <a:latin typeface="Space Grotesk" pitchFamily="34" charset="0"/>
-                <a:ea typeface="Space Grotesk" pitchFamily="34" charset="-122"/>
-                <a:cs typeface="Space Grotesk" pitchFamily="34" charset="-120"/>
+                <a:latin typeface="Arial"/>
+                <a:ea typeface="Arial"/>
+                <a:cs typeface="Arial"/>
               </a:rPr>
               <a:t>11</a:t>
             </a:r>
@@ -7512,7 +7510,7 @@
           <p:nvPr/>
         </p:nvPicPr>
         <p:blipFill>
-          <a:blip r:embed="rIdFig2"/>
+          <a:blip r:embed="rId3"/>
           <a:stretch>
             <a:fillRect/>
           </a:stretch>
@@ -7561,9 +7559,9 @@
                 <a:solidFill>
                   <a:srgbClr val="0B3D66"/>
                 </a:solidFill>
-                <a:latin typeface="Space Grotesk" pitchFamily="34" charset="0"/>
-                <a:ea typeface="Space Grotesk" pitchFamily="34" charset="-122"/>
-                <a:cs typeface="Space Grotesk" pitchFamily="34" charset="-120"/>
+                <a:latin typeface="Arial"/>
+                <a:ea typeface="Arial"/>
+                <a:cs typeface="Arial"/>
               </a:rPr>
               <a:t>Two-year outcomes</a:t>
             </a:r>
@@ -7623,9 +7621,9 @@
                 <a:solidFill>
                   <a:srgbClr val="000000"/>
                 </a:solidFill>
-                <a:latin typeface="Space Grotesk Light" pitchFamily="34" charset="0"/>
-                <a:ea typeface="Space Grotesk Light" pitchFamily="34" charset="-122"/>
-                <a:cs typeface="Space Grotesk Light" pitchFamily="34" charset="-120"/>
+                <a:latin typeface="Arial"/>
+                <a:ea typeface="Arial"/>
+                <a:cs typeface="Arial"/>
               </a:rPr>
               <a:t>Overall survival </a:t>
             </a:r>
@@ -7634,9 +7632,9 @@
                 <a:solidFill>
                   <a:srgbClr val="000000"/>
                 </a:solidFill>
-                <a:latin typeface="Space Grotesk Light" pitchFamily="34" charset="0"/>
-                <a:ea typeface="Space Grotesk Light" pitchFamily="34" charset="-122"/>
-                <a:cs typeface="Space Grotesk Light" pitchFamily="34" charset="-120"/>
+                <a:latin typeface="Arial"/>
+                <a:ea typeface="Arial"/>
+                <a:cs typeface="Arial"/>
               </a:rPr>
               <a:t>97.78%</a:t>
             </a:r>
@@ -7651,9 +7649,9 @@
                 <a:solidFill>
                   <a:srgbClr val="000000"/>
                 </a:solidFill>
-                <a:latin typeface="Space Grotesk Light" pitchFamily="34" charset="0"/>
-                <a:ea typeface="Space Grotesk Light" pitchFamily="34" charset="-122"/>
-                <a:cs typeface="Space Grotesk Light" pitchFamily="34" charset="-120"/>
+                <a:latin typeface="Arial"/>
+                <a:ea typeface="Arial"/>
+                <a:cs typeface="Arial"/>
               </a:rPr>
               <a:t>(Fig. 2, Kaplan-Meier)</a:t>
             </a:r>
@@ -7671,9 +7669,9 @@
                 <a:solidFill>
                   <a:srgbClr val="000000"/>
                 </a:solidFill>
-                <a:latin typeface="Space Grotesk Light" pitchFamily="34" charset="0"/>
-                <a:ea typeface="Space Grotesk Light" pitchFamily="34" charset="-122"/>
-                <a:cs typeface="Space Grotesk Light" pitchFamily="34" charset="-120"/>
+                <a:latin typeface="Arial"/>
+                <a:ea typeface="Arial"/>
+                <a:cs typeface="Arial"/>
               </a:rPr>
               <a:t>MACE-free </a:t>
             </a:r>
@@ -7682,9 +7680,9 @@
                 <a:solidFill>
                   <a:srgbClr val="000000"/>
                 </a:solidFill>
-                <a:latin typeface="Space Grotesk Light" pitchFamily="34" charset="0"/>
-                <a:ea typeface="Space Grotesk Light" pitchFamily="34" charset="-122"/>
-                <a:cs typeface="Space Grotesk Light" pitchFamily="34" charset="-120"/>
+                <a:latin typeface="Arial"/>
+                <a:ea typeface="Arial"/>
+                <a:cs typeface="Arial"/>
               </a:rPr>
               <a:t>93.3%</a:t>
             </a:r>
@@ -7702,9 +7700,9 @@
                 <a:solidFill>
                   <a:srgbClr val="000000"/>
                 </a:solidFill>
-                <a:latin typeface="Space Grotesk Light" pitchFamily="34" charset="0"/>
-                <a:ea typeface="Space Grotesk Light" pitchFamily="34" charset="-122"/>
-                <a:cs typeface="Space Grotesk Light" pitchFamily="34" charset="-120"/>
+                <a:latin typeface="Arial"/>
+                <a:ea typeface="Arial"/>
+                <a:cs typeface="Arial"/>
               </a:rPr>
               <a:t>1 death, 1 TLR, 1 TVMI</a:t>
             </a:r>
@@ -7722,9 +7720,9 @@
                 <a:solidFill>
                   <a:srgbClr val="000000"/>
                 </a:solidFill>
-                <a:latin typeface="Space Grotesk Light" pitchFamily="34" charset="0"/>
-                <a:ea typeface="Space Grotesk Light" pitchFamily="34" charset="-122"/>
-                <a:cs typeface="Space Grotesk Light" pitchFamily="34" charset="-120"/>
+                <a:latin typeface="Arial"/>
+                <a:ea typeface="Arial"/>
+                <a:cs typeface="Arial"/>
               </a:rPr>
               <a:t>No bleeding or stroke</a:t>
             </a:r>
@@ -7908,9 +7906,9 @@
                 <a:solidFill>
                   <a:srgbClr val="0B3D66"/>
                 </a:solidFill>
-                <a:latin typeface="Space Grotesk Light" pitchFamily="34" charset="0"/>
-                <a:ea typeface="Space Grotesk Light" pitchFamily="34" charset="-122"/>
-                <a:cs typeface="Space Grotesk Light" pitchFamily="34" charset="-120"/>
+                <a:latin typeface="Arial"/>
+                <a:ea typeface="Arial"/>
+                <a:cs typeface="Arial"/>
               </a:rPr>
               <a:t>Sohil MM et al.  |  Am Heart J Plus 2026;61:100678</a:t>
             </a:r>
@@ -7947,9 +7945,9 @@
                 <a:solidFill>
                   <a:srgbClr val="0B3D66"/>
                 </a:solidFill>
-                <a:latin typeface="Space Grotesk" pitchFamily="34" charset="0"/>
-                <a:ea typeface="Space Grotesk" pitchFamily="34" charset="-122"/>
-                <a:cs typeface="Space Grotesk" pitchFamily="34" charset="-120"/>
+                <a:latin typeface="Arial"/>
+                <a:ea typeface="Arial"/>
+                <a:cs typeface="Arial"/>
               </a:rPr>
               <a:t>12</a:t>
             </a:r>
@@ -8018,9 +8016,9 @@
                 <a:solidFill>
                   <a:srgbClr val="0B3D66"/>
                 </a:solidFill>
-                <a:latin typeface="Space Grotesk" pitchFamily="34" charset="0"/>
-                <a:ea typeface="Space Grotesk" pitchFamily="34" charset="-122"/>
-                <a:cs typeface="Space Grotesk" pitchFamily="34" charset="-120"/>
+                <a:latin typeface="Arial"/>
+                <a:ea typeface="Arial"/>
+                <a:cs typeface="Arial"/>
               </a:rPr>
               <a:t>Correlation analysis</a:t>
             </a:r>
@@ -8060,7 +8058,7 @@
           <p:nvPr>
             <p:extLst>
               <p:ext uri="{D42A27DB-BD31-4B8C-83A1-F6EECF244321}">
-                <p14:modId xmlns:p14="http://schemas.microsoft.com/office/powerpoint/2010/main" val="1579011935"/>
+                <p14:modId xmlns:p14="http://schemas.microsoft.com/office/powerpoint/2010/main" val="1425144359"/>
               </p:ext>
             </p:extLst>
           </p:nvPr>
@@ -8093,16 +8091,16 @@
                           <a:solidFill>
                             <a:srgbClr val="FFFFFF"/>
                           </a:solidFill>
-                          <a:latin typeface="Space Grotesk" pitchFamily="34" charset="0"/>
-                          <a:ea typeface="Space Grotesk" pitchFamily="34" charset="-122"/>
-                          <a:cs typeface="Space Grotesk" pitchFamily="34" charset="-120"/>
+                          <a:latin typeface="Arial"/>
+                          <a:ea typeface="Arial"/>
+                          <a:cs typeface="Arial"/>
                         </a:rPr>
                         <a:t>Variable pair</a:t>
                       </a:r>
                       <a:endParaRPr lang="en-US" sz="2200" dirty="0">
-                        <a:latin typeface="Space Grotesk" charset="0"/>
-                        <a:ea typeface="Space Grotesk" charset="0"/>
-                        <a:cs typeface="Space Grotesk" charset="0"/>
+                        <a:latin typeface="Arial"/>
+                        <a:ea typeface="Arial"/>
+                        <a:cs typeface="Arial"/>
                       </a:endParaRPr>
                     </a:p>
                   </a:txBody>
@@ -8161,16 +8159,16 @@
                           <a:solidFill>
                             <a:srgbClr val="FFFFFF"/>
                           </a:solidFill>
-                          <a:latin typeface="Space Grotesk" pitchFamily="34" charset="0"/>
-                          <a:ea typeface="Space Grotesk" pitchFamily="34" charset="-122"/>
-                          <a:cs typeface="Space Grotesk" pitchFamily="34" charset="-120"/>
+                          <a:latin typeface="Arial"/>
+                          <a:ea typeface="Arial"/>
+                          <a:cs typeface="Arial"/>
                         </a:rPr>
                         <a:t>Pearson r</a:t>
                       </a:r>
                       <a:endParaRPr lang="en-US" sz="2200" dirty="0">
-                        <a:latin typeface="Space Grotesk" charset="0"/>
-                        <a:ea typeface="Space Grotesk" charset="0"/>
-                        <a:cs typeface="Space Grotesk" charset="0"/>
+                        <a:latin typeface="Arial"/>
+                        <a:ea typeface="Arial"/>
+                        <a:cs typeface="Arial"/>
                       </a:endParaRPr>
                     </a:p>
                   </a:txBody>
@@ -8229,16 +8227,16 @@
                           <a:solidFill>
                             <a:srgbClr val="FFFFFF"/>
                           </a:solidFill>
-                          <a:latin typeface="Space Grotesk" pitchFamily="34" charset="0"/>
-                          <a:ea typeface="Space Grotesk" pitchFamily="34" charset="-122"/>
-                          <a:cs typeface="Space Grotesk" pitchFamily="34" charset="-120"/>
+                          <a:latin typeface="Arial"/>
+                          <a:ea typeface="Arial"/>
+                          <a:cs typeface="Arial"/>
                         </a:rPr>
                         <a:t>95% CI</a:t>
                       </a:r>
                       <a:endParaRPr lang="en-US" sz="2200" dirty="0">
-                        <a:latin typeface="Space Grotesk" charset="0"/>
-                        <a:ea typeface="Space Grotesk" charset="0"/>
-                        <a:cs typeface="Space Grotesk" charset="0"/>
+                        <a:latin typeface="Arial"/>
+                        <a:ea typeface="Arial"/>
+                        <a:cs typeface="Arial"/>
                       </a:endParaRPr>
                     </a:p>
                   </a:txBody>
@@ -8297,16 +8295,16 @@
                           <a:solidFill>
                             <a:srgbClr val="FFFFFF"/>
                           </a:solidFill>
-                          <a:latin typeface="Space Grotesk" pitchFamily="34" charset="0"/>
-                          <a:ea typeface="Space Grotesk" pitchFamily="34" charset="-122"/>
-                          <a:cs typeface="Space Grotesk" pitchFamily="34" charset="-120"/>
+                          <a:latin typeface="Arial"/>
+                          <a:ea typeface="Arial"/>
+                          <a:cs typeface="Arial"/>
                         </a:rPr>
                         <a:t>p</a:t>
                       </a:r>
                       <a:endParaRPr lang="en-US" sz="2200" dirty="0">
-                        <a:latin typeface="Space Grotesk" charset="0"/>
-                        <a:ea typeface="Space Grotesk" charset="0"/>
-                        <a:cs typeface="Space Grotesk" charset="0"/>
+                        <a:latin typeface="Arial"/>
+                        <a:ea typeface="Arial"/>
+                        <a:cs typeface="Arial"/>
                       </a:endParaRPr>
                     </a:p>
                   </a:txBody>
@@ -8367,16 +8365,16 @@
                           <a:solidFill>
                             <a:srgbClr val="000000"/>
                           </a:solidFill>
-                          <a:latin typeface="Space Grotesk Light" pitchFamily="34" charset="0"/>
-                          <a:ea typeface="Space Grotesk Light" pitchFamily="34" charset="-122"/>
-                          <a:cs typeface="Space Grotesk Light" pitchFamily="34" charset="-120"/>
+                          <a:latin typeface="Arial"/>
+                          <a:ea typeface="Arial"/>
+                          <a:cs typeface="Arial"/>
                         </a:rPr>
                         <a:t>Age vs SYNTAX score</a:t>
                       </a:r>
                       <a:endParaRPr lang="en-US" sz="2200" dirty="0">
-                        <a:latin typeface="Space Grotesk Light" charset="0"/>
-                        <a:ea typeface="Space Grotesk Light" charset="0"/>
-                        <a:cs typeface="Space Grotesk Light" charset="0"/>
+                        <a:latin typeface="Arial"/>
+                        <a:ea typeface="Arial"/>
+                        <a:cs typeface="Arial"/>
                       </a:endParaRPr>
                     </a:p>
                   </a:txBody>
@@ -8432,16 +8430,16 @@
                           <a:solidFill>
                             <a:srgbClr val="000000"/>
                           </a:solidFill>
-                          <a:latin typeface="Space Grotesk Light" pitchFamily="34" charset="0"/>
-                          <a:ea typeface="Space Grotesk Light" pitchFamily="34" charset="-122"/>
-                          <a:cs typeface="Space Grotesk Light" pitchFamily="34" charset="-120"/>
+                          <a:latin typeface="Arial"/>
+                          <a:ea typeface="Arial"/>
+                          <a:cs typeface="Arial"/>
                         </a:rPr>
                         <a:t>0.23</a:t>
                       </a:r>
                       <a:endParaRPr lang="en-US" sz="2200" dirty="0">
-                        <a:latin typeface="Space Grotesk Light" charset="0"/>
-                        <a:ea typeface="Space Grotesk Light" charset="0"/>
-                        <a:cs typeface="Space Grotesk Light" charset="0"/>
+                        <a:latin typeface="Arial"/>
+                        <a:ea typeface="Arial"/>
+                        <a:cs typeface="Arial"/>
                       </a:endParaRPr>
                     </a:p>
                   </a:txBody>
@@ -8497,16 +8495,16 @@
                           <a:solidFill>
                             <a:srgbClr val="000000"/>
                           </a:solidFill>
-                          <a:latin typeface="Space Grotesk Light" pitchFamily="34" charset="0"/>
-                          <a:ea typeface="Space Grotesk Light" pitchFamily="34" charset="-122"/>
-                          <a:cs typeface="Space Grotesk Light" pitchFamily="34" charset="-120"/>
+                          <a:latin typeface="Arial"/>
+                          <a:ea typeface="Arial"/>
+                          <a:cs typeface="Arial"/>
                         </a:rPr>
                         <a:t>0.02–0.42</a:t>
                       </a:r>
                       <a:endParaRPr lang="en-US" sz="2200" dirty="0">
-                        <a:latin typeface="Space Grotesk Light" charset="0"/>
-                        <a:ea typeface="Space Grotesk Light" charset="0"/>
-                        <a:cs typeface="Space Grotesk Light" charset="0"/>
+                        <a:latin typeface="Arial"/>
+                        <a:ea typeface="Arial"/>
+                        <a:cs typeface="Arial"/>
                       </a:endParaRPr>
                     </a:p>
                   </a:txBody>
@@ -8562,16 +8560,16 @@
                           <a:solidFill>
                             <a:srgbClr val="000000"/>
                           </a:solidFill>
-                          <a:latin typeface="Space Grotesk Light" pitchFamily="34" charset="0"/>
-                          <a:ea typeface="Space Grotesk Light" pitchFamily="34" charset="-122"/>
-                          <a:cs typeface="Space Grotesk Light" pitchFamily="34" charset="-120"/>
+                          <a:latin typeface="Arial"/>
+                          <a:ea typeface="Arial"/>
+                          <a:cs typeface="Arial"/>
                         </a:rPr>
                         <a:t>0.028</a:t>
                       </a:r>
                       <a:endParaRPr lang="en-US" sz="2200" dirty="0">
-                        <a:latin typeface="Space Grotesk Light" charset="0"/>
-                        <a:ea typeface="Space Grotesk Light" charset="0"/>
-                        <a:cs typeface="Space Grotesk Light" charset="0"/>
+                        <a:latin typeface="Arial"/>
+                        <a:ea typeface="Arial"/>
+                        <a:cs typeface="Arial"/>
                       </a:endParaRPr>
                     </a:p>
                   </a:txBody>
@@ -8629,16 +8627,16 @@
                           <a:solidFill>
                             <a:srgbClr val="000000"/>
                           </a:solidFill>
-                          <a:latin typeface="Space Grotesk Light" pitchFamily="34" charset="0"/>
-                          <a:ea typeface="Space Grotesk Light" pitchFamily="34" charset="-122"/>
-                          <a:cs typeface="Space Grotesk Light" pitchFamily="34" charset="-120"/>
+                          <a:latin typeface="Arial"/>
+                          <a:ea typeface="Arial"/>
+                          <a:cs typeface="Arial"/>
                         </a:rPr>
                         <a:t>EuroSCORE II vs age</a:t>
                       </a:r>
                       <a:endParaRPr lang="en-US" sz="2200" dirty="0">
-                        <a:latin typeface="Space Grotesk Light" charset="0"/>
-                        <a:ea typeface="Space Grotesk Light" charset="0"/>
-                        <a:cs typeface="Space Grotesk Light" charset="0"/>
+                        <a:latin typeface="Arial"/>
+                        <a:ea typeface="Arial"/>
+                        <a:cs typeface="Arial"/>
                       </a:endParaRPr>
                     </a:p>
                   </a:txBody>
@@ -8697,16 +8695,16 @@
                           <a:solidFill>
                             <a:srgbClr val="000000"/>
                           </a:solidFill>
-                          <a:latin typeface="Space Grotesk Light" pitchFamily="34" charset="0"/>
-                          <a:ea typeface="Space Grotesk Light" pitchFamily="34" charset="-122"/>
-                          <a:cs typeface="Space Grotesk Light" pitchFamily="34" charset="-120"/>
+                          <a:latin typeface="Arial"/>
+                          <a:ea typeface="Arial"/>
+                          <a:cs typeface="Arial"/>
                         </a:rPr>
                         <a:t>0.52</a:t>
                       </a:r>
                       <a:endParaRPr lang="en-US" sz="2200" dirty="0">
-                        <a:latin typeface="Space Grotesk Light" charset="0"/>
-                        <a:ea typeface="Space Grotesk Light" charset="0"/>
-                        <a:cs typeface="Space Grotesk Light" charset="0"/>
+                        <a:latin typeface="Arial"/>
+                        <a:ea typeface="Arial"/>
+                        <a:cs typeface="Arial"/>
                       </a:endParaRPr>
                     </a:p>
                   </a:txBody>
@@ -8765,16 +8763,16 @@
                           <a:solidFill>
                             <a:srgbClr val="000000"/>
                           </a:solidFill>
-                          <a:latin typeface="Space Grotesk Light" pitchFamily="34" charset="0"/>
-                          <a:ea typeface="Space Grotesk Light" pitchFamily="34" charset="-122"/>
-                          <a:cs typeface="Space Grotesk Light" pitchFamily="34" charset="-120"/>
+                          <a:latin typeface="Arial"/>
+                          <a:ea typeface="Arial"/>
+                          <a:cs typeface="Arial"/>
                         </a:rPr>
                         <a:t>0.34–0.67</a:t>
                       </a:r>
                       <a:endParaRPr lang="en-US" sz="2200" dirty="0">
-                        <a:latin typeface="Space Grotesk Light" charset="0"/>
-                        <a:ea typeface="Space Grotesk Light" charset="0"/>
-                        <a:cs typeface="Space Grotesk Light" charset="0"/>
+                        <a:latin typeface="Arial"/>
+                        <a:ea typeface="Arial"/>
+                        <a:cs typeface="Arial"/>
                       </a:endParaRPr>
                     </a:p>
                   </a:txBody>
@@ -8833,16 +8831,16 @@
                           <a:solidFill>
                             <a:srgbClr val="000000"/>
                           </a:solidFill>
-                          <a:latin typeface="Space Grotesk Light" pitchFamily="34" charset="0"/>
-                          <a:ea typeface="Space Grotesk Light" pitchFamily="34" charset="-122"/>
-                          <a:cs typeface="Space Grotesk Light" pitchFamily="34" charset="-120"/>
+                          <a:latin typeface="Arial"/>
+                          <a:ea typeface="Arial"/>
+                          <a:cs typeface="Arial"/>
                         </a:rPr>
                         <a:t>&lt;0.001</a:t>
                       </a:r>
                       <a:endParaRPr lang="en-US" sz="2200" dirty="0">
-                        <a:latin typeface="Space Grotesk Light" charset="0"/>
-                        <a:ea typeface="Space Grotesk Light" charset="0"/>
-                        <a:cs typeface="Space Grotesk Light" charset="0"/>
+                        <a:latin typeface="Arial"/>
+                        <a:ea typeface="Arial"/>
+                        <a:cs typeface="Arial"/>
                       </a:endParaRPr>
                     </a:p>
                   </a:txBody>
@@ -8903,16 +8901,16 @@
                           <a:solidFill>
                             <a:srgbClr val="000000"/>
                           </a:solidFill>
-                          <a:latin typeface="Space Grotesk Light" pitchFamily="34" charset="0"/>
-                          <a:ea typeface="Space Grotesk Light" pitchFamily="34" charset="-122"/>
-                          <a:cs typeface="Space Grotesk Light" pitchFamily="34" charset="-120"/>
+                          <a:latin typeface="Arial"/>
+                          <a:ea typeface="Arial"/>
+                          <a:cs typeface="Arial"/>
                         </a:rPr>
                         <a:t>LMCA stenosis vs fluoro</a:t>
                       </a:r>
                       <a:endParaRPr lang="en-US" sz="2200" dirty="0">
-                        <a:latin typeface="Space Grotesk Light" charset="0"/>
-                        <a:ea typeface="Space Grotesk Light" charset="0"/>
-                        <a:cs typeface="Space Grotesk Light" charset="0"/>
+                        <a:latin typeface="Arial"/>
+                        <a:ea typeface="Arial"/>
+                        <a:cs typeface="Arial"/>
                       </a:endParaRPr>
                     </a:p>
                   </a:txBody>
@@ -8968,16 +8966,16 @@
                           <a:solidFill>
                             <a:srgbClr val="000000"/>
                           </a:solidFill>
-                          <a:latin typeface="Space Grotesk Light" pitchFamily="34" charset="0"/>
-                          <a:ea typeface="Space Grotesk Light" pitchFamily="34" charset="-122"/>
-                          <a:cs typeface="Space Grotesk Light" pitchFamily="34" charset="-120"/>
+                          <a:latin typeface="Arial"/>
+                          <a:ea typeface="Arial"/>
+                          <a:cs typeface="Arial"/>
                         </a:rPr>
                         <a:t>0.31</a:t>
                       </a:r>
                       <a:endParaRPr lang="en-US" sz="2200" dirty="0">
-                        <a:latin typeface="Space Grotesk Light" charset="0"/>
-                        <a:ea typeface="Space Grotesk Light" charset="0"/>
-                        <a:cs typeface="Space Grotesk Light" charset="0"/>
+                        <a:latin typeface="Arial"/>
+                        <a:ea typeface="Arial"/>
+                        <a:cs typeface="Arial"/>
                       </a:endParaRPr>
                     </a:p>
                   </a:txBody>
@@ -9033,16 +9031,16 @@
                           <a:solidFill>
                             <a:srgbClr val="000000"/>
                           </a:solidFill>
-                          <a:latin typeface="Space Grotesk Light" pitchFamily="34" charset="0"/>
-                          <a:ea typeface="Space Grotesk Light" pitchFamily="34" charset="-122"/>
-                          <a:cs typeface="Space Grotesk Light" pitchFamily="34" charset="-120"/>
+                          <a:latin typeface="Arial"/>
+                          <a:ea typeface="Arial"/>
+                          <a:cs typeface="Arial"/>
                         </a:rPr>
                         <a:t>0.11–0.49</a:t>
                       </a:r>
                       <a:endParaRPr lang="en-US" sz="2200" dirty="0">
-                        <a:latin typeface="Space Grotesk Light" charset="0"/>
-                        <a:ea typeface="Space Grotesk Light" charset="0"/>
-                        <a:cs typeface="Space Grotesk Light" charset="0"/>
+                        <a:latin typeface="Arial"/>
+                        <a:ea typeface="Arial"/>
+                        <a:cs typeface="Arial"/>
                       </a:endParaRPr>
                     </a:p>
                   </a:txBody>
@@ -9098,16 +9096,16 @@
                           <a:solidFill>
                             <a:srgbClr val="000000"/>
                           </a:solidFill>
-                          <a:latin typeface="Space Grotesk Light" pitchFamily="34" charset="0"/>
-                          <a:ea typeface="Space Grotesk Light" pitchFamily="34" charset="-122"/>
-                          <a:cs typeface="Space Grotesk Light" pitchFamily="34" charset="-120"/>
+                          <a:latin typeface="Arial"/>
+                          <a:ea typeface="Arial"/>
+                          <a:cs typeface="Arial"/>
                         </a:rPr>
                         <a:t>0.003</a:t>
                       </a:r>
                       <a:endParaRPr lang="en-US" sz="2200" dirty="0">
-                        <a:latin typeface="Space Grotesk Light" charset="0"/>
-                        <a:ea typeface="Space Grotesk Light" charset="0"/>
-                        <a:cs typeface="Space Grotesk Light" charset="0"/>
+                        <a:latin typeface="Arial"/>
+                        <a:ea typeface="Arial"/>
+                        <a:cs typeface="Arial"/>
                       </a:endParaRPr>
                     </a:p>
                   </a:txBody>
@@ -9165,16 +9163,16 @@
                           <a:solidFill>
                             <a:srgbClr val="000000"/>
                           </a:solidFill>
-                          <a:latin typeface="Space Grotesk Light" pitchFamily="34" charset="0"/>
-                          <a:ea typeface="Space Grotesk Light" pitchFamily="34" charset="-122"/>
-                          <a:cs typeface="Space Grotesk Light" pitchFamily="34" charset="-120"/>
+                          <a:latin typeface="Arial"/>
+                          <a:ea typeface="Arial"/>
+                          <a:cs typeface="Arial"/>
                         </a:rPr>
                         <a:t>Contrast vs fluoro time</a:t>
                       </a:r>
                       <a:endParaRPr lang="en-US" sz="2200" dirty="0">
-                        <a:latin typeface="Space Grotesk Light" charset="0"/>
-                        <a:ea typeface="Space Grotesk Light" charset="0"/>
-                        <a:cs typeface="Space Grotesk Light" charset="0"/>
+                        <a:latin typeface="Arial"/>
+                        <a:ea typeface="Arial"/>
+                        <a:cs typeface="Arial"/>
                       </a:endParaRPr>
                     </a:p>
                   </a:txBody>
@@ -9233,16 +9231,16 @@
                           <a:solidFill>
                             <a:srgbClr val="000000"/>
                           </a:solidFill>
-                          <a:latin typeface="Space Grotesk Light" pitchFamily="34" charset="0"/>
-                          <a:ea typeface="Space Grotesk Light" pitchFamily="34" charset="-122"/>
-                          <a:cs typeface="Space Grotesk Light" pitchFamily="34" charset="-120"/>
+                          <a:latin typeface="Arial"/>
+                          <a:ea typeface="Arial"/>
+                          <a:cs typeface="Arial"/>
                         </a:rPr>
                         <a:t>0.38</a:t>
                       </a:r>
                       <a:endParaRPr lang="en-US" sz="2200" dirty="0">
-                        <a:latin typeface="Space Grotesk Light" charset="0"/>
-                        <a:ea typeface="Space Grotesk Light" charset="0"/>
-                        <a:cs typeface="Space Grotesk Light" charset="0"/>
+                        <a:latin typeface="Arial"/>
+                        <a:ea typeface="Arial"/>
+                        <a:cs typeface="Arial"/>
                       </a:endParaRPr>
                     </a:p>
                   </a:txBody>
@@ -9301,16 +9299,16 @@
                           <a:solidFill>
                             <a:srgbClr val="000000"/>
                           </a:solidFill>
-                          <a:latin typeface="Space Grotesk Light" pitchFamily="34" charset="0"/>
-                          <a:ea typeface="Space Grotesk Light" pitchFamily="34" charset="-122"/>
-                          <a:cs typeface="Space Grotesk Light" pitchFamily="34" charset="-120"/>
+                          <a:latin typeface="Arial"/>
+                          <a:ea typeface="Arial"/>
+                          <a:cs typeface="Arial"/>
                         </a:rPr>
                         <a:t>0.19–0.55</a:t>
                       </a:r>
                       <a:endParaRPr lang="en-US" sz="2200" dirty="0">
-                        <a:latin typeface="Space Grotesk Light" charset="0"/>
-                        <a:ea typeface="Space Grotesk Light" charset="0"/>
-                        <a:cs typeface="Space Grotesk Light" charset="0"/>
+                        <a:latin typeface="Arial"/>
+                        <a:ea typeface="Arial"/>
+                        <a:cs typeface="Arial"/>
                       </a:endParaRPr>
                     </a:p>
                   </a:txBody>
@@ -9369,16 +9367,16 @@
                           <a:solidFill>
                             <a:srgbClr val="000000"/>
                           </a:solidFill>
-                          <a:latin typeface="Space Grotesk Light" pitchFamily="34" charset="0"/>
-                          <a:ea typeface="Space Grotesk Light" pitchFamily="34" charset="-122"/>
-                          <a:cs typeface="Space Grotesk Light" pitchFamily="34" charset="-120"/>
+                          <a:latin typeface="Arial"/>
+                          <a:ea typeface="Arial"/>
+                          <a:cs typeface="Arial"/>
                         </a:rPr>
                         <a:t>0.001</a:t>
                       </a:r>
                       <a:endParaRPr lang="en-US" sz="2200" dirty="0">
-                        <a:latin typeface="Space Grotesk Light" charset="0"/>
-                        <a:ea typeface="Space Grotesk Light" charset="0"/>
-                        <a:cs typeface="Space Grotesk Light" charset="0"/>
+                        <a:latin typeface="Arial"/>
+                        <a:ea typeface="Arial"/>
+                        <a:cs typeface="Arial"/>
                       </a:endParaRPr>
                     </a:p>
                   </a:txBody>
@@ -9439,16 +9437,16 @@
                           <a:solidFill>
                             <a:srgbClr val="000000"/>
                           </a:solidFill>
-                          <a:latin typeface="Space Grotesk Light" pitchFamily="34" charset="0"/>
-                          <a:ea typeface="Space Grotesk Light" pitchFamily="34" charset="-122"/>
-                          <a:cs typeface="Space Grotesk Light" pitchFamily="34" charset="-120"/>
+                          <a:latin typeface="Arial"/>
+                          <a:ea typeface="Arial"/>
+                          <a:cs typeface="Arial"/>
                         </a:rPr>
                         <a:t>Burr size vs stent diam.</a:t>
                       </a:r>
                       <a:endParaRPr lang="en-US" sz="2200" dirty="0">
-                        <a:latin typeface="Space Grotesk Light" charset="0"/>
-                        <a:ea typeface="Space Grotesk Light" charset="0"/>
-                        <a:cs typeface="Space Grotesk Light" charset="0"/>
+                        <a:latin typeface="Arial"/>
+                        <a:ea typeface="Arial"/>
+                        <a:cs typeface="Arial"/>
                       </a:endParaRPr>
                     </a:p>
                   </a:txBody>
@@ -9504,16 +9502,16 @@
                           <a:solidFill>
                             <a:srgbClr val="000000"/>
                           </a:solidFill>
-                          <a:latin typeface="Space Grotesk Light" pitchFamily="34" charset="0"/>
-                          <a:ea typeface="Space Grotesk Light" pitchFamily="34" charset="-122"/>
-                          <a:cs typeface="Space Grotesk Light" pitchFamily="34" charset="-120"/>
+                          <a:latin typeface="Arial"/>
+                          <a:ea typeface="Arial"/>
+                          <a:cs typeface="Arial"/>
                         </a:rPr>
                         <a:t>0.45</a:t>
                       </a:r>
                       <a:endParaRPr lang="en-US" sz="2200" dirty="0">
-                        <a:latin typeface="Space Grotesk Light" charset="0"/>
-                        <a:ea typeface="Space Grotesk Light" charset="0"/>
-                        <a:cs typeface="Space Grotesk Light" charset="0"/>
+                        <a:latin typeface="Arial"/>
+                        <a:ea typeface="Arial"/>
+                        <a:cs typeface="Arial"/>
                       </a:endParaRPr>
                     </a:p>
                   </a:txBody>
@@ -9569,16 +9567,16 @@
                           <a:solidFill>
                             <a:srgbClr val="000000"/>
                           </a:solidFill>
-                          <a:latin typeface="Space Grotesk Light" pitchFamily="34" charset="0"/>
-                          <a:ea typeface="Space Grotesk Light" pitchFamily="34" charset="-122"/>
-                          <a:cs typeface="Space Grotesk Light" pitchFamily="34" charset="-120"/>
+                          <a:latin typeface="Arial"/>
+                          <a:ea typeface="Arial"/>
+                          <a:cs typeface="Arial"/>
                         </a:rPr>
                         <a:t>0.26–0.61</a:t>
                       </a:r>
                       <a:endParaRPr lang="en-US" sz="2200" dirty="0">
-                        <a:latin typeface="Space Grotesk Light" charset="0"/>
-                        <a:ea typeface="Space Grotesk Light" charset="0"/>
-                        <a:cs typeface="Space Grotesk Light" charset="0"/>
+                        <a:latin typeface="Arial"/>
+                        <a:ea typeface="Arial"/>
+                        <a:cs typeface="Arial"/>
                       </a:endParaRPr>
                     </a:p>
                   </a:txBody>
@@ -9634,16 +9632,16 @@
                           <a:solidFill>
                             <a:srgbClr val="000000"/>
                           </a:solidFill>
-                          <a:latin typeface="Space Grotesk Light" pitchFamily="34" charset="0"/>
-                          <a:ea typeface="Space Grotesk Light" pitchFamily="34" charset="-122"/>
-                          <a:cs typeface="Space Grotesk Light" pitchFamily="34" charset="-120"/>
+                          <a:latin typeface="Arial"/>
+                          <a:ea typeface="Arial"/>
+                          <a:cs typeface="Arial"/>
                         </a:rPr>
                         <a:t>&lt;0.001</a:t>
                       </a:r>
                       <a:endParaRPr lang="en-US" sz="2200" dirty="0">
-                        <a:latin typeface="Space Grotesk Light" charset="0"/>
-                        <a:ea typeface="Space Grotesk Light" charset="0"/>
-                        <a:cs typeface="Space Grotesk Light" charset="0"/>
+                        <a:latin typeface="Arial"/>
+                        <a:ea typeface="Arial"/>
+                        <a:cs typeface="Arial"/>
                       </a:endParaRPr>
                     </a:p>
                   </a:txBody>
@@ -9701,16 +9699,16 @@
                           <a:solidFill>
                             <a:srgbClr val="000000"/>
                           </a:solidFill>
-                          <a:latin typeface="Space Grotesk Light" pitchFamily="34" charset="0"/>
-                          <a:ea typeface="Space Grotesk Light" pitchFamily="34" charset="-122"/>
-                          <a:cs typeface="Space Grotesk Light" pitchFamily="34" charset="-120"/>
+                          <a:latin typeface="Arial"/>
+                          <a:ea typeface="Arial"/>
+                          <a:cs typeface="Arial"/>
                         </a:rPr>
                         <a:t>SYNTAX vs stent length</a:t>
                       </a:r>
                       <a:endParaRPr lang="en-US" sz="2200" dirty="0">
-                        <a:latin typeface="Space Grotesk Light" charset="0"/>
-                        <a:ea typeface="Space Grotesk Light" charset="0"/>
-                        <a:cs typeface="Space Grotesk Light" charset="0"/>
+                        <a:latin typeface="Arial"/>
+                        <a:ea typeface="Arial"/>
+                        <a:cs typeface="Arial"/>
                       </a:endParaRPr>
                     </a:p>
                   </a:txBody>
@@ -9769,16 +9767,16 @@
                           <a:solidFill>
                             <a:srgbClr val="000000"/>
                           </a:solidFill>
-                          <a:latin typeface="Space Grotesk Light" pitchFamily="34" charset="0"/>
-                          <a:ea typeface="Space Grotesk Light" pitchFamily="34" charset="-122"/>
-                          <a:cs typeface="Space Grotesk Light" pitchFamily="34" charset="-120"/>
+                          <a:latin typeface="Arial"/>
+                          <a:ea typeface="Arial"/>
+                          <a:cs typeface="Arial"/>
                         </a:rPr>
                         <a:t>0.28</a:t>
                       </a:r>
                       <a:endParaRPr lang="en-US" sz="2200" dirty="0">
-                        <a:latin typeface="Space Grotesk Light" charset="0"/>
-                        <a:ea typeface="Space Grotesk Light" charset="0"/>
-                        <a:cs typeface="Space Grotesk Light" charset="0"/>
+                        <a:latin typeface="Arial"/>
+                        <a:ea typeface="Arial"/>
+                        <a:cs typeface="Arial"/>
                       </a:endParaRPr>
                     </a:p>
                   </a:txBody>
@@ -9837,16 +9835,16 @@
                           <a:solidFill>
                             <a:srgbClr val="000000"/>
                           </a:solidFill>
-                          <a:latin typeface="Space Grotesk Light" pitchFamily="34" charset="0"/>
-                          <a:ea typeface="Space Grotesk Light" pitchFamily="34" charset="-122"/>
-                          <a:cs typeface="Space Grotesk Light" pitchFamily="34" charset="-120"/>
+                          <a:latin typeface="Arial"/>
+                          <a:ea typeface="Arial"/>
+                          <a:cs typeface="Arial"/>
                         </a:rPr>
                         <a:t>0.08–0.46</a:t>
                       </a:r>
                       <a:endParaRPr lang="en-US" sz="2200" dirty="0">
-                        <a:latin typeface="Space Grotesk Light" charset="0"/>
-                        <a:ea typeface="Space Grotesk Light" charset="0"/>
-                        <a:cs typeface="Space Grotesk Light" charset="0"/>
+                        <a:latin typeface="Arial"/>
+                        <a:ea typeface="Arial"/>
+                        <a:cs typeface="Arial"/>
                       </a:endParaRPr>
                     </a:p>
                   </a:txBody>
@@ -9905,16 +9903,16 @@
                           <a:solidFill>
                             <a:srgbClr val="000000"/>
                           </a:solidFill>
-                          <a:latin typeface="Space Grotesk Light" pitchFamily="34" charset="0"/>
-                          <a:ea typeface="Space Grotesk Light" pitchFamily="34" charset="-122"/>
-                          <a:cs typeface="Space Grotesk Light" pitchFamily="34" charset="-120"/>
+                          <a:latin typeface="Arial"/>
+                          <a:ea typeface="Arial"/>
+                          <a:cs typeface="Arial"/>
                         </a:rPr>
                         <a:t>0.006</a:t>
                       </a:r>
                       <a:endParaRPr lang="en-US" sz="2200" dirty="0">
-                        <a:latin typeface="Space Grotesk Light" charset="0"/>
-                        <a:ea typeface="Space Grotesk Light" charset="0"/>
-                        <a:cs typeface="Space Grotesk Light" charset="0"/>
+                        <a:latin typeface="Arial"/>
+                        <a:ea typeface="Arial"/>
+                        <a:cs typeface="Arial"/>
                       </a:endParaRPr>
                     </a:p>
                   </a:txBody>
@@ -10141,9 +10139,9 @@
                 <a:solidFill>
                   <a:srgbClr val="0B3D66"/>
                 </a:solidFill>
-                <a:latin typeface="Space Grotesk Light" pitchFamily="34" charset="0"/>
-                <a:ea typeface="Space Grotesk Light" pitchFamily="34" charset="-122"/>
-                <a:cs typeface="Space Grotesk Light" pitchFamily="34" charset="-120"/>
+                <a:latin typeface="Arial"/>
+                <a:ea typeface="Arial"/>
+                <a:cs typeface="Arial"/>
               </a:rPr>
               <a:t>Sohil MM et al.  |  Am Heart J Plus 2026;61:100678</a:t>
             </a:r>
@@ -10180,9 +10178,9 @@
                 <a:solidFill>
                   <a:srgbClr val="0B3D66"/>
                 </a:solidFill>
-                <a:latin typeface="Space Grotesk" pitchFamily="34" charset="0"/>
-                <a:ea typeface="Space Grotesk" pitchFamily="34" charset="-122"/>
-                <a:cs typeface="Space Grotesk" pitchFamily="34" charset="-120"/>
+                <a:latin typeface="Arial"/>
+                <a:ea typeface="Arial"/>
+                <a:cs typeface="Arial"/>
               </a:rPr>
               <a:t>13</a:t>
             </a:r>
@@ -10251,9 +10249,9 @@
                 <a:solidFill>
                   <a:srgbClr val="0B3D66"/>
                 </a:solidFill>
-                <a:latin typeface="Space Grotesk" pitchFamily="34" charset="0"/>
-                <a:ea typeface="Space Grotesk" pitchFamily="34" charset="-122"/>
-                <a:cs typeface="Space Grotesk" pitchFamily="34" charset="-120"/>
+                <a:latin typeface="Arial"/>
+                <a:ea typeface="Arial"/>
+                <a:cs typeface="Arial"/>
               </a:rPr>
               <a:t>Endpoints differ by study</a:t>
             </a:r>
@@ -10349,9 +10347,9 @@
                 <a:solidFill>
                   <a:srgbClr val="C8102E"/>
                 </a:solidFill>
-                <a:latin typeface="Space Grotesk" pitchFamily="34" charset="0"/>
-                <a:ea typeface="Space Grotesk" pitchFamily="34" charset="-122"/>
-                <a:cs typeface="Space Grotesk" pitchFamily="34" charset="-120"/>
+                <a:latin typeface="Arial"/>
+                <a:ea typeface="Arial"/>
+                <a:cs typeface="Arial"/>
               </a:rPr>
               <a:t>Not like-for-like</a:t>
             </a:r>
@@ -10369,9 +10367,9 @@
                 <a:solidFill>
                   <a:srgbClr val="0B3D66"/>
                 </a:solidFill>
-                <a:latin typeface="Space Grotesk" pitchFamily="34" charset="0"/>
-                <a:ea typeface="Space Grotesk" pitchFamily="34" charset="-122"/>
-                <a:cs typeface="Space Grotesk" pitchFamily="34" charset="-120"/>
+                <a:latin typeface="Arial"/>
+                <a:ea typeface="Arial"/>
+                <a:cs typeface="Arial"/>
               </a:rPr>
               <a:t>Garcia-Lara 2-yr cardiac-mortality-free survival</a:t>
             </a:r>
@@ -10386,9 +10384,9 @@
                 <a:solidFill>
                   <a:srgbClr val="0B3D66"/>
                 </a:solidFill>
-                <a:latin typeface="Space Grotesk" pitchFamily="34" charset="0"/>
-                <a:ea typeface="Space Grotesk" pitchFamily="34" charset="-122"/>
-                <a:cs typeface="Space Grotesk" pitchFamily="34" charset="-120"/>
+                <a:latin typeface="Arial"/>
+                <a:ea typeface="Arial"/>
+                <a:cs typeface="Arial"/>
               </a:rPr>
               <a:t>71 ± 7%</a:t>
             </a:r>
@@ -10572,9 +10570,9 @@
                 <a:solidFill>
                   <a:srgbClr val="0B3D66"/>
                 </a:solidFill>
-                <a:latin typeface="Space Grotesk Light" pitchFamily="34" charset="0"/>
-                <a:ea typeface="Space Grotesk Light" pitchFamily="34" charset="-122"/>
-                <a:cs typeface="Space Grotesk Light" pitchFamily="34" charset="-120"/>
+                <a:latin typeface="Arial"/>
+                <a:ea typeface="Arial"/>
+                <a:cs typeface="Arial"/>
               </a:rPr>
               <a:t>Sohil MM et al.  |  Am Heart J Plus 2026;61:100678</a:t>
             </a:r>
@@ -10611,9 +10609,9 @@
                 <a:solidFill>
                   <a:srgbClr val="0B3D66"/>
                 </a:solidFill>
-                <a:latin typeface="Space Grotesk" pitchFamily="34" charset="0"/>
-                <a:ea typeface="Space Grotesk" pitchFamily="34" charset="-122"/>
-                <a:cs typeface="Space Grotesk" pitchFamily="34" charset="-120"/>
+                <a:latin typeface="Arial"/>
+                <a:ea typeface="Arial"/>
+                <a:cs typeface="Arial"/>
               </a:rPr>
               <a:t>14</a:t>
             </a:r>
@@ -10682,9 +10680,9 @@
                 <a:solidFill>
                   <a:srgbClr val="0B3D66"/>
                 </a:solidFill>
-                <a:latin typeface="Space Grotesk" pitchFamily="34" charset="0"/>
-                <a:ea typeface="Space Grotesk" pitchFamily="34" charset="-122"/>
-                <a:cs typeface="Space Grotesk" pitchFamily="34" charset="-120"/>
+                <a:latin typeface="Arial"/>
+                <a:ea typeface="Arial"/>
+                <a:cs typeface="Arial"/>
               </a:rPr>
               <a:t>Limitations</a:t>
             </a:r>
@@ -10764,9 +10762,9 @@
                 <a:solidFill>
                   <a:srgbClr val="FFFFFF"/>
                 </a:solidFill>
-                <a:latin typeface="Space Grotesk" pitchFamily="34" charset="0"/>
-                <a:ea typeface="Space Grotesk" pitchFamily="34" charset="-122"/>
-                <a:cs typeface="Space Grotesk" pitchFamily="34" charset="-120"/>
+                <a:latin typeface="Arial"/>
+                <a:ea typeface="Arial"/>
+                <a:cs typeface="Arial"/>
               </a:rPr>
               <a:t>Design</a:t>
             </a:r>
@@ -10806,9 +10804,9 @@
                 <a:solidFill>
                   <a:srgbClr val="000000"/>
                 </a:solidFill>
-                <a:latin typeface="Space Grotesk Light" pitchFamily="34" charset="0"/>
-                <a:ea typeface="Space Grotesk Light" pitchFamily="34" charset="-122"/>
-                <a:cs typeface="Space Grotesk Light" pitchFamily="34" charset="-120"/>
+                <a:latin typeface="Arial"/>
+                <a:ea typeface="Arial"/>
+                <a:cs typeface="Arial"/>
               </a:rPr>
               <a:t>Single centre, small sample (n = 45)</a:t>
             </a:r>
@@ -10826,9 +10824,9 @@
                 <a:solidFill>
                   <a:srgbClr val="000000"/>
                 </a:solidFill>
-                <a:latin typeface="Space Grotesk Light" pitchFamily="34" charset="0"/>
-                <a:ea typeface="Space Grotesk Light" pitchFamily="34" charset="-122"/>
-                <a:cs typeface="Space Grotesk Light" pitchFamily="34" charset="-120"/>
+                <a:latin typeface="Arial"/>
+                <a:ea typeface="Arial"/>
+                <a:cs typeface="Arial"/>
               </a:rPr>
               <a:t>No control group (non-rota PCI or CABG)</a:t>
             </a:r>
@@ -10885,9 +10883,9 @@
                 <a:solidFill>
                   <a:srgbClr val="FFFFFF"/>
                 </a:solidFill>
-                <a:latin typeface="Space Grotesk" pitchFamily="34" charset="0"/>
-                <a:ea typeface="Space Grotesk" pitchFamily="34" charset="-122"/>
-                <a:cs typeface="Space Grotesk" pitchFamily="34" charset="-120"/>
+                <a:latin typeface="Arial"/>
+                <a:ea typeface="Arial"/>
+                <a:cs typeface="Arial"/>
               </a:rPr>
               <a:t>Scope</a:t>
             </a:r>
@@ -10927,9 +10925,9 @@
                 <a:solidFill>
                   <a:srgbClr val="000000"/>
                 </a:solidFill>
-                <a:latin typeface="Space Grotesk Light" pitchFamily="34" charset="0"/>
-                <a:ea typeface="Space Grotesk Light" pitchFamily="34" charset="-122"/>
-                <a:cs typeface="Space Grotesk Light" pitchFamily="34" charset="-120"/>
+                <a:latin typeface="Arial"/>
+                <a:ea typeface="Arial"/>
+                <a:cs typeface="Arial"/>
               </a:rPr>
               <a:t>No systematic angiographic follow-up</a:t>
             </a:r>
@@ -10947,9 +10945,9 @@
                 <a:solidFill>
                   <a:srgbClr val="000000"/>
                 </a:solidFill>
-                <a:latin typeface="Space Grotesk Light" pitchFamily="34" charset="0"/>
-                <a:ea typeface="Space Grotesk Light" pitchFamily="34" charset="-122"/>
-                <a:cs typeface="Space Grotesk Light" pitchFamily="34" charset="-120"/>
+                <a:latin typeface="Arial"/>
+                <a:ea typeface="Arial"/>
+                <a:cs typeface="Arial"/>
               </a:rPr>
               <a:t>Rotablator RA only: not orbital or IVL</a:t>
             </a:r>
@@ -11133,9 +11131,9 @@
                 <a:solidFill>
                   <a:srgbClr val="0B3D66"/>
                 </a:solidFill>
-                <a:latin typeface="Space Grotesk Light" pitchFamily="34" charset="0"/>
-                <a:ea typeface="Space Grotesk Light" pitchFamily="34" charset="-122"/>
-                <a:cs typeface="Space Grotesk Light" pitchFamily="34" charset="-120"/>
+                <a:latin typeface="Arial"/>
+                <a:ea typeface="Arial"/>
+                <a:cs typeface="Arial"/>
               </a:rPr>
               <a:t>Sohil MM et al.  |  Am Heart J Plus 2026;61:100678</a:t>
             </a:r>
@@ -11172,9 +11170,9 @@
                 <a:solidFill>
                   <a:srgbClr val="0B3D66"/>
                 </a:solidFill>
-                <a:latin typeface="Space Grotesk" pitchFamily="34" charset="0"/>
-                <a:ea typeface="Space Grotesk" pitchFamily="34" charset="-122"/>
-                <a:cs typeface="Space Grotesk" pitchFamily="34" charset="-120"/>
+                <a:latin typeface="Arial"/>
+                <a:ea typeface="Arial"/>
+                <a:cs typeface="Arial"/>
               </a:rPr>
               <a:t>15</a:t>
             </a:r>
@@ -11243,9 +11241,9 @@
                 <a:solidFill>
                   <a:srgbClr val="C8102E"/>
                 </a:solidFill>
-                <a:latin typeface="Space Grotesk" pitchFamily="34" charset="0"/>
-                <a:ea typeface="Space Grotesk" pitchFamily="34" charset="-122"/>
-                <a:cs typeface="Space Grotesk" pitchFamily="34" charset="-120"/>
+                <a:latin typeface="Arial"/>
+                <a:ea typeface="Arial"/>
+                <a:cs typeface="Arial"/>
               </a:rPr>
               <a:t>01</a:t>
             </a:r>
@@ -11282,9 +11280,9 @@
                 <a:solidFill>
                   <a:srgbClr val="D6E6F5"/>
                 </a:solidFill>
-                <a:latin typeface="Space Grotesk" pitchFamily="34" charset="0"/>
-                <a:ea typeface="Space Grotesk" pitchFamily="34" charset="-122"/>
-                <a:cs typeface="Space Grotesk" pitchFamily="34" charset="-120"/>
+                <a:latin typeface="Arial"/>
+                <a:ea typeface="Arial"/>
+                <a:cs typeface="Arial"/>
               </a:rPr>
               <a:t>BACKGROUND</a:t>
             </a:r>
@@ -11321,9 +11319,9 @@
                 <a:solidFill>
                   <a:srgbClr val="FFFFFF"/>
                 </a:solidFill>
-                <a:latin typeface="Space Grotesk" pitchFamily="34" charset="0"/>
-                <a:ea typeface="Space Grotesk" pitchFamily="34" charset="-122"/>
-                <a:cs typeface="Space Grotesk" pitchFamily="34" charset="-120"/>
+                <a:latin typeface="Arial"/>
+                <a:ea typeface="Arial"/>
+                <a:cs typeface="Arial"/>
               </a:rPr>
               <a:t>Calcified left main disease makes PCI hard, yet for some patients PCI is the only option.</a:t>
             </a:r>
@@ -11507,9 +11505,9 @@
                 <a:solidFill>
                   <a:srgbClr val="FFFFFF"/>
                 </a:solidFill>
-                <a:latin typeface="Space Grotesk Light" pitchFamily="34" charset="0"/>
-                <a:ea typeface="Space Grotesk Light" pitchFamily="34" charset="-122"/>
-                <a:cs typeface="Space Grotesk Light" pitchFamily="34" charset="-120"/>
+                <a:latin typeface="Arial"/>
+                <a:ea typeface="Arial"/>
+                <a:cs typeface="Arial"/>
               </a:rPr>
               <a:t>Sohil MM et al.  |  Am Heart J Plus 2026;61:100678</a:t>
             </a:r>
@@ -11546,9 +11544,9 @@
                 <a:solidFill>
                   <a:srgbClr val="FFFFFF"/>
                 </a:solidFill>
-                <a:latin typeface="Space Grotesk" pitchFamily="34" charset="0"/>
-                <a:ea typeface="Space Grotesk" pitchFamily="34" charset="-122"/>
-                <a:cs typeface="Space Grotesk" pitchFamily="34" charset="-120"/>
+                <a:latin typeface="Arial"/>
+                <a:ea typeface="Arial"/>
+                <a:cs typeface="Arial"/>
               </a:rPr>
               <a:t>2</a:t>
             </a:r>
@@ -11617,9 +11615,9 @@
                 <a:solidFill>
                   <a:srgbClr val="0B3D66"/>
                 </a:solidFill>
-                <a:latin typeface="Space Grotesk" pitchFamily="34" charset="0"/>
-                <a:ea typeface="Space Grotesk" pitchFamily="34" charset="-122"/>
-                <a:cs typeface="Space Grotesk" pitchFamily="34" charset="-120"/>
+                <a:latin typeface="Arial"/>
+                <a:ea typeface="Arial"/>
+                <a:cs typeface="Arial"/>
               </a:rPr>
               <a:t>Why Indian data matter</a:t>
             </a:r>
@@ -11682,9 +11680,9 @@
                 <a:solidFill>
                   <a:srgbClr val="000000"/>
                 </a:solidFill>
-                <a:latin typeface="Space Grotesk Light" pitchFamily="34" charset="0"/>
-                <a:ea typeface="Space Grotesk Light" pitchFamily="34" charset="-122"/>
-                <a:cs typeface="Space Grotesk Light" pitchFamily="34" charset="-120"/>
+                <a:latin typeface="Arial"/>
+                <a:ea typeface="Arial"/>
+                <a:cs typeface="Arial"/>
               </a:rPr>
               <a:t>Extensive, multivessel, heavily calcified CAD</a:t>
             </a:r>
@@ -11702,9 +11700,9 @@
                 <a:solidFill>
                   <a:srgbClr val="000000"/>
                 </a:solidFill>
-                <a:latin typeface="Space Grotesk Light" pitchFamily="34" charset="0"/>
-                <a:ea typeface="Space Grotesk Light" pitchFamily="34" charset="-122"/>
-                <a:cs typeface="Space Grotesk Light" pitchFamily="34" charset="-120"/>
+                <a:latin typeface="Arial"/>
+                <a:ea typeface="Arial"/>
+                <a:cs typeface="Arial"/>
               </a:rPr>
               <a:t>CAD a decade earlier than in the West</a:t>
             </a:r>
@@ -11722,9 +11720,9 @@
                 <a:solidFill>
                   <a:srgbClr val="000000"/>
                 </a:solidFill>
-                <a:latin typeface="Space Grotesk Light" pitchFamily="34" charset="0"/>
-                <a:ea typeface="Space Grotesk Light" pitchFamily="34" charset="-122"/>
-                <a:cs typeface="Space Grotesk Light" pitchFamily="34" charset="-120"/>
+                <a:latin typeface="Arial"/>
+                <a:ea typeface="Arial"/>
+                <a:cs typeface="Arial"/>
               </a:rPr>
               <a:t>High burden of diabetes and dyslipidemia</a:t>
             </a:r>
@@ -11742,9 +11740,9 @@
                 <a:solidFill>
                   <a:srgbClr val="000000"/>
                 </a:solidFill>
-                <a:latin typeface="Space Grotesk Light" pitchFamily="34" charset="0"/>
-                <a:ea typeface="Space Grotesk Light" pitchFamily="34" charset="-122"/>
-                <a:cs typeface="Space Grotesk Light" pitchFamily="34" charset="-120"/>
+                <a:latin typeface="Arial"/>
+                <a:ea typeface="Arial"/>
+                <a:cs typeface="Arial"/>
               </a:rPr>
               <a:t>DAPT compliance hit by cost and awareness</a:t>
             </a:r>
@@ -11762,9 +11760,9 @@
                 <a:solidFill>
                   <a:srgbClr val="000000"/>
                 </a:solidFill>
-                <a:latin typeface="Space Grotesk Light" pitchFamily="34" charset="0"/>
-                <a:ea typeface="Space Grotesk Light" pitchFamily="34" charset="-122"/>
-                <a:cs typeface="Space Grotesk Light" pitchFamily="34" charset="-120"/>
+                <a:latin typeface="Arial"/>
+                <a:ea typeface="Arial"/>
+                <a:cs typeface="Arial"/>
               </a:rPr>
               <a:t>Little rotablation LM-PCI evidence from India</a:t>
             </a:r>
@@ -11948,9 +11946,9 @@
                 <a:solidFill>
                   <a:srgbClr val="0B3D66"/>
                 </a:solidFill>
-                <a:latin typeface="Space Grotesk Light" pitchFamily="34" charset="0"/>
-                <a:ea typeface="Space Grotesk Light" pitchFamily="34" charset="-122"/>
-                <a:cs typeface="Space Grotesk Light" pitchFamily="34" charset="-120"/>
+                <a:latin typeface="Arial"/>
+                <a:ea typeface="Arial"/>
+                <a:cs typeface="Arial"/>
               </a:rPr>
               <a:t>Sohil MM et al.  |  Am Heart J Plus 2026;61:100678</a:t>
             </a:r>
@@ -11987,9 +11985,9 @@
                 <a:solidFill>
                   <a:srgbClr val="0B3D66"/>
                 </a:solidFill>
-                <a:latin typeface="Space Grotesk" pitchFamily="34" charset="0"/>
-                <a:ea typeface="Space Grotesk" pitchFamily="34" charset="-122"/>
-                <a:cs typeface="Space Grotesk" pitchFamily="34" charset="-120"/>
+                <a:latin typeface="Arial"/>
+                <a:ea typeface="Arial"/>
+                <a:cs typeface="Arial"/>
               </a:rPr>
               <a:t>3</a:t>
             </a:r>
@@ -12058,9 +12056,9 @@
                 <a:solidFill>
                   <a:srgbClr val="0B3D66"/>
                 </a:solidFill>
-                <a:latin typeface="Space Grotesk" pitchFamily="34" charset="0"/>
-                <a:ea typeface="Space Grotesk" pitchFamily="34" charset="-122"/>
-                <a:cs typeface="Space Grotesk" pitchFamily="34" charset="-120"/>
+                <a:latin typeface="Arial"/>
+                <a:ea typeface="Arial"/>
+                <a:cs typeface="Arial"/>
               </a:rPr>
               <a:t>Prospective study design</a:t>
             </a:r>
@@ -12120,9 +12118,9 @@
                 <a:solidFill>
                   <a:srgbClr val="0B3D66"/>
                 </a:solidFill>
-                <a:latin typeface="Space Grotesk" pitchFamily="34" charset="0"/>
-                <a:ea typeface="Space Grotesk" pitchFamily="34" charset="-122"/>
-                <a:cs typeface="Space Grotesk" pitchFamily="34" charset="-120"/>
+                <a:latin typeface="Arial"/>
+                <a:ea typeface="Arial"/>
+                <a:cs typeface="Arial"/>
               </a:rPr>
               <a:t>45</a:t>
             </a:r>
@@ -12159,11 +12157,32 @@
                 <a:solidFill>
                   <a:srgbClr val="000000"/>
                 </a:solidFill>
-                <a:latin typeface="Space Grotesk Light" pitchFamily="34" charset="0"/>
-                <a:ea typeface="Space Grotesk Light" pitchFamily="34" charset="-122"/>
-                <a:cs typeface="Space Grotesk Light" pitchFamily="34" charset="-120"/>
+                <a:latin typeface="Arial"/>
+                <a:ea typeface="Arial"/>
+                <a:cs typeface="Arial"/>
               </a:rPr>
-              <a:t>consecutive patients, rota LM-PCI</a:t>
+              <a:t>consecutive patients,</a:t>
+            </a:r>
+            <a:br>
+              <a:rPr lang="en-US" sz="2400" dirty="0">
+                <a:solidFill>
+                  <a:srgbClr val="000000"/>
+                </a:solidFill>
+                <a:latin typeface="Arial"/>
+                <a:ea typeface="Arial"/>
+                <a:cs typeface="Arial"/>
+              </a:rPr>
+            </a:br>
+            <a:r>
+              <a:rPr lang="en-US" sz="2400" dirty="0">
+                <a:solidFill>
+                  <a:srgbClr val="000000"/>
+                </a:solidFill>
+                <a:latin typeface="Arial"/>
+                <a:ea typeface="Arial"/>
+                <a:cs typeface="Arial"/>
+              </a:rPr>
+              <a:t>rota LM-PCI</a:t>
             </a:r>
             <a:endParaRPr lang="en-US" sz="2400" dirty="0"/>
           </a:p>
@@ -12221,9 +12240,9 @@
                 <a:solidFill>
                   <a:srgbClr val="0B3D66"/>
                 </a:solidFill>
-                <a:latin typeface="Space Grotesk" pitchFamily="34" charset="0"/>
-                <a:ea typeface="Space Grotesk" pitchFamily="34" charset="-122"/>
-                <a:cs typeface="Space Grotesk" pitchFamily="34" charset="-120"/>
+                <a:latin typeface="Arial"/>
+                <a:ea typeface="Arial"/>
+                <a:cs typeface="Arial"/>
               </a:rPr>
               <a:t>2020–23</a:t>
             </a:r>
@@ -12260,9 +12279,9 @@
                 <a:solidFill>
                   <a:srgbClr val="000000"/>
                 </a:solidFill>
-                <a:latin typeface="Space Grotesk Light" pitchFamily="34" charset="0"/>
-                <a:ea typeface="Space Grotesk Light" pitchFamily="34" charset="-122"/>
-                <a:cs typeface="Space Grotesk Light" pitchFamily="34" charset="-120"/>
+                <a:latin typeface="Arial"/>
+                <a:ea typeface="Arial"/>
+                <a:cs typeface="Arial"/>
               </a:rPr>
               <a:t>enrolled Jan 2020 – Jan 2023</a:t>
             </a:r>
@@ -12322,9 +12341,9 @@
                 <a:solidFill>
                   <a:srgbClr val="C8102E"/>
                 </a:solidFill>
-                <a:latin typeface="Space Grotesk" pitchFamily="34" charset="0"/>
-                <a:ea typeface="Space Grotesk" pitchFamily="34" charset="-122"/>
-                <a:cs typeface="Space Grotesk" pitchFamily="34" charset="-120"/>
+                <a:latin typeface="Arial"/>
+                <a:ea typeface="Arial"/>
+                <a:cs typeface="Arial"/>
               </a:rPr>
               <a:t>2 years</a:t>
             </a:r>
@@ -12361,9 +12380,9 @@
                 <a:solidFill>
                   <a:srgbClr val="000000"/>
                 </a:solidFill>
-                <a:latin typeface="Space Grotesk Light" pitchFamily="34" charset="0"/>
-                <a:ea typeface="Space Grotesk Light" pitchFamily="34" charset="-122"/>
-                <a:cs typeface="Space Grotesk Light" pitchFamily="34" charset="-120"/>
+                <a:latin typeface="Arial"/>
+                <a:ea typeface="Arial"/>
+                <a:cs typeface="Arial"/>
               </a:rPr>
               <a:t>follow-up, 100% complete</a:t>
             </a:r>
@@ -12547,9 +12566,9 @@
                 <a:solidFill>
                   <a:srgbClr val="0B3D66"/>
                 </a:solidFill>
-                <a:latin typeface="Space Grotesk Light" pitchFamily="34" charset="0"/>
-                <a:ea typeface="Space Grotesk Light" pitchFamily="34" charset="-122"/>
-                <a:cs typeface="Space Grotesk Light" pitchFamily="34" charset="-120"/>
+                <a:latin typeface="Arial"/>
+                <a:ea typeface="Arial"/>
+                <a:cs typeface="Arial"/>
               </a:rPr>
               <a:t>Sohil MM et al.  |  Am Heart J Plus 2026;61:100678</a:t>
             </a:r>
@@ -12586,9 +12605,9 @@
                 <a:solidFill>
                   <a:srgbClr val="0B3D66"/>
                 </a:solidFill>
-                <a:latin typeface="Space Grotesk" pitchFamily="34" charset="0"/>
-                <a:ea typeface="Space Grotesk" pitchFamily="34" charset="-122"/>
-                <a:cs typeface="Space Grotesk" pitchFamily="34" charset="-120"/>
+                <a:latin typeface="Arial"/>
+                <a:ea typeface="Arial"/>
+                <a:cs typeface="Arial"/>
               </a:rPr>
               <a:t>4</a:t>
             </a:r>
@@ -12657,9 +12676,9 @@
                 <a:solidFill>
                   <a:srgbClr val="0B3D66"/>
                 </a:solidFill>
-                <a:latin typeface="Space Grotesk" pitchFamily="34" charset="0"/>
-                <a:ea typeface="Space Grotesk" pitchFamily="34" charset="-122"/>
-                <a:cs typeface="Space Grotesk" pitchFamily="34" charset="-120"/>
+                <a:latin typeface="Arial"/>
+                <a:ea typeface="Arial"/>
+                <a:cs typeface="Arial"/>
               </a:rPr>
               <a:t>Elderly, high-risk cohort</a:t>
             </a:r>
@@ -12699,7 +12718,7 @@
           <p:nvPr>
             <p:extLst>
               <p:ext uri="{D42A27DB-BD31-4B8C-83A1-F6EECF244321}">
-                <p14:modId xmlns:p14="http://schemas.microsoft.com/office/powerpoint/2010/main" val="1579011935"/>
+                <p14:modId xmlns:p14="http://schemas.microsoft.com/office/powerpoint/2010/main" val="2845048858"/>
               </p:ext>
             </p:extLst>
           </p:nvPr>
@@ -12732,16 +12751,16 @@
                           <a:solidFill>
                             <a:srgbClr val="FFFFFF"/>
                           </a:solidFill>
-                          <a:latin typeface="Space Grotesk" pitchFamily="34" charset="0"/>
-                          <a:ea typeface="Space Grotesk" pitchFamily="34" charset="-122"/>
-                          <a:cs typeface="Space Grotesk" pitchFamily="34" charset="-120"/>
+                          <a:latin typeface="Arial"/>
+                          <a:ea typeface="Arial"/>
+                          <a:cs typeface="Arial"/>
                         </a:rPr>
                         <a:t>Clinical profile</a:t>
                       </a:r>
                       <a:endParaRPr lang="en-US" sz="2200" dirty="0">
-                        <a:latin typeface="Space Grotesk" charset="0"/>
-                        <a:ea typeface="Space Grotesk" charset="0"/>
-                        <a:cs typeface="Space Grotesk" charset="0"/>
+                        <a:latin typeface="Arial"/>
+                        <a:ea typeface="Arial"/>
+                        <a:cs typeface="Arial"/>
                       </a:endParaRPr>
                     </a:p>
                   </a:txBody>
@@ -12800,16 +12819,16 @@
                           <a:solidFill>
                             <a:srgbClr val="FFFFFF"/>
                           </a:solidFill>
-                          <a:latin typeface="Space Grotesk" pitchFamily="34" charset="0"/>
-                          <a:ea typeface="Space Grotesk" pitchFamily="34" charset="-122"/>
-                          <a:cs typeface="Space Grotesk" pitchFamily="34" charset="-120"/>
+                          <a:latin typeface="Arial"/>
+                          <a:ea typeface="Arial"/>
+                          <a:cs typeface="Arial"/>
                         </a:rPr>
                         <a:t>Value</a:t>
                       </a:r>
                       <a:endParaRPr lang="en-US" sz="2200" dirty="0">
-                        <a:latin typeface="Space Grotesk" charset="0"/>
-                        <a:ea typeface="Space Grotesk" charset="0"/>
-                        <a:cs typeface="Space Grotesk" charset="0"/>
+                        <a:latin typeface="Arial"/>
+                        <a:ea typeface="Arial"/>
+                        <a:cs typeface="Arial"/>
                       </a:endParaRPr>
                     </a:p>
                   </a:txBody>
@@ -12868,16 +12887,16 @@
                           <a:solidFill>
                             <a:srgbClr val="FFFFFF"/>
                           </a:solidFill>
-                          <a:latin typeface="Space Grotesk" pitchFamily="34" charset="0"/>
-                          <a:ea typeface="Space Grotesk" pitchFamily="34" charset="-122"/>
-                          <a:cs typeface="Space Grotesk" pitchFamily="34" charset="-120"/>
+                          <a:latin typeface="Arial"/>
+                          <a:ea typeface="Arial"/>
+                          <a:cs typeface="Arial"/>
                         </a:rPr>
                         <a:t>Risk / history</a:t>
                       </a:r>
                       <a:endParaRPr lang="en-US" sz="2200" dirty="0">
-                        <a:latin typeface="Space Grotesk" charset="0"/>
-                        <a:ea typeface="Space Grotesk" charset="0"/>
-                        <a:cs typeface="Space Grotesk" charset="0"/>
+                        <a:latin typeface="Arial"/>
+                        <a:ea typeface="Arial"/>
+                        <a:cs typeface="Arial"/>
                       </a:endParaRPr>
                     </a:p>
                   </a:txBody>
@@ -12936,16 +12955,16 @@
                           <a:solidFill>
                             <a:srgbClr val="FFFFFF"/>
                           </a:solidFill>
-                          <a:latin typeface="Space Grotesk" pitchFamily="34" charset="0"/>
-                          <a:ea typeface="Space Grotesk" pitchFamily="34" charset="-122"/>
-                          <a:cs typeface="Space Grotesk" pitchFamily="34" charset="-120"/>
+                          <a:latin typeface="Arial"/>
+                          <a:ea typeface="Arial"/>
+                          <a:cs typeface="Arial"/>
                         </a:rPr>
                         <a:t>n (%)</a:t>
                       </a:r>
                       <a:endParaRPr lang="en-US" sz="2200" dirty="0">
-                        <a:latin typeface="Space Grotesk" charset="0"/>
-                        <a:ea typeface="Space Grotesk" charset="0"/>
-                        <a:cs typeface="Space Grotesk" charset="0"/>
+                        <a:latin typeface="Arial"/>
+                        <a:ea typeface="Arial"/>
+                        <a:cs typeface="Arial"/>
                       </a:endParaRPr>
                     </a:p>
                   </a:txBody>
@@ -13006,16 +13025,16 @@
                           <a:solidFill>
                             <a:srgbClr val="000000"/>
                           </a:solidFill>
-                          <a:latin typeface="Space Grotesk Light" pitchFamily="34" charset="0"/>
-                          <a:ea typeface="Space Grotesk Light" pitchFamily="34" charset="-122"/>
-                          <a:cs typeface="Space Grotesk Light" pitchFamily="34" charset="-120"/>
+                          <a:latin typeface="Arial"/>
+                          <a:ea typeface="Arial"/>
+                          <a:cs typeface="Arial"/>
                         </a:rPr>
                         <a:t>Age (years)</a:t>
                       </a:r>
                       <a:endParaRPr lang="en-US" sz="2200" dirty="0">
-                        <a:latin typeface="Space Grotesk Light" charset="0"/>
-                        <a:ea typeface="Space Grotesk Light" charset="0"/>
-                        <a:cs typeface="Space Grotesk Light" charset="0"/>
+                        <a:latin typeface="Arial"/>
+                        <a:ea typeface="Arial"/>
+                        <a:cs typeface="Arial"/>
                       </a:endParaRPr>
                     </a:p>
                   </a:txBody>
@@ -13071,16 +13090,16 @@
                           <a:solidFill>
                             <a:srgbClr val="000000"/>
                           </a:solidFill>
-                          <a:latin typeface="Space Grotesk Light" pitchFamily="34" charset="0"/>
-                          <a:ea typeface="Space Grotesk Light" pitchFamily="34" charset="-122"/>
-                          <a:cs typeface="Space Grotesk Light" pitchFamily="34" charset="-120"/>
+                          <a:latin typeface="Arial"/>
+                          <a:ea typeface="Arial"/>
+                          <a:cs typeface="Arial"/>
                         </a:rPr>
                         <a:t>75.2 ± 5.9</a:t>
                       </a:r>
                       <a:endParaRPr lang="en-US" sz="2200" dirty="0">
-                        <a:latin typeface="Space Grotesk Light" charset="0"/>
-                        <a:ea typeface="Space Grotesk Light" charset="0"/>
-                        <a:cs typeface="Space Grotesk Light" charset="0"/>
+                        <a:latin typeface="Arial"/>
+                        <a:ea typeface="Arial"/>
+                        <a:cs typeface="Arial"/>
                       </a:endParaRPr>
                     </a:p>
                   </a:txBody>
@@ -13136,16 +13155,16 @@
                           <a:solidFill>
                             <a:srgbClr val="000000"/>
                           </a:solidFill>
-                          <a:latin typeface="Space Grotesk Light" pitchFamily="34" charset="0"/>
-                          <a:ea typeface="Space Grotesk Light" pitchFamily="34" charset="-122"/>
-                          <a:cs typeface="Space Grotesk Light" pitchFamily="34" charset="-120"/>
+                          <a:latin typeface="Arial"/>
+                          <a:ea typeface="Arial"/>
+                          <a:cs typeface="Arial"/>
                         </a:rPr>
                         <a:t>Hypertension</a:t>
                       </a:r>
                       <a:endParaRPr lang="en-US" sz="2200" dirty="0">
-                        <a:latin typeface="Space Grotesk Light" charset="0"/>
-                        <a:ea typeface="Space Grotesk Light" charset="0"/>
-                        <a:cs typeface="Space Grotesk Light" charset="0"/>
+                        <a:latin typeface="Arial"/>
+                        <a:ea typeface="Arial"/>
+                        <a:cs typeface="Arial"/>
                       </a:endParaRPr>
                     </a:p>
                   </a:txBody>
@@ -13201,16 +13220,16 @@
                           <a:solidFill>
                             <a:srgbClr val="000000"/>
                           </a:solidFill>
-                          <a:latin typeface="Space Grotesk Light" pitchFamily="34" charset="0"/>
-                          <a:ea typeface="Space Grotesk Light" pitchFamily="34" charset="-122"/>
-                          <a:cs typeface="Space Grotesk Light" pitchFamily="34" charset="-120"/>
+                          <a:latin typeface="Arial"/>
+                          <a:ea typeface="Arial"/>
+                          <a:cs typeface="Arial"/>
                         </a:rPr>
                         <a:t>38 (84.4%)</a:t>
                       </a:r>
                       <a:endParaRPr lang="en-US" sz="2200" dirty="0">
-                        <a:latin typeface="Space Grotesk Light" charset="0"/>
-                        <a:ea typeface="Space Grotesk Light" charset="0"/>
-                        <a:cs typeface="Space Grotesk Light" charset="0"/>
+                        <a:latin typeface="Arial"/>
+                        <a:ea typeface="Arial"/>
+                        <a:cs typeface="Arial"/>
                       </a:endParaRPr>
                     </a:p>
                   </a:txBody>
@@ -13268,16 +13287,16 @@
                           <a:solidFill>
                             <a:srgbClr val="000000"/>
                           </a:solidFill>
-                          <a:latin typeface="Space Grotesk Light" pitchFamily="34" charset="0"/>
-                          <a:ea typeface="Space Grotesk Light" pitchFamily="34" charset="-122"/>
-                          <a:cs typeface="Space Grotesk Light" pitchFamily="34" charset="-120"/>
+                          <a:latin typeface="Arial"/>
+                          <a:ea typeface="Arial"/>
+                          <a:cs typeface="Arial"/>
                         </a:rPr>
                         <a:t>Male</a:t>
                       </a:r>
                       <a:endParaRPr lang="en-US" sz="2200" dirty="0">
-                        <a:latin typeface="Space Grotesk Light" charset="0"/>
-                        <a:ea typeface="Space Grotesk Light" charset="0"/>
-                        <a:cs typeface="Space Grotesk Light" charset="0"/>
+                        <a:latin typeface="Arial"/>
+                        <a:ea typeface="Arial"/>
+                        <a:cs typeface="Arial"/>
                       </a:endParaRPr>
                     </a:p>
                   </a:txBody>
@@ -13336,16 +13355,16 @@
                           <a:solidFill>
                             <a:srgbClr val="000000"/>
                           </a:solidFill>
-                          <a:latin typeface="Space Grotesk Light" pitchFamily="34" charset="0"/>
-                          <a:ea typeface="Space Grotesk Light" pitchFamily="34" charset="-122"/>
-                          <a:cs typeface="Space Grotesk Light" pitchFamily="34" charset="-120"/>
+                          <a:latin typeface="Arial"/>
+                          <a:ea typeface="Arial"/>
+                          <a:cs typeface="Arial"/>
                         </a:rPr>
                         <a:t>31 (68.9%)</a:t>
                       </a:r>
                       <a:endParaRPr lang="en-US" sz="2200" dirty="0">
-                        <a:latin typeface="Space Grotesk Light" charset="0"/>
-                        <a:ea typeface="Space Grotesk Light" charset="0"/>
-                        <a:cs typeface="Space Grotesk Light" charset="0"/>
+                        <a:latin typeface="Arial"/>
+                        <a:ea typeface="Arial"/>
+                        <a:cs typeface="Arial"/>
                       </a:endParaRPr>
                     </a:p>
                   </a:txBody>
@@ -13404,16 +13423,16 @@
                           <a:solidFill>
                             <a:srgbClr val="000000"/>
                           </a:solidFill>
-                          <a:latin typeface="Space Grotesk Light" pitchFamily="34" charset="0"/>
-                          <a:ea typeface="Space Grotesk Light" pitchFamily="34" charset="-122"/>
-                          <a:cs typeface="Space Grotesk Light" pitchFamily="34" charset="-120"/>
+                          <a:latin typeface="Arial"/>
+                          <a:ea typeface="Arial"/>
+                          <a:cs typeface="Arial"/>
                         </a:rPr>
                         <a:t>Diabetes</a:t>
                       </a:r>
                       <a:endParaRPr lang="en-US" sz="2200" dirty="0">
-                        <a:latin typeface="Space Grotesk Light" charset="0"/>
-                        <a:ea typeface="Space Grotesk Light" charset="0"/>
-                        <a:cs typeface="Space Grotesk Light" charset="0"/>
+                        <a:latin typeface="Arial"/>
+                        <a:ea typeface="Arial"/>
+                        <a:cs typeface="Arial"/>
                       </a:endParaRPr>
                     </a:p>
                   </a:txBody>
@@ -13472,16 +13491,16 @@
                           <a:solidFill>
                             <a:srgbClr val="000000"/>
                           </a:solidFill>
-                          <a:latin typeface="Space Grotesk Light" pitchFamily="34" charset="0"/>
-                          <a:ea typeface="Space Grotesk Light" pitchFamily="34" charset="-122"/>
-                          <a:cs typeface="Space Grotesk Light" pitchFamily="34" charset="-120"/>
+                          <a:latin typeface="Arial"/>
+                          <a:ea typeface="Arial"/>
+                          <a:cs typeface="Arial"/>
                         </a:rPr>
                         <a:t>25 (55.6%)</a:t>
                       </a:r>
                       <a:endParaRPr lang="en-US" sz="2200" dirty="0">
-                        <a:latin typeface="Space Grotesk Light" charset="0"/>
-                        <a:ea typeface="Space Grotesk Light" charset="0"/>
-                        <a:cs typeface="Space Grotesk Light" charset="0"/>
+                        <a:latin typeface="Arial"/>
+                        <a:ea typeface="Arial"/>
+                        <a:cs typeface="Arial"/>
                       </a:endParaRPr>
                     </a:p>
                   </a:txBody>
@@ -13542,16 +13561,16 @@
                           <a:solidFill>
                             <a:srgbClr val="000000"/>
                           </a:solidFill>
-                          <a:latin typeface="Space Grotesk Light" pitchFamily="34" charset="0"/>
-                          <a:ea typeface="Space Grotesk Light" pitchFamily="34" charset="-122"/>
-                          <a:cs typeface="Space Grotesk Light" pitchFamily="34" charset="-120"/>
+                          <a:latin typeface="Arial"/>
+                          <a:ea typeface="Arial"/>
+                          <a:cs typeface="Arial"/>
                         </a:rPr>
                         <a:t>LVEF (%)</a:t>
                       </a:r>
                       <a:endParaRPr lang="en-US" sz="2200" dirty="0">
-                        <a:latin typeface="Space Grotesk Light" charset="0"/>
-                        <a:ea typeface="Space Grotesk Light" charset="0"/>
-                        <a:cs typeface="Space Grotesk Light" charset="0"/>
+                        <a:latin typeface="Arial"/>
+                        <a:ea typeface="Arial"/>
+                        <a:cs typeface="Arial"/>
                       </a:endParaRPr>
                     </a:p>
                   </a:txBody>
@@ -13607,16 +13626,16 @@
                           <a:solidFill>
                             <a:srgbClr val="000000"/>
                           </a:solidFill>
-                          <a:latin typeface="Space Grotesk Light" pitchFamily="34" charset="0"/>
-                          <a:ea typeface="Space Grotesk Light" pitchFamily="34" charset="-122"/>
-                          <a:cs typeface="Space Grotesk Light" pitchFamily="34" charset="-120"/>
+                          <a:latin typeface="Arial"/>
+                          <a:ea typeface="Arial"/>
+                          <a:cs typeface="Arial"/>
                         </a:rPr>
                         <a:t>43.3 ± 8.1</a:t>
                       </a:r>
                       <a:endParaRPr lang="en-US" sz="2200" dirty="0">
-                        <a:latin typeface="Space Grotesk Light" charset="0"/>
-                        <a:ea typeface="Space Grotesk Light" charset="0"/>
-                        <a:cs typeface="Space Grotesk Light" charset="0"/>
+                        <a:latin typeface="Arial"/>
+                        <a:ea typeface="Arial"/>
+                        <a:cs typeface="Arial"/>
                       </a:endParaRPr>
                     </a:p>
                   </a:txBody>
@@ -13672,16 +13691,16 @@
                           <a:solidFill>
                             <a:srgbClr val="000000"/>
                           </a:solidFill>
-                          <a:latin typeface="Space Grotesk Light" pitchFamily="34" charset="0"/>
-                          <a:ea typeface="Space Grotesk Light" pitchFamily="34" charset="-122"/>
-                          <a:cs typeface="Space Grotesk Light" pitchFamily="34" charset="-120"/>
+                          <a:latin typeface="Arial"/>
+                          <a:ea typeface="Arial"/>
+                          <a:cs typeface="Arial"/>
                         </a:rPr>
                         <a:t>Previous PCI</a:t>
                       </a:r>
                       <a:endParaRPr lang="en-US" sz="2200" dirty="0">
-                        <a:latin typeface="Space Grotesk Light" charset="0"/>
-                        <a:ea typeface="Space Grotesk Light" charset="0"/>
-                        <a:cs typeface="Space Grotesk Light" charset="0"/>
+                        <a:latin typeface="Arial"/>
+                        <a:ea typeface="Arial"/>
+                        <a:cs typeface="Arial"/>
                       </a:endParaRPr>
                     </a:p>
                   </a:txBody>
@@ -13737,16 +13756,16 @@
                           <a:solidFill>
                             <a:srgbClr val="000000"/>
                           </a:solidFill>
-                          <a:latin typeface="Space Grotesk Light" pitchFamily="34" charset="0"/>
-                          <a:ea typeface="Space Grotesk Light" pitchFamily="34" charset="-122"/>
-                          <a:cs typeface="Space Grotesk Light" pitchFamily="34" charset="-120"/>
+                          <a:latin typeface="Arial"/>
+                          <a:ea typeface="Arial"/>
+                          <a:cs typeface="Arial"/>
                         </a:rPr>
                         <a:t>15 (33.3%)</a:t>
                       </a:r>
                       <a:endParaRPr lang="en-US" sz="2200" dirty="0">
-                        <a:latin typeface="Space Grotesk Light" charset="0"/>
-                        <a:ea typeface="Space Grotesk Light" charset="0"/>
-                        <a:cs typeface="Space Grotesk Light" charset="0"/>
+                        <a:latin typeface="Arial"/>
+                        <a:ea typeface="Arial"/>
+                        <a:cs typeface="Arial"/>
                       </a:endParaRPr>
                     </a:p>
                   </a:txBody>
@@ -13804,16 +13823,16 @@
                           <a:solidFill>
                             <a:srgbClr val="000000"/>
                           </a:solidFill>
-                          <a:latin typeface="Space Grotesk Light" pitchFamily="34" charset="0"/>
-                          <a:ea typeface="Space Grotesk Light" pitchFamily="34" charset="-122"/>
-                          <a:cs typeface="Space Grotesk Light" pitchFamily="34" charset="-120"/>
+                          <a:latin typeface="Arial"/>
+                          <a:ea typeface="Arial"/>
+                          <a:cs typeface="Arial"/>
                         </a:rPr>
                         <a:t>SYNTAX score</a:t>
                       </a:r>
                       <a:endParaRPr lang="en-US" sz="2200" dirty="0">
-                        <a:latin typeface="Space Grotesk Light" charset="0"/>
-                        <a:ea typeface="Space Grotesk Light" charset="0"/>
-                        <a:cs typeface="Space Grotesk Light" charset="0"/>
+                        <a:latin typeface="Arial"/>
+                        <a:ea typeface="Arial"/>
+                        <a:cs typeface="Arial"/>
                       </a:endParaRPr>
                     </a:p>
                   </a:txBody>
@@ -13872,16 +13891,16 @@
                           <a:solidFill>
                             <a:srgbClr val="000000"/>
                           </a:solidFill>
-                          <a:latin typeface="Space Grotesk Light" pitchFamily="34" charset="0"/>
-                          <a:ea typeface="Space Grotesk Light" pitchFamily="34" charset="-122"/>
-                          <a:cs typeface="Space Grotesk Light" pitchFamily="34" charset="-120"/>
+                          <a:latin typeface="Arial"/>
+                          <a:ea typeface="Arial"/>
+                          <a:cs typeface="Arial"/>
                         </a:rPr>
                         <a:t>40.1 ± 8.2</a:t>
                       </a:r>
                       <a:endParaRPr lang="en-US" sz="2200" dirty="0">
-                        <a:latin typeface="Space Grotesk Light" charset="0"/>
-                        <a:ea typeface="Space Grotesk Light" charset="0"/>
-                        <a:cs typeface="Space Grotesk Light" charset="0"/>
+                        <a:latin typeface="Arial"/>
+                        <a:ea typeface="Arial"/>
+                        <a:cs typeface="Arial"/>
                       </a:endParaRPr>
                     </a:p>
                   </a:txBody>
@@ -13940,16 +13959,16 @@
                           <a:solidFill>
                             <a:srgbClr val="000000"/>
                           </a:solidFill>
-                          <a:latin typeface="Space Grotesk Light" pitchFamily="34" charset="0"/>
-                          <a:ea typeface="Space Grotesk Light" pitchFamily="34" charset="-122"/>
-                          <a:cs typeface="Space Grotesk Light" pitchFamily="34" charset="-120"/>
+                          <a:latin typeface="Arial"/>
+                          <a:ea typeface="Arial"/>
+                          <a:cs typeface="Arial"/>
                         </a:rPr>
                         <a:t>Previous CABG</a:t>
                       </a:r>
                       <a:endParaRPr lang="en-US" sz="2200" dirty="0">
-                        <a:latin typeface="Space Grotesk Light" charset="0"/>
-                        <a:ea typeface="Space Grotesk Light" charset="0"/>
-                        <a:cs typeface="Space Grotesk Light" charset="0"/>
+                        <a:latin typeface="Arial"/>
+                        <a:ea typeface="Arial"/>
+                        <a:cs typeface="Arial"/>
                       </a:endParaRPr>
                     </a:p>
                   </a:txBody>
@@ -14008,16 +14027,16 @@
                           <a:solidFill>
                             <a:srgbClr val="000000"/>
                           </a:solidFill>
-                          <a:latin typeface="Space Grotesk Light" pitchFamily="34" charset="0"/>
-                          <a:ea typeface="Space Grotesk Light" pitchFamily="34" charset="-122"/>
-                          <a:cs typeface="Space Grotesk Light" pitchFamily="34" charset="-120"/>
+                          <a:latin typeface="Arial"/>
+                          <a:ea typeface="Arial"/>
+                          <a:cs typeface="Arial"/>
                         </a:rPr>
                         <a:t>11 (24.4%)</a:t>
                       </a:r>
                       <a:endParaRPr lang="en-US" sz="2200" dirty="0">
-                        <a:latin typeface="Space Grotesk Light" charset="0"/>
-                        <a:ea typeface="Space Grotesk Light" charset="0"/>
-                        <a:cs typeface="Space Grotesk Light" charset="0"/>
+                        <a:latin typeface="Arial"/>
+                        <a:ea typeface="Arial"/>
+                        <a:cs typeface="Arial"/>
                       </a:endParaRPr>
                     </a:p>
                   </a:txBody>
@@ -14078,16 +14097,16 @@
                           <a:solidFill>
                             <a:srgbClr val="000000"/>
                           </a:solidFill>
-                          <a:latin typeface="Space Grotesk Light" pitchFamily="34" charset="0"/>
-                          <a:ea typeface="Space Grotesk Light" pitchFamily="34" charset="-122"/>
-                          <a:cs typeface="Space Grotesk Light" pitchFamily="34" charset="-120"/>
+                          <a:latin typeface="Arial"/>
+                          <a:ea typeface="Arial"/>
+                          <a:cs typeface="Arial"/>
                         </a:rPr>
                         <a:t>EuroSCORE II</a:t>
                       </a:r>
                       <a:endParaRPr lang="en-US" sz="2200" dirty="0">
-                        <a:latin typeface="Space Grotesk Light" charset="0"/>
-                        <a:ea typeface="Space Grotesk Light" charset="0"/>
-                        <a:cs typeface="Space Grotesk Light" charset="0"/>
+                        <a:latin typeface="Arial"/>
+                        <a:ea typeface="Arial"/>
+                        <a:cs typeface="Arial"/>
                       </a:endParaRPr>
                     </a:p>
                   </a:txBody>
@@ -14143,16 +14162,16 @@
                           <a:solidFill>
                             <a:srgbClr val="000000"/>
                           </a:solidFill>
-                          <a:latin typeface="Space Grotesk Light" pitchFamily="34" charset="0"/>
-                          <a:ea typeface="Space Grotesk Light" pitchFamily="34" charset="-122"/>
-                          <a:cs typeface="Space Grotesk Light" pitchFamily="34" charset="-120"/>
+                          <a:latin typeface="Arial"/>
+                          <a:ea typeface="Arial"/>
+                          <a:cs typeface="Arial"/>
                         </a:rPr>
                         <a:t>5.4 ± 1.9</a:t>
                       </a:r>
                       <a:endParaRPr lang="en-US" sz="2200" dirty="0">
-                        <a:latin typeface="Space Grotesk Light" charset="0"/>
-                        <a:ea typeface="Space Grotesk Light" charset="0"/>
-                        <a:cs typeface="Space Grotesk Light" charset="0"/>
+                        <a:latin typeface="Arial"/>
+                        <a:ea typeface="Arial"/>
+                        <a:cs typeface="Arial"/>
                       </a:endParaRPr>
                     </a:p>
                   </a:txBody>
@@ -14208,16 +14227,16 @@
                           <a:solidFill>
                             <a:srgbClr val="000000"/>
                           </a:solidFill>
-                          <a:latin typeface="Space Grotesk Light" pitchFamily="34" charset="0"/>
-                          <a:ea typeface="Space Grotesk Light" pitchFamily="34" charset="-122"/>
-                          <a:cs typeface="Space Grotesk Light" pitchFamily="34" charset="-120"/>
+                          <a:latin typeface="Arial"/>
+                          <a:ea typeface="Arial"/>
+                          <a:cs typeface="Arial"/>
                         </a:rPr>
                         <a:t>NSTEMI</a:t>
                       </a:r>
                       <a:endParaRPr lang="en-US" sz="2200" dirty="0">
-                        <a:latin typeface="Space Grotesk Light" charset="0"/>
-                        <a:ea typeface="Space Grotesk Light" charset="0"/>
-                        <a:cs typeface="Space Grotesk Light" charset="0"/>
+                        <a:latin typeface="Arial"/>
+                        <a:ea typeface="Arial"/>
+                        <a:cs typeface="Arial"/>
                       </a:endParaRPr>
                     </a:p>
                   </a:txBody>
@@ -14273,16 +14292,16 @@
                           <a:solidFill>
                             <a:srgbClr val="000000"/>
                           </a:solidFill>
-                          <a:latin typeface="Space Grotesk Light" pitchFamily="34" charset="0"/>
-                          <a:ea typeface="Space Grotesk Light" pitchFamily="34" charset="-122"/>
-                          <a:cs typeface="Space Grotesk Light" pitchFamily="34" charset="-120"/>
+                          <a:latin typeface="Arial"/>
+                          <a:ea typeface="Arial"/>
+                          <a:cs typeface="Arial"/>
                         </a:rPr>
                         <a:t>24 (53.3%)</a:t>
                       </a:r>
                       <a:endParaRPr lang="en-US" sz="2200" dirty="0">
-                        <a:latin typeface="Space Grotesk Light" charset="0"/>
-                        <a:ea typeface="Space Grotesk Light" charset="0"/>
-                        <a:cs typeface="Space Grotesk Light" charset="0"/>
+                        <a:latin typeface="Arial"/>
+                        <a:ea typeface="Arial"/>
+                        <a:cs typeface="Arial"/>
                       </a:endParaRPr>
                     </a:p>
                   </a:txBody>
@@ -14506,9 +14525,9 @@
                 <a:solidFill>
                   <a:srgbClr val="0B3D66"/>
                 </a:solidFill>
-                <a:latin typeface="Space Grotesk Light" pitchFamily="34" charset="0"/>
-                <a:ea typeface="Space Grotesk Light" pitchFamily="34" charset="-122"/>
-                <a:cs typeface="Space Grotesk Light" pitchFamily="34" charset="-120"/>
+                <a:latin typeface="Arial"/>
+                <a:ea typeface="Arial"/>
+                <a:cs typeface="Arial"/>
               </a:rPr>
               <a:t>Sohil MM et al.  |  Am Heart J Plus 2026;61:100678</a:t>
             </a:r>
@@ -14545,9 +14564,9 @@
                 <a:solidFill>
                   <a:srgbClr val="0B3D66"/>
                 </a:solidFill>
-                <a:latin typeface="Space Grotesk" pitchFamily="34" charset="0"/>
-                <a:ea typeface="Space Grotesk" pitchFamily="34" charset="-122"/>
-                <a:cs typeface="Space Grotesk" pitchFamily="34" charset="-120"/>
+                <a:latin typeface="Arial"/>
+                <a:ea typeface="Arial"/>
+                <a:cs typeface="Arial"/>
               </a:rPr>
               <a:t>8</a:t>
             </a:r>
@@ -14616,9 +14635,9 @@
                 <a:solidFill>
                   <a:srgbClr val="0B3D66"/>
                 </a:solidFill>
-                <a:latin typeface="Space Grotesk" pitchFamily="34" charset="0"/>
-                <a:ea typeface="Space Grotesk" pitchFamily="34" charset="-122"/>
-                <a:cs typeface="Space Grotesk" pitchFamily="34" charset="-120"/>
+                <a:latin typeface="Arial"/>
+                <a:ea typeface="Arial"/>
+                <a:cs typeface="Arial"/>
               </a:rPr>
               <a:t>Mostly LM + 3-vessel CAD</a:t>
             </a:r>
@@ -14714,9 +14733,9 @@
                 <a:solidFill>
                   <a:srgbClr val="C8102E"/>
                 </a:solidFill>
-                <a:latin typeface="Space Grotesk" pitchFamily="34" charset="0"/>
-                <a:ea typeface="Space Grotesk" pitchFamily="34" charset="-122"/>
-                <a:cs typeface="Space Grotesk" pitchFamily="34" charset="-120"/>
+                <a:latin typeface="Arial"/>
+                <a:ea typeface="Arial"/>
+                <a:cs typeface="Arial"/>
               </a:rPr>
               <a:t>86.7%</a:t>
             </a:r>
@@ -14731,9 +14750,9 @@
                 <a:solidFill>
                   <a:srgbClr val="000000"/>
                 </a:solidFill>
-                <a:latin typeface="Space Grotesk Light" pitchFamily="34" charset="0"/>
-                <a:ea typeface="Space Grotesk Light" pitchFamily="34" charset="-122"/>
-                <a:cs typeface="Space Grotesk Light" pitchFamily="34" charset="-120"/>
+                <a:latin typeface="Arial"/>
+                <a:ea typeface="Arial"/>
+                <a:cs typeface="Arial"/>
               </a:rPr>
               <a:t>severe LMCA calcification</a:t>
             </a:r>
@@ -14751,9 +14770,9 @@
                 <a:solidFill>
                   <a:srgbClr val="C8102E"/>
                 </a:solidFill>
-                <a:latin typeface="Space Grotesk" pitchFamily="34" charset="0"/>
-                <a:ea typeface="Space Grotesk" pitchFamily="34" charset="-122"/>
-                <a:cs typeface="Space Grotesk" pitchFamily="34" charset="-120"/>
+                <a:latin typeface="Arial"/>
+                <a:ea typeface="Arial"/>
+                <a:cs typeface="Arial"/>
               </a:rPr>
               <a:t>62.2%</a:t>
             </a:r>
@@ -14768,9 +14787,9 @@
                 <a:solidFill>
                   <a:srgbClr val="000000"/>
                 </a:solidFill>
-                <a:latin typeface="Space Grotesk Light" pitchFamily="34" charset="0"/>
-                <a:ea typeface="Space Grotesk Light" pitchFamily="34" charset="-122"/>
-                <a:cs typeface="Space Grotesk Light" pitchFamily="34" charset="-120"/>
+                <a:latin typeface="Arial"/>
+                <a:ea typeface="Arial"/>
+                <a:cs typeface="Arial"/>
               </a:rPr>
               <a:t>distal LMCA lesion</a:t>
             </a:r>
@@ -14954,9 +14973,9 @@
                 <a:solidFill>
                   <a:srgbClr val="0B3D66"/>
                 </a:solidFill>
-                <a:latin typeface="Space Grotesk Light" pitchFamily="34" charset="0"/>
-                <a:ea typeface="Space Grotesk Light" pitchFamily="34" charset="-122"/>
-                <a:cs typeface="Space Grotesk Light" pitchFamily="34" charset="-120"/>
+                <a:latin typeface="Arial"/>
+                <a:ea typeface="Arial"/>
+                <a:cs typeface="Arial"/>
               </a:rPr>
               <a:t>Sohil MM et al.  |  Am Heart J Plus 2026;61:100678</a:t>
             </a:r>
@@ -14993,9 +15012,9 @@
                 <a:solidFill>
                   <a:srgbClr val="0B3D66"/>
                 </a:solidFill>
-                <a:latin typeface="Space Grotesk" pitchFamily="34" charset="0"/>
-                <a:ea typeface="Space Grotesk" pitchFamily="34" charset="-122"/>
-                <a:cs typeface="Space Grotesk" pitchFamily="34" charset="-120"/>
+                <a:latin typeface="Arial"/>
+                <a:ea typeface="Arial"/>
+                <a:cs typeface="Arial"/>
               </a:rPr>
               <a:t>9</a:t>
             </a:r>
@@ -15064,7 +15083,7 @@
           <p:nvPr/>
         </p:nvPicPr>
         <p:blipFill>
-          <a:blip r:embed="rIdFig1"/>
+          <a:blip r:embed="rId3"/>
           <a:stretch>
             <a:fillRect/>
           </a:stretch>
@@ -15113,9 +15132,9 @@
                 <a:solidFill>
                   <a:srgbClr val="0B3D66"/>
                 </a:solidFill>
-                <a:latin typeface="Space Grotesk" pitchFamily="34" charset="0"/>
-                <a:ea typeface="Space Grotesk" pitchFamily="34" charset="-122"/>
-                <a:cs typeface="Space Grotesk" pitchFamily="34" charset="-120"/>
+                <a:latin typeface="Arial"/>
+                <a:ea typeface="Arial"/>
+                <a:cs typeface="Arial"/>
               </a:rPr>
               <a:t>Patient selection (Fig. 1)</a:t>
             </a:r>
@@ -15178,9 +15197,9 @@
                 <a:solidFill>
                   <a:srgbClr val="000000"/>
                 </a:solidFill>
-                <a:latin typeface="Space Grotesk Light" pitchFamily="34" charset="0"/>
-                <a:ea typeface="Space Grotesk Light" pitchFamily="34" charset="-122"/>
-                <a:cs typeface="Space Grotesk Light" pitchFamily="34" charset="-120"/>
+                <a:latin typeface="Arial"/>
+                <a:ea typeface="Arial"/>
+                <a:cs typeface="Arial"/>
               </a:rPr>
               <a:t>Heart team: SYNTAX &gt;32 advised CABG</a:t>
             </a:r>
@@ -15198,9 +15217,9 @@
                 <a:solidFill>
                   <a:srgbClr val="000000"/>
                 </a:solidFill>
-                <a:latin typeface="Space Grotesk Light" pitchFamily="34" charset="0"/>
-                <a:ea typeface="Space Grotesk Light" pitchFamily="34" charset="-122"/>
-                <a:cs typeface="Space Grotesk Light" pitchFamily="34" charset="-120"/>
+                <a:latin typeface="Arial"/>
+                <a:ea typeface="Arial"/>
+                <a:cs typeface="Arial"/>
               </a:rPr>
               <a:t>PCI by patient choice after counselling</a:t>
             </a:r>
@@ -15218,9 +15237,9 @@
                 <a:solidFill>
                   <a:srgbClr val="000000"/>
                 </a:solidFill>
-                <a:latin typeface="Space Grotesk Light" pitchFamily="34" charset="0"/>
-                <a:ea typeface="Space Grotesk Light" pitchFamily="34" charset="-122"/>
-                <a:cs typeface="Space Grotesk Light" pitchFamily="34" charset="-120"/>
+                <a:latin typeface="Arial"/>
+                <a:ea typeface="Arial"/>
+                <a:cs typeface="Arial"/>
               </a:rPr>
               <a:t>LMCA ≥50% + severe Ca or IVUS Ca score ≥2</a:t>
             </a:r>
@@ -15404,9 +15423,9 @@
                 <a:solidFill>
                   <a:srgbClr val="0B3D66"/>
                 </a:solidFill>
-                <a:latin typeface="Space Grotesk Light" pitchFamily="34" charset="0"/>
-                <a:ea typeface="Space Grotesk Light" pitchFamily="34" charset="-122"/>
-                <a:cs typeface="Space Grotesk Light" pitchFamily="34" charset="-120"/>
+                <a:latin typeface="Arial"/>
+                <a:ea typeface="Arial"/>
+                <a:cs typeface="Arial"/>
               </a:rPr>
               <a:t>Sohil MM et al.  |  Am Heart J Plus 2026;61:100678</a:t>
             </a:r>
@@ -15443,9 +15462,9 @@
                 <a:solidFill>
                   <a:srgbClr val="0B3D66"/>
                 </a:solidFill>
-                <a:latin typeface="Space Grotesk" pitchFamily="34" charset="0"/>
-                <a:ea typeface="Space Grotesk" pitchFamily="34" charset="-122"/>
-                <a:cs typeface="Space Grotesk" pitchFamily="34" charset="-120"/>
+                <a:latin typeface="Arial"/>
+                <a:ea typeface="Arial"/>
+                <a:cs typeface="Arial"/>
               </a:rPr>
               <a:t>5</a:t>
             </a:r>
@@ -15514,9 +15533,9 @@
                 <a:solidFill>
                   <a:srgbClr val="0B3D66"/>
                 </a:solidFill>
-                <a:latin typeface="Space Grotesk" pitchFamily="34" charset="0"/>
-                <a:ea typeface="Space Grotesk" pitchFamily="34" charset="-122"/>
-                <a:cs typeface="Space Grotesk" pitchFamily="34" charset="-120"/>
+                <a:latin typeface="Arial"/>
+                <a:ea typeface="Arial"/>
+                <a:cs typeface="Arial"/>
               </a:rPr>
               <a:t>Outcome definitions</a:t>
             </a:r>
@@ -15596,9 +15615,9 @@
                 <a:solidFill>
                   <a:srgbClr val="FFFFFF"/>
                 </a:solidFill>
-                <a:latin typeface="Space Grotesk" pitchFamily="34" charset="0"/>
-                <a:ea typeface="Space Grotesk" pitchFamily="34" charset="-122"/>
-                <a:cs typeface="Space Grotesk" pitchFamily="34" charset="-120"/>
+                <a:latin typeface="Arial"/>
+                <a:ea typeface="Arial"/>
+                <a:cs typeface="Arial"/>
               </a:rPr>
               <a:t>In-hospital</a:t>
             </a:r>
@@ -15638,9 +15657,9 @@
                 <a:solidFill>
                   <a:srgbClr val="000000"/>
                 </a:solidFill>
-                <a:latin typeface="Space Grotesk Light" pitchFamily="34" charset="0"/>
-                <a:ea typeface="Space Grotesk Light" pitchFamily="34" charset="-122"/>
-                <a:cs typeface="Space Grotesk Light" pitchFamily="34" charset="-120"/>
+                <a:latin typeface="Arial"/>
+                <a:ea typeface="Arial"/>
+                <a:cs typeface="Arial"/>
               </a:rPr>
               <a:t>Angiographic: &lt;20% residual, TIMI 3</a:t>
             </a:r>
@@ -15658,9 +15677,9 @@
                 <a:solidFill>
                   <a:srgbClr val="000000"/>
                 </a:solidFill>
-                <a:latin typeface="Space Grotesk Light" pitchFamily="34" charset="0"/>
-                <a:ea typeface="Space Grotesk Light" pitchFamily="34" charset="-122"/>
-                <a:cs typeface="Space Grotesk Light" pitchFamily="34" charset="-120"/>
+                <a:latin typeface="Arial"/>
+                <a:ea typeface="Arial"/>
+                <a:cs typeface="Arial"/>
               </a:rPr>
               <a:t>Procedural: no major complication, death, MI or emergency revasc.</a:t>
             </a:r>
@@ -15717,9 +15736,9 @@
                 <a:solidFill>
                   <a:srgbClr val="FFFFFF"/>
                 </a:solidFill>
-                <a:latin typeface="Space Grotesk" pitchFamily="34" charset="0"/>
-                <a:ea typeface="Space Grotesk" pitchFamily="34" charset="-122"/>
-                <a:cs typeface="Space Grotesk" pitchFamily="34" charset="-120"/>
+                <a:latin typeface="Arial"/>
+                <a:ea typeface="Arial"/>
+                <a:cs typeface="Arial"/>
               </a:rPr>
               <a:t>Two-year</a:t>
             </a:r>
@@ -15759,9 +15778,9 @@
                 <a:solidFill>
                   <a:srgbClr val="000000"/>
                 </a:solidFill>
-                <a:latin typeface="Space Grotesk Light" pitchFamily="34" charset="0"/>
-                <a:ea typeface="Space Grotesk Light" pitchFamily="34" charset="-122"/>
-                <a:cs typeface="Space Grotesk Light" pitchFamily="34" charset="-120"/>
+                <a:latin typeface="Arial"/>
+                <a:ea typeface="Arial"/>
+                <a:cs typeface="Arial"/>
               </a:rPr>
               <a:t>MACE: cardiac death, nonfatal MI, TLR</a:t>
             </a:r>
@@ -15779,9 +15798,9 @@
                 <a:solidFill>
                   <a:srgbClr val="000000"/>
                 </a:solidFill>
-                <a:latin typeface="Space Grotesk Light" pitchFamily="34" charset="0"/>
-                <a:ea typeface="Space Grotesk Light" pitchFamily="34" charset="-122"/>
-                <a:cs typeface="Space Grotesk Light" pitchFamily="34" charset="-120"/>
+                <a:latin typeface="Arial"/>
+                <a:ea typeface="Arial"/>
+                <a:cs typeface="Arial"/>
               </a:rPr>
               <a:t>Stent thrombosis (ARC), stroke, bleeding (BARC)</a:t>
             </a:r>
@@ -15965,9 +15984,9 @@
                 <a:solidFill>
                   <a:srgbClr val="0B3D66"/>
                 </a:solidFill>
-                <a:latin typeface="Space Grotesk Light" pitchFamily="34" charset="0"/>
-                <a:ea typeface="Space Grotesk Light" pitchFamily="34" charset="-122"/>
-                <a:cs typeface="Space Grotesk Light" pitchFamily="34" charset="-120"/>
+                <a:latin typeface="Arial"/>
+                <a:ea typeface="Arial"/>
+                <a:cs typeface="Arial"/>
               </a:rPr>
               <a:t>Sohil MM et al.  |  Am Heart J Plus 2026;61:100678</a:t>
             </a:r>
@@ -16004,9 +16023,9 @@
                 <a:solidFill>
                   <a:srgbClr val="0B3D66"/>
                 </a:solidFill>
-                <a:latin typeface="Space Grotesk" pitchFamily="34" charset="0"/>
-                <a:ea typeface="Space Grotesk" pitchFamily="34" charset="-122"/>
-                <a:cs typeface="Space Grotesk" pitchFamily="34" charset="-120"/>
+                <a:latin typeface="Arial"/>
+                <a:ea typeface="Arial"/>
+                <a:cs typeface="Arial"/>
               </a:rPr>
               <a:t>7</a:t>
             </a:r>
@@ -16075,9 +16094,9 @@
                 <a:solidFill>
                   <a:srgbClr val="FFFFFF"/>
                 </a:solidFill>
-                <a:latin typeface="Space Grotesk" pitchFamily="34" charset="0"/>
-                <a:ea typeface="Space Grotesk" pitchFamily="34" charset="-122"/>
-                <a:cs typeface="Space Grotesk" pitchFamily="34" charset="-120"/>
+                <a:latin typeface="Arial"/>
+                <a:ea typeface="Arial"/>
+                <a:cs typeface="Arial"/>
               </a:rPr>
               <a:t>Take-home messages</a:t>
             </a:r>
@@ -16206,9 +16225,9 @@
                 <a:solidFill>
                   <a:srgbClr val="FFFFFF"/>
                 </a:solidFill>
-                <a:latin typeface="Space Grotesk Light" pitchFamily="34" charset="0"/>
-                <a:ea typeface="Space Grotesk Light" pitchFamily="34" charset="-122"/>
-                <a:cs typeface="Space Grotesk Light" pitchFamily="34" charset="-120"/>
+                <a:latin typeface="Arial"/>
+                <a:ea typeface="Arial"/>
+                <a:cs typeface="Arial"/>
               </a:rPr>
               <a:t>Rota-assisted LM-PCI is feasible, safe and effective in severely calcified lesions</a:t>
             </a:r>
@@ -16314,9 +16333,9 @@
                 <a:solidFill>
                   <a:srgbClr val="FFFFFF"/>
                 </a:solidFill>
-                <a:latin typeface="Space Grotesk Light" pitchFamily="34" charset="0"/>
-                <a:ea typeface="Space Grotesk Light" pitchFamily="34" charset="-122"/>
-                <a:cs typeface="Space Grotesk Light" pitchFamily="34" charset="-120"/>
+                <a:latin typeface="Arial"/>
+                <a:ea typeface="Arial"/>
+                <a:cs typeface="Arial"/>
               </a:rPr>
               <a:t>Procedural success 97.8%, with a low rate of periprocedural complications</a:t>
             </a:r>
@@ -16422,9 +16441,9 @@
                 <a:solidFill>
                   <a:srgbClr val="FFFFFF"/>
                 </a:solidFill>
-                <a:latin typeface="Space Grotesk Light" pitchFamily="34" charset="0"/>
-                <a:ea typeface="Space Grotesk Light" pitchFamily="34" charset="-122"/>
-                <a:cs typeface="Space Grotesk Light" pitchFamily="34" charset="-120"/>
+                <a:latin typeface="Arial"/>
+                <a:ea typeface="Arial"/>
+                <a:cs typeface="Arial"/>
               </a:rPr>
               <a:t>Durable two-year outcomes: MACE-free survival 93.3%</a:t>
             </a:r>
@@ -16608,9 +16627,9 @@
                 <a:solidFill>
                   <a:srgbClr val="FFFFFF"/>
                 </a:solidFill>
-                <a:latin typeface="Space Grotesk Light" pitchFamily="34" charset="0"/>
-                <a:ea typeface="Space Grotesk Light" pitchFamily="34" charset="-122"/>
-                <a:cs typeface="Space Grotesk Light" pitchFamily="34" charset="-120"/>
+                <a:latin typeface="Arial"/>
+                <a:ea typeface="Arial"/>
+                <a:cs typeface="Arial"/>
               </a:rPr>
               <a:t>Sohil MM et al.  |  Am Heart J Plus 2026;61:100678</a:t>
             </a:r>
@@ -16647,9 +16666,9 @@
                 <a:solidFill>
                   <a:srgbClr val="FFFFFF"/>
                 </a:solidFill>
-                <a:latin typeface="Space Grotesk" pitchFamily="34" charset="0"/>
-                <a:ea typeface="Space Grotesk" pitchFamily="34" charset="-122"/>
-                <a:cs typeface="Space Grotesk" pitchFamily="34" charset="-120"/>
+                <a:latin typeface="Arial"/>
+                <a:ea typeface="Arial"/>
+                <a:cs typeface="Arial"/>
               </a:rPr>
               <a:t>16</a:t>
             </a:r>
@@ -16708,7 +16727,7 @@
     </a:clrScheme>
     <a:fontScheme name="Office">
       <a:majorFont>
-        <a:latin typeface="Calibri Light" panose="020F0302020204030204"/>
+        <a:latin typeface="Arial"/>
         <a:ea typeface=""/>
         <a:cs typeface=""/>
         <a:font script="Jpan" typeface="游ゴシック Light"/>
@@ -16760,7 +16779,302 @@
         <a:font script="Tfng" typeface="Ebrima"/>
       </a:majorFont>
       <a:minorFont>
-        <a:latin typeface="Calibri" panose="020F0502020204030204"/>
+        <a:latin typeface="Arial"/>
+        <a:ea typeface=""/>
+        <a:cs typeface=""/>
+        <a:font script="Jpan" typeface="游ゴシック"/>
+        <a:font script="Hang" typeface="맑은 고딕"/>
+        <a:font script="Hans" typeface="等线"/>
+        <a:font script="Hant" typeface="新細明體"/>
+        <a:font script="Arab" typeface="Arial"/>
+        <a:font script="Hebr" typeface="Arial"/>
+        <a:font script="Thai" typeface="Cordia New"/>
+        <a:font script="Ethi" typeface="Nyala"/>
+        <a:font script="Beng" typeface="Vrinda"/>
+        <a:font script="Gujr" typeface="Shruti"/>
+        <a:font script="Khmr" typeface="DaunPenh"/>
+        <a:font script="Knda" typeface="Tunga"/>
+        <a:font script="Guru" typeface="Raavi"/>
+        <a:font script="Cans" typeface="Euphemia"/>
+        <a:font script="Cher" typeface="Plantagenet Cherokee"/>
+        <a:font script="Yiii" typeface="Microsoft Yi Baiti"/>
+        <a:font script="Tibt" typeface="Microsoft Himalaya"/>
+        <a:font script="Thaa" typeface="MV Boli"/>
+        <a:font script="Deva" typeface="Mangal"/>
+        <a:font script="Telu" typeface="Gautami"/>
+        <a:font script="Taml" typeface="Latha"/>
+        <a:font script="Syrc" typeface="Estrangelo Edessa"/>
+        <a:font script="Orya" typeface="Kalinga"/>
+        <a:font script="Mlym" typeface="Kartika"/>
+        <a:font script="Laoo" typeface="DokChampa"/>
+        <a:font script="Sinh" typeface="Iskoola Pota"/>
+        <a:font script="Mong" typeface="Mongolian Baiti"/>
+        <a:font script="Viet" typeface="Arial"/>
+        <a:font script="Uigh" typeface="Microsoft Uighur"/>
+        <a:font script="Geor" typeface="Sylfaen"/>
+        <a:font script="Armn" typeface="Arial"/>
+        <a:font script="Bugi" typeface="Leelawadee UI"/>
+        <a:font script="Bopo" typeface="Microsoft JhengHei"/>
+        <a:font script="Java" typeface="Javanese Text"/>
+        <a:font script="Lisu" typeface="Segoe UI"/>
+        <a:font script="Mymr" typeface="Myanmar Text"/>
+        <a:font script="Nkoo" typeface="Ebrima"/>
+        <a:font script="Olck" typeface="Nirmala UI"/>
+        <a:font script="Osma" typeface="Ebrima"/>
+        <a:font script="Phag" typeface="Phagspa"/>
+        <a:font script="Syrn" typeface="Estrangelo Edessa"/>
+        <a:font script="Syrj" typeface="Estrangelo Edessa"/>
+        <a:font script="Syre" typeface="Estrangelo Edessa"/>
+        <a:font script="Sora" typeface="Nirmala UI"/>
+        <a:font script="Tale" typeface="Microsoft Tai Le"/>
+        <a:font script="Talu" typeface="Microsoft New Tai Lue"/>
+        <a:font script="Tfng" typeface="Ebrima"/>
+      </a:minorFont>
+    </a:fontScheme>
+    <a:fmtScheme name="Office">
+      <a:fillStyleLst>
+        <a:solidFill>
+          <a:schemeClr val="phClr"/>
+        </a:solidFill>
+        <a:gradFill rotWithShape="1">
+          <a:gsLst>
+            <a:gs pos="0">
+              <a:schemeClr val="phClr">
+                <a:lumMod val="110000"/>
+                <a:satMod val="105000"/>
+                <a:tint val="67000"/>
+              </a:schemeClr>
+            </a:gs>
+            <a:gs pos="50000">
+              <a:schemeClr val="phClr">
+                <a:lumMod val="105000"/>
+                <a:satMod val="103000"/>
+                <a:tint val="73000"/>
+              </a:schemeClr>
+            </a:gs>
+            <a:gs pos="100000">
+              <a:schemeClr val="phClr">
+                <a:lumMod val="105000"/>
+                <a:satMod val="109000"/>
+                <a:tint val="81000"/>
+              </a:schemeClr>
+            </a:gs>
+          </a:gsLst>
+          <a:lin ang="5400000" scaled="0"/>
+        </a:gradFill>
+        <a:gradFill rotWithShape="1">
+          <a:gsLst>
+            <a:gs pos="0">
+              <a:schemeClr val="phClr">
+                <a:satMod val="103000"/>
+                <a:lumMod val="102000"/>
+                <a:tint val="94000"/>
+              </a:schemeClr>
+            </a:gs>
+            <a:gs pos="50000">
+              <a:schemeClr val="phClr">
+                <a:satMod val="110000"/>
+                <a:lumMod val="100000"/>
+                <a:shade val="100000"/>
+              </a:schemeClr>
+            </a:gs>
+            <a:gs pos="100000">
+              <a:schemeClr val="phClr">
+                <a:lumMod val="99000"/>
+                <a:satMod val="120000"/>
+                <a:shade val="78000"/>
+              </a:schemeClr>
+            </a:gs>
+          </a:gsLst>
+          <a:lin ang="5400000" scaled="0"/>
+        </a:gradFill>
+      </a:fillStyleLst>
+      <a:lnStyleLst>
+        <a:ln w="6350" cap="flat" cmpd="sng" algn="ctr">
+          <a:solidFill>
+            <a:schemeClr val="phClr"/>
+          </a:solidFill>
+          <a:prstDash val="solid"/>
+          <a:miter lim="800000"/>
+        </a:ln>
+        <a:ln w="12700" cap="flat" cmpd="sng" algn="ctr">
+          <a:solidFill>
+            <a:schemeClr val="phClr"/>
+          </a:solidFill>
+          <a:prstDash val="solid"/>
+          <a:miter lim="800000"/>
+        </a:ln>
+        <a:ln w="19050" cap="flat" cmpd="sng" algn="ctr">
+          <a:solidFill>
+            <a:schemeClr val="phClr"/>
+          </a:solidFill>
+          <a:prstDash val="solid"/>
+          <a:miter lim="800000"/>
+        </a:ln>
+      </a:lnStyleLst>
+      <a:effectStyleLst>
+        <a:effectStyle>
+          <a:effectLst/>
+        </a:effectStyle>
+        <a:effectStyle>
+          <a:effectLst/>
+        </a:effectStyle>
+        <a:effectStyle>
+          <a:effectLst>
+            <a:outerShdw blurRad="57150" dist="19050" dir="5400000" algn="ctr" rotWithShape="0">
+              <a:srgbClr val="000000">
+                <a:alpha val="63000"/>
+              </a:srgbClr>
+            </a:outerShdw>
+          </a:effectLst>
+        </a:effectStyle>
+      </a:effectStyleLst>
+      <a:bgFillStyleLst>
+        <a:solidFill>
+          <a:schemeClr val="phClr"/>
+        </a:solidFill>
+        <a:solidFill>
+          <a:schemeClr val="phClr">
+            <a:tint val="95000"/>
+            <a:satMod val="170000"/>
+          </a:schemeClr>
+        </a:solidFill>
+        <a:gradFill rotWithShape="1">
+          <a:gsLst>
+            <a:gs pos="0">
+              <a:schemeClr val="phClr">
+                <a:tint val="93000"/>
+                <a:satMod val="150000"/>
+                <a:shade val="98000"/>
+                <a:lumMod val="102000"/>
+              </a:schemeClr>
+            </a:gs>
+            <a:gs pos="50000">
+              <a:schemeClr val="phClr">
+                <a:tint val="98000"/>
+                <a:satMod val="130000"/>
+                <a:shade val="90000"/>
+                <a:lumMod val="103000"/>
+              </a:schemeClr>
+            </a:gs>
+            <a:gs pos="100000">
+              <a:schemeClr val="phClr">
+                <a:shade val="63000"/>
+                <a:satMod val="120000"/>
+              </a:schemeClr>
+            </a:gs>
+          </a:gsLst>
+          <a:lin ang="5400000" scaled="0"/>
+        </a:gradFill>
+      </a:bgFillStyleLst>
+    </a:fmtScheme>
+  </a:themeElements>
+  <a:objectDefaults/>
+  <a:extraClrSchemeLst/>
+  <a:extLst>
+    <a:ext uri="{05A4C25C-085E-4340-85A3-A5531E510DB2}">
+      <thm15:themeFamily xmlns:thm15="http://schemas.microsoft.com/office/thememl/2012/main" name="Office Theme" id="{62F939B6-93AF-4DB8-9C6B-D6C7DFDC589F}" vid="{4A3C46E8-61CC-4603-A589-7422A47A8E4A}"/>
+    </a:ext>
+  </a:extLst>
+</a:theme>
+</file>
+
+<file path=ppt/theme/theme2.xml><?xml version="1.0" encoding="utf-8"?>
+<a:theme xmlns:a="http://schemas.openxmlformats.org/drawingml/2006/main" name="Office Theme">
+  <a:themeElements>
+    <a:clrScheme name="Office">
+      <a:dk1>
+        <a:sysClr val="windowText" lastClr="000000"/>
+      </a:dk1>
+      <a:lt1>
+        <a:sysClr val="window" lastClr="FFFFFF"/>
+      </a:lt1>
+      <a:dk2>
+        <a:srgbClr val="44546A"/>
+      </a:dk2>
+      <a:lt2>
+        <a:srgbClr val="E7E6E6"/>
+      </a:lt2>
+      <a:accent1>
+        <a:srgbClr val="4472C4"/>
+      </a:accent1>
+      <a:accent2>
+        <a:srgbClr val="ED7D31"/>
+      </a:accent2>
+      <a:accent3>
+        <a:srgbClr val="A5A5A5"/>
+      </a:accent3>
+      <a:accent4>
+        <a:srgbClr val="FFC000"/>
+      </a:accent4>
+      <a:accent5>
+        <a:srgbClr val="5B9BD5"/>
+      </a:accent5>
+      <a:accent6>
+        <a:srgbClr val="70AD47"/>
+      </a:accent6>
+      <a:hlink>
+        <a:srgbClr val="0563C1"/>
+      </a:hlink>
+      <a:folHlink>
+        <a:srgbClr val="954F72"/>
+      </a:folHlink>
+    </a:clrScheme>
+    <a:fontScheme name="Office">
+      <a:majorFont>
+        <a:latin typeface="Arial"/>
+        <a:ea typeface=""/>
+        <a:cs typeface=""/>
+        <a:font script="Jpan" typeface="游ゴシック Light"/>
+        <a:font script="Hang" typeface="맑은 고딕"/>
+        <a:font script="Hans" typeface="等线 Light"/>
+        <a:font script="Hant" typeface="新細明體"/>
+        <a:font script="Arab" typeface="Times New Roman"/>
+        <a:font script="Hebr" typeface="Times New Roman"/>
+        <a:font script="Thai" typeface="Angsana New"/>
+        <a:font script="Ethi" typeface="Nyala"/>
+        <a:font script="Beng" typeface="Vrinda"/>
+        <a:font script="Gujr" typeface="Shruti"/>
+        <a:font script="Khmr" typeface="MoolBoran"/>
+        <a:font script="Knda" typeface="Tunga"/>
+        <a:font script="Guru" typeface="Raavi"/>
+        <a:font script="Cans" typeface="Euphemia"/>
+        <a:font script="Cher" typeface="Plantagenet Cherokee"/>
+        <a:font script="Yiii" typeface="Microsoft Yi Baiti"/>
+        <a:font script="Tibt" typeface="Microsoft Himalaya"/>
+        <a:font script="Thaa" typeface="MV Boli"/>
+        <a:font script="Deva" typeface="Mangal"/>
+        <a:font script="Telu" typeface="Gautami"/>
+        <a:font script="Taml" typeface="Latha"/>
+        <a:font script="Syrc" typeface="Estrangelo Edessa"/>
+        <a:font script="Orya" typeface="Kalinga"/>
+        <a:font script="Mlym" typeface="Kartika"/>
+        <a:font script="Laoo" typeface="DokChampa"/>
+        <a:font script="Sinh" typeface="Iskoola Pota"/>
+        <a:font script="Mong" typeface="Mongolian Baiti"/>
+        <a:font script="Viet" typeface="Times New Roman"/>
+        <a:font script="Uigh" typeface="Microsoft Uighur"/>
+        <a:font script="Geor" typeface="Sylfaen"/>
+        <a:font script="Armn" typeface="Arial"/>
+        <a:font script="Bugi" typeface="Leelawadee UI"/>
+        <a:font script="Bopo" typeface="Microsoft JhengHei"/>
+        <a:font script="Java" typeface="Javanese Text"/>
+        <a:font script="Lisu" typeface="Segoe UI"/>
+        <a:font script="Mymr" typeface="Myanmar Text"/>
+        <a:font script="Nkoo" typeface="Ebrima"/>
+        <a:font script="Olck" typeface="Nirmala UI"/>
+        <a:font script="Osma" typeface="Ebrima"/>
+        <a:font script="Phag" typeface="Phagspa"/>
+        <a:font script="Syrn" typeface="Estrangelo Edessa"/>
+        <a:font script="Syrj" typeface="Estrangelo Edessa"/>
+        <a:font script="Syre" typeface="Estrangelo Edessa"/>
+        <a:font script="Sora" typeface="Nirmala UI"/>
+        <a:font script="Tale" typeface="Microsoft Tai Le"/>
+        <a:font script="Talu" typeface="Microsoft New Tai Lue"/>
+        <a:font script="Tfng" typeface="Ebrima"/>
+      </a:majorFont>
+      <a:minorFont>
+        <a:latin typeface="Arial"/>
         <a:ea typeface=""/>
         <a:cs typeface=""/>
         <a:font script="Jpan" typeface="游ゴシック"/>

</xml_diff>

<commit_message>
Replace rotablation left main PCI slides with a PowerPoint-compatible build (#12)
Swap the PowerPoint and PDF for the version that opens in Microsoft PowerPoint on Android.
</commit_message>
<xml_diff>
--- a/presentations/Rotablation-Left-Main-PCI-Sohil-2026.pptx
+++ b/presentations/Rotablation-Left-Main-PCI-Sohil-2026.pptx
@@ -27,7 +27,7 @@
     <p:sldId id="265" r:id="rId11"/>
   </p:sldIdLst>
   <p:sldSz cx="9144000" cy="5143500"/>
-  <p:notesSz cx="5143500" cy="9144000"/>
+  <p:notesSz cx="6858000" cy="9144000"/>
   <p:defaultTextStyle>
     <a:lvl1pPr marL="0" algn="l" defTabSz="914400" rtl="0" eaLnBrk="1" latinLnBrk="0" hangingPunct="1">
       <a:defRPr sz="1800" kern="1200">
@@ -126,7 +126,8 @@
 <file path=ppt/charts/chart1.xml><?xml version="1.0" encoding="utf-8"?>
 <c:chartSpace xmlns:c="http://schemas.openxmlformats.org/drawingml/2006/chart" xmlns:a="http://schemas.openxmlformats.org/drawingml/2006/main" xmlns:r="http://schemas.openxmlformats.org/officeDocument/2006/relationships">
   <c:date1904 val="0"/>
-  <c:roundedCorners val="1"/>
+  <c:lang val="en-US"/>
+  <c:roundedCorners val="0"/>
   <c:chart>
     <c:autoTitleDeleted val="1"/>
     <c:plotArea>
@@ -187,7 +188,7 @@
                     <a:solidFill>
                       <a:srgbClr val="0B3D66"/>
                     </a:solidFill>
-                    <a:latin typeface="Space Grotesk"/>
+                    <a:latin typeface="Arial"/>
                   </a:defRPr>
                 </a:pPr>
               </a:p>
@@ -201,32 +202,30 @@
             <c:showLeaderLines val="0"/>
           </c:dLbls>
           <c:cat>
-            <c:multiLvlStrRef>
+            <c:strRef>
               <c:f>Sheet1!$A$2:$A$7</c:f>
-              <c:multiLvlStrCache>
+              <c:strCache>
                 <c:ptCount val="6"/>
-                <c:lvl>
-                  <c:pt idx="0">
-                    <c:v>This study: in-hosp. death</c:v>
-                  </c:pt>
-                  <c:pt idx="1">
-                    <c:v>This study: 2-yr TLR</c:v>
-                  </c:pt>
-                  <c:pt idx="2">
-                    <c:v>ROTATE: in-hosp. MACE</c:v>
-                  </c:pt>
-                  <c:pt idx="3">
-                    <c:v>Bouisset: 1-yr MACE</c:v>
-                  </c:pt>
-                  <c:pt idx="4">
-                    <c:v>Garcia-Lara: 2-yr TVR</c:v>
-                  </c:pt>
-                  <c:pt idx="5">
-                    <c:v>ROTATE: 2-yr MACE</c:v>
-                  </c:pt>
-                </c:lvl>
-              </c:multiLvlStrCache>
-            </c:multiLvlStrRef>
+                <c:pt idx="0">
+                  <c:v>This study: in-hosp. death</c:v>
+                </c:pt>
+                <c:pt idx="1">
+                  <c:v>This study: 2-yr TLR</c:v>
+                </c:pt>
+                <c:pt idx="2">
+                  <c:v>ROTATE: in-hosp. MACE</c:v>
+                </c:pt>
+                <c:pt idx="3">
+                  <c:v>Bouisset: 1-yr MACE</c:v>
+                </c:pt>
+                <c:pt idx="4">
+                  <c:v>Garcia-Lara: 2-yr TVR</c:v>
+                </c:pt>
+                <c:pt idx="5">
+                  <c:v>ROTATE: 2-yr MACE</c:v>
+                </c:pt>
+              </c:strCache>
+            </c:strRef>
           </c:cat>
           <c:val>
             <c:numRef>
@@ -267,7 +266,7 @@
                   <a:solidFill>
                     <a:srgbClr val="0B3D66"/>
                   </a:solidFill>
-                  <a:latin typeface="Space Grotesk"/>
+                  <a:latin typeface="Arial"/>
                 </a:defRPr>
               </a:pPr>
             </a:p>
@@ -314,7 +313,7 @@
                 <a:solidFill>
                   <a:srgbClr val="000000"/>
                 </a:solidFill>
-                <a:latin typeface="Space Grotesk Light"/>
+                <a:latin typeface="Arial"/>
               </a:defRPr>
             </a:pPr>
             <a:endParaRPr lang="en-US"/>
@@ -394,7 +393,8 @@
 <file path=ppt/charts/chart2.xml><?xml version="1.0" encoding="utf-8"?>
 <c:chartSpace xmlns:c="http://schemas.openxmlformats.org/drawingml/2006/chart" xmlns:a="http://schemas.openxmlformats.org/drawingml/2006/main" xmlns:r="http://schemas.openxmlformats.org/officeDocument/2006/relationships">
   <c:date1904 val="0"/>
-  <c:roundedCorners val="1"/>
+  <c:lang val="en-US"/>
+  <c:roundedCorners val="0"/>
   <c:chart>
     <c:autoTitleDeleted val="1"/>
     <c:plotArea>
@@ -445,7 +445,7 @@
                     <a:solidFill>
                       <a:srgbClr val="0B3D66"/>
                     </a:solidFill>
-                    <a:latin typeface="Space Grotesk"/>
+                    <a:latin typeface="Arial"/>
                   </a:defRPr>
                 </a:pPr>
               </a:p>
@@ -459,26 +459,24 @@
             <c:showLeaderLines val="0"/>
           </c:dLbls>
           <c:cat>
-            <c:multiLvlStrRef>
+            <c:strRef>
               <c:f>Sheet1!$A$2:$A$5</c:f>
-              <c:multiLvlStrCache>
+              <c:strCache>
                 <c:ptCount val="4"/>
-                <c:lvl>
-                  <c:pt idx="0">
-                    <c:v>Isolated LMCA</c:v>
-                  </c:pt>
-                  <c:pt idx="1">
-                    <c:v>LMCA + SVD</c:v>
-                  </c:pt>
-                  <c:pt idx="2">
-                    <c:v>LMCA + DVD</c:v>
-                  </c:pt>
-                  <c:pt idx="3">
-                    <c:v>LMCA + TVD</c:v>
-                  </c:pt>
-                </c:lvl>
-              </c:multiLvlStrCache>
-            </c:multiLvlStrRef>
+                <c:pt idx="0">
+                  <c:v>Isolated LMCA</c:v>
+                </c:pt>
+                <c:pt idx="1">
+                  <c:v>LMCA + SVD</c:v>
+                </c:pt>
+                <c:pt idx="2">
+                  <c:v>LMCA + DVD</c:v>
+                </c:pt>
+                <c:pt idx="3">
+                  <c:v>LMCA + TVD</c:v>
+                </c:pt>
+              </c:strCache>
+            </c:strRef>
           </c:cat>
           <c:val>
             <c:numRef>
@@ -513,7 +511,7 @@
                   <a:solidFill>
                     <a:srgbClr val="0B3D66"/>
                   </a:solidFill>
-                  <a:latin typeface="Space Grotesk"/>
+                  <a:latin typeface="Arial"/>
                 </a:defRPr>
               </a:pPr>
             </a:p>
@@ -560,7 +558,7 @@
                 <a:solidFill>
                   <a:srgbClr val="000000"/>
                 </a:solidFill>
-                <a:latin typeface="Space Grotesk Light"/>
+                <a:latin typeface="Arial"/>
               </a:defRPr>
             </a:pPr>
             <a:endParaRPr lang="en-US"/>
@@ -886,7 +884,7 @@
     </p:spTree>
     <p:extLst>
       <p:ext uri="{BB962C8B-B14F-4D97-AF65-F5344CB8AC3E}">
-        <p14:creationId xmlns:p14="http://schemas.microsoft.com/office/powerpoint/2010/main" val="1024086991"/>
+        <p14:creationId xmlns:p14="http://schemas.microsoft.com/office/powerpoint/2010/main" val="3019500803"/>
       </p:ext>
     </p:extLst>
   </p:cSld>
@@ -1099,7 +1097,7 @@
     </p:spTree>
     <p:extLst>
       <p:ext uri="{BB962C8B-B14F-4D97-AF65-F5344CB8AC3E}">
-        <p14:creationId xmlns:p14="http://schemas.microsoft.com/office/powerpoint/2010/main" val="1024086991"/>
+        <p14:creationId xmlns:p14="http://schemas.microsoft.com/office/powerpoint/2010/main" val="1614454866"/>
       </p:ext>
     </p:extLst>
   </p:cSld>
@@ -1210,7 +1208,7 @@
     </p:spTree>
     <p:extLst>
       <p:ext uri="{BB962C8B-B14F-4D97-AF65-F5344CB8AC3E}">
-        <p14:creationId xmlns:p14="http://schemas.microsoft.com/office/powerpoint/2010/main" val="1024086991"/>
+        <p14:creationId xmlns:p14="http://schemas.microsoft.com/office/powerpoint/2010/main" val="2588017306"/>
       </p:ext>
     </p:extLst>
   </p:cSld>
@@ -1333,7 +1331,7 @@
     </p:spTree>
     <p:extLst>
       <p:ext uri="{BB962C8B-B14F-4D97-AF65-F5344CB8AC3E}">
-        <p14:creationId xmlns:p14="http://schemas.microsoft.com/office/powerpoint/2010/main" val="1024086991"/>
+        <p14:creationId xmlns:p14="http://schemas.microsoft.com/office/powerpoint/2010/main" val="1315283931"/>
       </p:ext>
     </p:extLst>
   </p:cSld>
@@ -1450,7 +1448,7 @@
     </p:spTree>
     <p:extLst>
       <p:ext uri="{BB962C8B-B14F-4D97-AF65-F5344CB8AC3E}">
-        <p14:creationId xmlns:p14="http://schemas.microsoft.com/office/powerpoint/2010/main" val="1024086991"/>
+        <p14:creationId xmlns:p14="http://schemas.microsoft.com/office/powerpoint/2010/main" val="3767399567"/>
       </p:ext>
     </p:extLst>
   </p:cSld>
@@ -1555,7 +1553,7 @@
     </p:spTree>
     <p:extLst>
       <p:ext uri="{BB962C8B-B14F-4D97-AF65-F5344CB8AC3E}">
-        <p14:creationId xmlns:p14="http://schemas.microsoft.com/office/powerpoint/2010/main" val="1024086991"/>
+        <p14:creationId xmlns:p14="http://schemas.microsoft.com/office/powerpoint/2010/main" val="841091593"/>
       </p:ext>
     </p:extLst>
   </p:cSld>
@@ -1684,7 +1682,7 @@
     </p:spTree>
     <p:extLst>
       <p:ext uri="{BB962C8B-B14F-4D97-AF65-F5344CB8AC3E}">
-        <p14:creationId xmlns:p14="http://schemas.microsoft.com/office/powerpoint/2010/main" val="1024086991"/>
+        <p14:creationId xmlns:p14="http://schemas.microsoft.com/office/powerpoint/2010/main" val="308373719"/>
       </p:ext>
     </p:extLst>
   </p:cSld>
@@ -1795,7 +1793,7 @@
     </p:spTree>
     <p:extLst>
       <p:ext uri="{BB962C8B-B14F-4D97-AF65-F5344CB8AC3E}">
-        <p14:creationId xmlns:p14="http://schemas.microsoft.com/office/powerpoint/2010/main" val="1024086991"/>
+        <p14:creationId xmlns:p14="http://schemas.microsoft.com/office/powerpoint/2010/main" val="3637378079"/>
       </p:ext>
     </p:extLst>
   </p:cSld>
@@ -1918,7 +1916,7 @@
     </p:spTree>
     <p:extLst>
       <p:ext uri="{BB962C8B-B14F-4D97-AF65-F5344CB8AC3E}">
-        <p14:creationId xmlns:p14="http://schemas.microsoft.com/office/powerpoint/2010/main" val="1024086991"/>
+        <p14:creationId xmlns:p14="http://schemas.microsoft.com/office/powerpoint/2010/main" val="1137582237"/>
       </p:ext>
     </p:extLst>
   </p:cSld>
@@ -2035,7 +2033,7 @@
     </p:spTree>
     <p:extLst>
       <p:ext uri="{BB962C8B-B14F-4D97-AF65-F5344CB8AC3E}">
-        <p14:creationId xmlns:p14="http://schemas.microsoft.com/office/powerpoint/2010/main" val="1024086991"/>
+        <p14:creationId xmlns:p14="http://schemas.microsoft.com/office/powerpoint/2010/main" val="1089763266"/>
       </p:ext>
     </p:extLst>
   </p:cSld>
@@ -2152,7 +2150,7 @@
     </p:spTree>
     <p:extLst>
       <p:ext uri="{BB962C8B-B14F-4D97-AF65-F5344CB8AC3E}">
-        <p14:creationId xmlns:p14="http://schemas.microsoft.com/office/powerpoint/2010/main" val="1024086991"/>
+        <p14:creationId xmlns:p14="http://schemas.microsoft.com/office/powerpoint/2010/main" val="1107426713"/>
       </p:ext>
     </p:extLst>
   </p:cSld>
@@ -2275,7 +2273,7 @@
     </p:spTree>
     <p:extLst>
       <p:ext uri="{BB962C8B-B14F-4D97-AF65-F5344CB8AC3E}">
-        <p14:creationId xmlns:p14="http://schemas.microsoft.com/office/powerpoint/2010/main" val="1024086991"/>
+        <p14:creationId xmlns:p14="http://schemas.microsoft.com/office/powerpoint/2010/main" val="112566049"/>
       </p:ext>
     </p:extLst>
   </p:cSld>
@@ -2392,7 +2390,7 @@
     </p:spTree>
     <p:extLst>
       <p:ext uri="{BB962C8B-B14F-4D97-AF65-F5344CB8AC3E}">
-        <p14:creationId xmlns:p14="http://schemas.microsoft.com/office/powerpoint/2010/main" val="1024086991"/>
+        <p14:creationId xmlns:p14="http://schemas.microsoft.com/office/powerpoint/2010/main" val="3165157091"/>
       </p:ext>
     </p:extLst>
   </p:cSld>
@@ -2521,7 +2519,7 @@
     </p:spTree>
     <p:extLst>
       <p:ext uri="{BB962C8B-B14F-4D97-AF65-F5344CB8AC3E}">
-        <p14:creationId xmlns:p14="http://schemas.microsoft.com/office/powerpoint/2010/main" val="1024086991"/>
+        <p14:creationId xmlns:p14="http://schemas.microsoft.com/office/powerpoint/2010/main" val="3645493547"/>
       </p:ext>
     </p:extLst>
   </p:cSld>
@@ -2644,7 +2642,7 @@
     </p:spTree>
     <p:extLst>
       <p:ext uri="{BB962C8B-B14F-4D97-AF65-F5344CB8AC3E}">
-        <p14:creationId xmlns:p14="http://schemas.microsoft.com/office/powerpoint/2010/main" val="1024086991"/>
+        <p14:creationId xmlns:p14="http://schemas.microsoft.com/office/powerpoint/2010/main" val="2448450340"/>
       </p:ext>
     </p:extLst>
   </p:cSld>
@@ -2761,7 +2759,7 @@
     </p:spTree>
     <p:extLst>
       <p:ext uri="{BB962C8B-B14F-4D97-AF65-F5344CB8AC3E}">
-        <p14:creationId xmlns:p14="http://schemas.microsoft.com/office/powerpoint/2010/main" val="1024086991"/>
+        <p14:creationId xmlns:p14="http://schemas.microsoft.com/office/powerpoint/2010/main" val="665518533"/>
       </p:ext>
     </p:extLst>
   </p:cSld>
@@ -2890,7 +2888,7 @@
     </p:spTree>
     <p:extLst>
       <p:ext uri="{BB962C8B-B14F-4D97-AF65-F5344CB8AC3E}">
-        <p14:creationId xmlns:p14="http://schemas.microsoft.com/office/powerpoint/2010/main" val="1024086991"/>
+        <p14:creationId xmlns:p14="http://schemas.microsoft.com/office/powerpoint/2010/main" val="353793912"/>
       </p:ext>
     </p:extLst>
   </p:cSld>
@@ -3001,7 +2999,7 @@
     </p:spTree>
     <p:extLst>
       <p:ext uri="{BB962C8B-B14F-4D97-AF65-F5344CB8AC3E}">
-        <p14:creationId xmlns:p14="http://schemas.microsoft.com/office/powerpoint/2010/main" val="1024086991"/>
+        <p14:creationId xmlns:p14="http://schemas.microsoft.com/office/powerpoint/2010/main" val="954062247"/>
       </p:ext>
     </p:extLst>
   </p:cSld>
@@ -3371,9 +3369,9 @@
                 <a:solidFill>
                   <a:srgbClr val="FFFFFF"/>
                 </a:solidFill>
-                <a:latin typeface="Space Grotesk" pitchFamily="34" charset="0"/>
-                <a:ea typeface="Space Grotesk" pitchFamily="34" charset="-122"/>
-                <a:cs typeface="Space Grotesk" pitchFamily="34" charset="-120"/>
+                <a:latin typeface="Arial"/>
+                <a:ea typeface="Arial"/>
+                <a:cs typeface="Arial"/>
               </a:rPr>
               <a:t>ROTABLATION-ASSISTED</a:t>
             </a:r>
@@ -3410,9 +3408,9 @@
                 <a:solidFill>
                   <a:srgbClr val="FFFFFF"/>
                 </a:solidFill>
-                <a:latin typeface="Space Grotesk" pitchFamily="34" charset="0"/>
-                <a:ea typeface="Space Grotesk" pitchFamily="34" charset="-122"/>
-                <a:cs typeface="Space Grotesk" pitchFamily="34" charset="-120"/>
+                <a:latin typeface="Arial"/>
+                <a:ea typeface="Arial"/>
+                <a:cs typeface="Arial"/>
               </a:rPr>
               <a:t>LEFT MAIN PCI</a:t>
             </a:r>
@@ -3449,9 +3447,9 @@
                 <a:solidFill>
                   <a:srgbClr val="D6E6F5"/>
                 </a:solidFill>
-                <a:latin typeface="Space Grotesk Light" pitchFamily="34" charset="0"/>
-                <a:ea typeface="Space Grotesk Light" pitchFamily="34" charset="-122"/>
-                <a:cs typeface="Space Grotesk Light" pitchFamily="34" charset="-120"/>
+                <a:latin typeface="Arial"/>
+                <a:ea typeface="Arial"/>
+                <a:cs typeface="Arial"/>
               </a:rPr>
               <a:t>A single centre experience</a:t>
             </a:r>
@@ -3508,9 +3506,9 @@
                 <a:solidFill>
                   <a:srgbClr val="FFFFFF"/>
                 </a:solidFill>
-                <a:latin typeface="Space Grotesk" pitchFamily="34" charset="0"/>
-                <a:ea typeface="Space Grotesk" pitchFamily="34" charset="-122"/>
-                <a:cs typeface="Space Grotesk" pitchFamily="34" charset="-120"/>
+                <a:latin typeface="Arial"/>
+                <a:ea typeface="Arial"/>
+                <a:cs typeface="Arial"/>
               </a:rPr>
               <a:t>Dr. Mohd Maqbool Sohil, MD, DM, FSCAI</a:t>
             </a:r>
@@ -3525,9 +3523,9 @@
                 <a:solidFill>
                   <a:srgbClr val="FFFFFF"/>
                 </a:solidFill>
-                <a:latin typeface="Space Grotesk Light" pitchFamily="34" charset="0"/>
-                <a:ea typeface="Space Grotesk Light" pitchFamily="34" charset="-122"/>
-                <a:cs typeface="Space Grotesk Light" pitchFamily="34" charset="-120"/>
+                <a:latin typeface="Arial"/>
+                <a:ea typeface="Arial"/>
+                <a:cs typeface="Arial"/>
               </a:rPr>
               <a:t>Interventional Cardiologist</a:t>
             </a:r>
@@ -3545,9 +3543,9 @@
                 <a:solidFill>
                   <a:srgbClr val="FFFFFF"/>
                 </a:solidFill>
-                <a:latin typeface="Space Grotesk Light" pitchFamily="34" charset="0"/>
-                <a:ea typeface="Space Grotesk Light" pitchFamily="34" charset="-122"/>
-                <a:cs typeface="Space Grotesk Light" pitchFamily="34" charset="-120"/>
+                <a:latin typeface="Arial"/>
+                <a:ea typeface="Arial"/>
+                <a:cs typeface="Arial"/>
               </a:rPr>
               <a:t>Sohil MM</a:t>
             </a:r>
@@ -3556,9 +3554,9 @@
                 <a:solidFill>
                   <a:srgbClr val="FFFFFF"/>
                 </a:solidFill>
-                <a:latin typeface="Space Grotesk Light" pitchFamily="34" charset="0"/>
-                <a:ea typeface="Space Grotesk Light" pitchFamily="34" charset="-122"/>
-                <a:cs typeface="Space Grotesk Light" pitchFamily="34" charset="-120"/>
+                <a:latin typeface="Arial"/>
+                <a:ea typeface="Arial"/>
+                <a:cs typeface="Arial"/>
               </a:rPr>
               <a:t>a</a:t>
             </a:r>
@@ -3567,9 +3565,9 @@
                 <a:solidFill>
                   <a:srgbClr val="FFFFFF"/>
                 </a:solidFill>
-                <a:latin typeface="Space Grotesk Light" pitchFamily="34" charset="0"/>
-                <a:ea typeface="Space Grotesk Light" pitchFamily="34" charset="-122"/>
-                <a:cs typeface="Space Grotesk Light" pitchFamily="34" charset="-120"/>
+                <a:latin typeface="Arial"/>
+                <a:ea typeface="Arial"/>
+                <a:cs typeface="Arial"/>
               </a:rPr>
               <a:t>, Masood I</a:t>
             </a:r>
@@ -3578,9 +3576,9 @@
                 <a:solidFill>
                   <a:srgbClr val="FFFFFF"/>
                 </a:solidFill>
-                <a:latin typeface="Space Grotesk Light" pitchFamily="34" charset="0"/>
-                <a:ea typeface="Space Grotesk Light" pitchFamily="34" charset="-122"/>
-                <a:cs typeface="Space Grotesk Light" pitchFamily="34" charset="-120"/>
+                <a:latin typeface="Arial"/>
+                <a:ea typeface="Arial"/>
+                <a:cs typeface="Arial"/>
               </a:rPr>
               <a:t>b</a:t>
             </a:r>
@@ -3589,9 +3587,9 @@
                 <a:solidFill>
                   <a:srgbClr val="FFFFFF"/>
                 </a:solidFill>
-                <a:latin typeface="Space Grotesk Light" pitchFamily="34" charset="0"/>
-                <a:ea typeface="Space Grotesk Light" pitchFamily="34" charset="-122"/>
-                <a:cs typeface="Space Grotesk Light" pitchFamily="34" charset="-120"/>
+                <a:latin typeface="Arial"/>
+                <a:ea typeface="Arial"/>
+                <a:cs typeface="Arial"/>
               </a:rPr>
               <a:t>, Goyal D</a:t>
             </a:r>
@@ -3600,9 +3598,9 @@
                 <a:solidFill>
                   <a:srgbClr val="FFFFFF"/>
                 </a:solidFill>
-                <a:latin typeface="Space Grotesk Light" pitchFamily="34" charset="0"/>
-                <a:ea typeface="Space Grotesk Light" pitchFamily="34" charset="-122"/>
-                <a:cs typeface="Space Grotesk Light" pitchFamily="34" charset="-120"/>
+                <a:latin typeface="Arial"/>
+                <a:ea typeface="Arial"/>
+                <a:cs typeface="Arial"/>
               </a:rPr>
               <a:t>b</a:t>
             </a:r>
@@ -3611,9 +3609,9 @@
                 <a:solidFill>
                   <a:srgbClr val="FFFFFF"/>
                 </a:solidFill>
-                <a:latin typeface="Space Grotesk Light" pitchFamily="34" charset="0"/>
-                <a:ea typeface="Space Grotesk Light" pitchFamily="34" charset="-122"/>
-                <a:cs typeface="Space Grotesk Light" pitchFamily="34" charset="-120"/>
+                <a:latin typeface="Arial"/>
+                <a:ea typeface="Arial"/>
+                <a:cs typeface="Arial"/>
               </a:rPr>
               <a:t>, Rashid H</a:t>
             </a:r>
@@ -3622,9 +3620,9 @@
                 <a:solidFill>
                   <a:srgbClr val="FFFFFF"/>
                 </a:solidFill>
-                <a:latin typeface="Space Grotesk Light" pitchFamily="34" charset="0"/>
-                <a:ea typeface="Space Grotesk Light" pitchFamily="34" charset="-122"/>
-                <a:cs typeface="Space Grotesk Light" pitchFamily="34" charset="-120"/>
+                <a:latin typeface="Arial"/>
+                <a:ea typeface="Arial"/>
+                <a:cs typeface="Arial"/>
               </a:rPr>
               <a:t>a</a:t>
             </a:r>
@@ -3639,9 +3637,9 @@
                 <a:solidFill>
                   <a:srgbClr val="FFFFFF"/>
                 </a:solidFill>
-                <a:latin typeface="Space Grotesk Light" pitchFamily="34" charset="0"/>
-                <a:ea typeface="Space Grotesk Light" pitchFamily="34" charset="-122"/>
-                <a:cs typeface="Space Grotesk Light" pitchFamily="34" charset="-120"/>
+                <a:latin typeface="Arial"/>
+                <a:ea typeface="Arial"/>
+                <a:cs typeface="Arial"/>
               </a:rPr>
               <a:t>a</a:t>
             </a:r>
@@ -3650,9 +3648,9 @@
                 <a:solidFill>
                   <a:srgbClr val="FFFFFF"/>
                 </a:solidFill>
-                <a:latin typeface="Space Grotesk Light" pitchFamily="34" charset="0"/>
-                <a:ea typeface="Space Grotesk Light" pitchFamily="34" charset="-122"/>
-                <a:cs typeface="Space Grotesk Light" pitchFamily="34" charset="-120"/>
+                <a:latin typeface="Arial"/>
+                <a:ea typeface="Arial"/>
+                <a:cs typeface="Arial"/>
               </a:rPr>
               <a:t> Paras Hospital Srinagar, J&amp;K   </a:t>
             </a:r>
@@ -3661,9 +3659,9 @@
                 <a:solidFill>
                   <a:srgbClr val="FFFFFF"/>
                 </a:solidFill>
-                <a:latin typeface="Space Grotesk Light" pitchFamily="34" charset="0"/>
-                <a:ea typeface="Space Grotesk Light" pitchFamily="34" charset="-122"/>
-                <a:cs typeface="Space Grotesk Light" pitchFamily="34" charset="-120"/>
+                <a:latin typeface="Arial"/>
+                <a:ea typeface="Arial"/>
+                <a:cs typeface="Arial"/>
               </a:rPr>
               <a:t>b</a:t>
             </a:r>
@@ -3672,9 +3670,9 @@
                 <a:solidFill>
                   <a:srgbClr val="FFFFFF"/>
                 </a:solidFill>
-                <a:latin typeface="Space Grotesk Light" pitchFamily="34" charset="0"/>
-                <a:ea typeface="Space Grotesk Light" pitchFamily="34" charset="-122"/>
-                <a:cs typeface="Space Grotesk Light" pitchFamily="34" charset="-120"/>
+                <a:latin typeface="Arial"/>
+                <a:ea typeface="Arial"/>
+                <a:cs typeface="Arial"/>
               </a:rPr>
               <a:t> Max Hospital Bathinda, Punjab, India</a:t>
             </a:r>
@@ -3711,9 +3709,9 @@
                 <a:solidFill>
                   <a:srgbClr val="FFFFFF"/>
                 </a:solidFill>
-                <a:latin typeface="Space Grotesk Light" pitchFamily="34" charset="0"/>
-                <a:ea typeface="Space Grotesk Light" pitchFamily="34" charset="-122"/>
-                <a:cs typeface="Space Grotesk Light" pitchFamily="34" charset="-120"/>
+                <a:latin typeface="Arial"/>
+                <a:ea typeface="Arial"/>
+                <a:cs typeface="Arial"/>
               </a:rPr>
               <a:t>Am Heart J Plus: Cardiol Res Pract 2026;61:100678  |  doi:10.1016/j.ahjo.2025.100678</a:t>
             </a:r>
@@ -3929,9 +3927,9 @@
                 <a:solidFill>
                   <a:srgbClr val="0B3D66"/>
                 </a:solidFill>
-                <a:latin typeface="Space Grotesk" pitchFamily="34" charset="0"/>
-                <a:ea typeface="Space Grotesk" pitchFamily="34" charset="-122"/>
-                <a:cs typeface="Space Grotesk" pitchFamily="34" charset="-120"/>
+                <a:latin typeface="Arial"/>
+                <a:ea typeface="Arial"/>
+                <a:cs typeface="Arial"/>
               </a:rPr>
               <a:t>THANK YOU</a:t>
             </a:r>
@@ -3988,9 +3986,9 @@
                 <a:solidFill>
                   <a:srgbClr val="000000"/>
                 </a:solidFill>
-                <a:latin typeface="Space Grotesk Light" pitchFamily="34" charset="0"/>
-                <a:ea typeface="Space Grotesk Light" pitchFamily="34" charset="-122"/>
-                <a:cs typeface="Space Grotesk Light" pitchFamily="34" charset="-120"/>
+                <a:latin typeface="Arial"/>
+                <a:ea typeface="Arial"/>
+                <a:cs typeface="Arial"/>
               </a:rPr>
               <a:t>Questions and discussion</a:t>
             </a:r>
@@ -4005,9 +4003,9 @@
                 <a:solidFill>
                   <a:srgbClr val="0B3D66"/>
                 </a:solidFill>
-                <a:latin typeface="Space Grotesk Light" pitchFamily="34" charset="0"/>
-                <a:ea typeface="Space Grotesk Light" pitchFamily="34" charset="-122"/>
-                <a:cs typeface="Space Grotesk Light" pitchFamily="34" charset="-120"/>
+                <a:latin typeface="Arial"/>
+                <a:ea typeface="Arial"/>
+                <a:cs typeface="Arial"/>
               </a:rPr>
               <a:t>Dr. Mohd Maqbool Sohil, MD, DM, FSCAI</a:t>
             </a:r>
@@ -4022,9 +4020,9 @@
                 <a:solidFill>
                   <a:srgbClr val="000000"/>
                 </a:solidFill>
-                <a:latin typeface="Space Grotesk Light" pitchFamily="34" charset="0"/>
-                <a:ea typeface="Space Grotesk Light" pitchFamily="34" charset="-122"/>
-                <a:cs typeface="Space Grotesk Light" pitchFamily="34" charset="-120"/>
+                <a:latin typeface="Arial"/>
+                <a:ea typeface="Arial"/>
+                <a:cs typeface="Arial"/>
               </a:rPr>
               <a:t>Interventional Cardiologist  |  drmaqboolsohil.deed.page</a:t>
             </a:r>
@@ -4042,9 +4040,9 @@
                 <a:solidFill>
                   <a:srgbClr val="000000"/>
                 </a:solidFill>
-                <a:latin typeface="Space Grotesk Light" pitchFamily="34" charset="0"/>
-                <a:ea typeface="Space Grotesk Light" pitchFamily="34" charset="-122"/>
-                <a:cs typeface="Space Grotesk Light" pitchFamily="34" charset="-120"/>
+                <a:latin typeface="Arial"/>
+                <a:ea typeface="Arial"/>
+                <a:cs typeface="Arial"/>
               </a:rPr>
               <a:t>Sohil MM, Masood I, Goyal D, Rashid H. Single centre experience of rotablation-assisted left main percutaneous coronary intervention. Am Heart J Plus: Cardiol Res Pract 2026;61:100678.</a:t>
             </a:r>
@@ -4059,9 +4057,9 @@
                 <a:solidFill>
                   <a:srgbClr val="000000"/>
                 </a:solidFill>
-                <a:latin typeface="Space Grotesk Light" pitchFamily="34" charset="0"/>
-                <a:ea typeface="Space Grotesk Light" pitchFamily="34" charset="-122"/>
-                <a:cs typeface="Space Grotesk Light" pitchFamily="34" charset="-120"/>
+                <a:latin typeface="Arial"/>
+                <a:ea typeface="Arial"/>
+                <a:cs typeface="Arial"/>
               </a:rPr>
               <a:t>doi:10.1016/j.ahjo.2025.100678  |  Open access, CC BY-NC-ND 4.0</a:t>
             </a:r>
@@ -4245,9 +4243,9 @@
                 <a:solidFill>
                   <a:srgbClr val="0B3D66"/>
                 </a:solidFill>
-                <a:latin typeface="Space Grotesk Light" pitchFamily="34" charset="0"/>
-                <a:ea typeface="Space Grotesk Light" pitchFamily="34" charset="-122"/>
-                <a:cs typeface="Space Grotesk Light" pitchFamily="34" charset="-120"/>
+                <a:latin typeface="Arial"/>
+                <a:ea typeface="Arial"/>
+                <a:cs typeface="Arial"/>
               </a:rPr>
               <a:t>Sohil MM et al.  |  Am Heart J Plus 2026;61:100678</a:t>
             </a:r>
@@ -4284,9 +4282,9 @@
                 <a:solidFill>
                   <a:srgbClr val="0B3D66"/>
                 </a:solidFill>
-                <a:latin typeface="Space Grotesk" pitchFamily="34" charset="0"/>
-                <a:ea typeface="Space Grotesk" pitchFamily="34" charset="-122"/>
-                <a:cs typeface="Space Grotesk" pitchFamily="34" charset="-120"/>
+                <a:latin typeface="Arial"/>
+                <a:ea typeface="Arial"/>
+                <a:cs typeface="Arial"/>
               </a:rPr>
               <a:t>17</a:t>
             </a:r>
@@ -4355,9 +4353,9 @@
                 <a:solidFill>
                   <a:srgbClr val="0B3D66"/>
                 </a:solidFill>
-                <a:latin typeface="Space Grotesk" pitchFamily="34" charset="0"/>
-                <a:ea typeface="Space Grotesk" pitchFamily="34" charset="-122"/>
-                <a:cs typeface="Space Grotesk" pitchFamily="34" charset="-120"/>
+                <a:latin typeface="Arial"/>
+                <a:ea typeface="Arial"/>
+                <a:cs typeface="Arial"/>
               </a:rPr>
               <a:t>Rotablator RA technique</a:t>
             </a:r>
@@ -4417,9 +4415,9 @@
                 <a:solidFill>
                   <a:srgbClr val="0B3D66"/>
                 </a:solidFill>
-                <a:latin typeface="Space Grotesk" pitchFamily="34" charset="0"/>
-                <a:ea typeface="Space Grotesk" pitchFamily="34" charset="-122"/>
-                <a:cs typeface="Space Grotesk" pitchFamily="34" charset="-120"/>
+                <a:latin typeface="Arial"/>
+                <a:ea typeface="Arial"/>
+                <a:cs typeface="Arial"/>
               </a:rPr>
               <a:t>0.7</a:t>
             </a:r>
@@ -4456,9 +4454,9 @@
                 <a:solidFill>
                   <a:srgbClr val="000000"/>
                 </a:solidFill>
-                <a:latin typeface="Space Grotesk Light" pitchFamily="34" charset="0"/>
-                <a:ea typeface="Space Grotesk Light" pitchFamily="34" charset="-122"/>
-                <a:cs typeface="Space Grotesk Light" pitchFamily="34" charset="-120"/>
+                <a:latin typeface="Arial"/>
+                <a:ea typeface="Arial"/>
+                <a:cs typeface="Arial"/>
               </a:rPr>
               <a:t>target burr : artery ratio</a:t>
             </a:r>
@@ -4518,9 +4516,9 @@
                 <a:solidFill>
                   <a:srgbClr val="0B3D66"/>
                 </a:solidFill>
-                <a:latin typeface="Space Grotesk" pitchFamily="34" charset="0"/>
-                <a:ea typeface="Space Grotesk" pitchFamily="34" charset="-122"/>
-                <a:cs typeface="Space Grotesk" pitchFamily="34" charset="-120"/>
+                <a:latin typeface="Arial"/>
+                <a:ea typeface="Arial"/>
+                <a:cs typeface="Arial"/>
               </a:rPr>
               <a:t>1.25–2.0</a:t>
             </a:r>
@@ -4557,9 +4555,9 @@
                 <a:solidFill>
                   <a:srgbClr val="000000"/>
                 </a:solidFill>
-                <a:latin typeface="Space Grotesk Light" pitchFamily="34" charset="0"/>
-                <a:ea typeface="Space Grotesk Light" pitchFamily="34" charset="-122"/>
-                <a:cs typeface="Space Grotesk Light" pitchFamily="34" charset="-120"/>
+                <a:latin typeface="Arial"/>
+                <a:ea typeface="Arial"/>
+                <a:cs typeface="Arial"/>
               </a:rPr>
               <a:t>mm burrs; multiple if needed</a:t>
             </a:r>
@@ -4619,9 +4617,9 @@
                 <a:solidFill>
                   <a:srgbClr val="C8102E"/>
                 </a:solidFill>
-                <a:latin typeface="Space Grotesk" pitchFamily="34" charset="0"/>
-                <a:ea typeface="Space Grotesk" pitchFamily="34" charset="-122"/>
-                <a:cs typeface="Space Grotesk" pitchFamily="34" charset="-120"/>
+                <a:latin typeface="Arial"/>
+                <a:ea typeface="Arial"/>
+                <a:cs typeface="Arial"/>
               </a:rPr>
               <a:t>140–180k</a:t>
             </a:r>
@@ -4658,9 +4656,9 @@
                 <a:solidFill>
                   <a:srgbClr val="000000"/>
                 </a:solidFill>
-                <a:latin typeface="Space Grotesk Light" pitchFamily="34" charset="0"/>
-                <a:ea typeface="Space Grotesk Light" pitchFamily="34" charset="-122"/>
-                <a:cs typeface="Space Grotesk Light" pitchFamily="34" charset="-120"/>
+                <a:latin typeface="Arial"/>
+                <a:ea typeface="Arial"/>
+                <a:cs typeface="Arial"/>
               </a:rPr>
               <a:t>rpm; burr runs &lt;30 s</a:t>
             </a:r>
@@ -4844,9 +4842,9 @@
                 <a:solidFill>
                   <a:srgbClr val="0B3D66"/>
                 </a:solidFill>
-                <a:latin typeface="Space Grotesk Light" pitchFamily="34" charset="0"/>
-                <a:ea typeface="Space Grotesk Light" pitchFamily="34" charset="-122"/>
-                <a:cs typeface="Space Grotesk Light" pitchFamily="34" charset="-120"/>
+                <a:latin typeface="Arial"/>
+                <a:ea typeface="Arial"/>
+                <a:cs typeface="Arial"/>
               </a:rPr>
               <a:t>Sohil MM et al.  |  Am Heart J Plus 2026;61:100678</a:t>
             </a:r>
@@ -4883,9 +4881,9 @@
                 <a:solidFill>
                   <a:srgbClr val="0B3D66"/>
                 </a:solidFill>
-                <a:latin typeface="Space Grotesk" pitchFamily="34" charset="0"/>
-                <a:ea typeface="Space Grotesk" pitchFamily="34" charset="-122"/>
-                <a:cs typeface="Space Grotesk" pitchFamily="34" charset="-120"/>
+                <a:latin typeface="Arial"/>
+                <a:ea typeface="Arial"/>
+                <a:cs typeface="Arial"/>
               </a:rPr>
               <a:t>6</a:t>
             </a:r>
@@ -4954,9 +4952,9 @@
                 <a:solidFill>
                   <a:srgbClr val="0B3D66"/>
                 </a:solidFill>
-                <a:latin typeface="Space Grotesk" pitchFamily="34" charset="0"/>
-                <a:ea typeface="Space Grotesk" pitchFamily="34" charset="-122"/>
-                <a:cs typeface="Space Grotesk" pitchFamily="34" charset="-120"/>
+                <a:latin typeface="Arial"/>
+                <a:ea typeface="Arial"/>
+                <a:cs typeface="Arial"/>
               </a:rPr>
               <a:t>Procedural details</a:t>
             </a:r>
@@ -4996,7 +4994,7 @@
           <p:nvPr>
             <p:extLst>
               <p:ext uri="{D42A27DB-BD31-4B8C-83A1-F6EECF244321}">
-                <p14:modId xmlns:p14="http://schemas.microsoft.com/office/powerpoint/2010/main" val="1579011935"/>
+                <p14:modId xmlns:p14="http://schemas.microsoft.com/office/powerpoint/2010/main" val="930656917"/>
               </p:ext>
             </p:extLst>
           </p:nvPr>
@@ -5029,16 +5027,16 @@
                           <a:solidFill>
                             <a:srgbClr val="FFFFFF"/>
                           </a:solidFill>
-                          <a:latin typeface="Space Grotesk" pitchFamily="34" charset="0"/>
-                          <a:ea typeface="Space Grotesk" pitchFamily="34" charset="-122"/>
-                          <a:cs typeface="Space Grotesk" pitchFamily="34" charset="-120"/>
+                          <a:latin typeface="Arial"/>
+                          <a:ea typeface="Arial"/>
+                          <a:cs typeface="Arial"/>
                         </a:rPr>
                         <a:t>Technique</a:t>
                       </a:r>
                       <a:endParaRPr lang="en-US" sz="2200" dirty="0">
-                        <a:latin typeface="Space Grotesk" charset="0"/>
-                        <a:ea typeface="Space Grotesk" charset="0"/>
-                        <a:cs typeface="Space Grotesk" charset="0"/>
+                        <a:latin typeface="Arial"/>
+                        <a:ea typeface="Arial"/>
+                        <a:cs typeface="Arial"/>
                       </a:endParaRPr>
                     </a:p>
                   </a:txBody>
@@ -5097,16 +5095,16 @@
                           <a:solidFill>
                             <a:srgbClr val="FFFFFF"/>
                           </a:solidFill>
-                          <a:latin typeface="Space Grotesk" pitchFamily="34" charset="0"/>
-                          <a:ea typeface="Space Grotesk" pitchFamily="34" charset="-122"/>
-                          <a:cs typeface="Space Grotesk" pitchFamily="34" charset="-120"/>
+                          <a:latin typeface="Arial"/>
+                          <a:ea typeface="Arial"/>
+                          <a:cs typeface="Arial"/>
                         </a:rPr>
                         <a:t>n (%)</a:t>
                       </a:r>
                       <a:endParaRPr lang="en-US" sz="2200" dirty="0">
-                        <a:latin typeface="Space Grotesk" charset="0"/>
-                        <a:ea typeface="Space Grotesk" charset="0"/>
-                        <a:cs typeface="Space Grotesk" charset="0"/>
+                        <a:latin typeface="Arial"/>
+                        <a:ea typeface="Arial"/>
+                        <a:cs typeface="Arial"/>
                       </a:endParaRPr>
                     </a:p>
                   </a:txBody>
@@ -5165,16 +5163,16 @@
                           <a:solidFill>
                             <a:srgbClr val="FFFFFF"/>
                           </a:solidFill>
-                          <a:latin typeface="Space Grotesk" pitchFamily="34" charset="0"/>
-                          <a:ea typeface="Space Grotesk" pitchFamily="34" charset="-122"/>
-                          <a:cs typeface="Space Grotesk" pitchFamily="34" charset="-120"/>
+                          <a:latin typeface="Arial"/>
+                          <a:ea typeface="Arial"/>
+                          <a:cs typeface="Arial"/>
                         </a:rPr>
                         <a:t>Parameter</a:t>
                       </a:r>
                       <a:endParaRPr lang="en-US" sz="2200" dirty="0">
-                        <a:latin typeface="Space Grotesk" charset="0"/>
-                        <a:ea typeface="Space Grotesk" charset="0"/>
-                        <a:cs typeface="Space Grotesk" charset="0"/>
+                        <a:latin typeface="Arial"/>
+                        <a:ea typeface="Arial"/>
+                        <a:cs typeface="Arial"/>
                       </a:endParaRPr>
                     </a:p>
                   </a:txBody>
@@ -5233,16 +5231,16 @@
                           <a:solidFill>
                             <a:srgbClr val="FFFFFF"/>
                           </a:solidFill>
-                          <a:latin typeface="Space Grotesk" pitchFamily="34" charset="0"/>
-                          <a:ea typeface="Space Grotesk" pitchFamily="34" charset="-122"/>
-                          <a:cs typeface="Space Grotesk" pitchFamily="34" charset="-120"/>
+                          <a:latin typeface="Arial"/>
+                          <a:ea typeface="Arial"/>
+                          <a:cs typeface="Arial"/>
                         </a:rPr>
                         <a:t>Value</a:t>
                       </a:r>
                       <a:endParaRPr lang="en-US" sz="2200" dirty="0">
-                        <a:latin typeface="Space Grotesk" charset="0"/>
-                        <a:ea typeface="Space Grotesk" charset="0"/>
-                        <a:cs typeface="Space Grotesk" charset="0"/>
+                        <a:latin typeface="Arial"/>
+                        <a:ea typeface="Arial"/>
+                        <a:cs typeface="Arial"/>
                       </a:endParaRPr>
                     </a:p>
                   </a:txBody>
@@ -5303,16 +5301,16 @@
                           <a:solidFill>
                             <a:srgbClr val="000000"/>
                           </a:solidFill>
-                          <a:latin typeface="Space Grotesk Light" pitchFamily="34" charset="0"/>
-                          <a:ea typeface="Space Grotesk Light" pitchFamily="34" charset="-122"/>
-                          <a:cs typeface="Space Grotesk Light" pitchFamily="34" charset="-120"/>
+                          <a:latin typeface="Arial"/>
+                          <a:ea typeface="Arial"/>
+                          <a:cs typeface="Arial"/>
                         </a:rPr>
                         <a:t>Femoral access</a:t>
                       </a:r>
                       <a:endParaRPr lang="en-US" sz="2200" dirty="0">
-                        <a:latin typeface="Space Grotesk Light" charset="0"/>
-                        <a:ea typeface="Space Grotesk Light" charset="0"/>
-                        <a:cs typeface="Space Grotesk Light" charset="0"/>
+                        <a:latin typeface="Arial"/>
+                        <a:ea typeface="Arial"/>
+                        <a:cs typeface="Arial"/>
                       </a:endParaRPr>
                     </a:p>
                   </a:txBody>
@@ -5368,16 +5366,16 @@
                           <a:solidFill>
                             <a:srgbClr val="000000"/>
                           </a:solidFill>
-                          <a:latin typeface="Space Grotesk Light" pitchFamily="34" charset="0"/>
-                          <a:ea typeface="Space Grotesk Light" pitchFamily="34" charset="-122"/>
-                          <a:cs typeface="Space Grotesk Light" pitchFamily="34" charset="-120"/>
+                          <a:latin typeface="Arial"/>
+                          <a:ea typeface="Arial"/>
+                          <a:cs typeface="Arial"/>
                         </a:rPr>
                         <a:t>38 (84.4%)</a:t>
                       </a:r>
                       <a:endParaRPr lang="en-US" sz="2200" dirty="0">
-                        <a:latin typeface="Space Grotesk Light" charset="0"/>
-                        <a:ea typeface="Space Grotesk Light" charset="0"/>
-                        <a:cs typeface="Space Grotesk Light" charset="0"/>
+                        <a:latin typeface="Arial"/>
+                        <a:ea typeface="Arial"/>
+                        <a:cs typeface="Arial"/>
                       </a:endParaRPr>
                     </a:p>
                   </a:txBody>
@@ -5433,16 +5431,16 @@
                           <a:solidFill>
                             <a:srgbClr val="000000"/>
                           </a:solidFill>
-                          <a:latin typeface="Space Grotesk Light" pitchFamily="34" charset="0"/>
-                          <a:ea typeface="Space Grotesk Light" pitchFamily="34" charset="-122"/>
-                          <a:cs typeface="Space Grotesk Light" pitchFamily="34" charset="-120"/>
+                          <a:latin typeface="Arial"/>
+                          <a:ea typeface="Arial"/>
+                          <a:cs typeface="Arial"/>
                         </a:rPr>
                         <a:t>Max burr, mm</a:t>
                       </a:r>
                       <a:endParaRPr lang="en-US" sz="2200" dirty="0">
-                        <a:latin typeface="Space Grotesk Light" charset="0"/>
-                        <a:ea typeface="Space Grotesk Light" charset="0"/>
-                        <a:cs typeface="Space Grotesk Light" charset="0"/>
+                        <a:latin typeface="Arial"/>
+                        <a:ea typeface="Arial"/>
+                        <a:cs typeface="Arial"/>
                       </a:endParaRPr>
                     </a:p>
                   </a:txBody>
@@ -5498,16 +5496,16 @@
                           <a:solidFill>
                             <a:srgbClr val="000000"/>
                           </a:solidFill>
-                          <a:latin typeface="Space Grotesk Light" pitchFamily="34" charset="0"/>
-                          <a:ea typeface="Space Grotesk Light" pitchFamily="34" charset="-122"/>
-                          <a:cs typeface="Space Grotesk Light" pitchFamily="34" charset="-120"/>
+                          <a:latin typeface="Arial"/>
+                          <a:ea typeface="Arial"/>
+                          <a:cs typeface="Arial"/>
                         </a:rPr>
                         <a:t>1.50 ± 0.13</a:t>
                       </a:r>
                       <a:endParaRPr lang="en-US" sz="2200" dirty="0">
-                        <a:latin typeface="Space Grotesk Light" charset="0"/>
-                        <a:ea typeface="Space Grotesk Light" charset="0"/>
-                        <a:cs typeface="Space Grotesk Light" charset="0"/>
+                        <a:latin typeface="Arial"/>
+                        <a:ea typeface="Arial"/>
+                        <a:cs typeface="Arial"/>
                       </a:endParaRPr>
                     </a:p>
                   </a:txBody>
@@ -5565,16 +5563,16 @@
                           <a:solidFill>
                             <a:srgbClr val="000000"/>
                           </a:solidFill>
-                          <a:latin typeface="Space Grotesk Light" pitchFamily="34" charset="0"/>
-                          <a:ea typeface="Space Grotesk Light" pitchFamily="34" charset="-122"/>
-                          <a:cs typeface="Space Grotesk Light" pitchFamily="34" charset="-120"/>
+                          <a:latin typeface="Arial"/>
+                          <a:ea typeface="Arial"/>
+                          <a:cs typeface="Arial"/>
                         </a:rPr>
                         <a:t>7F guide</a:t>
                       </a:r>
                       <a:endParaRPr lang="en-US" sz="2200" dirty="0">
-                        <a:latin typeface="Space Grotesk Light" charset="0"/>
-                        <a:ea typeface="Space Grotesk Light" charset="0"/>
-                        <a:cs typeface="Space Grotesk Light" charset="0"/>
+                        <a:latin typeface="Arial"/>
+                        <a:ea typeface="Arial"/>
+                        <a:cs typeface="Arial"/>
                       </a:endParaRPr>
                     </a:p>
                   </a:txBody>
@@ -5633,16 +5631,16 @@
                           <a:solidFill>
                             <a:srgbClr val="000000"/>
                           </a:solidFill>
-                          <a:latin typeface="Space Grotesk Light" pitchFamily="34" charset="0"/>
-                          <a:ea typeface="Space Grotesk Light" pitchFamily="34" charset="-122"/>
-                          <a:cs typeface="Space Grotesk Light" pitchFamily="34" charset="-120"/>
+                          <a:latin typeface="Arial"/>
+                          <a:ea typeface="Arial"/>
+                          <a:cs typeface="Arial"/>
                         </a:rPr>
                         <a:t>45 (100%)</a:t>
                       </a:r>
                       <a:endParaRPr lang="en-US" sz="2200" dirty="0">
-                        <a:latin typeface="Space Grotesk Light" charset="0"/>
-                        <a:ea typeface="Space Grotesk Light" charset="0"/>
-                        <a:cs typeface="Space Grotesk Light" charset="0"/>
+                        <a:latin typeface="Arial"/>
+                        <a:ea typeface="Arial"/>
+                        <a:cs typeface="Arial"/>
                       </a:endParaRPr>
                     </a:p>
                   </a:txBody>
@@ -5701,16 +5699,16 @@
                           <a:solidFill>
                             <a:srgbClr val="000000"/>
                           </a:solidFill>
-                          <a:latin typeface="Space Grotesk Light" pitchFamily="34" charset="0"/>
-                          <a:ea typeface="Space Grotesk Light" pitchFamily="34" charset="-122"/>
-                          <a:cs typeface="Space Grotesk Light" pitchFamily="34" charset="-120"/>
+                          <a:latin typeface="Arial"/>
+                          <a:ea typeface="Arial"/>
+                          <a:cs typeface="Arial"/>
                         </a:rPr>
                         <a:t>Burrs/patient</a:t>
                       </a:r>
                       <a:endParaRPr lang="en-US" sz="2200" dirty="0">
-                        <a:latin typeface="Space Grotesk Light" charset="0"/>
-                        <a:ea typeface="Space Grotesk Light" charset="0"/>
-                        <a:cs typeface="Space Grotesk Light" charset="0"/>
+                        <a:latin typeface="Arial"/>
+                        <a:ea typeface="Arial"/>
+                        <a:cs typeface="Arial"/>
                       </a:endParaRPr>
                     </a:p>
                   </a:txBody>
@@ -5769,16 +5767,16 @@
                           <a:solidFill>
                             <a:srgbClr val="000000"/>
                           </a:solidFill>
-                          <a:latin typeface="Space Grotesk Light" pitchFamily="34" charset="0"/>
-                          <a:ea typeface="Space Grotesk Light" pitchFamily="34" charset="-122"/>
-                          <a:cs typeface="Space Grotesk Light" pitchFamily="34" charset="-120"/>
+                          <a:latin typeface="Arial"/>
+                          <a:ea typeface="Arial"/>
+                          <a:cs typeface="Arial"/>
                         </a:rPr>
                         <a:t>1.11 ± 0.31</a:t>
                       </a:r>
                       <a:endParaRPr lang="en-US" sz="2200" dirty="0">
-                        <a:latin typeface="Space Grotesk Light" charset="0"/>
-                        <a:ea typeface="Space Grotesk Light" charset="0"/>
-                        <a:cs typeface="Space Grotesk Light" charset="0"/>
+                        <a:latin typeface="Arial"/>
+                        <a:ea typeface="Arial"/>
+                        <a:cs typeface="Arial"/>
                       </a:endParaRPr>
                     </a:p>
                   </a:txBody>
@@ -5839,16 +5837,16 @@
                           <a:solidFill>
                             <a:srgbClr val="000000"/>
                           </a:solidFill>
-                          <a:latin typeface="Space Grotesk Light" pitchFamily="34" charset="0"/>
-                          <a:ea typeface="Space Grotesk Light" pitchFamily="34" charset="-122"/>
-                          <a:cs typeface="Space Grotesk Light" pitchFamily="34" charset="-120"/>
+                          <a:latin typeface="Arial"/>
+                          <a:ea typeface="Arial"/>
+                          <a:cs typeface="Arial"/>
                         </a:rPr>
                         <a:t>Two-stent</a:t>
                       </a:r>
                       <a:endParaRPr lang="en-US" sz="2200" dirty="0">
-                        <a:latin typeface="Space Grotesk Light" charset="0"/>
-                        <a:ea typeface="Space Grotesk Light" charset="0"/>
-                        <a:cs typeface="Space Grotesk Light" charset="0"/>
+                        <a:latin typeface="Arial"/>
+                        <a:ea typeface="Arial"/>
+                        <a:cs typeface="Arial"/>
                       </a:endParaRPr>
                     </a:p>
                   </a:txBody>
@@ -5904,16 +5902,16 @@
                           <a:solidFill>
                             <a:srgbClr val="000000"/>
                           </a:solidFill>
-                          <a:latin typeface="Space Grotesk Light" pitchFamily="34" charset="0"/>
-                          <a:ea typeface="Space Grotesk Light" pitchFamily="34" charset="-122"/>
-                          <a:cs typeface="Space Grotesk Light" pitchFamily="34" charset="-120"/>
+                          <a:latin typeface="Arial"/>
+                          <a:ea typeface="Arial"/>
+                          <a:cs typeface="Arial"/>
                         </a:rPr>
                         <a:t>34 (75.6%)</a:t>
                       </a:r>
                       <a:endParaRPr lang="en-US" sz="2200" dirty="0">
-                        <a:latin typeface="Space Grotesk Light" charset="0"/>
-                        <a:ea typeface="Space Grotesk Light" charset="0"/>
-                        <a:cs typeface="Space Grotesk Light" charset="0"/>
+                        <a:latin typeface="Arial"/>
+                        <a:ea typeface="Arial"/>
+                        <a:cs typeface="Arial"/>
                       </a:endParaRPr>
                     </a:p>
                   </a:txBody>
@@ -5969,16 +5967,16 @@
                           <a:solidFill>
                             <a:srgbClr val="000000"/>
                           </a:solidFill>
-                          <a:latin typeface="Space Grotesk Light" pitchFamily="34" charset="0"/>
-                          <a:ea typeface="Space Grotesk Light" pitchFamily="34" charset="-122"/>
-                          <a:cs typeface="Space Grotesk Light" pitchFamily="34" charset="-120"/>
+                          <a:latin typeface="Arial"/>
+                          <a:ea typeface="Arial"/>
+                          <a:cs typeface="Arial"/>
                         </a:rPr>
                         <a:t>Stent len., mm</a:t>
                       </a:r>
                       <a:endParaRPr lang="en-US" sz="2200" dirty="0">
-                        <a:latin typeface="Space Grotesk Light" charset="0"/>
-                        <a:ea typeface="Space Grotesk Light" charset="0"/>
-                        <a:cs typeface="Space Grotesk Light" charset="0"/>
+                        <a:latin typeface="Arial"/>
+                        <a:ea typeface="Arial"/>
+                        <a:cs typeface="Arial"/>
                       </a:endParaRPr>
                     </a:p>
                   </a:txBody>
@@ -6034,16 +6032,16 @@
                           <a:solidFill>
                             <a:srgbClr val="000000"/>
                           </a:solidFill>
-                          <a:latin typeface="Space Grotesk Light" pitchFamily="34" charset="0"/>
-                          <a:ea typeface="Space Grotesk Light" pitchFamily="34" charset="-122"/>
-                          <a:cs typeface="Space Grotesk Light" pitchFamily="34" charset="-120"/>
+                          <a:latin typeface="Arial"/>
+                          <a:ea typeface="Arial"/>
+                          <a:cs typeface="Arial"/>
                         </a:rPr>
                         <a:t>22.98 ± 6.54</a:t>
                       </a:r>
                       <a:endParaRPr lang="en-US" sz="2200" dirty="0">
-                        <a:latin typeface="Space Grotesk Light" charset="0"/>
-                        <a:ea typeface="Space Grotesk Light" charset="0"/>
-                        <a:cs typeface="Space Grotesk Light" charset="0"/>
+                        <a:latin typeface="Arial"/>
+                        <a:ea typeface="Arial"/>
+                        <a:cs typeface="Arial"/>
                       </a:endParaRPr>
                     </a:p>
                   </a:txBody>
@@ -6101,16 +6099,16 @@
                           <a:solidFill>
                             <a:srgbClr val="000000"/>
                           </a:solidFill>
-                          <a:latin typeface="Space Grotesk Light" pitchFamily="34" charset="0"/>
-                          <a:ea typeface="Space Grotesk Light" pitchFamily="34" charset="-122"/>
-                          <a:cs typeface="Space Grotesk Light" pitchFamily="34" charset="-120"/>
+                          <a:latin typeface="Arial"/>
+                          <a:ea typeface="Arial"/>
+                          <a:cs typeface="Arial"/>
                         </a:rPr>
                         <a:t>DK crush</a:t>
                       </a:r>
                       <a:endParaRPr lang="en-US" sz="2200" dirty="0">
-                        <a:latin typeface="Space Grotesk Light" charset="0"/>
-                        <a:ea typeface="Space Grotesk Light" charset="0"/>
-                        <a:cs typeface="Space Grotesk Light" charset="0"/>
+                        <a:latin typeface="Arial"/>
+                        <a:ea typeface="Arial"/>
+                        <a:cs typeface="Arial"/>
                       </a:endParaRPr>
                     </a:p>
                   </a:txBody>
@@ -6169,16 +6167,16 @@
                           <a:solidFill>
                             <a:srgbClr val="000000"/>
                           </a:solidFill>
-                          <a:latin typeface="Space Grotesk Light" pitchFamily="34" charset="0"/>
-                          <a:ea typeface="Space Grotesk Light" pitchFamily="34" charset="-122"/>
-                          <a:cs typeface="Space Grotesk Light" pitchFamily="34" charset="-120"/>
+                          <a:latin typeface="Arial"/>
+                          <a:ea typeface="Arial"/>
+                          <a:cs typeface="Arial"/>
                         </a:rPr>
                         <a:t>32 (71.1%)</a:t>
                       </a:r>
                       <a:endParaRPr lang="en-US" sz="2200" dirty="0">
-                        <a:latin typeface="Space Grotesk Light" charset="0"/>
-                        <a:ea typeface="Space Grotesk Light" charset="0"/>
-                        <a:cs typeface="Space Grotesk Light" charset="0"/>
+                        <a:latin typeface="Arial"/>
+                        <a:ea typeface="Arial"/>
+                        <a:cs typeface="Arial"/>
                       </a:endParaRPr>
                     </a:p>
                   </a:txBody>
@@ -6237,16 +6235,16 @@
                           <a:solidFill>
                             <a:srgbClr val="000000"/>
                           </a:solidFill>
-                          <a:latin typeface="Space Grotesk Light" pitchFamily="34" charset="0"/>
-                          <a:ea typeface="Space Grotesk Light" pitchFamily="34" charset="-122"/>
-                          <a:cs typeface="Space Grotesk Light" pitchFamily="34" charset="-120"/>
+                          <a:latin typeface="Arial"/>
+                          <a:ea typeface="Arial"/>
+                          <a:cs typeface="Arial"/>
                         </a:rPr>
                         <a:t>Stent dia., mm</a:t>
                       </a:r>
                       <a:endParaRPr lang="en-US" sz="2200" dirty="0">
-                        <a:latin typeface="Space Grotesk Light" charset="0"/>
-                        <a:ea typeface="Space Grotesk Light" charset="0"/>
-                        <a:cs typeface="Space Grotesk Light" charset="0"/>
+                        <a:latin typeface="Arial"/>
+                        <a:ea typeface="Arial"/>
+                        <a:cs typeface="Arial"/>
                       </a:endParaRPr>
                     </a:p>
                   </a:txBody>
@@ -6305,16 +6303,16 @@
                           <a:solidFill>
                             <a:srgbClr val="000000"/>
                           </a:solidFill>
-                          <a:latin typeface="Space Grotesk Light" pitchFamily="34" charset="0"/>
-                          <a:ea typeface="Space Grotesk Light" pitchFamily="34" charset="-122"/>
-                          <a:cs typeface="Space Grotesk Light" pitchFamily="34" charset="-120"/>
+                          <a:latin typeface="Arial"/>
+                          <a:ea typeface="Arial"/>
+                          <a:cs typeface="Arial"/>
                         </a:rPr>
                         <a:t>3.49 ± 0.40</a:t>
                       </a:r>
                       <a:endParaRPr lang="en-US" sz="2200" dirty="0">
-                        <a:latin typeface="Space Grotesk Light" charset="0"/>
-                        <a:ea typeface="Space Grotesk Light" charset="0"/>
-                        <a:cs typeface="Space Grotesk Light" charset="0"/>
+                        <a:latin typeface="Arial"/>
+                        <a:ea typeface="Arial"/>
+                        <a:cs typeface="Arial"/>
                       </a:endParaRPr>
                     </a:p>
                   </a:txBody>
@@ -6375,16 +6373,16 @@
                           <a:solidFill>
                             <a:srgbClr val="000000"/>
                           </a:solidFill>
-                          <a:latin typeface="Space Grotesk Light" pitchFamily="34" charset="0"/>
-                          <a:ea typeface="Space Grotesk Light" pitchFamily="34" charset="-122"/>
-                          <a:cs typeface="Space Grotesk Light" pitchFamily="34" charset="-120"/>
+                          <a:latin typeface="Arial"/>
+                          <a:ea typeface="Arial"/>
+                          <a:cs typeface="Arial"/>
                         </a:rPr>
                         <a:t>IVUS</a:t>
                       </a:r>
                       <a:endParaRPr lang="en-US" sz="2200" dirty="0">
-                        <a:latin typeface="Space Grotesk Light" charset="0"/>
-                        <a:ea typeface="Space Grotesk Light" charset="0"/>
-                        <a:cs typeface="Space Grotesk Light" charset="0"/>
+                        <a:latin typeface="Arial"/>
+                        <a:ea typeface="Arial"/>
+                        <a:cs typeface="Arial"/>
                       </a:endParaRPr>
                     </a:p>
                   </a:txBody>
@@ -6440,16 +6438,16 @@
                           <a:solidFill>
                             <a:srgbClr val="000000"/>
                           </a:solidFill>
-                          <a:latin typeface="Space Grotesk Light" pitchFamily="34" charset="0"/>
-                          <a:ea typeface="Space Grotesk Light" pitchFamily="34" charset="-122"/>
-                          <a:cs typeface="Space Grotesk Light" pitchFamily="34" charset="-120"/>
+                          <a:latin typeface="Arial"/>
+                          <a:ea typeface="Arial"/>
+                          <a:cs typeface="Arial"/>
                         </a:rPr>
                         <a:t>34 (75.6%)</a:t>
                       </a:r>
                       <a:endParaRPr lang="en-US" sz="2200" dirty="0">
-                        <a:latin typeface="Space Grotesk Light" charset="0"/>
-                        <a:ea typeface="Space Grotesk Light" charset="0"/>
-                        <a:cs typeface="Space Grotesk Light" charset="0"/>
+                        <a:latin typeface="Arial"/>
+                        <a:ea typeface="Arial"/>
+                        <a:cs typeface="Arial"/>
                       </a:endParaRPr>
                     </a:p>
                   </a:txBody>
@@ -6505,16 +6503,16 @@
                           <a:solidFill>
                             <a:srgbClr val="000000"/>
                           </a:solidFill>
-                          <a:latin typeface="Space Grotesk Light" pitchFamily="34" charset="0"/>
-                          <a:ea typeface="Space Grotesk Light" pitchFamily="34" charset="-122"/>
-                          <a:cs typeface="Space Grotesk Light" pitchFamily="34" charset="-120"/>
+                          <a:latin typeface="Arial"/>
+                          <a:ea typeface="Arial"/>
+                          <a:cs typeface="Arial"/>
                         </a:rPr>
                         <a:t>IABP, n (%)</a:t>
                       </a:r>
                       <a:endParaRPr lang="en-US" sz="2200" dirty="0">
-                        <a:latin typeface="Space Grotesk Light" charset="0"/>
-                        <a:ea typeface="Space Grotesk Light" charset="0"/>
-                        <a:cs typeface="Space Grotesk Light" charset="0"/>
+                        <a:latin typeface="Arial"/>
+                        <a:ea typeface="Arial"/>
+                        <a:cs typeface="Arial"/>
                       </a:endParaRPr>
                     </a:p>
                   </a:txBody>
@@ -6570,16 +6568,16 @@
                           <a:solidFill>
                             <a:srgbClr val="000000"/>
                           </a:solidFill>
-                          <a:latin typeface="Space Grotesk Light" pitchFamily="34" charset="0"/>
-                          <a:ea typeface="Space Grotesk Light" pitchFamily="34" charset="-122"/>
-                          <a:cs typeface="Space Grotesk Light" pitchFamily="34" charset="-120"/>
+                          <a:latin typeface="Arial"/>
+                          <a:ea typeface="Arial"/>
+                          <a:cs typeface="Arial"/>
                         </a:rPr>
                         <a:t>7 (15.6%)</a:t>
                       </a:r>
                       <a:endParaRPr lang="en-US" sz="2200" dirty="0">
-                        <a:latin typeface="Space Grotesk Light" charset="0"/>
-                        <a:ea typeface="Space Grotesk Light" charset="0"/>
-                        <a:cs typeface="Space Grotesk Light" charset="0"/>
+                        <a:latin typeface="Arial"/>
+                        <a:ea typeface="Arial"/>
+                        <a:cs typeface="Arial"/>
                       </a:endParaRPr>
                     </a:p>
                   </a:txBody>
@@ -6803,9 +6801,9 @@
                 <a:solidFill>
                   <a:srgbClr val="0B3D66"/>
                 </a:solidFill>
-                <a:latin typeface="Space Grotesk Light" pitchFamily="34" charset="0"/>
-                <a:ea typeface="Space Grotesk Light" pitchFamily="34" charset="-122"/>
-                <a:cs typeface="Space Grotesk Light" pitchFamily="34" charset="-120"/>
+                <a:latin typeface="Arial"/>
+                <a:ea typeface="Arial"/>
+                <a:cs typeface="Arial"/>
               </a:rPr>
               <a:t>Sohil MM et al.  |  Am Heart J Plus 2026;61:100678</a:t>
             </a:r>
@@ -6842,9 +6840,9 @@
                 <a:solidFill>
                   <a:srgbClr val="0B3D66"/>
                 </a:solidFill>
-                <a:latin typeface="Space Grotesk" pitchFamily="34" charset="0"/>
-                <a:ea typeface="Space Grotesk" pitchFamily="34" charset="-122"/>
-                <a:cs typeface="Space Grotesk" pitchFamily="34" charset="-120"/>
+                <a:latin typeface="Arial"/>
+                <a:ea typeface="Arial"/>
+                <a:cs typeface="Arial"/>
               </a:rPr>
               <a:t>10</a:t>
             </a:r>
@@ -6913,9 +6911,9 @@
                 <a:solidFill>
                   <a:srgbClr val="0B3D66"/>
                 </a:solidFill>
-                <a:latin typeface="Space Grotesk" pitchFamily="34" charset="0"/>
-                <a:ea typeface="Space Grotesk" pitchFamily="34" charset="-122"/>
-                <a:cs typeface="Space Grotesk" pitchFamily="34" charset="-120"/>
+                <a:latin typeface="Arial"/>
+                <a:ea typeface="Arial"/>
+                <a:cs typeface="Arial"/>
               </a:rPr>
               <a:t>In-hospital outcomes</a:t>
             </a:r>
@@ -6975,9 +6973,9 @@
                 <a:solidFill>
                   <a:srgbClr val="0B3D66"/>
                 </a:solidFill>
-                <a:latin typeface="Space Grotesk" pitchFamily="34" charset="0"/>
-                <a:ea typeface="Space Grotesk" pitchFamily="34" charset="-122"/>
-                <a:cs typeface="Space Grotesk" pitchFamily="34" charset="-120"/>
+                <a:latin typeface="Arial"/>
+                <a:ea typeface="Arial"/>
+                <a:cs typeface="Arial"/>
               </a:rPr>
               <a:t>100%</a:t>
             </a:r>
@@ -7014,9 +7012,9 @@
                 <a:solidFill>
                   <a:srgbClr val="000000"/>
                 </a:solidFill>
-                <a:latin typeface="Space Grotesk Light" pitchFamily="34" charset="0"/>
-                <a:ea typeface="Space Grotesk Light" pitchFamily="34" charset="-122"/>
-                <a:cs typeface="Space Grotesk Light" pitchFamily="34" charset="-120"/>
+                <a:latin typeface="Arial"/>
+                <a:ea typeface="Arial"/>
+                <a:cs typeface="Arial"/>
               </a:rPr>
               <a:t>angiographic success (45/45)</a:t>
             </a:r>
@@ -7076,9 +7074,9 @@
                 <a:solidFill>
                   <a:srgbClr val="0B3D66"/>
                 </a:solidFill>
-                <a:latin typeface="Space Grotesk" pitchFamily="34" charset="0"/>
-                <a:ea typeface="Space Grotesk" pitchFamily="34" charset="-122"/>
-                <a:cs typeface="Space Grotesk" pitchFamily="34" charset="-120"/>
+                <a:latin typeface="Arial"/>
+                <a:ea typeface="Arial"/>
+                <a:cs typeface="Arial"/>
               </a:rPr>
               <a:t>97.8%</a:t>
             </a:r>
@@ -7115,9 +7113,9 @@
                 <a:solidFill>
                   <a:srgbClr val="000000"/>
                 </a:solidFill>
-                <a:latin typeface="Space Grotesk Light" pitchFamily="34" charset="0"/>
-                <a:ea typeface="Space Grotesk Light" pitchFamily="34" charset="-122"/>
-                <a:cs typeface="Space Grotesk Light" pitchFamily="34" charset="-120"/>
+                <a:latin typeface="Arial"/>
+                <a:ea typeface="Arial"/>
+                <a:cs typeface="Arial"/>
               </a:rPr>
               <a:t>procedural success (44/45)</a:t>
             </a:r>
@@ -7177,9 +7175,9 @@
                 <a:solidFill>
                   <a:srgbClr val="C8102E"/>
                 </a:solidFill>
-                <a:latin typeface="Space Grotesk" pitchFamily="34" charset="0"/>
-                <a:ea typeface="Space Grotesk" pitchFamily="34" charset="-122"/>
-                <a:cs typeface="Space Grotesk" pitchFamily="34" charset="-120"/>
+                <a:latin typeface="Arial"/>
+                <a:ea typeface="Arial"/>
+                <a:cs typeface="Arial"/>
               </a:rPr>
               <a:t>2.2%</a:t>
             </a:r>
@@ -7216,9 +7214,9 @@
                 <a:solidFill>
                   <a:srgbClr val="000000"/>
                 </a:solidFill>
-                <a:latin typeface="Space Grotesk Light" pitchFamily="34" charset="0"/>
-                <a:ea typeface="Space Grotesk Light" pitchFamily="34" charset="-122"/>
-                <a:cs typeface="Space Grotesk Light" pitchFamily="34" charset="-120"/>
+                <a:latin typeface="Arial"/>
+                <a:ea typeface="Arial"/>
+                <a:cs typeface="Arial"/>
               </a:rPr>
               <a:t>in-hospital death (1/45)</a:t>
             </a:r>
@@ -7402,9 +7400,9 @@
                 <a:solidFill>
                   <a:srgbClr val="0B3D66"/>
                 </a:solidFill>
-                <a:latin typeface="Space Grotesk Light" pitchFamily="34" charset="0"/>
-                <a:ea typeface="Space Grotesk Light" pitchFamily="34" charset="-122"/>
-                <a:cs typeface="Space Grotesk Light" pitchFamily="34" charset="-120"/>
+                <a:latin typeface="Arial"/>
+                <a:ea typeface="Arial"/>
+                <a:cs typeface="Arial"/>
               </a:rPr>
               <a:t>Sohil MM et al.  |  Am Heart J Plus 2026;61:100678</a:t>
             </a:r>
@@ -7441,9 +7439,9 @@
                 <a:solidFill>
                   <a:srgbClr val="0B3D66"/>
                 </a:solidFill>
-                <a:latin typeface="Space Grotesk" pitchFamily="34" charset="0"/>
-                <a:ea typeface="Space Grotesk" pitchFamily="34" charset="-122"/>
-                <a:cs typeface="Space Grotesk" pitchFamily="34" charset="-120"/>
+                <a:latin typeface="Arial"/>
+                <a:ea typeface="Arial"/>
+                <a:cs typeface="Arial"/>
               </a:rPr>
               <a:t>11</a:t>
             </a:r>
@@ -7512,7 +7510,7 @@
           <p:nvPr/>
         </p:nvPicPr>
         <p:blipFill>
-          <a:blip r:embed="rIdFig2"/>
+          <a:blip r:embed="rId3"/>
           <a:stretch>
             <a:fillRect/>
           </a:stretch>
@@ -7561,9 +7559,9 @@
                 <a:solidFill>
                   <a:srgbClr val="0B3D66"/>
                 </a:solidFill>
-                <a:latin typeface="Space Grotesk" pitchFamily="34" charset="0"/>
-                <a:ea typeface="Space Grotesk" pitchFamily="34" charset="-122"/>
-                <a:cs typeface="Space Grotesk" pitchFamily="34" charset="-120"/>
+                <a:latin typeface="Arial"/>
+                <a:ea typeface="Arial"/>
+                <a:cs typeface="Arial"/>
               </a:rPr>
               <a:t>Two-year outcomes</a:t>
             </a:r>
@@ -7623,9 +7621,9 @@
                 <a:solidFill>
                   <a:srgbClr val="000000"/>
                 </a:solidFill>
-                <a:latin typeface="Space Grotesk Light" pitchFamily="34" charset="0"/>
-                <a:ea typeface="Space Grotesk Light" pitchFamily="34" charset="-122"/>
-                <a:cs typeface="Space Grotesk Light" pitchFamily="34" charset="-120"/>
+                <a:latin typeface="Arial"/>
+                <a:ea typeface="Arial"/>
+                <a:cs typeface="Arial"/>
               </a:rPr>
               <a:t>Overall survival </a:t>
             </a:r>
@@ -7634,9 +7632,9 @@
                 <a:solidFill>
                   <a:srgbClr val="000000"/>
                 </a:solidFill>
-                <a:latin typeface="Space Grotesk Light" pitchFamily="34" charset="0"/>
-                <a:ea typeface="Space Grotesk Light" pitchFamily="34" charset="-122"/>
-                <a:cs typeface="Space Grotesk Light" pitchFamily="34" charset="-120"/>
+                <a:latin typeface="Arial"/>
+                <a:ea typeface="Arial"/>
+                <a:cs typeface="Arial"/>
               </a:rPr>
               <a:t>97.78%</a:t>
             </a:r>
@@ -7651,9 +7649,9 @@
                 <a:solidFill>
                   <a:srgbClr val="000000"/>
                 </a:solidFill>
-                <a:latin typeface="Space Grotesk Light" pitchFamily="34" charset="0"/>
-                <a:ea typeface="Space Grotesk Light" pitchFamily="34" charset="-122"/>
-                <a:cs typeface="Space Grotesk Light" pitchFamily="34" charset="-120"/>
+                <a:latin typeface="Arial"/>
+                <a:ea typeface="Arial"/>
+                <a:cs typeface="Arial"/>
               </a:rPr>
               <a:t>(Fig. 2, Kaplan-Meier)</a:t>
             </a:r>
@@ -7671,9 +7669,9 @@
                 <a:solidFill>
                   <a:srgbClr val="000000"/>
                 </a:solidFill>
-                <a:latin typeface="Space Grotesk Light" pitchFamily="34" charset="0"/>
-                <a:ea typeface="Space Grotesk Light" pitchFamily="34" charset="-122"/>
-                <a:cs typeface="Space Grotesk Light" pitchFamily="34" charset="-120"/>
+                <a:latin typeface="Arial"/>
+                <a:ea typeface="Arial"/>
+                <a:cs typeface="Arial"/>
               </a:rPr>
               <a:t>MACE-free </a:t>
             </a:r>
@@ -7682,9 +7680,9 @@
                 <a:solidFill>
                   <a:srgbClr val="000000"/>
                 </a:solidFill>
-                <a:latin typeface="Space Grotesk Light" pitchFamily="34" charset="0"/>
-                <a:ea typeface="Space Grotesk Light" pitchFamily="34" charset="-122"/>
-                <a:cs typeface="Space Grotesk Light" pitchFamily="34" charset="-120"/>
+                <a:latin typeface="Arial"/>
+                <a:ea typeface="Arial"/>
+                <a:cs typeface="Arial"/>
               </a:rPr>
               <a:t>93.3%</a:t>
             </a:r>
@@ -7702,9 +7700,9 @@
                 <a:solidFill>
                   <a:srgbClr val="000000"/>
                 </a:solidFill>
-                <a:latin typeface="Space Grotesk Light" pitchFamily="34" charset="0"/>
-                <a:ea typeface="Space Grotesk Light" pitchFamily="34" charset="-122"/>
-                <a:cs typeface="Space Grotesk Light" pitchFamily="34" charset="-120"/>
+                <a:latin typeface="Arial"/>
+                <a:ea typeface="Arial"/>
+                <a:cs typeface="Arial"/>
               </a:rPr>
               <a:t>1 death, 1 TLR, 1 TVMI</a:t>
             </a:r>
@@ -7722,9 +7720,9 @@
                 <a:solidFill>
                   <a:srgbClr val="000000"/>
                 </a:solidFill>
-                <a:latin typeface="Space Grotesk Light" pitchFamily="34" charset="0"/>
-                <a:ea typeface="Space Grotesk Light" pitchFamily="34" charset="-122"/>
-                <a:cs typeface="Space Grotesk Light" pitchFamily="34" charset="-120"/>
+                <a:latin typeface="Arial"/>
+                <a:ea typeface="Arial"/>
+                <a:cs typeface="Arial"/>
               </a:rPr>
               <a:t>No bleeding or stroke</a:t>
             </a:r>
@@ -7908,9 +7906,9 @@
                 <a:solidFill>
                   <a:srgbClr val="0B3D66"/>
                 </a:solidFill>
-                <a:latin typeface="Space Grotesk Light" pitchFamily="34" charset="0"/>
-                <a:ea typeface="Space Grotesk Light" pitchFamily="34" charset="-122"/>
-                <a:cs typeface="Space Grotesk Light" pitchFamily="34" charset="-120"/>
+                <a:latin typeface="Arial"/>
+                <a:ea typeface="Arial"/>
+                <a:cs typeface="Arial"/>
               </a:rPr>
               <a:t>Sohil MM et al.  |  Am Heart J Plus 2026;61:100678</a:t>
             </a:r>
@@ -7947,9 +7945,9 @@
                 <a:solidFill>
                   <a:srgbClr val="0B3D66"/>
                 </a:solidFill>
-                <a:latin typeface="Space Grotesk" pitchFamily="34" charset="0"/>
-                <a:ea typeface="Space Grotesk" pitchFamily="34" charset="-122"/>
-                <a:cs typeface="Space Grotesk" pitchFamily="34" charset="-120"/>
+                <a:latin typeface="Arial"/>
+                <a:ea typeface="Arial"/>
+                <a:cs typeface="Arial"/>
               </a:rPr>
               <a:t>12</a:t>
             </a:r>
@@ -8018,9 +8016,9 @@
                 <a:solidFill>
                   <a:srgbClr val="0B3D66"/>
                 </a:solidFill>
-                <a:latin typeface="Space Grotesk" pitchFamily="34" charset="0"/>
-                <a:ea typeface="Space Grotesk" pitchFamily="34" charset="-122"/>
-                <a:cs typeface="Space Grotesk" pitchFamily="34" charset="-120"/>
+                <a:latin typeface="Arial"/>
+                <a:ea typeface="Arial"/>
+                <a:cs typeface="Arial"/>
               </a:rPr>
               <a:t>Correlation analysis</a:t>
             </a:r>
@@ -8060,7 +8058,7 @@
           <p:nvPr>
             <p:extLst>
               <p:ext uri="{D42A27DB-BD31-4B8C-83A1-F6EECF244321}">
-                <p14:modId xmlns:p14="http://schemas.microsoft.com/office/powerpoint/2010/main" val="1579011935"/>
+                <p14:modId xmlns:p14="http://schemas.microsoft.com/office/powerpoint/2010/main" val="1425144359"/>
               </p:ext>
             </p:extLst>
           </p:nvPr>
@@ -8093,16 +8091,16 @@
                           <a:solidFill>
                             <a:srgbClr val="FFFFFF"/>
                           </a:solidFill>
-                          <a:latin typeface="Space Grotesk" pitchFamily="34" charset="0"/>
-                          <a:ea typeface="Space Grotesk" pitchFamily="34" charset="-122"/>
-                          <a:cs typeface="Space Grotesk" pitchFamily="34" charset="-120"/>
+                          <a:latin typeface="Arial"/>
+                          <a:ea typeface="Arial"/>
+                          <a:cs typeface="Arial"/>
                         </a:rPr>
                         <a:t>Variable pair</a:t>
                       </a:r>
                       <a:endParaRPr lang="en-US" sz="2200" dirty="0">
-                        <a:latin typeface="Space Grotesk" charset="0"/>
-                        <a:ea typeface="Space Grotesk" charset="0"/>
-                        <a:cs typeface="Space Grotesk" charset="0"/>
+                        <a:latin typeface="Arial"/>
+                        <a:ea typeface="Arial"/>
+                        <a:cs typeface="Arial"/>
                       </a:endParaRPr>
                     </a:p>
                   </a:txBody>
@@ -8161,16 +8159,16 @@
                           <a:solidFill>
                             <a:srgbClr val="FFFFFF"/>
                           </a:solidFill>
-                          <a:latin typeface="Space Grotesk" pitchFamily="34" charset="0"/>
-                          <a:ea typeface="Space Grotesk" pitchFamily="34" charset="-122"/>
-                          <a:cs typeface="Space Grotesk" pitchFamily="34" charset="-120"/>
+                          <a:latin typeface="Arial"/>
+                          <a:ea typeface="Arial"/>
+                          <a:cs typeface="Arial"/>
                         </a:rPr>
                         <a:t>Pearson r</a:t>
                       </a:r>
                       <a:endParaRPr lang="en-US" sz="2200" dirty="0">
-                        <a:latin typeface="Space Grotesk" charset="0"/>
-                        <a:ea typeface="Space Grotesk" charset="0"/>
-                        <a:cs typeface="Space Grotesk" charset="0"/>
+                        <a:latin typeface="Arial"/>
+                        <a:ea typeface="Arial"/>
+                        <a:cs typeface="Arial"/>
                       </a:endParaRPr>
                     </a:p>
                   </a:txBody>
@@ -8229,16 +8227,16 @@
                           <a:solidFill>
                             <a:srgbClr val="FFFFFF"/>
                           </a:solidFill>
-                          <a:latin typeface="Space Grotesk" pitchFamily="34" charset="0"/>
-                          <a:ea typeface="Space Grotesk" pitchFamily="34" charset="-122"/>
-                          <a:cs typeface="Space Grotesk" pitchFamily="34" charset="-120"/>
+                          <a:latin typeface="Arial"/>
+                          <a:ea typeface="Arial"/>
+                          <a:cs typeface="Arial"/>
                         </a:rPr>
                         <a:t>95% CI</a:t>
                       </a:r>
                       <a:endParaRPr lang="en-US" sz="2200" dirty="0">
-                        <a:latin typeface="Space Grotesk" charset="0"/>
-                        <a:ea typeface="Space Grotesk" charset="0"/>
-                        <a:cs typeface="Space Grotesk" charset="0"/>
+                        <a:latin typeface="Arial"/>
+                        <a:ea typeface="Arial"/>
+                        <a:cs typeface="Arial"/>
                       </a:endParaRPr>
                     </a:p>
                   </a:txBody>
@@ -8297,16 +8295,16 @@
                           <a:solidFill>
                             <a:srgbClr val="FFFFFF"/>
                           </a:solidFill>
-                          <a:latin typeface="Space Grotesk" pitchFamily="34" charset="0"/>
-                          <a:ea typeface="Space Grotesk" pitchFamily="34" charset="-122"/>
-                          <a:cs typeface="Space Grotesk" pitchFamily="34" charset="-120"/>
+                          <a:latin typeface="Arial"/>
+                          <a:ea typeface="Arial"/>
+                          <a:cs typeface="Arial"/>
                         </a:rPr>
                         <a:t>p</a:t>
                       </a:r>
                       <a:endParaRPr lang="en-US" sz="2200" dirty="0">
-                        <a:latin typeface="Space Grotesk" charset="0"/>
-                        <a:ea typeface="Space Grotesk" charset="0"/>
-                        <a:cs typeface="Space Grotesk" charset="0"/>
+                        <a:latin typeface="Arial"/>
+                        <a:ea typeface="Arial"/>
+                        <a:cs typeface="Arial"/>
                       </a:endParaRPr>
                     </a:p>
                   </a:txBody>
@@ -8367,16 +8365,16 @@
                           <a:solidFill>
                             <a:srgbClr val="000000"/>
                           </a:solidFill>
-                          <a:latin typeface="Space Grotesk Light" pitchFamily="34" charset="0"/>
-                          <a:ea typeface="Space Grotesk Light" pitchFamily="34" charset="-122"/>
-                          <a:cs typeface="Space Grotesk Light" pitchFamily="34" charset="-120"/>
+                          <a:latin typeface="Arial"/>
+                          <a:ea typeface="Arial"/>
+                          <a:cs typeface="Arial"/>
                         </a:rPr>
                         <a:t>Age vs SYNTAX score</a:t>
                       </a:r>
                       <a:endParaRPr lang="en-US" sz="2200" dirty="0">
-                        <a:latin typeface="Space Grotesk Light" charset="0"/>
-                        <a:ea typeface="Space Grotesk Light" charset="0"/>
-                        <a:cs typeface="Space Grotesk Light" charset="0"/>
+                        <a:latin typeface="Arial"/>
+                        <a:ea typeface="Arial"/>
+                        <a:cs typeface="Arial"/>
                       </a:endParaRPr>
                     </a:p>
                   </a:txBody>
@@ -8432,16 +8430,16 @@
                           <a:solidFill>
                             <a:srgbClr val="000000"/>
                           </a:solidFill>
-                          <a:latin typeface="Space Grotesk Light" pitchFamily="34" charset="0"/>
-                          <a:ea typeface="Space Grotesk Light" pitchFamily="34" charset="-122"/>
-                          <a:cs typeface="Space Grotesk Light" pitchFamily="34" charset="-120"/>
+                          <a:latin typeface="Arial"/>
+                          <a:ea typeface="Arial"/>
+                          <a:cs typeface="Arial"/>
                         </a:rPr>
                         <a:t>0.23</a:t>
                       </a:r>
                       <a:endParaRPr lang="en-US" sz="2200" dirty="0">
-                        <a:latin typeface="Space Grotesk Light" charset="0"/>
-                        <a:ea typeface="Space Grotesk Light" charset="0"/>
-                        <a:cs typeface="Space Grotesk Light" charset="0"/>
+                        <a:latin typeface="Arial"/>
+                        <a:ea typeface="Arial"/>
+                        <a:cs typeface="Arial"/>
                       </a:endParaRPr>
                     </a:p>
                   </a:txBody>
@@ -8497,16 +8495,16 @@
                           <a:solidFill>
                             <a:srgbClr val="000000"/>
                           </a:solidFill>
-                          <a:latin typeface="Space Grotesk Light" pitchFamily="34" charset="0"/>
-                          <a:ea typeface="Space Grotesk Light" pitchFamily="34" charset="-122"/>
-                          <a:cs typeface="Space Grotesk Light" pitchFamily="34" charset="-120"/>
+                          <a:latin typeface="Arial"/>
+                          <a:ea typeface="Arial"/>
+                          <a:cs typeface="Arial"/>
                         </a:rPr>
                         <a:t>0.02–0.42</a:t>
                       </a:r>
                       <a:endParaRPr lang="en-US" sz="2200" dirty="0">
-                        <a:latin typeface="Space Grotesk Light" charset="0"/>
-                        <a:ea typeface="Space Grotesk Light" charset="0"/>
-                        <a:cs typeface="Space Grotesk Light" charset="0"/>
+                        <a:latin typeface="Arial"/>
+                        <a:ea typeface="Arial"/>
+                        <a:cs typeface="Arial"/>
                       </a:endParaRPr>
                     </a:p>
                   </a:txBody>
@@ -8562,16 +8560,16 @@
                           <a:solidFill>
                             <a:srgbClr val="000000"/>
                           </a:solidFill>
-                          <a:latin typeface="Space Grotesk Light" pitchFamily="34" charset="0"/>
-                          <a:ea typeface="Space Grotesk Light" pitchFamily="34" charset="-122"/>
-                          <a:cs typeface="Space Grotesk Light" pitchFamily="34" charset="-120"/>
+                          <a:latin typeface="Arial"/>
+                          <a:ea typeface="Arial"/>
+                          <a:cs typeface="Arial"/>
                         </a:rPr>
                         <a:t>0.028</a:t>
                       </a:r>
                       <a:endParaRPr lang="en-US" sz="2200" dirty="0">
-                        <a:latin typeface="Space Grotesk Light" charset="0"/>
-                        <a:ea typeface="Space Grotesk Light" charset="0"/>
-                        <a:cs typeface="Space Grotesk Light" charset="0"/>
+                        <a:latin typeface="Arial"/>
+                        <a:ea typeface="Arial"/>
+                        <a:cs typeface="Arial"/>
                       </a:endParaRPr>
                     </a:p>
                   </a:txBody>
@@ -8629,16 +8627,16 @@
                           <a:solidFill>
                             <a:srgbClr val="000000"/>
                           </a:solidFill>
-                          <a:latin typeface="Space Grotesk Light" pitchFamily="34" charset="0"/>
-                          <a:ea typeface="Space Grotesk Light" pitchFamily="34" charset="-122"/>
-                          <a:cs typeface="Space Grotesk Light" pitchFamily="34" charset="-120"/>
+                          <a:latin typeface="Arial"/>
+                          <a:ea typeface="Arial"/>
+                          <a:cs typeface="Arial"/>
                         </a:rPr>
                         <a:t>EuroSCORE II vs age</a:t>
                       </a:r>
                       <a:endParaRPr lang="en-US" sz="2200" dirty="0">
-                        <a:latin typeface="Space Grotesk Light" charset="0"/>
-                        <a:ea typeface="Space Grotesk Light" charset="0"/>
-                        <a:cs typeface="Space Grotesk Light" charset="0"/>
+                        <a:latin typeface="Arial"/>
+                        <a:ea typeface="Arial"/>
+                        <a:cs typeface="Arial"/>
                       </a:endParaRPr>
                     </a:p>
                   </a:txBody>
@@ -8697,16 +8695,16 @@
                           <a:solidFill>
                             <a:srgbClr val="000000"/>
                           </a:solidFill>
-                          <a:latin typeface="Space Grotesk Light" pitchFamily="34" charset="0"/>
-                          <a:ea typeface="Space Grotesk Light" pitchFamily="34" charset="-122"/>
-                          <a:cs typeface="Space Grotesk Light" pitchFamily="34" charset="-120"/>
+                          <a:latin typeface="Arial"/>
+                          <a:ea typeface="Arial"/>
+                          <a:cs typeface="Arial"/>
                         </a:rPr>
                         <a:t>0.52</a:t>
                       </a:r>
                       <a:endParaRPr lang="en-US" sz="2200" dirty="0">
-                        <a:latin typeface="Space Grotesk Light" charset="0"/>
-                        <a:ea typeface="Space Grotesk Light" charset="0"/>
-                        <a:cs typeface="Space Grotesk Light" charset="0"/>
+                        <a:latin typeface="Arial"/>
+                        <a:ea typeface="Arial"/>
+                        <a:cs typeface="Arial"/>
                       </a:endParaRPr>
                     </a:p>
                   </a:txBody>
@@ -8765,16 +8763,16 @@
                           <a:solidFill>
                             <a:srgbClr val="000000"/>
                           </a:solidFill>
-                          <a:latin typeface="Space Grotesk Light" pitchFamily="34" charset="0"/>
-                          <a:ea typeface="Space Grotesk Light" pitchFamily="34" charset="-122"/>
-                          <a:cs typeface="Space Grotesk Light" pitchFamily="34" charset="-120"/>
+                          <a:latin typeface="Arial"/>
+                          <a:ea typeface="Arial"/>
+                          <a:cs typeface="Arial"/>
                         </a:rPr>
                         <a:t>0.34–0.67</a:t>
                       </a:r>
                       <a:endParaRPr lang="en-US" sz="2200" dirty="0">
-                        <a:latin typeface="Space Grotesk Light" charset="0"/>
-                        <a:ea typeface="Space Grotesk Light" charset="0"/>
-                        <a:cs typeface="Space Grotesk Light" charset="0"/>
+                        <a:latin typeface="Arial"/>
+                        <a:ea typeface="Arial"/>
+                        <a:cs typeface="Arial"/>
                       </a:endParaRPr>
                     </a:p>
                   </a:txBody>
@@ -8833,16 +8831,16 @@
                           <a:solidFill>
                             <a:srgbClr val="000000"/>
                           </a:solidFill>
-                          <a:latin typeface="Space Grotesk Light" pitchFamily="34" charset="0"/>
-                          <a:ea typeface="Space Grotesk Light" pitchFamily="34" charset="-122"/>
-                          <a:cs typeface="Space Grotesk Light" pitchFamily="34" charset="-120"/>
+                          <a:latin typeface="Arial"/>
+                          <a:ea typeface="Arial"/>
+                          <a:cs typeface="Arial"/>
                         </a:rPr>
                         <a:t>&lt;0.001</a:t>
                       </a:r>
                       <a:endParaRPr lang="en-US" sz="2200" dirty="0">
-                        <a:latin typeface="Space Grotesk Light" charset="0"/>
-                        <a:ea typeface="Space Grotesk Light" charset="0"/>
-                        <a:cs typeface="Space Grotesk Light" charset="0"/>
+                        <a:latin typeface="Arial"/>
+                        <a:ea typeface="Arial"/>
+                        <a:cs typeface="Arial"/>
                       </a:endParaRPr>
                     </a:p>
                   </a:txBody>
@@ -8903,16 +8901,16 @@
                           <a:solidFill>
                             <a:srgbClr val="000000"/>
                           </a:solidFill>
-                          <a:latin typeface="Space Grotesk Light" pitchFamily="34" charset="0"/>
-                          <a:ea typeface="Space Grotesk Light" pitchFamily="34" charset="-122"/>
-                          <a:cs typeface="Space Grotesk Light" pitchFamily="34" charset="-120"/>
+                          <a:latin typeface="Arial"/>
+                          <a:ea typeface="Arial"/>
+                          <a:cs typeface="Arial"/>
                         </a:rPr>
                         <a:t>LMCA stenosis vs fluoro</a:t>
                       </a:r>
                       <a:endParaRPr lang="en-US" sz="2200" dirty="0">
-                        <a:latin typeface="Space Grotesk Light" charset="0"/>
-                        <a:ea typeface="Space Grotesk Light" charset="0"/>
-                        <a:cs typeface="Space Grotesk Light" charset="0"/>
+                        <a:latin typeface="Arial"/>
+                        <a:ea typeface="Arial"/>
+                        <a:cs typeface="Arial"/>
                       </a:endParaRPr>
                     </a:p>
                   </a:txBody>
@@ -8968,16 +8966,16 @@
                           <a:solidFill>
                             <a:srgbClr val="000000"/>
                           </a:solidFill>
-                          <a:latin typeface="Space Grotesk Light" pitchFamily="34" charset="0"/>
-                          <a:ea typeface="Space Grotesk Light" pitchFamily="34" charset="-122"/>
-                          <a:cs typeface="Space Grotesk Light" pitchFamily="34" charset="-120"/>
+                          <a:latin typeface="Arial"/>
+                          <a:ea typeface="Arial"/>
+                          <a:cs typeface="Arial"/>
                         </a:rPr>
                         <a:t>0.31</a:t>
                       </a:r>
                       <a:endParaRPr lang="en-US" sz="2200" dirty="0">
-                        <a:latin typeface="Space Grotesk Light" charset="0"/>
-                        <a:ea typeface="Space Grotesk Light" charset="0"/>
-                        <a:cs typeface="Space Grotesk Light" charset="0"/>
+                        <a:latin typeface="Arial"/>
+                        <a:ea typeface="Arial"/>
+                        <a:cs typeface="Arial"/>
                       </a:endParaRPr>
                     </a:p>
                   </a:txBody>
@@ -9033,16 +9031,16 @@
                           <a:solidFill>
                             <a:srgbClr val="000000"/>
                           </a:solidFill>
-                          <a:latin typeface="Space Grotesk Light" pitchFamily="34" charset="0"/>
-                          <a:ea typeface="Space Grotesk Light" pitchFamily="34" charset="-122"/>
-                          <a:cs typeface="Space Grotesk Light" pitchFamily="34" charset="-120"/>
+                          <a:latin typeface="Arial"/>
+                          <a:ea typeface="Arial"/>
+                          <a:cs typeface="Arial"/>
                         </a:rPr>
                         <a:t>0.11–0.49</a:t>
                       </a:r>
                       <a:endParaRPr lang="en-US" sz="2200" dirty="0">
-                        <a:latin typeface="Space Grotesk Light" charset="0"/>
-                        <a:ea typeface="Space Grotesk Light" charset="0"/>
-                        <a:cs typeface="Space Grotesk Light" charset="0"/>
+                        <a:latin typeface="Arial"/>
+                        <a:ea typeface="Arial"/>
+                        <a:cs typeface="Arial"/>
                       </a:endParaRPr>
                     </a:p>
                   </a:txBody>
@@ -9098,16 +9096,16 @@
                           <a:solidFill>
                             <a:srgbClr val="000000"/>
                           </a:solidFill>
-                          <a:latin typeface="Space Grotesk Light" pitchFamily="34" charset="0"/>
-                          <a:ea typeface="Space Grotesk Light" pitchFamily="34" charset="-122"/>
-                          <a:cs typeface="Space Grotesk Light" pitchFamily="34" charset="-120"/>
+                          <a:latin typeface="Arial"/>
+                          <a:ea typeface="Arial"/>
+                          <a:cs typeface="Arial"/>
                         </a:rPr>
                         <a:t>0.003</a:t>
                       </a:r>
                       <a:endParaRPr lang="en-US" sz="2200" dirty="0">
-                        <a:latin typeface="Space Grotesk Light" charset="0"/>
-                        <a:ea typeface="Space Grotesk Light" charset="0"/>
-                        <a:cs typeface="Space Grotesk Light" charset="0"/>
+                        <a:latin typeface="Arial"/>
+                        <a:ea typeface="Arial"/>
+                        <a:cs typeface="Arial"/>
                       </a:endParaRPr>
                     </a:p>
                   </a:txBody>
@@ -9165,16 +9163,16 @@
                           <a:solidFill>
                             <a:srgbClr val="000000"/>
                           </a:solidFill>
-                          <a:latin typeface="Space Grotesk Light" pitchFamily="34" charset="0"/>
-                          <a:ea typeface="Space Grotesk Light" pitchFamily="34" charset="-122"/>
-                          <a:cs typeface="Space Grotesk Light" pitchFamily="34" charset="-120"/>
+                          <a:latin typeface="Arial"/>
+                          <a:ea typeface="Arial"/>
+                          <a:cs typeface="Arial"/>
                         </a:rPr>
                         <a:t>Contrast vs fluoro time</a:t>
                       </a:r>
                       <a:endParaRPr lang="en-US" sz="2200" dirty="0">
-                        <a:latin typeface="Space Grotesk Light" charset="0"/>
-                        <a:ea typeface="Space Grotesk Light" charset="0"/>
-                        <a:cs typeface="Space Grotesk Light" charset="0"/>
+                        <a:latin typeface="Arial"/>
+                        <a:ea typeface="Arial"/>
+                        <a:cs typeface="Arial"/>
                       </a:endParaRPr>
                     </a:p>
                   </a:txBody>
@@ -9233,16 +9231,16 @@
                           <a:solidFill>
                             <a:srgbClr val="000000"/>
                           </a:solidFill>
-                          <a:latin typeface="Space Grotesk Light" pitchFamily="34" charset="0"/>
-                          <a:ea typeface="Space Grotesk Light" pitchFamily="34" charset="-122"/>
-                          <a:cs typeface="Space Grotesk Light" pitchFamily="34" charset="-120"/>
+                          <a:latin typeface="Arial"/>
+                          <a:ea typeface="Arial"/>
+                          <a:cs typeface="Arial"/>
                         </a:rPr>
                         <a:t>0.38</a:t>
                       </a:r>
                       <a:endParaRPr lang="en-US" sz="2200" dirty="0">
-                        <a:latin typeface="Space Grotesk Light" charset="0"/>
-                        <a:ea typeface="Space Grotesk Light" charset="0"/>
-                        <a:cs typeface="Space Grotesk Light" charset="0"/>
+                        <a:latin typeface="Arial"/>
+                        <a:ea typeface="Arial"/>
+                        <a:cs typeface="Arial"/>
                       </a:endParaRPr>
                     </a:p>
                   </a:txBody>
@@ -9301,16 +9299,16 @@
                           <a:solidFill>
                             <a:srgbClr val="000000"/>
                           </a:solidFill>
-                          <a:latin typeface="Space Grotesk Light" pitchFamily="34" charset="0"/>
-                          <a:ea typeface="Space Grotesk Light" pitchFamily="34" charset="-122"/>
-                          <a:cs typeface="Space Grotesk Light" pitchFamily="34" charset="-120"/>
+                          <a:latin typeface="Arial"/>
+                          <a:ea typeface="Arial"/>
+                          <a:cs typeface="Arial"/>
                         </a:rPr>
                         <a:t>0.19–0.55</a:t>
                       </a:r>
                       <a:endParaRPr lang="en-US" sz="2200" dirty="0">
-                        <a:latin typeface="Space Grotesk Light" charset="0"/>
-                        <a:ea typeface="Space Grotesk Light" charset="0"/>
-                        <a:cs typeface="Space Grotesk Light" charset="0"/>
+                        <a:latin typeface="Arial"/>
+                        <a:ea typeface="Arial"/>
+                        <a:cs typeface="Arial"/>
                       </a:endParaRPr>
                     </a:p>
                   </a:txBody>
@@ -9369,16 +9367,16 @@
                           <a:solidFill>
                             <a:srgbClr val="000000"/>
                           </a:solidFill>
-                          <a:latin typeface="Space Grotesk Light" pitchFamily="34" charset="0"/>
-                          <a:ea typeface="Space Grotesk Light" pitchFamily="34" charset="-122"/>
-                          <a:cs typeface="Space Grotesk Light" pitchFamily="34" charset="-120"/>
+                          <a:latin typeface="Arial"/>
+                          <a:ea typeface="Arial"/>
+                          <a:cs typeface="Arial"/>
                         </a:rPr>
                         <a:t>0.001</a:t>
                       </a:r>
                       <a:endParaRPr lang="en-US" sz="2200" dirty="0">
-                        <a:latin typeface="Space Grotesk Light" charset="0"/>
-                        <a:ea typeface="Space Grotesk Light" charset="0"/>
-                        <a:cs typeface="Space Grotesk Light" charset="0"/>
+                        <a:latin typeface="Arial"/>
+                        <a:ea typeface="Arial"/>
+                        <a:cs typeface="Arial"/>
                       </a:endParaRPr>
                     </a:p>
                   </a:txBody>
@@ -9439,16 +9437,16 @@
                           <a:solidFill>
                             <a:srgbClr val="000000"/>
                           </a:solidFill>
-                          <a:latin typeface="Space Grotesk Light" pitchFamily="34" charset="0"/>
-                          <a:ea typeface="Space Grotesk Light" pitchFamily="34" charset="-122"/>
-                          <a:cs typeface="Space Grotesk Light" pitchFamily="34" charset="-120"/>
+                          <a:latin typeface="Arial"/>
+                          <a:ea typeface="Arial"/>
+                          <a:cs typeface="Arial"/>
                         </a:rPr>
                         <a:t>Burr size vs stent diam.</a:t>
                       </a:r>
                       <a:endParaRPr lang="en-US" sz="2200" dirty="0">
-                        <a:latin typeface="Space Grotesk Light" charset="0"/>
-                        <a:ea typeface="Space Grotesk Light" charset="0"/>
-                        <a:cs typeface="Space Grotesk Light" charset="0"/>
+                        <a:latin typeface="Arial"/>
+                        <a:ea typeface="Arial"/>
+                        <a:cs typeface="Arial"/>
                       </a:endParaRPr>
                     </a:p>
                   </a:txBody>
@@ -9504,16 +9502,16 @@
                           <a:solidFill>
                             <a:srgbClr val="000000"/>
                           </a:solidFill>
-                          <a:latin typeface="Space Grotesk Light" pitchFamily="34" charset="0"/>
-                          <a:ea typeface="Space Grotesk Light" pitchFamily="34" charset="-122"/>
-                          <a:cs typeface="Space Grotesk Light" pitchFamily="34" charset="-120"/>
+                          <a:latin typeface="Arial"/>
+                          <a:ea typeface="Arial"/>
+                          <a:cs typeface="Arial"/>
                         </a:rPr>
                         <a:t>0.45</a:t>
                       </a:r>
                       <a:endParaRPr lang="en-US" sz="2200" dirty="0">
-                        <a:latin typeface="Space Grotesk Light" charset="0"/>
-                        <a:ea typeface="Space Grotesk Light" charset="0"/>
-                        <a:cs typeface="Space Grotesk Light" charset="0"/>
+                        <a:latin typeface="Arial"/>
+                        <a:ea typeface="Arial"/>
+                        <a:cs typeface="Arial"/>
                       </a:endParaRPr>
                     </a:p>
                   </a:txBody>
@@ -9569,16 +9567,16 @@
                           <a:solidFill>
                             <a:srgbClr val="000000"/>
                           </a:solidFill>
-                          <a:latin typeface="Space Grotesk Light" pitchFamily="34" charset="0"/>
-                          <a:ea typeface="Space Grotesk Light" pitchFamily="34" charset="-122"/>
-                          <a:cs typeface="Space Grotesk Light" pitchFamily="34" charset="-120"/>
+                          <a:latin typeface="Arial"/>
+                          <a:ea typeface="Arial"/>
+                          <a:cs typeface="Arial"/>
                         </a:rPr>
                         <a:t>0.26–0.61</a:t>
                       </a:r>
                       <a:endParaRPr lang="en-US" sz="2200" dirty="0">
-                        <a:latin typeface="Space Grotesk Light" charset="0"/>
-                        <a:ea typeface="Space Grotesk Light" charset="0"/>
-                        <a:cs typeface="Space Grotesk Light" charset="0"/>
+                        <a:latin typeface="Arial"/>
+                        <a:ea typeface="Arial"/>
+                        <a:cs typeface="Arial"/>
                       </a:endParaRPr>
                     </a:p>
                   </a:txBody>
@@ -9634,16 +9632,16 @@
                           <a:solidFill>
                             <a:srgbClr val="000000"/>
                           </a:solidFill>
-                          <a:latin typeface="Space Grotesk Light" pitchFamily="34" charset="0"/>
-                          <a:ea typeface="Space Grotesk Light" pitchFamily="34" charset="-122"/>
-                          <a:cs typeface="Space Grotesk Light" pitchFamily="34" charset="-120"/>
+                          <a:latin typeface="Arial"/>
+                          <a:ea typeface="Arial"/>
+                          <a:cs typeface="Arial"/>
                         </a:rPr>
                         <a:t>&lt;0.001</a:t>
                       </a:r>
                       <a:endParaRPr lang="en-US" sz="2200" dirty="0">
-                        <a:latin typeface="Space Grotesk Light" charset="0"/>
-                        <a:ea typeface="Space Grotesk Light" charset="0"/>
-                        <a:cs typeface="Space Grotesk Light" charset="0"/>
+                        <a:latin typeface="Arial"/>
+                        <a:ea typeface="Arial"/>
+                        <a:cs typeface="Arial"/>
                       </a:endParaRPr>
                     </a:p>
                   </a:txBody>
@@ -9701,16 +9699,16 @@
                           <a:solidFill>
                             <a:srgbClr val="000000"/>
                           </a:solidFill>
-                          <a:latin typeface="Space Grotesk Light" pitchFamily="34" charset="0"/>
-                          <a:ea typeface="Space Grotesk Light" pitchFamily="34" charset="-122"/>
-                          <a:cs typeface="Space Grotesk Light" pitchFamily="34" charset="-120"/>
+                          <a:latin typeface="Arial"/>
+                          <a:ea typeface="Arial"/>
+                          <a:cs typeface="Arial"/>
                         </a:rPr>
                         <a:t>SYNTAX vs stent length</a:t>
                       </a:r>
                       <a:endParaRPr lang="en-US" sz="2200" dirty="0">
-                        <a:latin typeface="Space Grotesk Light" charset="0"/>
-                        <a:ea typeface="Space Grotesk Light" charset="0"/>
-                        <a:cs typeface="Space Grotesk Light" charset="0"/>
+                        <a:latin typeface="Arial"/>
+                        <a:ea typeface="Arial"/>
+                        <a:cs typeface="Arial"/>
                       </a:endParaRPr>
                     </a:p>
                   </a:txBody>
@@ -9769,16 +9767,16 @@
                           <a:solidFill>
                             <a:srgbClr val="000000"/>
                           </a:solidFill>
-                          <a:latin typeface="Space Grotesk Light" pitchFamily="34" charset="0"/>
-                          <a:ea typeface="Space Grotesk Light" pitchFamily="34" charset="-122"/>
-                          <a:cs typeface="Space Grotesk Light" pitchFamily="34" charset="-120"/>
+                          <a:latin typeface="Arial"/>
+                          <a:ea typeface="Arial"/>
+                          <a:cs typeface="Arial"/>
                         </a:rPr>
                         <a:t>0.28</a:t>
                       </a:r>
                       <a:endParaRPr lang="en-US" sz="2200" dirty="0">
-                        <a:latin typeface="Space Grotesk Light" charset="0"/>
-                        <a:ea typeface="Space Grotesk Light" charset="0"/>
-                        <a:cs typeface="Space Grotesk Light" charset="0"/>
+                        <a:latin typeface="Arial"/>
+                        <a:ea typeface="Arial"/>
+                        <a:cs typeface="Arial"/>
                       </a:endParaRPr>
                     </a:p>
                   </a:txBody>
@@ -9837,16 +9835,16 @@
                           <a:solidFill>
                             <a:srgbClr val="000000"/>
                           </a:solidFill>
-                          <a:latin typeface="Space Grotesk Light" pitchFamily="34" charset="0"/>
-                          <a:ea typeface="Space Grotesk Light" pitchFamily="34" charset="-122"/>
-                          <a:cs typeface="Space Grotesk Light" pitchFamily="34" charset="-120"/>
+                          <a:latin typeface="Arial"/>
+                          <a:ea typeface="Arial"/>
+                          <a:cs typeface="Arial"/>
                         </a:rPr>
                         <a:t>0.08–0.46</a:t>
                       </a:r>
                       <a:endParaRPr lang="en-US" sz="2200" dirty="0">
-                        <a:latin typeface="Space Grotesk Light" charset="0"/>
-                        <a:ea typeface="Space Grotesk Light" charset="0"/>
-                        <a:cs typeface="Space Grotesk Light" charset="0"/>
+                        <a:latin typeface="Arial"/>
+                        <a:ea typeface="Arial"/>
+                        <a:cs typeface="Arial"/>
                       </a:endParaRPr>
                     </a:p>
                   </a:txBody>
@@ -9905,16 +9903,16 @@
                           <a:solidFill>
                             <a:srgbClr val="000000"/>
                           </a:solidFill>
-                          <a:latin typeface="Space Grotesk Light" pitchFamily="34" charset="0"/>
-                          <a:ea typeface="Space Grotesk Light" pitchFamily="34" charset="-122"/>
-                          <a:cs typeface="Space Grotesk Light" pitchFamily="34" charset="-120"/>
+                          <a:latin typeface="Arial"/>
+                          <a:ea typeface="Arial"/>
+                          <a:cs typeface="Arial"/>
                         </a:rPr>
                         <a:t>0.006</a:t>
                       </a:r>
                       <a:endParaRPr lang="en-US" sz="2200" dirty="0">
-                        <a:latin typeface="Space Grotesk Light" charset="0"/>
-                        <a:ea typeface="Space Grotesk Light" charset="0"/>
-                        <a:cs typeface="Space Grotesk Light" charset="0"/>
+                        <a:latin typeface="Arial"/>
+                        <a:ea typeface="Arial"/>
+                        <a:cs typeface="Arial"/>
                       </a:endParaRPr>
                     </a:p>
                   </a:txBody>
@@ -10141,9 +10139,9 @@
                 <a:solidFill>
                   <a:srgbClr val="0B3D66"/>
                 </a:solidFill>
-                <a:latin typeface="Space Grotesk Light" pitchFamily="34" charset="0"/>
-                <a:ea typeface="Space Grotesk Light" pitchFamily="34" charset="-122"/>
-                <a:cs typeface="Space Grotesk Light" pitchFamily="34" charset="-120"/>
+                <a:latin typeface="Arial"/>
+                <a:ea typeface="Arial"/>
+                <a:cs typeface="Arial"/>
               </a:rPr>
               <a:t>Sohil MM et al.  |  Am Heart J Plus 2026;61:100678</a:t>
             </a:r>
@@ -10180,9 +10178,9 @@
                 <a:solidFill>
                   <a:srgbClr val="0B3D66"/>
                 </a:solidFill>
-                <a:latin typeface="Space Grotesk" pitchFamily="34" charset="0"/>
-                <a:ea typeface="Space Grotesk" pitchFamily="34" charset="-122"/>
-                <a:cs typeface="Space Grotesk" pitchFamily="34" charset="-120"/>
+                <a:latin typeface="Arial"/>
+                <a:ea typeface="Arial"/>
+                <a:cs typeface="Arial"/>
               </a:rPr>
               <a:t>13</a:t>
             </a:r>
@@ -10251,9 +10249,9 @@
                 <a:solidFill>
                   <a:srgbClr val="0B3D66"/>
                 </a:solidFill>
-                <a:latin typeface="Space Grotesk" pitchFamily="34" charset="0"/>
-                <a:ea typeface="Space Grotesk" pitchFamily="34" charset="-122"/>
-                <a:cs typeface="Space Grotesk" pitchFamily="34" charset="-120"/>
+                <a:latin typeface="Arial"/>
+                <a:ea typeface="Arial"/>
+                <a:cs typeface="Arial"/>
               </a:rPr>
               <a:t>Endpoints differ by study</a:t>
             </a:r>
@@ -10349,9 +10347,9 @@
                 <a:solidFill>
                   <a:srgbClr val="C8102E"/>
                 </a:solidFill>
-                <a:latin typeface="Space Grotesk" pitchFamily="34" charset="0"/>
-                <a:ea typeface="Space Grotesk" pitchFamily="34" charset="-122"/>
-                <a:cs typeface="Space Grotesk" pitchFamily="34" charset="-120"/>
+                <a:latin typeface="Arial"/>
+                <a:ea typeface="Arial"/>
+                <a:cs typeface="Arial"/>
               </a:rPr>
               <a:t>Not like-for-like</a:t>
             </a:r>
@@ -10369,9 +10367,9 @@
                 <a:solidFill>
                   <a:srgbClr val="0B3D66"/>
                 </a:solidFill>
-                <a:latin typeface="Space Grotesk" pitchFamily="34" charset="0"/>
-                <a:ea typeface="Space Grotesk" pitchFamily="34" charset="-122"/>
-                <a:cs typeface="Space Grotesk" pitchFamily="34" charset="-120"/>
+                <a:latin typeface="Arial"/>
+                <a:ea typeface="Arial"/>
+                <a:cs typeface="Arial"/>
               </a:rPr>
               <a:t>Garcia-Lara 2-yr cardiac-mortality-free survival</a:t>
             </a:r>
@@ -10386,9 +10384,9 @@
                 <a:solidFill>
                   <a:srgbClr val="0B3D66"/>
                 </a:solidFill>
-                <a:latin typeface="Space Grotesk" pitchFamily="34" charset="0"/>
-                <a:ea typeface="Space Grotesk" pitchFamily="34" charset="-122"/>
-                <a:cs typeface="Space Grotesk" pitchFamily="34" charset="-120"/>
+                <a:latin typeface="Arial"/>
+                <a:ea typeface="Arial"/>
+                <a:cs typeface="Arial"/>
               </a:rPr>
               <a:t>71 ± 7%</a:t>
             </a:r>
@@ -10572,9 +10570,9 @@
                 <a:solidFill>
                   <a:srgbClr val="0B3D66"/>
                 </a:solidFill>
-                <a:latin typeface="Space Grotesk Light" pitchFamily="34" charset="0"/>
-                <a:ea typeface="Space Grotesk Light" pitchFamily="34" charset="-122"/>
-                <a:cs typeface="Space Grotesk Light" pitchFamily="34" charset="-120"/>
+                <a:latin typeface="Arial"/>
+                <a:ea typeface="Arial"/>
+                <a:cs typeface="Arial"/>
               </a:rPr>
               <a:t>Sohil MM et al.  |  Am Heart J Plus 2026;61:100678</a:t>
             </a:r>
@@ -10611,9 +10609,9 @@
                 <a:solidFill>
                   <a:srgbClr val="0B3D66"/>
                 </a:solidFill>
-                <a:latin typeface="Space Grotesk" pitchFamily="34" charset="0"/>
-                <a:ea typeface="Space Grotesk" pitchFamily="34" charset="-122"/>
-                <a:cs typeface="Space Grotesk" pitchFamily="34" charset="-120"/>
+                <a:latin typeface="Arial"/>
+                <a:ea typeface="Arial"/>
+                <a:cs typeface="Arial"/>
               </a:rPr>
               <a:t>14</a:t>
             </a:r>
@@ -10682,9 +10680,9 @@
                 <a:solidFill>
                   <a:srgbClr val="0B3D66"/>
                 </a:solidFill>
-                <a:latin typeface="Space Grotesk" pitchFamily="34" charset="0"/>
-                <a:ea typeface="Space Grotesk" pitchFamily="34" charset="-122"/>
-                <a:cs typeface="Space Grotesk" pitchFamily="34" charset="-120"/>
+                <a:latin typeface="Arial"/>
+                <a:ea typeface="Arial"/>
+                <a:cs typeface="Arial"/>
               </a:rPr>
               <a:t>Limitations</a:t>
             </a:r>
@@ -10764,9 +10762,9 @@
                 <a:solidFill>
                   <a:srgbClr val="FFFFFF"/>
                 </a:solidFill>
-                <a:latin typeface="Space Grotesk" pitchFamily="34" charset="0"/>
-                <a:ea typeface="Space Grotesk" pitchFamily="34" charset="-122"/>
-                <a:cs typeface="Space Grotesk" pitchFamily="34" charset="-120"/>
+                <a:latin typeface="Arial"/>
+                <a:ea typeface="Arial"/>
+                <a:cs typeface="Arial"/>
               </a:rPr>
               <a:t>Design</a:t>
             </a:r>
@@ -10806,9 +10804,9 @@
                 <a:solidFill>
                   <a:srgbClr val="000000"/>
                 </a:solidFill>
-                <a:latin typeface="Space Grotesk Light" pitchFamily="34" charset="0"/>
-                <a:ea typeface="Space Grotesk Light" pitchFamily="34" charset="-122"/>
-                <a:cs typeface="Space Grotesk Light" pitchFamily="34" charset="-120"/>
+                <a:latin typeface="Arial"/>
+                <a:ea typeface="Arial"/>
+                <a:cs typeface="Arial"/>
               </a:rPr>
               <a:t>Single centre, small sample (n = 45)</a:t>
             </a:r>
@@ -10826,9 +10824,9 @@
                 <a:solidFill>
                   <a:srgbClr val="000000"/>
                 </a:solidFill>
-                <a:latin typeface="Space Grotesk Light" pitchFamily="34" charset="0"/>
-                <a:ea typeface="Space Grotesk Light" pitchFamily="34" charset="-122"/>
-                <a:cs typeface="Space Grotesk Light" pitchFamily="34" charset="-120"/>
+                <a:latin typeface="Arial"/>
+                <a:ea typeface="Arial"/>
+                <a:cs typeface="Arial"/>
               </a:rPr>
               <a:t>No control group (non-rota PCI or CABG)</a:t>
             </a:r>
@@ -10885,9 +10883,9 @@
                 <a:solidFill>
                   <a:srgbClr val="FFFFFF"/>
                 </a:solidFill>
-                <a:latin typeface="Space Grotesk" pitchFamily="34" charset="0"/>
-                <a:ea typeface="Space Grotesk" pitchFamily="34" charset="-122"/>
-                <a:cs typeface="Space Grotesk" pitchFamily="34" charset="-120"/>
+                <a:latin typeface="Arial"/>
+                <a:ea typeface="Arial"/>
+                <a:cs typeface="Arial"/>
               </a:rPr>
               <a:t>Scope</a:t>
             </a:r>
@@ -10927,9 +10925,9 @@
                 <a:solidFill>
                   <a:srgbClr val="000000"/>
                 </a:solidFill>
-                <a:latin typeface="Space Grotesk Light" pitchFamily="34" charset="0"/>
-                <a:ea typeface="Space Grotesk Light" pitchFamily="34" charset="-122"/>
-                <a:cs typeface="Space Grotesk Light" pitchFamily="34" charset="-120"/>
+                <a:latin typeface="Arial"/>
+                <a:ea typeface="Arial"/>
+                <a:cs typeface="Arial"/>
               </a:rPr>
               <a:t>No systematic angiographic follow-up</a:t>
             </a:r>
@@ -10947,9 +10945,9 @@
                 <a:solidFill>
                   <a:srgbClr val="000000"/>
                 </a:solidFill>
-                <a:latin typeface="Space Grotesk Light" pitchFamily="34" charset="0"/>
-                <a:ea typeface="Space Grotesk Light" pitchFamily="34" charset="-122"/>
-                <a:cs typeface="Space Grotesk Light" pitchFamily="34" charset="-120"/>
+                <a:latin typeface="Arial"/>
+                <a:ea typeface="Arial"/>
+                <a:cs typeface="Arial"/>
               </a:rPr>
               <a:t>Rotablator RA only: not orbital or IVL</a:t>
             </a:r>
@@ -11133,9 +11131,9 @@
                 <a:solidFill>
                   <a:srgbClr val="0B3D66"/>
                 </a:solidFill>
-                <a:latin typeface="Space Grotesk Light" pitchFamily="34" charset="0"/>
-                <a:ea typeface="Space Grotesk Light" pitchFamily="34" charset="-122"/>
-                <a:cs typeface="Space Grotesk Light" pitchFamily="34" charset="-120"/>
+                <a:latin typeface="Arial"/>
+                <a:ea typeface="Arial"/>
+                <a:cs typeface="Arial"/>
               </a:rPr>
               <a:t>Sohil MM et al.  |  Am Heart J Plus 2026;61:100678</a:t>
             </a:r>
@@ -11172,9 +11170,9 @@
                 <a:solidFill>
                   <a:srgbClr val="0B3D66"/>
                 </a:solidFill>
-                <a:latin typeface="Space Grotesk" pitchFamily="34" charset="0"/>
-                <a:ea typeface="Space Grotesk" pitchFamily="34" charset="-122"/>
-                <a:cs typeface="Space Grotesk" pitchFamily="34" charset="-120"/>
+                <a:latin typeface="Arial"/>
+                <a:ea typeface="Arial"/>
+                <a:cs typeface="Arial"/>
               </a:rPr>
               <a:t>15</a:t>
             </a:r>
@@ -11243,9 +11241,9 @@
                 <a:solidFill>
                   <a:srgbClr val="C8102E"/>
                 </a:solidFill>
-                <a:latin typeface="Space Grotesk" pitchFamily="34" charset="0"/>
-                <a:ea typeface="Space Grotesk" pitchFamily="34" charset="-122"/>
-                <a:cs typeface="Space Grotesk" pitchFamily="34" charset="-120"/>
+                <a:latin typeface="Arial"/>
+                <a:ea typeface="Arial"/>
+                <a:cs typeface="Arial"/>
               </a:rPr>
               <a:t>01</a:t>
             </a:r>
@@ -11282,9 +11280,9 @@
                 <a:solidFill>
                   <a:srgbClr val="D6E6F5"/>
                 </a:solidFill>
-                <a:latin typeface="Space Grotesk" pitchFamily="34" charset="0"/>
-                <a:ea typeface="Space Grotesk" pitchFamily="34" charset="-122"/>
-                <a:cs typeface="Space Grotesk" pitchFamily="34" charset="-120"/>
+                <a:latin typeface="Arial"/>
+                <a:ea typeface="Arial"/>
+                <a:cs typeface="Arial"/>
               </a:rPr>
               <a:t>BACKGROUND</a:t>
             </a:r>
@@ -11321,9 +11319,9 @@
                 <a:solidFill>
                   <a:srgbClr val="FFFFFF"/>
                 </a:solidFill>
-                <a:latin typeface="Space Grotesk" pitchFamily="34" charset="0"/>
-                <a:ea typeface="Space Grotesk" pitchFamily="34" charset="-122"/>
-                <a:cs typeface="Space Grotesk" pitchFamily="34" charset="-120"/>
+                <a:latin typeface="Arial"/>
+                <a:ea typeface="Arial"/>
+                <a:cs typeface="Arial"/>
               </a:rPr>
               <a:t>Calcified left main disease makes PCI hard, yet for some patients PCI is the only option.</a:t>
             </a:r>
@@ -11507,9 +11505,9 @@
                 <a:solidFill>
                   <a:srgbClr val="FFFFFF"/>
                 </a:solidFill>
-                <a:latin typeface="Space Grotesk Light" pitchFamily="34" charset="0"/>
-                <a:ea typeface="Space Grotesk Light" pitchFamily="34" charset="-122"/>
-                <a:cs typeface="Space Grotesk Light" pitchFamily="34" charset="-120"/>
+                <a:latin typeface="Arial"/>
+                <a:ea typeface="Arial"/>
+                <a:cs typeface="Arial"/>
               </a:rPr>
               <a:t>Sohil MM et al.  |  Am Heart J Plus 2026;61:100678</a:t>
             </a:r>
@@ -11546,9 +11544,9 @@
                 <a:solidFill>
                   <a:srgbClr val="FFFFFF"/>
                 </a:solidFill>
-                <a:latin typeface="Space Grotesk" pitchFamily="34" charset="0"/>
-                <a:ea typeface="Space Grotesk" pitchFamily="34" charset="-122"/>
-                <a:cs typeface="Space Grotesk" pitchFamily="34" charset="-120"/>
+                <a:latin typeface="Arial"/>
+                <a:ea typeface="Arial"/>
+                <a:cs typeface="Arial"/>
               </a:rPr>
               <a:t>2</a:t>
             </a:r>
@@ -11617,9 +11615,9 @@
                 <a:solidFill>
                   <a:srgbClr val="0B3D66"/>
                 </a:solidFill>
-                <a:latin typeface="Space Grotesk" pitchFamily="34" charset="0"/>
-                <a:ea typeface="Space Grotesk" pitchFamily="34" charset="-122"/>
-                <a:cs typeface="Space Grotesk" pitchFamily="34" charset="-120"/>
+                <a:latin typeface="Arial"/>
+                <a:ea typeface="Arial"/>
+                <a:cs typeface="Arial"/>
               </a:rPr>
               <a:t>Why Indian data matter</a:t>
             </a:r>
@@ -11682,9 +11680,9 @@
                 <a:solidFill>
                   <a:srgbClr val="000000"/>
                 </a:solidFill>
-                <a:latin typeface="Space Grotesk Light" pitchFamily="34" charset="0"/>
-                <a:ea typeface="Space Grotesk Light" pitchFamily="34" charset="-122"/>
-                <a:cs typeface="Space Grotesk Light" pitchFamily="34" charset="-120"/>
+                <a:latin typeface="Arial"/>
+                <a:ea typeface="Arial"/>
+                <a:cs typeface="Arial"/>
               </a:rPr>
               <a:t>Extensive, multivessel, heavily calcified CAD</a:t>
             </a:r>
@@ -11702,9 +11700,9 @@
                 <a:solidFill>
                   <a:srgbClr val="000000"/>
                 </a:solidFill>
-                <a:latin typeface="Space Grotesk Light" pitchFamily="34" charset="0"/>
-                <a:ea typeface="Space Grotesk Light" pitchFamily="34" charset="-122"/>
-                <a:cs typeface="Space Grotesk Light" pitchFamily="34" charset="-120"/>
+                <a:latin typeface="Arial"/>
+                <a:ea typeface="Arial"/>
+                <a:cs typeface="Arial"/>
               </a:rPr>
               <a:t>CAD a decade earlier than in the West</a:t>
             </a:r>
@@ -11722,9 +11720,9 @@
                 <a:solidFill>
                   <a:srgbClr val="000000"/>
                 </a:solidFill>
-                <a:latin typeface="Space Grotesk Light" pitchFamily="34" charset="0"/>
-                <a:ea typeface="Space Grotesk Light" pitchFamily="34" charset="-122"/>
-                <a:cs typeface="Space Grotesk Light" pitchFamily="34" charset="-120"/>
+                <a:latin typeface="Arial"/>
+                <a:ea typeface="Arial"/>
+                <a:cs typeface="Arial"/>
               </a:rPr>
               <a:t>High burden of diabetes and dyslipidemia</a:t>
             </a:r>
@@ -11742,9 +11740,9 @@
                 <a:solidFill>
                   <a:srgbClr val="000000"/>
                 </a:solidFill>
-                <a:latin typeface="Space Grotesk Light" pitchFamily="34" charset="0"/>
-                <a:ea typeface="Space Grotesk Light" pitchFamily="34" charset="-122"/>
-                <a:cs typeface="Space Grotesk Light" pitchFamily="34" charset="-120"/>
+                <a:latin typeface="Arial"/>
+                <a:ea typeface="Arial"/>
+                <a:cs typeface="Arial"/>
               </a:rPr>
               <a:t>DAPT compliance hit by cost and awareness</a:t>
             </a:r>
@@ -11762,9 +11760,9 @@
                 <a:solidFill>
                   <a:srgbClr val="000000"/>
                 </a:solidFill>
-                <a:latin typeface="Space Grotesk Light" pitchFamily="34" charset="0"/>
-                <a:ea typeface="Space Grotesk Light" pitchFamily="34" charset="-122"/>
-                <a:cs typeface="Space Grotesk Light" pitchFamily="34" charset="-120"/>
+                <a:latin typeface="Arial"/>
+                <a:ea typeface="Arial"/>
+                <a:cs typeface="Arial"/>
               </a:rPr>
               <a:t>Little rotablation LM-PCI evidence from India</a:t>
             </a:r>
@@ -11948,9 +11946,9 @@
                 <a:solidFill>
                   <a:srgbClr val="0B3D66"/>
                 </a:solidFill>
-                <a:latin typeface="Space Grotesk Light" pitchFamily="34" charset="0"/>
-                <a:ea typeface="Space Grotesk Light" pitchFamily="34" charset="-122"/>
-                <a:cs typeface="Space Grotesk Light" pitchFamily="34" charset="-120"/>
+                <a:latin typeface="Arial"/>
+                <a:ea typeface="Arial"/>
+                <a:cs typeface="Arial"/>
               </a:rPr>
               <a:t>Sohil MM et al.  |  Am Heart J Plus 2026;61:100678</a:t>
             </a:r>
@@ -11987,9 +11985,9 @@
                 <a:solidFill>
                   <a:srgbClr val="0B3D66"/>
                 </a:solidFill>
-                <a:latin typeface="Space Grotesk" pitchFamily="34" charset="0"/>
-                <a:ea typeface="Space Grotesk" pitchFamily="34" charset="-122"/>
-                <a:cs typeface="Space Grotesk" pitchFamily="34" charset="-120"/>
+                <a:latin typeface="Arial"/>
+                <a:ea typeface="Arial"/>
+                <a:cs typeface="Arial"/>
               </a:rPr>
               <a:t>3</a:t>
             </a:r>
@@ -12058,9 +12056,9 @@
                 <a:solidFill>
                   <a:srgbClr val="0B3D66"/>
                 </a:solidFill>
-                <a:latin typeface="Space Grotesk" pitchFamily="34" charset="0"/>
-                <a:ea typeface="Space Grotesk" pitchFamily="34" charset="-122"/>
-                <a:cs typeface="Space Grotesk" pitchFamily="34" charset="-120"/>
+                <a:latin typeface="Arial"/>
+                <a:ea typeface="Arial"/>
+                <a:cs typeface="Arial"/>
               </a:rPr>
               <a:t>Prospective study design</a:t>
             </a:r>
@@ -12120,9 +12118,9 @@
                 <a:solidFill>
                   <a:srgbClr val="0B3D66"/>
                 </a:solidFill>
-                <a:latin typeface="Space Grotesk" pitchFamily="34" charset="0"/>
-                <a:ea typeface="Space Grotesk" pitchFamily="34" charset="-122"/>
-                <a:cs typeface="Space Grotesk" pitchFamily="34" charset="-120"/>
+                <a:latin typeface="Arial"/>
+                <a:ea typeface="Arial"/>
+                <a:cs typeface="Arial"/>
               </a:rPr>
               <a:t>45</a:t>
             </a:r>
@@ -12159,11 +12157,32 @@
                 <a:solidFill>
                   <a:srgbClr val="000000"/>
                 </a:solidFill>
-                <a:latin typeface="Space Grotesk Light" pitchFamily="34" charset="0"/>
-                <a:ea typeface="Space Grotesk Light" pitchFamily="34" charset="-122"/>
-                <a:cs typeface="Space Grotesk Light" pitchFamily="34" charset="-120"/>
+                <a:latin typeface="Arial"/>
+                <a:ea typeface="Arial"/>
+                <a:cs typeface="Arial"/>
               </a:rPr>
-              <a:t>consecutive patients, rota LM-PCI</a:t>
+              <a:t>consecutive patients,</a:t>
+            </a:r>
+            <a:br>
+              <a:rPr lang="en-US" sz="2400" dirty="0">
+                <a:solidFill>
+                  <a:srgbClr val="000000"/>
+                </a:solidFill>
+                <a:latin typeface="Arial"/>
+                <a:ea typeface="Arial"/>
+                <a:cs typeface="Arial"/>
+              </a:rPr>
+            </a:br>
+            <a:r>
+              <a:rPr lang="en-US" sz="2400" dirty="0">
+                <a:solidFill>
+                  <a:srgbClr val="000000"/>
+                </a:solidFill>
+                <a:latin typeface="Arial"/>
+                <a:ea typeface="Arial"/>
+                <a:cs typeface="Arial"/>
+              </a:rPr>
+              <a:t>rota LM-PCI</a:t>
             </a:r>
             <a:endParaRPr lang="en-US" sz="2400" dirty="0"/>
           </a:p>
@@ -12221,9 +12240,9 @@
                 <a:solidFill>
                   <a:srgbClr val="0B3D66"/>
                 </a:solidFill>
-                <a:latin typeface="Space Grotesk" pitchFamily="34" charset="0"/>
-                <a:ea typeface="Space Grotesk" pitchFamily="34" charset="-122"/>
-                <a:cs typeface="Space Grotesk" pitchFamily="34" charset="-120"/>
+                <a:latin typeface="Arial"/>
+                <a:ea typeface="Arial"/>
+                <a:cs typeface="Arial"/>
               </a:rPr>
               <a:t>2020–23</a:t>
             </a:r>
@@ -12260,9 +12279,9 @@
                 <a:solidFill>
                   <a:srgbClr val="000000"/>
                 </a:solidFill>
-                <a:latin typeface="Space Grotesk Light" pitchFamily="34" charset="0"/>
-                <a:ea typeface="Space Grotesk Light" pitchFamily="34" charset="-122"/>
-                <a:cs typeface="Space Grotesk Light" pitchFamily="34" charset="-120"/>
+                <a:latin typeface="Arial"/>
+                <a:ea typeface="Arial"/>
+                <a:cs typeface="Arial"/>
               </a:rPr>
               <a:t>enrolled Jan 2020 – Jan 2023</a:t>
             </a:r>
@@ -12322,9 +12341,9 @@
                 <a:solidFill>
                   <a:srgbClr val="C8102E"/>
                 </a:solidFill>
-                <a:latin typeface="Space Grotesk" pitchFamily="34" charset="0"/>
-                <a:ea typeface="Space Grotesk" pitchFamily="34" charset="-122"/>
-                <a:cs typeface="Space Grotesk" pitchFamily="34" charset="-120"/>
+                <a:latin typeface="Arial"/>
+                <a:ea typeface="Arial"/>
+                <a:cs typeface="Arial"/>
               </a:rPr>
               <a:t>2 years</a:t>
             </a:r>
@@ -12361,9 +12380,9 @@
                 <a:solidFill>
                   <a:srgbClr val="000000"/>
                 </a:solidFill>
-                <a:latin typeface="Space Grotesk Light" pitchFamily="34" charset="0"/>
-                <a:ea typeface="Space Grotesk Light" pitchFamily="34" charset="-122"/>
-                <a:cs typeface="Space Grotesk Light" pitchFamily="34" charset="-120"/>
+                <a:latin typeface="Arial"/>
+                <a:ea typeface="Arial"/>
+                <a:cs typeface="Arial"/>
               </a:rPr>
               <a:t>follow-up, 100% complete</a:t>
             </a:r>
@@ -12547,9 +12566,9 @@
                 <a:solidFill>
                   <a:srgbClr val="0B3D66"/>
                 </a:solidFill>
-                <a:latin typeface="Space Grotesk Light" pitchFamily="34" charset="0"/>
-                <a:ea typeface="Space Grotesk Light" pitchFamily="34" charset="-122"/>
-                <a:cs typeface="Space Grotesk Light" pitchFamily="34" charset="-120"/>
+                <a:latin typeface="Arial"/>
+                <a:ea typeface="Arial"/>
+                <a:cs typeface="Arial"/>
               </a:rPr>
               <a:t>Sohil MM et al.  |  Am Heart J Plus 2026;61:100678</a:t>
             </a:r>
@@ -12586,9 +12605,9 @@
                 <a:solidFill>
                   <a:srgbClr val="0B3D66"/>
                 </a:solidFill>
-                <a:latin typeface="Space Grotesk" pitchFamily="34" charset="0"/>
-                <a:ea typeface="Space Grotesk" pitchFamily="34" charset="-122"/>
-                <a:cs typeface="Space Grotesk" pitchFamily="34" charset="-120"/>
+                <a:latin typeface="Arial"/>
+                <a:ea typeface="Arial"/>
+                <a:cs typeface="Arial"/>
               </a:rPr>
               <a:t>4</a:t>
             </a:r>
@@ -12657,9 +12676,9 @@
                 <a:solidFill>
                   <a:srgbClr val="0B3D66"/>
                 </a:solidFill>
-                <a:latin typeface="Space Grotesk" pitchFamily="34" charset="0"/>
-                <a:ea typeface="Space Grotesk" pitchFamily="34" charset="-122"/>
-                <a:cs typeface="Space Grotesk" pitchFamily="34" charset="-120"/>
+                <a:latin typeface="Arial"/>
+                <a:ea typeface="Arial"/>
+                <a:cs typeface="Arial"/>
               </a:rPr>
               <a:t>Elderly, high-risk cohort</a:t>
             </a:r>
@@ -12699,7 +12718,7 @@
           <p:nvPr>
             <p:extLst>
               <p:ext uri="{D42A27DB-BD31-4B8C-83A1-F6EECF244321}">
-                <p14:modId xmlns:p14="http://schemas.microsoft.com/office/powerpoint/2010/main" val="1579011935"/>
+                <p14:modId xmlns:p14="http://schemas.microsoft.com/office/powerpoint/2010/main" val="2845048858"/>
               </p:ext>
             </p:extLst>
           </p:nvPr>
@@ -12732,16 +12751,16 @@
                           <a:solidFill>
                             <a:srgbClr val="FFFFFF"/>
                           </a:solidFill>
-                          <a:latin typeface="Space Grotesk" pitchFamily="34" charset="0"/>
-                          <a:ea typeface="Space Grotesk" pitchFamily="34" charset="-122"/>
-                          <a:cs typeface="Space Grotesk" pitchFamily="34" charset="-120"/>
+                          <a:latin typeface="Arial"/>
+                          <a:ea typeface="Arial"/>
+                          <a:cs typeface="Arial"/>
                         </a:rPr>
                         <a:t>Clinical profile</a:t>
                       </a:r>
                       <a:endParaRPr lang="en-US" sz="2200" dirty="0">
-                        <a:latin typeface="Space Grotesk" charset="0"/>
-                        <a:ea typeface="Space Grotesk" charset="0"/>
-                        <a:cs typeface="Space Grotesk" charset="0"/>
+                        <a:latin typeface="Arial"/>
+                        <a:ea typeface="Arial"/>
+                        <a:cs typeface="Arial"/>
                       </a:endParaRPr>
                     </a:p>
                   </a:txBody>
@@ -12800,16 +12819,16 @@
                           <a:solidFill>
                             <a:srgbClr val="FFFFFF"/>
                           </a:solidFill>
-                          <a:latin typeface="Space Grotesk" pitchFamily="34" charset="0"/>
-                          <a:ea typeface="Space Grotesk" pitchFamily="34" charset="-122"/>
-                          <a:cs typeface="Space Grotesk" pitchFamily="34" charset="-120"/>
+                          <a:latin typeface="Arial"/>
+                          <a:ea typeface="Arial"/>
+                          <a:cs typeface="Arial"/>
                         </a:rPr>
                         <a:t>Value</a:t>
                       </a:r>
                       <a:endParaRPr lang="en-US" sz="2200" dirty="0">
-                        <a:latin typeface="Space Grotesk" charset="0"/>
-                        <a:ea typeface="Space Grotesk" charset="0"/>
-                        <a:cs typeface="Space Grotesk" charset="0"/>
+                        <a:latin typeface="Arial"/>
+                        <a:ea typeface="Arial"/>
+                        <a:cs typeface="Arial"/>
                       </a:endParaRPr>
                     </a:p>
                   </a:txBody>
@@ -12868,16 +12887,16 @@
                           <a:solidFill>
                             <a:srgbClr val="FFFFFF"/>
                           </a:solidFill>
-                          <a:latin typeface="Space Grotesk" pitchFamily="34" charset="0"/>
-                          <a:ea typeface="Space Grotesk" pitchFamily="34" charset="-122"/>
-                          <a:cs typeface="Space Grotesk" pitchFamily="34" charset="-120"/>
+                          <a:latin typeface="Arial"/>
+                          <a:ea typeface="Arial"/>
+                          <a:cs typeface="Arial"/>
                         </a:rPr>
                         <a:t>Risk / history</a:t>
                       </a:r>
                       <a:endParaRPr lang="en-US" sz="2200" dirty="0">
-                        <a:latin typeface="Space Grotesk" charset="0"/>
-                        <a:ea typeface="Space Grotesk" charset="0"/>
-                        <a:cs typeface="Space Grotesk" charset="0"/>
+                        <a:latin typeface="Arial"/>
+                        <a:ea typeface="Arial"/>
+                        <a:cs typeface="Arial"/>
                       </a:endParaRPr>
                     </a:p>
                   </a:txBody>
@@ -12936,16 +12955,16 @@
                           <a:solidFill>
                             <a:srgbClr val="FFFFFF"/>
                           </a:solidFill>
-                          <a:latin typeface="Space Grotesk" pitchFamily="34" charset="0"/>
-                          <a:ea typeface="Space Grotesk" pitchFamily="34" charset="-122"/>
-                          <a:cs typeface="Space Grotesk" pitchFamily="34" charset="-120"/>
+                          <a:latin typeface="Arial"/>
+                          <a:ea typeface="Arial"/>
+                          <a:cs typeface="Arial"/>
                         </a:rPr>
                         <a:t>n (%)</a:t>
                       </a:r>
                       <a:endParaRPr lang="en-US" sz="2200" dirty="0">
-                        <a:latin typeface="Space Grotesk" charset="0"/>
-                        <a:ea typeface="Space Grotesk" charset="0"/>
-                        <a:cs typeface="Space Grotesk" charset="0"/>
+                        <a:latin typeface="Arial"/>
+                        <a:ea typeface="Arial"/>
+                        <a:cs typeface="Arial"/>
                       </a:endParaRPr>
                     </a:p>
                   </a:txBody>
@@ -13006,16 +13025,16 @@
                           <a:solidFill>
                             <a:srgbClr val="000000"/>
                           </a:solidFill>
-                          <a:latin typeface="Space Grotesk Light" pitchFamily="34" charset="0"/>
-                          <a:ea typeface="Space Grotesk Light" pitchFamily="34" charset="-122"/>
-                          <a:cs typeface="Space Grotesk Light" pitchFamily="34" charset="-120"/>
+                          <a:latin typeface="Arial"/>
+                          <a:ea typeface="Arial"/>
+                          <a:cs typeface="Arial"/>
                         </a:rPr>
                         <a:t>Age (years)</a:t>
                       </a:r>
                       <a:endParaRPr lang="en-US" sz="2200" dirty="0">
-                        <a:latin typeface="Space Grotesk Light" charset="0"/>
-                        <a:ea typeface="Space Grotesk Light" charset="0"/>
-                        <a:cs typeface="Space Grotesk Light" charset="0"/>
+                        <a:latin typeface="Arial"/>
+                        <a:ea typeface="Arial"/>
+                        <a:cs typeface="Arial"/>
                       </a:endParaRPr>
                     </a:p>
                   </a:txBody>
@@ -13071,16 +13090,16 @@
                           <a:solidFill>
                             <a:srgbClr val="000000"/>
                           </a:solidFill>
-                          <a:latin typeface="Space Grotesk Light" pitchFamily="34" charset="0"/>
-                          <a:ea typeface="Space Grotesk Light" pitchFamily="34" charset="-122"/>
-                          <a:cs typeface="Space Grotesk Light" pitchFamily="34" charset="-120"/>
+                          <a:latin typeface="Arial"/>
+                          <a:ea typeface="Arial"/>
+                          <a:cs typeface="Arial"/>
                         </a:rPr>
                         <a:t>75.2 ± 5.9</a:t>
                       </a:r>
                       <a:endParaRPr lang="en-US" sz="2200" dirty="0">
-                        <a:latin typeface="Space Grotesk Light" charset="0"/>
-                        <a:ea typeface="Space Grotesk Light" charset="0"/>
-                        <a:cs typeface="Space Grotesk Light" charset="0"/>
+                        <a:latin typeface="Arial"/>
+                        <a:ea typeface="Arial"/>
+                        <a:cs typeface="Arial"/>
                       </a:endParaRPr>
                     </a:p>
                   </a:txBody>
@@ -13136,16 +13155,16 @@
                           <a:solidFill>
                             <a:srgbClr val="000000"/>
                           </a:solidFill>
-                          <a:latin typeface="Space Grotesk Light" pitchFamily="34" charset="0"/>
-                          <a:ea typeface="Space Grotesk Light" pitchFamily="34" charset="-122"/>
-                          <a:cs typeface="Space Grotesk Light" pitchFamily="34" charset="-120"/>
+                          <a:latin typeface="Arial"/>
+                          <a:ea typeface="Arial"/>
+                          <a:cs typeface="Arial"/>
                         </a:rPr>
                         <a:t>Hypertension</a:t>
                       </a:r>
                       <a:endParaRPr lang="en-US" sz="2200" dirty="0">
-                        <a:latin typeface="Space Grotesk Light" charset="0"/>
-                        <a:ea typeface="Space Grotesk Light" charset="0"/>
-                        <a:cs typeface="Space Grotesk Light" charset="0"/>
+                        <a:latin typeface="Arial"/>
+                        <a:ea typeface="Arial"/>
+                        <a:cs typeface="Arial"/>
                       </a:endParaRPr>
                     </a:p>
                   </a:txBody>
@@ -13201,16 +13220,16 @@
                           <a:solidFill>
                             <a:srgbClr val="000000"/>
                           </a:solidFill>
-                          <a:latin typeface="Space Grotesk Light" pitchFamily="34" charset="0"/>
-                          <a:ea typeface="Space Grotesk Light" pitchFamily="34" charset="-122"/>
-                          <a:cs typeface="Space Grotesk Light" pitchFamily="34" charset="-120"/>
+                          <a:latin typeface="Arial"/>
+                          <a:ea typeface="Arial"/>
+                          <a:cs typeface="Arial"/>
                         </a:rPr>
                         <a:t>38 (84.4%)</a:t>
                       </a:r>
                       <a:endParaRPr lang="en-US" sz="2200" dirty="0">
-                        <a:latin typeface="Space Grotesk Light" charset="0"/>
-                        <a:ea typeface="Space Grotesk Light" charset="0"/>
-                        <a:cs typeface="Space Grotesk Light" charset="0"/>
+                        <a:latin typeface="Arial"/>
+                        <a:ea typeface="Arial"/>
+                        <a:cs typeface="Arial"/>
                       </a:endParaRPr>
                     </a:p>
                   </a:txBody>
@@ -13268,16 +13287,16 @@
                           <a:solidFill>
                             <a:srgbClr val="000000"/>
                           </a:solidFill>
-                          <a:latin typeface="Space Grotesk Light" pitchFamily="34" charset="0"/>
-                          <a:ea typeface="Space Grotesk Light" pitchFamily="34" charset="-122"/>
-                          <a:cs typeface="Space Grotesk Light" pitchFamily="34" charset="-120"/>
+                          <a:latin typeface="Arial"/>
+                          <a:ea typeface="Arial"/>
+                          <a:cs typeface="Arial"/>
                         </a:rPr>
                         <a:t>Male</a:t>
                       </a:r>
                       <a:endParaRPr lang="en-US" sz="2200" dirty="0">
-                        <a:latin typeface="Space Grotesk Light" charset="0"/>
-                        <a:ea typeface="Space Grotesk Light" charset="0"/>
-                        <a:cs typeface="Space Grotesk Light" charset="0"/>
+                        <a:latin typeface="Arial"/>
+                        <a:ea typeface="Arial"/>
+                        <a:cs typeface="Arial"/>
                       </a:endParaRPr>
                     </a:p>
                   </a:txBody>
@@ -13336,16 +13355,16 @@
                           <a:solidFill>
                             <a:srgbClr val="000000"/>
                           </a:solidFill>
-                          <a:latin typeface="Space Grotesk Light" pitchFamily="34" charset="0"/>
-                          <a:ea typeface="Space Grotesk Light" pitchFamily="34" charset="-122"/>
-                          <a:cs typeface="Space Grotesk Light" pitchFamily="34" charset="-120"/>
+                          <a:latin typeface="Arial"/>
+                          <a:ea typeface="Arial"/>
+                          <a:cs typeface="Arial"/>
                         </a:rPr>
                         <a:t>31 (68.9%)</a:t>
                       </a:r>
                       <a:endParaRPr lang="en-US" sz="2200" dirty="0">
-                        <a:latin typeface="Space Grotesk Light" charset="0"/>
-                        <a:ea typeface="Space Grotesk Light" charset="0"/>
-                        <a:cs typeface="Space Grotesk Light" charset="0"/>
+                        <a:latin typeface="Arial"/>
+                        <a:ea typeface="Arial"/>
+                        <a:cs typeface="Arial"/>
                       </a:endParaRPr>
                     </a:p>
                   </a:txBody>
@@ -13404,16 +13423,16 @@
                           <a:solidFill>
                             <a:srgbClr val="000000"/>
                           </a:solidFill>
-                          <a:latin typeface="Space Grotesk Light" pitchFamily="34" charset="0"/>
-                          <a:ea typeface="Space Grotesk Light" pitchFamily="34" charset="-122"/>
-                          <a:cs typeface="Space Grotesk Light" pitchFamily="34" charset="-120"/>
+                          <a:latin typeface="Arial"/>
+                          <a:ea typeface="Arial"/>
+                          <a:cs typeface="Arial"/>
                         </a:rPr>
                         <a:t>Diabetes</a:t>
                       </a:r>
                       <a:endParaRPr lang="en-US" sz="2200" dirty="0">
-                        <a:latin typeface="Space Grotesk Light" charset="0"/>
-                        <a:ea typeface="Space Grotesk Light" charset="0"/>
-                        <a:cs typeface="Space Grotesk Light" charset="0"/>
+                        <a:latin typeface="Arial"/>
+                        <a:ea typeface="Arial"/>
+                        <a:cs typeface="Arial"/>
                       </a:endParaRPr>
                     </a:p>
                   </a:txBody>
@@ -13472,16 +13491,16 @@
                           <a:solidFill>
                             <a:srgbClr val="000000"/>
                           </a:solidFill>
-                          <a:latin typeface="Space Grotesk Light" pitchFamily="34" charset="0"/>
-                          <a:ea typeface="Space Grotesk Light" pitchFamily="34" charset="-122"/>
-                          <a:cs typeface="Space Grotesk Light" pitchFamily="34" charset="-120"/>
+                          <a:latin typeface="Arial"/>
+                          <a:ea typeface="Arial"/>
+                          <a:cs typeface="Arial"/>
                         </a:rPr>
                         <a:t>25 (55.6%)</a:t>
                       </a:r>
                       <a:endParaRPr lang="en-US" sz="2200" dirty="0">
-                        <a:latin typeface="Space Grotesk Light" charset="0"/>
-                        <a:ea typeface="Space Grotesk Light" charset="0"/>
-                        <a:cs typeface="Space Grotesk Light" charset="0"/>
+                        <a:latin typeface="Arial"/>
+                        <a:ea typeface="Arial"/>
+                        <a:cs typeface="Arial"/>
                       </a:endParaRPr>
                     </a:p>
                   </a:txBody>
@@ -13542,16 +13561,16 @@
                           <a:solidFill>
                             <a:srgbClr val="000000"/>
                           </a:solidFill>
-                          <a:latin typeface="Space Grotesk Light" pitchFamily="34" charset="0"/>
-                          <a:ea typeface="Space Grotesk Light" pitchFamily="34" charset="-122"/>
-                          <a:cs typeface="Space Grotesk Light" pitchFamily="34" charset="-120"/>
+                          <a:latin typeface="Arial"/>
+                          <a:ea typeface="Arial"/>
+                          <a:cs typeface="Arial"/>
                         </a:rPr>
                         <a:t>LVEF (%)</a:t>
                       </a:r>
                       <a:endParaRPr lang="en-US" sz="2200" dirty="0">
-                        <a:latin typeface="Space Grotesk Light" charset="0"/>
-                        <a:ea typeface="Space Grotesk Light" charset="0"/>
-                        <a:cs typeface="Space Grotesk Light" charset="0"/>
+                        <a:latin typeface="Arial"/>
+                        <a:ea typeface="Arial"/>
+                        <a:cs typeface="Arial"/>
                       </a:endParaRPr>
                     </a:p>
                   </a:txBody>
@@ -13607,16 +13626,16 @@
                           <a:solidFill>
                             <a:srgbClr val="000000"/>
                           </a:solidFill>
-                          <a:latin typeface="Space Grotesk Light" pitchFamily="34" charset="0"/>
-                          <a:ea typeface="Space Grotesk Light" pitchFamily="34" charset="-122"/>
-                          <a:cs typeface="Space Grotesk Light" pitchFamily="34" charset="-120"/>
+                          <a:latin typeface="Arial"/>
+                          <a:ea typeface="Arial"/>
+                          <a:cs typeface="Arial"/>
                         </a:rPr>
                         <a:t>43.3 ± 8.1</a:t>
                       </a:r>
                       <a:endParaRPr lang="en-US" sz="2200" dirty="0">
-                        <a:latin typeface="Space Grotesk Light" charset="0"/>
-                        <a:ea typeface="Space Grotesk Light" charset="0"/>
-                        <a:cs typeface="Space Grotesk Light" charset="0"/>
+                        <a:latin typeface="Arial"/>
+                        <a:ea typeface="Arial"/>
+                        <a:cs typeface="Arial"/>
                       </a:endParaRPr>
                     </a:p>
                   </a:txBody>
@@ -13672,16 +13691,16 @@
                           <a:solidFill>
                             <a:srgbClr val="000000"/>
                           </a:solidFill>
-                          <a:latin typeface="Space Grotesk Light" pitchFamily="34" charset="0"/>
-                          <a:ea typeface="Space Grotesk Light" pitchFamily="34" charset="-122"/>
-                          <a:cs typeface="Space Grotesk Light" pitchFamily="34" charset="-120"/>
+                          <a:latin typeface="Arial"/>
+                          <a:ea typeface="Arial"/>
+                          <a:cs typeface="Arial"/>
                         </a:rPr>
                         <a:t>Previous PCI</a:t>
                       </a:r>
                       <a:endParaRPr lang="en-US" sz="2200" dirty="0">
-                        <a:latin typeface="Space Grotesk Light" charset="0"/>
-                        <a:ea typeface="Space Grotesk Light" charset="0"/>
-                        <a:cs typeface="Space Grotesk Light" charset="0"/>
+                        <a:latin typeface="Arial"/>
+                        <a:ea typeface="Arial"/>
+                        <a:cs typeface="Arial"/>
                       </a:endParaRPr>
                     </a:p>
                   </a:txBody>
@@ -13737,16 +13756,16 @@
                           <a:solidFill>
                             <a:srgbClr val="000000"/>
                           </a:solidFill>
-                          <a:latin typeface="Space Grotesk Light" pitchFamily="34" charset="0"/>
-                          <a:ea typeface="Space Grotesk Light" pitchFamily="34" charset="-122"/>
-                          <a:cs typeface="Space Grotesk Light" pitchFamily="34" charset="-120"/>
+                          <a:latin typeface="Arial"/>
+                          <a:ea typeface="Arial"/>
+                          <a:cs typeface="Arial"/>
                         </a:rPr>
                         <a:t>15 (33.3%)</a:t>
                       </a:r>
                       <a:endParaRPr lang="en-US" sz="2200" dirty="0">
-                        <a:latin typeface="Space Grotesk Light" charset="0"/>
-                        <a:ea typeface="Space Grotesk Light" charset="0"/>
-                        <a:cs typeface="Space Grotesk Light" charset="0"/>
+                        <a:latin typeface="Arial"/>
+                        <a:ea typeface="Arial"/>
+                        <a:cs typeface="Arial"/>
                       </a:endParaRPr>
                     </a:p>
                   </a:txBody>
@@ -13804,16 +13823,16 @@
                           <a:solidFill>
                             <a:srgbClr val="000000"/>
                           </a:solidFill>
-                          <a:latin typeface="Space Grotesk Light" pitchFamily="34" charset="0"/>
-                          <a:ea typeface="Space Grotesk Light" pitchFamily="34" charset="-122"/>
-                          <a:cs typeface="Space Grotesk Light" pitchFamily="34" charset="-120"/>
+                          <a:latin typeface="Arial"/>
+                          <a:ea typeface="Arial"/>
+                          <a:cs typeface="Arial"/>
                         </a:rPr>
                         <a:t>SYNTAX score</a:t>
                       </a:r>
                       <a:endParaRPr lang="en-US" sz="2200" dirty="0">
-                        <a:latin typeface="Space Grotesk Light" charset="0"/>
-                        <a:ea typeface="Space Grotesk Light" charset="0"/>
-                        <a:cs typeface="Space Grotesk Light" charset="0"/>
+                        <a:latin typeface="Arial"/>
+                        <a:ea typeface="Arial"/>
+                        <a:cs typeface="Arial"/>
                       </a:endParaRPr>
                     </a:p>
                   </a:txBody>
@@ -13872,16 +13891,16 @@
                           <a:solidFill>
                             <a:srgbClr val="000000"/>
                           </a:solidFill>
-                          <a:latin typeface="Space Grotesk Light" pitchFamily="34" charset="0"/>
-                          <a:ea typeface="Space Grotesk Light" pitchFamily="34" charset="-122"/>
-                          <a:cs typeface="Space Grotesk Light" pitchFamily="34" charset="-120"/>
+                          <a:latin typeface="Arial"/>
+                          <a:ea typeface="Arial"/>
+                          <a:cs typeface="Arial"/>
                         </a:rPr>
                         <a:t>40.1 ± 8.2</a:t>
                       </a:r>
                       <a:endParaRPr lang="en-US" sz="2200" dirty="0">
-                        <a:latin typeface="Space Grotesk Light" charset="0"/>
-                        <a:ea typeface="Space Grotesk Light" charset="0"/>
-                        <a:cs typeface="Space Grotesk Light" charset="0"/>
+                        <a:latin typeface="Arial"/>
+                        <a:ea typeface="Arial"/>
+                        <a:cs typeface="Arial"/>
                       </a:endParaRPr>
                     </a:p>
                   </a:txBody>
@@ -13940,16 +13959,16 @@
                           <a:solidFill>
                             <a:srgbClr val="000000"/>
                           </a:solidFill>
-                          <a:latin typeface="Space Grotesk Light" pitchFamily="34" charset="0"/>
-                          <a:ea typeface="Space Grotesk Light" pitchFamily="34" charset="-122"/>
-                          <a:cs typeface="Space Grotesk Light" pitchFamily="34" charset="-120"/>
+                          <a:latin typeface="Arial"/>
+                          <a:ea typeface="Arial"/>
+                          <a:cs typeface="Arial"/>
                         </a:rPr>
                         <a:t>Previous CABG</a:t>
                       </a:r>
                       <a:endParaRPr lang="en-US" sz="2200" dirty="0">
-                        <a:latin typeface="Space Grotesk Light" charset="0"/>
-                        <a:ea typeface="Space Grotesk Light" charset="0"/>
-                        <a:cs typeface="Space Grotesk Light" charset="0"/>
+                        <a:latin typeface="Arial"/>
+                        <a:ea typeface="Arial"/>
+                        <a:cs typeface="Arial"/>
                       </a:endParaRPr>
                     </a:p>
                   </a:txBody>
@@ -14008,16 +14027,16 @@
                           <a:solidFill>
                             <a:srgbClr val="000000"/>
                           </a:solidFill>
-                          <a:latin typeface="Space Grotesk Light" pitchFamily="34" charset="0"/>
-                          <a:ea typeface="Space Grotesk Light" pitchFamily="34" charset="-122"/>
-                          <a:cs typeface="Space Grotesk Light" pitchFamily="34" charset="-120"/>
+                          <a:latin typeface="Arial"/>
+                          <a:ea typeface="Arial"/>
+                          <a:cs typeface="Arial"/>
                         </a:rPr>
                         <a:t>11 (24.4%)</a:t>
                       </a:r>
                       <a:endParaRPr lang="en-US" sz="2200" dirty="0">
-                        <a:latin typeface="Space Grotesk Light" charset="0"/>
-                        <a:ea typeface="Space Grotesk Light" charset="0"/>
-                        <a:cs typeface="Space Grotesk Light" charset="0"/>
+                        <a:latin typeface="Arial"/>
+                        <a:ea typeface="Arial"/>
+                        <a:cs typeface="Arial"/>
                       </a:endParaRPr>
                     </a:p>
                   </a:txBody>
@@ -14078,16 +14097,16 @@
                           <a:solidFill>
                             <a:srgbClr val="000000"/>
                           </a:solidFill>
-                          <a:latin typeface="Space Grotesk Light" pitchFamily="34" charset="0"/>
-                          <a:ea typeface="Space Grotesk Light" pitchFamily="34" charset="-122"/>
-                          <a:cs typeface="Space Grotesk Light" pitchFamily="34" charset="-120"/>
+                          <a:latin typeface="Arial"/>
+                          <a:ea typeface="Arial"/>
+                          <a:cs typeface="Arial"/>
                         </a:rPr>
                         <a:t>EuroSCORE II</a:t>
                       </a:r>
                       <a:endParaRPr lang="en-US" sz="2200" dirty="0">
-                        <a:latin typeface="Space Grotesk Light" charset="0"/>
-                        <a:ea typeface="Space Grotesk Light" charset="0"/>
-                        <a:cs typeface="Space Grotesk Light" charset="0"/>
+                        <a:latin typeface="Arial"/>
+                        <a:ea typeface="Arial"/>
+                        <a:cs typeface="Arial"/>
                       </a:endParaRPr>
                     </a:p>
                   </a:txBody>
@@ -14143,16 +14162,16 @@
                           <a:solidFill>
                             <a:srgbClr val="000000"/>
                           </a:solidFill>
-                          <a:latin typeface="Space Grotesk Light" pitchFamily="34" charset="0"/>
-                          <a:ea typeface="Space Grotesk Light" pitchFamily="34" charset="-122"/>
-                          <a:cs typeface="Space Grotesk Light" pitchFamily="34" charset="-120"/>
+                          <a:latin typeface="Arial"/>
+                          <a:ea typeface="Arial"/>
+                          <a:cs typeface="Arial"/>
                         </a:rPr>
                         <a:t>5.4 ± 1.9</a:t>
                       </a:r>
                       <a:endParaRPr lang="en-US" sz="2200" dirty="0">
-                        <a:latin typeface="Space Grotesk Light" charset="0"/>
-                        <a:ea typeface="Space Grotesk Light" charset="0"/>
-                        <a:cs typeface="Space Grotesk Light" charset="0"/>
+                        <a:latin typeface="Arial"/>
+                        <a:ea typeface="Arial"/>
+                        <a:cs typeface="Arial"/>
                       </a:endParaRPr>
                     </a:p>
                   </a:txBody>
@@ -14208,16 +14227,16 @@
                           <a:solidFill>
                             <a:srgbClr val="000000"/>
                           </a:solidFill>
-                          <a:latin typeface="Space Grotesk Light" pitchFamily="34" charset="0"/>
-                          <a:ea typeface="Space Grotesk Light" pitchFamily="34" charset="-122"/>
-                          <a:cs typeface="Space Grotesk Light" pitchFamily="34" charset="-120"/>
+                          <a:latin typeface="Arial"/>
+                          <a:ea typeface="Arial"/>
+                          <a:cs typeface="Arial"/>
                         </a:rPr>
                         <a:t>NSTEMI</a:t>
                       </a:r>
                       <a:endParaRPr lang="en-US" sz="2200" dirty="0">
-                        <a:latin typeface="Space Grotesk Light" charset="0"/>
-                        <a:ea typeface="Space Grotesk Light" charset="0"/>
-                        <a:cs typeface="Space Grotesk Light" charset="0"/>
+                        <a:latin typeface="Arial"/>
+                        <a:ea typeface="Arial"/>
+                        <a:cs typeface="Arial"/>
                       </a:endParaRPr>
                     </a:p>
                   </a:txBody>
@@ -14273,16 +14292,16 @@
                           <a:solidFill>
                             <a:srgbClr val="000000"/>
                           </a:solidFill>
-                          <a:latin typeface="Space Grotesk Light" pitchFamily="34" charset="0"/>
-                          <a:ea typeface="Space Grotesk Light" pitchFamily="34" charset="-122"/>
-                          <a:cs typeface="Space Grotesk Light" pitchFamily="34" charset="-120"/>
+                          <a:latin typeface="Arial"/>
+                          <a:ea typeface="Arial"/>
+                          <a:cs typeface="Arial"/>
                         </a:rPr>
                         <a:t>24 (53.3%)</a:t>
                       </a:r>
                       <a:endParaRPr lang="en-US" sz="2200" dirty="0">
-                        <a:latin typeface="Space Grotesk Light" charset="0"/>
-                        <a:ea typeface="Space Grotesk Light" charset="0"/>
-                        <a:cs typeface="Space Grotesk Light" charset="0"/>
+                        <a:latin typeface="Arial"/>
+                        <a:ea typeface="Arial"/>
+                        <a:cs typeface="Arial"/>
                       </a:endParaRPr>
                     </a:p>
                   </a:txBody>
@@ -14506,9 +14525,9 @@
                 <a:solidFill>
                   <a:srgbClr val="0B3D66"/>
                 </a:solidFill>
-                <a:latin typeface="Space Grotesk Light" pitchFamily="34" charset="0"/>
-                <a:ea typeface="Space Grotesk Light" pitchFamily="34" charset="-122"/>
-                <a:cs typeface="Space Grotesk Light" pitchFamily="34" charset="-120"/>
+                <a:latin typeface="Arial"/>
+                <a:ea typeface="Arial"/>
+                <a:cs typeface="Arial"/>
               </a:rPr>
               <a:t>Sohil MM et al.  |  Am Heart J Plus 2026;61:100678</a:t>
             </a:r>
@@ -14545,9 +14564,9 @@
                 <a:solidFill>
                   <a:srgbClr val="0B3D66"/>
                 </a:solidFill>
-                <a:latin typeface="Space Grotesk" pitchFamily="34" charset="0"/>
-                <a:ea typeface="Space Grotesk" pitchFamily="34" charset="-122"/>
-                <a:cs typeface="Space Grotesk" pitchFamily="34" charset="-120"/>
+                <a:latin typeface="Arial"/>
+                <a:ea typeface="Arial"/>
+                <a:cs typeface="Arial"/>
               </a:rPr>
               <a:t>8</a:t>
             </a:r>
@@ -14616,9 +14635,9 @@
                 <a:solidFill>
                   <a:srgbClr val="0B3D66"/>
                 </a:solidFill>
-                <a:latin typeface="Space Grotesk" pitchFamily="34" charset="0"/>
-                <a:ea typeface="Space Grotesk" pitchFamily="34" charset="-122"/>
-                <a:cs typeface="Space Grotesk" pitchFamily="34" charset="-120"/>
+                <a:latin typeface="Arial"/>
+                <a:ea typeface="Arial"/>
+                <a:cs typeface="Arial"/>
               </a:rPr>
               <a:t>Mostly LM + 3-vessel CAD</a:t>
             </a:r>
@@ -14714,9 +14733,9 @@
                 <a:solidFill>
                   <a:srgbClr val="C8102E"/>
                 </a:solidFill>
-                <a:latin typeface="Space Grotesk" pitchFamily="34" charset="0"/>
-                <a:ea typeface="Space Grotesk" pitchFamily="34" charset="-122"/>
-                <a:cs typeface="Space Grotesk" pitchFamily="34" charset="-120"/>
+                <a:latin typeface="Arial"/>
+                <a:ea typeface="Arial"/>
+                <a:cs typeface="Arial"/>
               </a:rPr>
               <a:t>86.7%</a:t>
             </a:r>
@@ -14731,9 +14750,9 @@
                 <a:solidFill>
                   <a:srgbClr val="000000"/>
                 </a:solidFill>
-                <a:latin typeface="Space Grotesk Light" pitchFamily="34" charset="0"/>
-                <a:ea typeface="Space Grotesk Light" pitchFamily="34" charset="-122"/>
-                <a:cs typeface="Space Grotesk Light" pitchFamily="34" charset="-120"/>
+                <a:latin typeface="Arial"/>
+                <a:ea typeface="Arial"/>
+                <a:cs typeface="Arial"/>
               </a:rPr>
               <a:t>severe LMCA calcification</a:t>
             </a:r>
@@ -14751,9 +14770,9 @@
                 <a:solidFill>
                   <a:srgbClr val="C8102E"/>
                 </a:solidFill>
-                <a:latin typeface="Space Grotesk" pitchFamily="34" charset="0"/>
-                <a:ea typeface="Space Grotesk" pitchFamily="34" charset="-122"/>
-                <a:cs typeface="Space Grotesk" pitchFamily="34" charset="-120"/>
+                <a:latin typeface="Arial"/>
+                <a:ea typeface="Arial"/>
+                <a:cs typeface="Arial"/>
               </a:rPr>
               <a:t>62.2%</a:t>
             </a:r>
@@ -14768,9 +14787,9 @@
                 <a:solidFill>
                   <a:srgbClr val="000000"/>
                 </a:solidFill>
-                <a:latin typeface="Space Grotesk Light" pitchFamily="34" charset="0"/>
-                <a:ea typeface="Space Grotesk Light" pitchFamily="34" charset="-122"/>
-                <a:cs typeface="Space Grotesk Light" pitchFamily="34" charset="-120"/>
+                <a:latin typeface="Arial"/>
+                <a:ea typeface="Arial"/>
+                <a:cs typeface="Arial"/>
               </a:rPr>
               <a:t>distal LMCA lesion</a:t>
             </a:r>
@@ -14954,9 +14973,9 @@
                 <a:solidFill>
                   <a:srgbClr val="0B3D66"/>
                 </a:solidFill>
-                <a:latin typeface="Space Grotesk Light" pitchFamily="34" charset="0"/>
-                <a:ea typeface="Space Grotesk Light" pitchFamily="34" charset="-122"/>
-                <a:cs typeface="Space Grotesk Light" pitchFamily="34" charset="-120"/>
+                <a:latin typeface="Arial"/>
+                <a:ea typeface="Arial"/>
+                <a:cs typeface="Arial"/>
               </a:rPr>
               <a:t>Sohil MM et al.  |  Am Heart J Plus 2026;61:100678</a:t>
             </a:r>
@@ -14993,9 +15012,9 @@
                 <a:solidFill>
                   <a:srgbClr val="0B3D66"/>
                 </a:solidFill>
-                <a:latin typeface="Space Grotesk" pitchFamily="34" charset="0"/>
-                <a:ea typeface="Space Grotesk" pitchFamily="34" charset="-122"/>
-                <a:cs typeface="Space Grotesk" pitchFamily="34" charset="-120"/>
+                <a:latin typeface="Arial"/>
+                <a:ea typeface="Arial"/>
+                <a:cs typeface="Arial"/>
               </a:rPr>
               <a:t>9</a:t>
             </a:r>
@@ -15064,7 +15083,7 @@
           <p:nvPr/>
         </p:nvPicPr>
         <p:blipFill>
-          <a:blip r:embed="rIdFig1"/>
+          <a:blip r:embed="rId3"/>
           <a:stretch>
             <a:fillRect/>
           </a:stretch>
@@ -15113,9 +15132,9 @@
                 <a:solidFill>
                   <a:srgbClr val="0B3D66"/>
                 </a:solidFill>
-                <a:latin typeface="Space Grotesk" pitchFamily="34" charset="0"/>
-                <a:ea typeface="Space Grotesk" pitchFamily="34" charset="-122"/>
-                <a:cs typeface="Space Grotesk" pitchFamily="34" charset="-120"/>
+                <a:latin typeface="Arial"/>
+                <a:ea typeface="Arial"/>
+                <a:cs typeface="Arial"/>
               </a:rPr>
               <a:t>Patient selection (Fig. 1)</a:t>
             </a:r>
@@ -15178,9 +15197,9 @@
                 <a:solidFill>
                   <a:srgbClr val="000000"/>
                 </a:solidFill>
-                <a:latin typeface="Space Grotesk Light" pitchFamily="34" charset="0"/>
-                <a:ea typeface="Space Grotesk Light" pitchFamily="34" charset="-122"/>
-                <a:cs typeface="Space Grotesk Light" pitchFamily="34" charset="-120"/>
+                <a:latin typeface="Arial"/>
+                <a:ea typeface="Arial"/>
+                <a:cs typeface="Arial"/>
               </a:rPr>
               <a:t>Heart team: SYNTAX &gt;32 advised CABG</a:t>
             </a:r>
@@ -15198,9 +15217,9 @@
                 <a:solidFill>
                   <a:srgbClr val="000000"/>
                 </a:solidFill>
-                <a:latin typeface="Space Grotesk Light" pitchFamily="34" charset="0"/>
-                <a:ea typeface="Space Grotesk Light" pitchFamily="34" charset="-122"/>
-                <a:cs typeface="Space Grotesk Light" pitchFamily="34" charset="-120"/>
+                <a:latin typeface="Arial"/>
+                <a:ea typeface="Arial"/>
+                <a:cs typeface="Arial"/>
               </a:rPr>
               <a:t>PCI by patient choice after counselling</a:t>
             </a:r>
@@ -15218,9 +15237,9 @@
                 <a:solidFill>
                   <a:srgbClr val="000000"/>
                 </a:solidFill>
-                <a:latin typeface="Space Grotesk Light" pitchFamily="34" charset="0"/>
-                <a:ea typeface="Space Grotesk Light" pitchFamily="34" charset="-122"/>
-                <a:cs typeface="Space Grotesk Light" pitchFamily="34" charset="-120"/>
+                <a:latin typeface="Arial"/>
+                <a:ea typeface="Arial"/>
+                <a:cs typeface="Arial"/>
               </a:rPr>
               <a:t>LMCA ≥50% + severe Ca or IVUS Ca score ≥2</a:t>
             </a:r>
@@ -15404,9 +15423,9 @@
                 <a:solidFill>
                   <a:srgbClr val="0B3D66"/>
                 </a:solidFill>
-                <a:latin typeface="Space Grotesk Light" pitchFamily="34" charset="0"/>
-                <a:ea typeface="Space Grotesk Light" pitchFamily="34" charset="-122"/>
-                <a:cs typeface="Space Grotesk Light" pitchFamily="34" charset="-120"/>
+                <a:latin typeface="Arial"/>
+                <a:ea typeface="Arial"/>
+                <a:cs typeface="Arial"/>
               </a:rPr>
               <a:t>Sohil MM et al.  |  Am Heart J Plus 2026;61:100678</a:t>
             </a:r>
@@ -15443,9 +15462,9 @@
                 <a:solidFill>
                   <a:srgbClr val="0B3D66"/>
                 </a:solidFill>
-                <a:latin typeface="Space Grotesk" pitchFamily="34" charset="0"/>
-                <a:ea typeface="Space Grotesk" pitchFamily="34" charset="-122"/>
-                <a:cs typeface="Space Grotesk" pitchFamily="34" charset="-120"/>
+                <a:latin typeface="Arial"/>
+                <a:ea typeface="Arial"/>
+                <a:cs typeface="Arial"/>
               </a:rPr>
               <a:t>5</a:t>
             </a:r>
@@ -15514,9 +15533,9 @@
                 <a:solidFill>
                   <a:srgbClr val="0B3D66"/>
                 </a:solidFill>
-                <a:latin typeface="Space Grotesk" pitchFamily="34" charset="0"/>
-                <a:ea typeface="Space Grotesk" pitchFamily="34" charset="-122"/>
-                <a:cs typeface="Space Grotesk" pitchFamily="34" charset="-120"/>
+                <a:latin typeface="Arial"/>
+                <a:ea typeface="Arial"/>
+                <a:cs typeface="Arial"/>
               </a:rPr>
               <a:t>Outcome definitions</a:t>
             </a:r>
@@ -15596,9 +15615,9 @@
                 <a:solidFill>
                   <a:srgbClr val="FFFFFF"/>
                 </a:solidFill>
-                <a:latin typeface="Space Grotesk" pitchFamily="34" charset="0"/>
-                <a:ea typeface="Space Grotesk" pitchFamily="34" charset="-122"/>
-                <a:cs typeface="Space Grotesk" pitchFamily="34" charset="-120"/>
+                <a:latin typeface="Arial"/>
+                <a:ea typeface="Arial"/>
+                <a:cs typeface="Arial"/>
               </a:rPr>
               <a:t>In-hospital</a:t>
             </a:r>
@@ -15638,9 +15657,9 @@
                 <a:solidFill>
                   <a:srgbClr val="000000"/>
                 </a:solidFill>
-                <a:latin typeface="Space Grotesk Light" pitchFamily="34" charset="0"/>
-                <a:ea typeface="Space Grotesk Light" pitchFamily="34" charset="-122"/>
-                <a:cs typeface="Space Grotesk Light" pitchFamily="34" charset="-120"/>
+                <a:latin typeface="Arial"/>
+                <a:ea typeface="Arial"/>
+                <a:cs typeface="Arial"/>
               </a:rPr>
               <a:t>Angiographic: &lt;20% residual, TIMI 3</a:t>
             </a:r>
@@ -15658,9 +15677,9 @@
                 <a:solidFill>
                   <a:srgbClr val="000000"/>
                 </a:solidFill>
-                <a:latin typeface="Space Grotesk Light" pitchFamily="34" charset="0"/>
-                <a:ea typeface="Space Grotesk Light" pitchFamily="34" charset="-122"/>
-                <a:cs typeface="Space Grotesk Light" pitchFamily="34" charset="-120"/>
+                <a:latin typeface="Arial"/>
+                <a:ea typeface="Arial"/>
+                <a:cs typeface="Arial"/>
               </a:rPr>
               <a:t>Procedural: no major complication, death, MI or emergency revasc.</a:t>
             </a:r>
@@ -15717,9 +15736,9 @@
                 <a:solidFill>
                   <a:srgbClr val="FFFFFF"/>
                 </a:solidFill>
-                <a:latin typeface="Space Grotesk" pitchFamily="34" charset="0"/>
-                <a:ea typeface="Space Grotesk" pitchFamily="34" charset="-122"/>
-                <a:cs typeface="Space Grotesk" pitchFamily="34" charset="-120"/>
+                <a:latin typeface="Arial"/>
+                <a:ea typeface="Arial"/>
+                <a:cs typeface="Arial"/>
               </a:rPr>
               <a:t>Two-year</a:t>
             </a:r>
@@ -15759,9 +15778,9 @@
                 <a:solidFill>
                   <a:srgbClr val="000000"/>
                 </a:solidFill>
-                <a:latin typeface="Space Grotesk Light" pitchFamily="34" charset="0"/>
-                <a:ea typeface="Space Grotesk Light" pitchFamily="34" charset="-122"/>
-                <a:cs typeface="Space Grotesk Light" pitchFamily="34" charset="-120"/>
+                <a:latin typeface="Arial"/>
+                <a:ea typeface="Arial"/>
+                <a:cs typeface="Arial"/>
               </a:rPr>
               <a:t>MACE: cardiac death, nonfatal MI, TLR</a:t>
             </a:r>
@@ -15779,9 +15798,9 @@
                 <a:solidFill>
                   <a:srgbClr val="000000"/>
                 </a:solidFill>
-                <a:latin typeface="Space Grotesk Light" pitchFamily="34" charset="0"/>
-                <a:ea typeface="Space Grotesk Light" pitchFamily="34" charset="-122"/>
-                <a:cs typeface="Space Grotesk Light" pitchFamily="34" charset="-120"/>
+                <a:latin typeface="Arial"/>
+                <a:ea typeface="Arial"/>
+                <a:cs typeface="Arial"/>
               </a:rPr>
               <a:t>Stent thrombosis (ARC), stroke, bleeding (BARC)</a:t>
             </a:r>
@@ -15965,9 +15984,9 @@
                 <a:solidFill>
                   <a:srgbClr val="0B3D66"/>
                 </a:solidFill>
-                <a:latin typeface="Space Grotesk Light" pitchFamily="34" charset="0"/>
-                <a:ea typeface="Space Grotesk Light" pitchFamily="34" charset="-122"/>
-                <a:cs typeface="Space Grotesk Light" pitchFamily="34" charset="-120"/>
+                <a:latin typeface="Arial"/>
+                <a:ea typeface="Arial"/>
+                <a:cs typeface="Arial"/>
               </a:rPr>
               <a:t>Sohil MM et al.  |  Am Heart J Plus 2026;61:100678</a:t>
             </a:r>
@@ -16004,9 +16023,9 @@
                 <a:solidFill>
                   <a:srgbClr val="0B3D66"/>
                 </a:solidFill>
-                <a:latin typeface="Space Grotesk" pitchFamily="34" charset="0"/>
-                <a:ea typeface="Space Grotesk" pitchFamily="34" charset="-122"/>
-                <a:cs typeface="Space Grotesk" pitchFamily="34" charset="-120"/>
+                <a:latin typeface="Arial"/>
+                <a:ea typeface="Arial"/>
+                <a:cs typeface="Arial"/>
               </a:rPr>
               <a:t>7</a:t>
             </a:r>
@@ -16075,9 +16094,9 @@
                 <a:solidFill>
                   <a:srgbClr val="FFFFFF"/>
                 </a:solidFill>
-                <a:latin typeface="Space Grotesk" pitchFamily="34" charset="0"/>
-                <a:ea typeface="Space Grotesk" pitchFamily="34" charset="-122"/>
-                <a:cs typeface="Space Grotesk" pitchFamily="34" charset="-120"/>
+                <a:latin typeface="Arial"/>
+                <a:ea typeface="Arial"/>
+                <a:cs typeface="Arial"/>
               </a:rPr>
               <a:t>Take-home messages</a:t>
             </a:r>
@@ -16206,9 +16225,9 @@
                 <a:solidFill>
                   <a:srgbClr val="FFFFFF"/>
                 </a:solidFill>
-                <a:latin typeface="Space Grotesk Light" pitchFamily="34" charset="0"/>
-                <a:ea typeface="Space Grotesk Light" pitchFamily="34" charset="-122"/>
-                <a:cs typeface="Space Grotesk Light" pitchFamily="34" charset="-120"/>
+                <a:latin typeface="Arial"/>
+                <a:ea typeface="Arial"/>
+                <a:cs typeface="Arial"/>
               </a:rPr>
               <a:t>Rota-assisted LM-PCI is feasible, safe and effective in severely calcified lesions</a:t>
             </a:r>
@@ -16314,9 +16333,9 @@
                 <a:solidFill>
                   <a:srgbClr val="FFFFFF"/>
                 </a:solidFill>
-                <a:latin typeface="Space Grotesk Light" pitchFamily="34" charset="0"/>
-                <a:ea typeface="Space Grotesk Light" pitchFamily="34" charset="-122"/>
-                <a:cs typeface="Space Grotesk Light" pitchFamily="34" charset="-120"/>
+                <a:latin typeface="Arial"/>
+                <a:ea typeface="Arial"/>
+                <a:cs typeface="Arial"/>
               </a:rPr>
               <a:t>Procedural success 97.8%, with a low rate of periprocedural complications</a:t>
             </a:r>
@@ -16422,9 +16441,9 @@
                 <a:solidFill>
                   <a:srgbClr val="FFFFFF"/>
                 </a:solidFill>
-                <a:latin typeface="Space Grotesk Light" pitchFamily="34" charset="0"/>
-                <a:ea typeface="Space Grotesk Light" pitchFamily="34" charset="-122"/>
-                <a:cs typeface="Space Grotesk Light" pitchFamily="34" charset="-120"/>
+                <a:latin typeface="Arial"/>
+                <a:ea typeface="Arial"/>
+                <a:cs typeface="Arial"/>
               </a:rPr>
               <a:t>Durable two-year outcomes: MACE-free survival 93.3%</a:t>
             </a:r>
@@ -16608,9 +16627,9 @@
                 <a:solidFill>
                   <a:srgbClr val="FFFFFF"/>
                 </a:solidFill>
-                <a:latin typeface="Space Grotesk Light" pitchFamily="34" charset="0"/>
-                <a:ea typeface="Space Grotesk Light" pitchFamily="34" charset="-122"/>
-                <a:cs typeface="Space Grotesk Light" pitchFamily="34" charset="-120"/>
+                <a:latin typeface="Arial"/>
+                <a:ea typeface="Arial"/>
+                <a:cs typeface="Arial"/>
               </a:rPr>
               <a:t>Sohil MM et al.  |  Am Heart J Plus 2026;61:100678</a:t>
             </a:r>
@@ -16647,9 +16666,9 @@
                 <a:solidFill>
                   <a:srgbClr val="FFFFFF"/>
                 </a:solidFill>
-                <a:latin typeface="Space Grotesk" pitchFamily="34" charset="0"/>
-                <a:ea typeface="Space Grotesk" pitchFamily="34" charset="-122"/>
-                <a:cs typeface="Space Grotesk" pitchFamily="34" charset="-120"/>
+                <a:latin typeface="Arial"/>
+                <a:ea typeface="Arial"/>
+                <a:cs typeface="Arial"/>
               </a:rPr>
               <a:t>16</a:t>
             </a:r>
@@ -16708,7 +16727,7 @@
     </a:clrScheme>
     <a:fontScheme name="Office">
       <a:majorFont>
-        <a:latin typeface="Calibri Light" panose="020F0302020204030204"/>
+        <a:latin typeface="Arial"/>
         <a:ea typeface=""/>
         <a:cs typeface=""/>
         <a:font script="Jpan" typeface="游ゴシック Light"/>
@@ -16760,7 +16779,302 @@
         <a:font script="Tfng" typeface="Ebrima"/>
       </a:majorFont>
       <a:minorFont>
-        <a:latin typeface="Calibri" panose="020F0502020204030204"/>
+        <a:latin typeface="Arial"/>
+        <a:ea typeface=""/>
+        <a:cs typeface=""/>
+        <a:font script="Jpan" typeface="游ゴシック"/>
+        <a:font script="Hang" typeface="맑은 고딕"/>
+        <a:font script="Hans" typeface="等线"/>
+        <a:font script="Hant" typeface="新細明體"/>
+        <a:font script="Arab" typeface="Arial"/>
+        <a:font script="Hebr" typeface="Arial"/>
+        <a:font script="Thai" typeface="Cordia New"/>
+        <a:font script="Ethi" typeface="Nyala"/>
+        <a:font script="Beng" typeface="Vrinda"/>
+        <a:font script="Gujr" typeface="Shruti"/>
+        <a:font script="Khmr" typeface="DaunPenh"/>
+        <a:font script="Knda" typeface="Tunga"/>
+        <a:font script="Guru" typeface="Raavi"/>
+        <a:font script="Cans" typeface="Euphemia"/>
+        <a:font script="Cher" typeface="Plantagenet Cherokee"/>
+        <a:font script="Yiii" typeface="Microsoft Yi Baiti"/>
+        <a:font script="Tibt" typeface="Microsoft Himalaya"/>
+        <a:font script="Thaa" typeface="MV Boli"/>
+        <a:font script="Deva" typeface="Mangal"/>
+        <a:font script="Telu" typeface="Gautami"/>
+        <a:font script="Taml" typeface="Latha"/>
+        <a:font script="Syrc" typeface="Estrangelo Edessa"/>
+        <a:font script="Orya" typeface="Kalinga"/>
+        <a:font script="Mlym" typeface="Kartika"/>
+        <a:font script="Laoo" typeface="DokChampa"/>
+        <a:font script="Sinh" typeface="Iskoola Pota"/>
+        <a:font script="Mong" typeface="Mongolian Baiti"/>
+        <a:font script="Viet" typeface="Arial"/>
+        <a:font script="Uigh" typeface="Microsoft Uighur"/>
+        <a:font script="Geor" typeface="Sylfaen"/>
+        <a:font script="Armn" typeface="Arial"/>
+        <a:font script="Bugi" typeface="Leelawadee UI"/>
+        <a:font script="Bopo" typeface="Microsoft JhengHei"/>
+        <a:font script="Java" typeface="Javanese Text"/>
+        <a:font script="Lisu" typeface="Segoe UI"/>
+        <a:font script="Mymr" typeface="Myanmar Text"/>
+        <a:font script="Nkoo" typeface="Ebrima"/>
+        <a:font script="Olck" typeface="Nirmala UI"/>
+        <a:font script="Osma" typeface="Ebrima"/>
+        <a:font script="Phag" typeface="Phagspa"/>
+        <a:font script="Syrn" typeface="Estrangelo Edessa"/>
+        <a:font script="Syrj" typeface="Estrangelo Edessa"/>
+        <a:font script="Syre" typeface="Estrangelo Edessa"/>
+        <a:font script="Sora" typeface="Nirmala UI"/>
+        <a:font script="Tale" typeface="Microsoft Tai Le"/>
+        <a:font script="Talu" typeface="Microsoft New Tai Lue"/>
+        <a:font script="Tfng" typeface="Ebrima"/>
+      </a:minorFont>
+    </a:fontScheme>
+    <a:fmtScheme name="Office">
+      <a:fillStyleLst>
+        <a:solidFill>
+          <a:schemeClr val="phClr"/>
+        </a:solidFill>
+        <a:gradFill rotWithShape="1">
+          <a:gsLst>
+            <a:gs pos="0">
+              <a:schemeClr val="phClr">
+                <a:lumMod val="110000"/>
+                <a:satMod val="105000"/>
+                <a:tint val="67000"/>
+              </a:schemeClr>
+            </a:gs>
+            <a:gs pos="50000">
+              <a:schemeClr val="phClr">
+                <a:lumMod val="105000"/>
+                <a:satMod val="103000"/>
+                <a:tint val="73000"/>
+              </a:schemeClr>
+            </a:gs>
+            <a:gs pos="100000">
+              <a:schemeClr val="phClr">
+                <a:lumMod val="105000"/>
+                <a:satMod val="109000"/>
+                <a:tint val="81000"/>
+              </a:schemeClr>
+            </a:gs>
+          </a:gsLst>
+          <a:lin ang="5400000" scaled="0"/>
+        </a:gradFill>
+        <a:gradFill rotWithShape="1">
+          <a:gsLst>
+            <a:gs pos="0">
+              <a:schemeClr val="phClr">
+                <a:satMod val="103000"/>
+                <a:lumMod val="102000"/>
+                <a:tint val="94000"/>
+              </a:schemeClr>
+            </a:gs>
+            <a:gs pos="50000">
+              <a:schemeClr val="phClr">
+                <a:satMod val="110000"/>
+                <a:lumMod val="100000"/>
+                <a:shade val="100000"/>
+              </a:schemeClr>
+            </a:gs>
+            <a:gs pos="100000">
+              <a:schemeClr val="phClr">
+                <a:lumMod val="99000"/>
+                <a:satMod val="120000"/>
+                <a:shade val="78000"/>
+              </a:schemeClr>
+            </a:gs>
+          </a:gsLst>
+          <a:lin ang="5400000" scaled="0"/>
+        </a:gradFill>
+      </a:fillStyleLst>
+      <a:lnStyleLst>
+        <a:ln w="6350" cap="flat" cmpd="sng" algn="ctr">
+          <a:solidFill>
+            <a:schemeClr val="phClr"/>
+          </a:solidFill>
+          <a:prstDash val="solid"/>
+          <a:miter lim="800000"/>
+        </a:ln>
+        <a:ln w="12700" cap="flat" cmpd="sng" algn="ctr">
+          <a:solidFill>
+            <a:schemeClr val="phClr"/>
+          </a:solidFill>
+          <a:prstDash val="solid"/>
+          <a:miter lim="800000"/>
+        </a:ln>
+        <a:ln w="19050" cap="flat" cmpd="sng" algn="ctr">
+          <a:solidFill>
+            <a:schemeClr val="phClr"/>
+          </a:solidFill>
+          <a:prstDash val="solid"/>
+          <a:miter lim="800000"/>
+        </a:ln>
+      </a:lnStyleLst>
+      <a:effectStyleLst>
+        <a:effectStyle>
+          <a:effectLst/>
+        </a:effectStyle>
+        <a:effectStyle>
+          <a:effectLst/>
+        </a:effectStyle>
+        <a:effectStyle>
+          <a:effectLst>
+            <a:outerShdw blurRad="57150" dist="19050" dir="5400000" algn="ctr" rotWithShape="0">
+              <a:srgbClr val="000000">
+                <a:alpha val="63000"/>
+              </a:srgbClr>
+            </a:outerShdw>
+          </a:effectLst>
+        </a:effectStyle>
+      </a:effectStyleLst>
+      <a:bgFillStyleLst>
+        <a:solidFill>
+          <a:schemeClr val="phClr"/>
+        </a:solidFill>
+        <a:solidFill>
+          <a:schemeClr val="phClr">
+            <a:tint val="95000"/>
+            <a:satMod val="170000"/>
+          </a:schemeClr>
+        </a:solidFill>
+        <a:gradFill rotWithShape="1">
+          <a:gsLst>
+            <a:gs pos="0">
+              <a:schemeClr val="phClr">
+                <a:tint val="93000"/>
+                <a:satMod val="150000"/>
+                <a:shade val="98000"/>
+                <a:lumMod val="102000"/>
+              </a:schemeClr>
+            </a:gs>
+            <a:gs pos="50000">
+              <a:schemeClr val="phClr">
+                <a:tint val="98000"/>
+                <a:satMod val="130000"/>
+                <a:shade val="90000"/>
+                <a:lumMod val="103000"/>
+              </a:schemeClr>
+            </a:gs>
+            <a:gs pos="100000">
+              <a:schemeClr val="phClr">
+                <a:shade val="63000"/>
+                <a:satMod val="120000"/>
+              </a:schemeClr>
+            </a:gs>
+          </a:gsLst>
+          <a:lin ang="5400000" scaled="0"/>
+        </a:gradFill>
+      </a:bgFillStyleLst>
+    </a:fmtScheme>
+  </a:themeElements>
+  <a:objectDefaults/>
+  <a:extraClrSchemeLst/>
+  <a:extLst>
+    <a:ext uri="{05A4C25C-085E-4340-85A3-A5531E510DB2}">
+      <thm15:themeFamily xmlns:thm15="http://schemas.microsoft.com/office/thememl/2012/main" name="Office Theme" id="{62F939B6-93AF-4DB8-9C6B-D6C7DFDC589F}" vid="{4A3C46E8-61CC-4603-A589-7422A47A8E4A}"/>
+    </a:ext>
+  </a:extLst>
+</a:theme>
+</file>
+
+<file path=ppt/theme/theme2.xml><?xml version="1.0" encoding="utf-8"?>
+<a:theme xmlns:a="http://schemas.openxmlformats.org/drawingml/2006/main" name="Office Theme">
+  <a:themeElements>
+    <a:clrScheme name="Office">
+      <a:dk1>
+        <a:sysClr val="windowText" lastClr="000000"/>
+      </a:dk1>
+      <a:lt1>
+        <a:sysClr val="window" lastClr="FFFFFF"/>
+      </a:lt1>
+      <a:dk2>
+        <a:srgbClr val="44546A"/>
+      </a:dk2>
+      <a:lt2>
+        <a:srgbClr val="E7E6E6"/>
+      </a:lt2>
+      <a:accent1>
+        <a:srgbClr val="4472C4"/>
+      </a:accent1>
+      <a:accent2>
+        <a:srgbClr val="ED7D31"/>
+      </a:accent2>
+      <a:accent3>
+        <a:srgbClr val="A5A5A5"/>
+      </a:accent3>
+      <a:accent4>
+        <a:srgbClr val="FFC000"/>
+      </a:accent4>
+      <a:accent5>
+        <a:srgbClr val="5B9BD5"/>
+      </a:accent5>
+      <a:accent6>
+        <a:srgbClr val="70AD47"/>
+      </a:accent6>
+      <a:hlink>
+        <a:srgbClr val="0563C1"/>
+      </a:hlink>
+      <a:folHlink>
+        <a:srgbClr val="954F72"/>
+      </a:folHlink>
+    </a:clrScheme>
+    <a:fontScheme name="Office">
+      <a:majorFont>
+        <a:latin typeface="Arial"/>
+        <a:ea typeface=""/>
+        <a:cs typeface=""/>
+        <a:font script="Jpan" typeface="游ゴシック Light"/>
+        <a:font script="Hang" typeface="맑은 고딕"/>
+        <a:font script="Hans" typeface="等线 Light"/>
+        <a:font script="Hant" typeface="新細明體"/>
+        <a:font script="Arab" typeface="Times New Roman"/>
+        <a:font script="Hebr" typeface="Times New Roman"/>
+        <a:font script="Thai" typeface="Angsana New"/>
+        <a:font script="Ethi" typeface="Nyala"/>
+        <a:font script="Beng" typeface="Vrinda"/>
+        <a:font script="Gujr" typeface="Shruti"/>
+        <a:font script="Khmr" typeface="MoolBoran"/>
+        <a:font script="Knda" typeface="Tunga"/>
+        <a:font script="Guru" typeface="Raavi"/>
+        <a:font script="Cans" typeface="Euphemia"/>
+        <a:font script="Cher" typeface="Plantagenet Cherokee"/>
+        <a:font script="Yiii" typeface="Microsoft Yi Baiti"/>
+        <a:font script="Tibt" typeface="Microsoft Himalaya"/>
+        <a:font script="Thaa" typeface="MV Boli"/>
+        <a:font script="Deva" typeface="Mangal"/>
+        <a:font script="Telu" typeface="Gautami"/>
+        <a:font script="Taml" typeface="Latha"/>
+        <a:font script="Syrc" typeface="Estrangelo Edessa"/>
+        <a:font script="Orya" typeface="Kalinga"/>
+        <a:font script="Mlym" typeface="Kartika"/>
+        <a:font script="Laoo" typeface="DokChampa"/>
+        <a:font script="Sinh" typeface="Iskoola Pota"/>
+        <a:font script="Mong" typeface="Mongolian Baiti"/>
+        <a:font script="Viet" typeface="Times New Roman"/>
+        <a:font script="Uigh" typeface="Microsoft Uighur"/>
+        <a:font script="Geor" typeface="Sylfaen"/>
+        <a:font script="Armn" typeface="Arial"/>
+        <a:font script="Bugi" typeface="Leelawadee UI"/>
+        <a:font script="Bopo" typeface="Microsoft JhengHei"/>
+        <a:font script="Java" typeface="Javanese Text"/>
+        <a:font script="Lisu" typeface="Segoe UI"/>
+        <a:font script="Mymr" typeface="Myanmar Text"/>
+        <a:font script="Nkoo" typeface="Ebrima"/>
+        <a:font script="Olck" typeface="Nirmala UI"/>
+        <a:font script="Osma" typeface="Ebrima"/>
+        <a:font script="Phag" typeface="Phagspa"/>
+        <a:font script="Syrn" typeface="Estrangelo Edessa"/>
+        <a:font script="Syrj" typeface="Estrangelo Edessa"/>
+        <a:font script="Syre" typeface="Estrangelo Edessa"/>
+        <a:font script="Sora" typeface="Nirmala UI"/>
+        <a:font script="Tale" typeface="Microsoft Tai Le"/>
+        <a:font script="Talu" typeface="Microsoft New Tai Lue"/>
+        <a:font script="Tfng" typeface="Ebrima"/>
+      </a:majorFont>
+      <a:minorFont>
+        <a:latin typeface="Arial"/>
         <a:ea typeface=""/>
         <a:cs typeface=""/>
         <a:font script="Jpan" typeface="游ゴシック"/>

</xml_diff>